<commit_message>
Quita comillas de los ejemplos de la guia DIPS
</commit_message>
<xml_diff>
--- a/docs/Guia_DIPS_reglas_referencias.pptx
+++ b/docs/Guia_DIPS_reglas_referencias.pptx
@@ -2,15 +2,15 @@
 <file path=ppt/presentation.xml><?xml version="1.0" encoding="utf-8"?>
 <p:presentation xmlns:p="http://schemas.openxmlformats.org/presentationml/2006/main">
   <p:sldMasterIdLst>
-    <p:sldMasterId xmlns:r="http://schemas.openxmlformats.org/officeDocument/2006/relationships" id="2147483648" r:id="R0764c5cece554828"/>
+    <p:sldMasterId xmlns:r="http://schemas.openxmlformats.org/officeDocument/2006/relationships" id="2147483648" r:id="R4b51cc8ae8274d38"/>
   </p:sldMasterIdLst>
   <p:notesMasterIdLst>
-    <p:notesMasterId xmlns:r="http://schemas.openxmlformats.org/officeDocument/2006/relationships" r:id="Rbcb9d35cdbe74679"/>
+    <p:notesMasterId xmlns:r="http://schemas.openxmlformats.org/officeDocument/2006/relationships" r:id="R2193b590df1347c8"/>
   </p:notesMasterIdLst>
   <p:sldIdLst>
-    <p:sldId xmlns:r="http://schemas.openxmlformats.org/officeDocument/2006/relationships" id="256" r:id="Rd22706c06091444c"/>
-    <p:sldId xmlns:r="http://schemas.openxmlformats.org/officeDocument/2006/relationships" id="257" r:id="R4fc97e11adac40f3"/>
-    <p:sldId xmlns:r="http://schemas.openxmlformats.org/officeDocument/2006/relationships" id="258" r:id="R335557921a8a4279"/>
+    <p:sldId xmlns:r="http://schemas.openxmlformats.org/officeDocument/2006/relationships" id="256" r:id="R5962c71fc3a74b7b"/>
+    <p:sldId xmlns:r="http://schemas.openxmlformats.org/officeDocument/2006/relationships" id="257" r:id="Rd23aa237bfd5414d"/>
+    <p:sldId xmlns:r="http://schemas.openxmlformats.org/officeDocument/2006/relationships" id="258" r:id="R01e1b1ebe54146dc"/>
   </p:sldIdLst>
   <p:sldSz cx="9753600" cy="14630400"/>
   <p:notesSz cx="6858000" cy="9144000"/>
@@ -652,7 +652,7 @@
   </p:cSld>
   <p:clrMap bg1="lt1" tx1="dk1" bg2="lt2" tx2="dk2" accent1="accent1" accent2="accent2" accent3="accent3" accent4="accent4" accent5="accent5" accent6="accent6" hlink="hlink" folHlink="folHlink"/>
   <p:sldLayoutIdLst>
-    <p:sldLayoutId xmlns:r="http://schemas.openxmlformats.org/officeDocument/2006/relationships" id="2147483649" r:id="Rd3968366d35e4a2d"/>
+    <p:sldLayoutId xmlns:r="http://schemas.openxmlformats.org/officeDocument/2006/relationships" id="2147483649" r:id="Re62864cbfec141a0"/>
   </p:sldLayoutIdLst>
   <p:txStyles>
     <p:titleStyle>
@@ -1203,7 +1203,7 @@
           <p:cNvPr id="54" name="">
             <a:extLst xmlns:a="http://schemas.openxmlformats.org/drawingml/2006/main">
               <a:ext uri="{FF2B5EF4-FFF2-40B4-BE49-F238E27FC236}">
-                <a16:creationId xmlns:a16="http://schemas.microsoft.com/office/drawing/2014/main" id="{5B9B7017-9322-4586-B585-393B35E1C9FC}"/>
+                <a16:creationId xmlns:a16="http://schemas.microsoft.com/office/drawing/2014/main" id="{3947AC8A-9F55-423C-ACC9-CCA0B90E64E9}"/>
               </a:ext>
             </a:extLst>
           </p:cNvPr>
@@ -1247,7 +1247,7 @@
           <p:cNvPr id="2" name="">
             <a:extLst xmlns:a="http://schemas.openxmlformats.org/drawingml/2006/main">
               <a:ext uri="{FF2B5EF4-FFF2-40B4-BE49-F238E27FC236}">
-                <a16:creationId xmlns:a16="http://schemas.microsoft.com/office/drawing/2014/main" id="{706E1509-0C84-443C-9B3B-0DC38D38CF2E}"/>
+                <a16:creationId xmlns:a16="http://schemas.microsoft.com/office/drawing/2014/main" id="{81D4B7D2-977E-4BC5-AFA4-23AA0A2C841A}"/>
               </a:ext>
             </a:extLst>
           </p:cNvPr>
@@ -1304,7 +1304,7 @@
           <p:cNvPr id="3" name="">
             <a:extLst xmlns:a="http://schemas.openxmlformats.org/drawingml/2006/main">
               <a:ext uri="{FF2B5EF4-FFF2-40B4-BE49-F238E27FC236}">
-                <a16:creationId xmlns:a16="http://schemas.microsoft.com/office/drawing/2014/main" id="{446903E8-4AA3-4FCE-989A-EBB7227A0729}"/>
+                <a16:creationId xmlns:a16="http://schemas.microsoft.com/office/drawing/2014/main" id="{E1AE5A72-F8CE-442E-A985-AE9A044D344A}"/>
               </a:ext>
             </a:extLst>
           </p:cNvPr>
@@ -1334,7 +1334,7 @@
           <p:cNvPr id="4" name="">
             <a:extLst xmlns:a="http://schemas.openxmlformats.org/drawingml/2006/main">
               <a:ext uri="{FF2B5EF4-FFF2-40B4-BE49-F238E27FC236}">
-                <a16:creationId xmlns:a16="http://schemas.microsoft.com/office/drawing/2014/main" id="{6726027B-7DFD-4CD8-A9FC-251940DFD0C8}"/>
+                <a16:creationId xmlns:a16="http://schemas.microsoft.com/office/drawing/2014/main" id="{4624110B-135B-414F-A6E4-3FF9A5283AE2}"/>
               </a:ext>
             </a:extLst>
           </p:cNvPr>
@@ -1391,7 +1391,7 @@
           <p:cNvPr id="5" name="">
             <a:extLst xmlns:a="http://schemas.openxmlformats.org/drawingml/2006/main">
               <a:ext uri="{FF2B5EF4-FFF2-40B4-BE49-F238E27FC236}">
-                <a16:creationId xmlns:a16="http://schemas.microsoft.com/office/drawing/2014/main" id="{A759CB0A-E725-4BCC-A43C-11D149A0E60D}"/>
+                <a16:creationId xmlns:a16="http://schemas.microsoft.com/office/drawing/2014/main" id="{2CA43DF9-52B2-455E-9792-33662BE6AF37}"/>
               </a:ext>
             </a:extLst>
           </p:cNvPr>
@@ -1452,7 +1452,7 @@
           <p:nvPr/>
         </p:nvPicPr>
         <p:blipFill>
-          <a:blip xmlns:r="http://schemas.openxmlformats.org/officeDocument/2006/relationships" xmlns:a="http://schemas.openxmlformats.org/drawingml/2006/main" r:embed="R6e05846f847046c2"/>
+          <a:blip xmlns:r="http://schemas.openxmlformats.org/officeDocument/2006/relationships" xmlns:a="http://schemas.openxmlformats.org/drawingml/2006/main" r:embed="R14ad780f4b584656"/>
           <a:stretch xmlns:a="http://schemas.openxmlformats.org/drawingml/2006/main"/>
         </p:blipFill>
         <p:spPr>
@@ -1470,7 +1470,7 @@
           <p:cNvPr id="7" name="">
             <a:extLst xmlns:a="http://schemas.openxmlformats.org/drawingml/2006/main">
               <a:ext uri="{FF2B5EF4-FFF2-40B4-BE49-F238E27FC236}">
-                <a16:creationId xmlns:a16="http://schemas.microsoft.com/office/drawing/2014/main" id="{58116738-F99A-40E4-AC06-12B2F1D9ED06}"/>
+                <a16:creationId xmlns:a16="http://schemas.microsoft.com/office/drawing/2014/main" id="{71BC520D-B5F9-4AAE-8F85-5F41951D8182}"/>
               </a:ext>
             </a:extLst>
           </p:cNvPr>
@@ -1512,7 +1512,7 @@
           <p:nvPr/>
         </p:nvPicPr>
         <p:blipFill>
-          <a:blip xmlns:r="http://schemas.openxmlformats.org/officeDocument/2006/relationships" xmlns:a="http://schemas.openxmlformats.org/drawingml/2006/main" r:embed="R171e549e51f7473f"/>
+          <a:blip xmlns:r="http://schemas.openxmlformats.org/officeDocument/2006/relationships" xmlns:a="http://schemas.openxmlformats.org/drawingml/2006/main" r:embed="R0a6e65a7e1bb4626"/>
           <a:stretch xmlns:a="http://schemas.openxmlformats.org/drawingml/2006/main"/>
         </p:blipFill>
         <p:spPr>
@@ -1530,7 +1530,7 @@
           <p:cNvPr id="9" name="">
             <a:extLst xmlns:a="http://schemas.openxmlformats.org/drawingml/2006/main">
               <a:ext uri="{FF2B5EF4-FFF2-40B4-BE49-F238E27FC236}">
-                <a16:creationId xmlns:a16="http://schemas.microsoft.com/office/drawing/2014/main" id="{D067F1D8-5667-495C-8DC9-17FD04E0A441}"/>
+                <a16:creationId xmlns:a16="http://schemas.microsoft.com/office/drawing/2014/main" id="{EC2F37D0-55D0-42B0-8D66-7D9A324F2F1A}"/>
               </a:ext>
             </a:extLst>
           </p:cNvPr>
@@ -1587,7 +1587,7 @@
           <p:cNvPr id="10" name="">
             <a:extLst xmlns:a="http://schemas.openxmlformats.org/drawingml/2006/main">
               <a:ext uri="{FF2B5EF4-FFF2-40B4-BE49-F238E27FC236}">
-                <a16:creationId xmlns:a16="http://schemas.microsoft.com/office/drawing/2014/main" id="{976BACDA-E8F8-4697-A4DF-F53C02427902}"/>
+                <a16:creationId xmlns:a16="http://schemas.microsoft.com/office/drawing/2014/main" id="{1926262D-0E95-4861-BBC2-572D04DC40B5}"/>
               </a:ext>
             </a:extLst>
           </p:cNvPr>
@@ -1644,7 +1644,7 @@
           <p:cNvPr id="11" name="">
             <a:extLst xmlns:a="http://schemas.openxmlformats.org/drawingml/2006/main">
               <a:ext uri="{FF2B5EF4-FFF2-40B4-BE49-F238E27FC236}">
-                <a16:creationId xmlns:a16="http://schemas.microsoft.com/office/drawing/2014/main" id="{FD9AE040-30C6-4675-821A-CC7937E202AC}"/>
+                <a16:creationId xmlns:a16="http://schemas.microsoft.com/office/drawing/2014/main" id="{771D88FD-AC66-41BE-ACF5-5CE1FCAC516F}"/>
               </a:ext>
             </a:extLst>
           </p:cNvPr>
@@ -1707,7 +1707,7 @@
           <p:cNvPr id="12" name="">
             <a:extLst xmlns:a="http://schemas.openxmlformats.org/drawingml/2006/main">
               <a:ext uri="{FF2B5EF4-FFF2-40B4-BE49-F238E27FC236}">
-                <a16:creationId xmlns:a16="http://schemas.microsoft.com/office/drawing/2014/main" id="{44255E98-9BC2-426D-B744-8270A61B69BF}"/>
+                <a16:creationId xmlns:a16="http://schemas.microsoft.com/office/drawing/2014/main" id="{604F4BA0-AD34-45C6-83A3-4025361D1352}"/>
               </a:ext>
             </a:extLst>
           </p:cNvPr>
@@ -1771,7 +1771,7 @@
                 <a:ea typeface="Consolas"/>
                 <a:cs typeface="Consolas"/>
               </a:rPr>
-              <a:t>«$»</a:t>
+              <a:t>$</a:t>
             </a:r>
             <a:r>
               <a:rPr sz="1500" b="0">
@@ -1792,7 +1792,7 @@
           <p:cNvPr id="13" name="">
             <a:extLst xmlns:a="http://schemas.openxmlformats.org/drawingml/2006/main">
               <a:ext uri="{FF2B5EF4-FFF2-40B4-BE49-F238E27FC236}">
-                <a16:creationId xmlns:a16="http://schemas.microsoft.com/office/drawing/2014/main" id="{C88EAB31-F5B6-48EA-9E91-D0165536F005}"/>
+                <a16:creationId xmlns:a16="http://schemas.microsoft.com/office/drawing/2014/main" id="{55E646A6-7924-4302-AAAD-FFD3B0CB65C1}"/>
               </a:ext>
             </a:extLst>
           </p:cNvPr>
@@ -1856,7 +1856,7 @@
                 <a:ea typeface="Consolas"/>
                 <a:cs typeface="Consolas"/>
               </a:rPr>
-              <a:t>«entrada.xlsx»</a:t>
+              <a:t>entrada.xlsx</a:t>
             </a:r>
             <a:r>
               <a:rPr sz="1500" b="0">
@@ -1877,7 +1877,7 @@
           <p:cNvPr id="14" name="">
             <a:extLst xmlns:a="http://schemas.openxmlformats.org/drawingml/2006/main">
               <a:ext uri="{FF2B5EF4-FFF2-40B4-BE49-F238E27FC236}">
-                <a16:creationId xmlns:a16="http://schemas.microsoft.com/office/drawing/2014/main" id="{732E924B-9A99-4437-9F79-5D2BD2E0C96F}"/>
+                <a16:creationId xmlns:a16="http://schemas.microsoft.com/office/drawing/2014/main" id="{2DD9EB5E-E811-4353-9376-34211DC28779}"/>
               </a:ext>
             </a:extLst>
           </p:cNvPr>
@@ -1911,7 +1911,7 @@
           <p:cNvPr id="15" name="">
             <a:extLst xmlns:a="http://schemas.openxmlformats.org/drawingml/2006/main">
               <a:ext uri="{FF2B5EF4-FFF2-40B4-BE49-F238E27FC236}">
-                <a16:creationId xmlns:a16="http://schemas.microsoft.com/office/drawing/2014/main" id="{71CF02AF-3440-4890-AAFB-19142FCA1425}"/>
+                <a16:creationId xmlns:a16="http://schemas.microsoft.com/office/drawing/2014/main" id="{2BB7F5A4-F72B-4CDB-BB49-9AA823956F1C}"/>
               </a:ext>
             </a:extLst>
           </p:cNvPr>
@@ -1943,7 +1943,7 @@
           <p:cNvPr id="16" name="">
             <a:extLst xmlns:a="http://schemas.openxmlformats.org/drawingml/2006/main">
               <a:ext uri="{FF2B5EF4-FFF2-40B4-BE49-F238E27FC236}">
-                <a16:creationId xmlns:a16="http://schemas.microsoft.com/office/drawing/2014/main" id="{6AA25C14-E715-4FF3-8604-AD634EFBA17C}"/>
+                <a16:creationId xmlns:a16="http://schemas.microsoft.com/office/drawing/2014/main" id="{C396360C-7014-4284-988C-CFA0B2954D29}"/>
               </a:ext>
             </a:extLst>
           </p:cNvPr>
@@ -2000,7 +2000,7 @@
           <p:cNvPr id="17" name="">
             <a:extLst xmlns:a="http://schemas.openxmlformats.org/drawingml/2006/main">
               <a:ext uri="{FF2B5EF4-FFF2-40B4-BE49-F238E27FC236}">
-                <a16:creationId xmlns:a16="http://schemas.microsoft.com/office/drawing/2014/main" id="{B7C3A872-4509-4783-8C5F-9E574A8AEFB2}"/>
+                <a16:creationId xmlns:a16="http://schemas.microsoft.com/office/drawing/2014/main" id="{7A9F96FE-DB6C-4F56-B9AB-A1E6809A731C}"/>
               </a:ext>
             </a:extLst>
           </p:cNvPr>
@@ -2057,7 +2057,7 @@
           <p:cNvPr id="18" name="">
             <a:extLst xmlns:a="http://schemas.openxmlformats.org/drawingml/2006/main">
               <a:ext uri="{FF2B5EF4-FFF2-40B4-BE49-F238E27FC236}">
-                <a16:creationId xmlns:a16="http://schemas.microsoft.com/office/drawing/2014/main" id="{3C8B31E2-9AA3-4A9F-AA73-FBB731E39217}"/>
+                <a16:creationId xmlns:a16="http://schemas.microsoft.com/office/drawing/2014/main" id="{5465A2D1-ED85-48C4-A59F-3CCBE702EC32}"/>
               </a:ext>
             </a:extLst>
           </p:cNvPr>
@@ -2121,7 +2121,7 @@
                 <a:ea typeface="Consolas"/>
                 <a:cs typeface="Consolas"/>
               </a:rPr>
-              <a:t>«.\setup.bat»</a:t>
+              <a:t>.\setup.bat</a:t>
             </a:r>
             <a:r>
               <a:rPr sz="1500" b="0">
@@ -2142,7 +2142,7 @@
           <p:cNvPr id="19" name="">
             <a:extLst xmlns:a="http://schemas.openxmlformats.org/drawingml/2006/main">
               <a:ext uri="{FF2B5EF4-FFF2-40B4-BE49-F238E27FC236}">
-                <a16:creationId xmlns:a16="http://schemas.microsoft.com/office/drawing/2014/main" id="{58FA0CD2-CBF6-4806-B0D2-933CEF165630}"/>
+                <a16:creationId xmlns:a16="http://schemas.microsoft.com/office/drawing/2014/main" id="{ADE4A140-9965-4892-8B09-FC816E431ADC}"/>
               </a:ext>
             </a:extLst>
           </p:cNvPr>
@@ -2206,7 +2206,7 @@
                 <a:ea typeface="Consolas"/>
                 <a:cs typeface="Consolas"/>
               </a:rPr>
-              <a:t>«.\auditar.bat»</a:t>
+              <a:t>.\auditar.bat</a:t>
             </a:r>
             <a:r>
               <a:rPr sz="1500" b="0">
@@ -2227,7 +2227,7 @@
           <p:cNvPr id="20" name="">
             <a:extLst xmlns:a="http://schemas.openxmlformats.org/drawingml/2006/main">
               <a:ext uri="{FF2B5EF4-FFF2-40B4-BE49-F238E27FC236}">
-                <a16:creationId xmlns:a16="http://schemas.microsoft.com/office/drawing/2014/main" id="{7C5A4B6B-FA4C-4BF6-82B9-13C09A2A540F}"/>
+                <a16:creationId xmlns:a16="http://schemas.microsoft.com/office/drawing/2014/main" id="{C534BC60-5030-4D40-9071-8C91659E92D6}"/>
               </a:ext>
             </a:extLst>
           </p:cNvPr>
@@ -2261,7 +2261,7 @@
           <p:cNvPr id="21" name="">
             <a:extLst xmlns:a="http://schemas.openxmlformats.org/drawingml/2006/main">
               <a:ext uri="{FF2B5EF4-FFF2-40B4-BE49-F238E27FC236}">
-                <a16:creationId xmlns:a16="http://schemas.microsoft.com/office/drawing/2014/main" id="{98F95416-E8E1-4FF8-95AD-F660EFBD1C8D}"/>
+                <a16:creationId xmlns:a16="http://schemas.microsoft.com/office/drawing/2014/main" id="{4E9A7E7B-DBAE-4556-8D4B-FEF0C0D20D33}"/>
               </a:ext>
             </a:extLst>
           </p:cNvPr>
@@ -2318,7 +2318,7 @@
           <p:cNvPr id="22" name="">
             <a:extLst xmlns:a="http://schemas.openxmlformats.org/drawingml/2006/main">
               <a:ext uri="{FF2B5EF4-FFF2-40B4-BE49-F238E27FC236}">
-                <a16:creationId xmlns:a16="http://schemas.microsoft.com/office/drawing/2014/main" id="{60DCA7CC-EAA2-4F1D-9257-9EEAB0A5C47F}"/>
+                <a16:creationId xmlns:a16="http://schemas.microsoft.com/office/drawing/2014/main" id="{0FCFC611-52C2-4D33-A245-0308AD26F089}"/>
               </a:ext>
             </a:extLst>
           </p:cNvPr>
@@ -2375,7 +2375,7 @@
           <p:cNvPr id="23" name="">
             <a:extLst xmlns:a="http://schemas.openxmlformats.org/drawingml/2006/main">
               <a:ext uri="{FF2B5EF4-FFF2-40B4-BE49-F238E27FC236}">
-                <a16:creationId xmlns:a16="http://schemas.microsoft.com/office/drawing/2014/main" id="{47F355F4-3F5F-47ED-885A-619E08CC6732}"/>
+                <a16:creationId xmlns:a16="http://schemas.microsoft.com/office/drawing/2014/main" id="{DE5B1BBC-5C96-4D12-B8AC-62551E27E6AB}"/>
               </a:ext>
             </a:extLst>
           </p:cNvPr>
@@ -2432,7 +2432,7 @@
           <p:cNvPr id="24" name="">
             <a:extLst xmlns:a="http://schemas.openxmlformats.org/drawingml/2006/main">
               <a:ext uri="{FF2B5EF4-FFF2-40B4-BE49-F238E27FC236}">
-                <a16:creationId xmlns:a16="http://schemas.microsoft.com/office/drawing/2014/main" id="{5A995972-B6DF-4E59-A2E5-5E5D1579D6A4}"/>
+                <a16:creationId xmlns:a16="http://schemas.microsoft.com/office/drawing/2014/main" id="{C76D2E2B-4B61-406A-A3FA-38E9289C8A1E}"/>
               </a:ext>
             </a:extLst>
           </p:cNvPr>
@@ -2466,7 +2466,7 @@
           <p:cNvPr id="25" name="">
             <a:extLst xmlns:a="http://schemas.openxmlformats.org/drawingml/2006/main">
               <a:ext uri="{FF2B5EF4-FFF2-40B4-BE49-F238E27FC236}">
-                <a16:creationId xmlns:a16="http://schemas.microsoft.com/office/drawing/2014/main" id="{9ECD8F63-F95F-4553-85F4-32C56DCCE468}"/>
+                <a16:creationId xmlns:a16="http://schemas.microsoft.com/office/drawing/2014/main" id="{34421262-AF73-415E-B38D-243D6A105048}"/>
               </a:ext>
             </a:extLst>
           </p:cNvPr>
@@ -2498,7 +2498,7 @@
           <p:cNvPr id="26" name="">
             <a:extLst xmlns:a="http://schemas.openxmlformats.org/drawingml/2006/main">
               <a:ext uri="{FF2B5EF4-FFF2-40B4-BE49-F238E27FC236}">
-                <a16:creationId xmlns:a16="http://schemas.microsoft.com/office/drawing/2014/main" id="{0C0879A3-6D39-40A9-980B-875D54665DE1}"/>
+                <a16:creationId xmlns:a16="http://schemas.microsoft.com/office/drawing/2014/main" id="{2694DB42-FE26-4D8B-977D-F9D4469B104D}"/>
               </a:ext>
             </a:extLst>
           </p:cNvPr>
@@ -2555,7 +2555,7 @@
           <p:cNvPr id="27" name="">
             <a:extLst xmlns:a="http://schemas.openxmlformats.org/drawingml/2006/main">
               <a:ext uri="{FF2B5EF4-FFF2-40B4-BE49-F238E27FC236}">
-                <a16:creationId xmlns:a16="http://schemas.microsoft.com/office/drawing/2014/main" id="{2F7E0E8F-2316-4A57-8EDF-40C97D222970}"/>
+                <a16:creationId xmlns:a16="http://schemas.microsoft.com/office/drawing/2014/main" id="{3ED5CAAA-AF1B-4545-A7D8-431317A19BE0}"/>
               </a:ext>
             </a:extLst>
           </p:cNvPr>
@@ -2612,7 +2612,7 @@
           <p:cNvPr id="28" name="">
             <a:extLst xmlns:a="http://schemas.openxmlformats.org/drawingml/2006/main">
               <a:ext uri="{FF2B5EF4-FFF2-40B4-BE49-F238E27FC236}">
-                <a16:creationId xmlns:a16="http://schemas.microsoft.com/office/drawing/2014/main" id="{615F4AB1-175F-4AA9-9BDA-086007319A7B}"/>
+                <a16:creationId xmlns:a16="http://schemas.microsoft.com/office/drawing/2014/main" id="{31807BB4-A898-44AD-A793-291F51BAAA8C}"/>
               </a:ext>
             </a:extLst>
           </p:cNvPr>
@@ -2646,7 +2646,7 @@
           <p:cNvPr id="29" name="">
             <a:extLst xmlns:a="http://schemas.openxmlformats.org/drawingml/2006/main">
               <a:ext uri="{FF2B5EF4-FFF2-40B4-BE49-F238E27FC236}">
-                <a16:creationId xmlns:a16="http://schemas.microsoft.com/office/drawing/2014/main" id="{D403D2EA-B222-4466-BCB1-577B8E714C02}"/>
+                <a16:creationId xmlns:a16="http://schemas.microsoft.com/office/drawing/2014/main" id="{9F40DF52-F8F3-47BE-95E6-D35050D5355D}"/>
               </a:ext>
             </a:extLst>
           </p:cNvPr>
@@ -2703,7 +2703,7 @@
           <p:cNvPr id="30" name="">
             <a:extLst xmlns:a="http://schemas.openxmlformats.org/drawingml/2006/main">
               <a:ext uri="{FF2B5EF4-FFF2-40B4-BE49-F238E27FC236}">
-                <a16:creationId xmlns:a16="http://schemas.microsoft.com/office/drawing/2014/main" id="{BC7DC33B-EAC2-423C-9821-9EA7B120AC9D}"/>
+                <a16:creationId xmlns:a16="http://schemas.microsoft.com/office/drawing/2014/main" id="{C6ACFDED-8299-4AE8-913C-EA140738CE69}"/>
               </a:ext>
             </a:extLst>
           </p:cNvPr>
@@ -2760,7 +2760,7 @@
           <p:cNvPr id="31" name="">
             <a:extLst xmlns:a="http://schemas.openxmlformats.org/drawingml/2006/main">
               <a:ext uri="{FF2B5EF4-FFF2-40B4-BE49-F238E27FC236}">
-                <a16:creationId xmlns:a16="http://schemas.microsoft.com/office/drawing/2014/main" id="{3C37C564-8EE5-4C2A-B09D-832587926401}"/>
+                <a16:creationId xmlns:a16="http://schemas.microsoft.com/office/drawing/2014/main" id="{9769471A-61CB-45EE-9837-3A0024869FC1}"/>
               </a:ext>
             </a:extLst>
           </p:cNvPr>
@@ -2813,7 +2813,7 @@
                 <a:ea typeface="Consolas"/>
                 <a:cs typeface="Consolas"/>
               </a:rPr>
-              <a:t>«--icam»</a:t>
+              <a:t>--icam</a:t>
             </a:r>
             <a:r>
               <a:rPr sz="1500" b="0">
@@ -2834,7 +2834,7 @@
           <p:cNvPr id="32" name="">
             <a:extLst xmlns:a="http://schemas.openxmlformats.org/drawingml/2006/main">
               <a:ext uri="{FF2B5EF4-FFF2-40B4-BE49-F238E27FC236}">
-                <a16:creationId xmlns:a16="http://schemas.microsoft.com/office/drawing/2014/main" id="{79E5C4A0-0CF1-4C7D-A045-4475E67A63B4}"/>
+                <a16:creationId xmlns:a16="http://schemas.microsoft.com/office/drawing/2014/main" id="{6E7DDAEB-4300-41FD-B8C9-B312A6957F24}"/>
               </a:ext>
             </a:extLst>
           </p:cNvPr>
@@ -2898,7 +2898,7 @@
                 <a:ea typeface="Consolas"/>
                 <a:cs typeface="Consolas"/>
               </a:rPr>
-              <a:t>«--no-cache»</a:t>
+              <a:t>--no-cache</a:t>
             </a:r>
             <a:r>
               <a:rPr sz="1500" b="0">
@@ -2919,7 +2919,7 @@
           <p:cNvPr id="33" name="">
             <a:extLst xmlns:a="http://schemas.openxmlformats.org/drawingml/2006/main">
               <a:ext uri="{FF2B5EF4-FFF2-40B4-BE49-F238E27FC236}">
-                <a16:creationId xmlns:a16="http://schemas.microsoft.com/office/drawing/2014/main" id="{9D9DA229-2C20-4610-8374-B926AE3E6FA9}"/>
+                <a16:creationId xmlns:a16="http://schemas.microsoft.com/office/drawing/2014/main" id="{CDBDFFB9-45A3-4813-9FAA-385321FD6C05}"/>
               </a:ext>
             </a:extLst>
           </p:cNvPr>
@@ -2972,7 +2972,7 @@
                 <a:ea typeface="Consolas"/>
                 <a:cs typeface="Consolas"/>
               </a:rPr>
-              <a:t>«--pendientes»</a:t>
+              <a:t>--pendientes</a:t>
             </a:r>
             <a:r>
               <a:rPr sz="1500" b="0">
@@ -2994,7 +2994,7 @@
                 <a:ea typeface="Consolas"/>
                 <a:cs typeface="Consolas"/>
               </a:rPr>
-              <a:t>«DIP Open Audit User»</a:t>
+              <a:t>DIP Open Audit User</a:t>
             </a:r>
             <a:r>
               <a:rPr sz="1500" b="0">
@@ -3015,7 +3015,7 @@
           <p:cNvPr id="34" name="">
             <a:extLst xmlns:a="http://schemas.openxmlformats.org/drawingml/2006/main">
               <a:ext uri="{FF2B5EF4-FFF2-40B4-BE49-F238E27FC236}">
-                <a16:creationId xmlns:a16="http://schemas.microsoft.com/office/drawing/2014/main" id="{0730A458-0755-4605-93E5-FF72C85F27E3}"/>
+                <a16:creationId xmlns:a16="http://schemas.microsoft.com/office/drawing/2014/main" id="{441E7CBF-6162-4924-AB99-9A1801D1A1B5}"/>
               </a:ext>
             </a:extLst>
           </p:cNvPr>
@@ -3079,7 +3079,7 @@
                 <a:ea typeface="Consolas"/>
                 <a:cs typeface="Consolas"/>
               </a:rPr>
-              <a:t>«DIP Closed Audit User»</a:t>
+              <a:t>DIP Closed Audit User</a:t>
             </a:r>
             <a:r>
               <a:rPr sz="1500" b="0">
@@ -3100,7 +3100,7 @@
           <p:cNvPr id="35" name="">
             <a:extLst xmlns:a="http://schemas.openxmlformats.org/drawingml/2006/main">
               <a:ext uri="{FF2B5EF4-FFF2-40B4-BE49-F238E27FC236}">
-                <a16:creationId xmlns:a16="http://schemas.microsoft.com/office/drawing/2014/main" id="{16741F46-0A9F-4288-BCD7-9DC7799E215B}"/>
+                <a16:creationId xmlns:a16="http://schemas.microsoft.com/office/drawing/2014/main" id="{17332B80-7953-4FAD-9E08-BA9898CB1421}"/>
               </a:ext>
             </a:extLst>
           </p:cNvPr>
@@ -3164,7 +3164,7 @@
                 <a:ea typeface="Consolas"/>
                 <a:cs typeface="Consolas"/>
               </a:rPr>
-              <a:t>«FILTERED.xlsx»</a:t>
+              <a:t>FILTERED.xlsx</a:t>
             </a:r>
             <a:r>
               <a:rPr sz="1500" b="0">
@@ -3185,7 +3185,7 @@
           <p:cNvPr id="36" name="">
             <a:extLst xmlns:a="http://schemas.openxmlformats.org/drawingml/2006/main">
               <a:ext uri="{FF2B5EF4-FFF2-40B4-BE49-F238E27FC236}">
-                <a16:creationId xmlns:a16="http://schemas.microsoft.com/office/drawing/2014/main" id="{C7EF8ADE-2EE2-4817-90EE-FC47922D28D9}"/>
+                <a16:creationId xmlns:a16="http://schemas.microsoft.com/office/drawing/2014/main" id="{1B75EA88-F2B0-47F0-8FB8-445DFDC5785A}"/>
               </a:ext>
             </a:extLst>
           </p:cNvPr>
@@ -3248,7 +3248,7 @@
           <p:cNvPr id="37" name="">
             <a:extLst xmlns:a="http://schemas.openxmlformats.org/drawingml/2006/main">
               <a:ext uri="{FF2B5EF4-FFF2-40B4-BE49-F238E27FC236}">
-                <a16:creationId xmlns:a16="http://schemas.microsoft.com/office/drawing/2014/main" id="{6E267659-0501-4CA0-A38A-92FBDE213DD1}"/>
+                <a16:creationId xmlns:a16="http://schemas.microsoft.com/office/drawing/2014/main" id="{4615B768-FA4D-454D-AF01-F8F4435B5BE6}"/>
               </a:ext>
             </a:extLst>
           </p:cNvPr>
@@ -3282,7 +3282,7 @@
           <p:cNvPr id="38" name="">
             <a:extLst xmlns:a="http://schemas.openxmlformats.org/drawingml/2006/main">
               <a:ext uri="{FF2B5EF4-FFF2-40B4-BE49-F238E27FC236}">
-                <a16:creationId xmlns:a16="http://schemas.microsoft.com/office/drawing/2014/main" id="{E0311619-6DD7-4806-88BD-0C22B17AF01E}"/>
+                <a16:creationId xmlns:a16="http://schemas.microsoft.com/office/drawing/2014/main" id="{7FE16594-7148-4BF9-86EE-601F3DFC8AC5}"/>
               </a:ext>
             </a:extLst>
           </p:cNvPr>
@@ -3314,7 +3314,7 @@
           <p:cNvPr id="39" name="">
             <a:extLst xmlns:a="http://schemas.openxmlformats.org/drawingml/2006/main">
               <a:ext uri="{FF2B5EF4-FFF2-40B4-BE49-F238E27FC236}">
-                <a16:creationId xmlns:a16="http://schemas.microsoft.com/office/drawing/2014/main" id="{063BDB55-AC18-418F-8CCD-A873FE95568C}"/>
+                <a16:creationId xmlns:a16="http://schemas.microsoft.com/office/drawing/2014/main" id="{9BA4FB4B-3212-4A98-84FB-4D62B808F2F9}"/>
               </a:ext>
             </a:extLst>
           </p:cNvPr>
@@ -3371,7 +3371,7 @@
           <p:cNvPr id="40" name="">
             <a:extLst xmlns:a="http://schemas.openxmlformats.org/drawingml/2006/main">
               <a:ext uri="{FF2B5EF4-FFF2-40B4-BE49-F238E27FC236}">
-                <a16:creationId xmlns:a16="http://schemas.microsoft.com/office/drawing/2014/main" id="{DB982709-DEA5-4B42-AFA0-F7226FF00748}"/>
+                <a16:creationId xmlns:a16="http://schemas.microsoft.com/office/drawing/2014/main" id="{43FB390B-5218-4236-8370-6CD45910BCEE}"/>
               </a:ext>
             </a:extLst>
           </p:cNvPr>
@@ -3428,7 +3428,7 @@
           <p:cNvPr id="41" name="">
             <a:extLst xmlns:a="http://schemas.openxmlformats.org/drawingml/2006/main">
               <a:ext uri="{FF2B5EF4-FFF2-40B4-BE49-F238E27FC236}">
-                <a16:creationId xmlns:a16="http://schemas.microsoft.com/office/drawing/2014/main" id="{8D173ED3-1534-48A6-B561-47510BE78D61}"/>
+                <a16:creationId xmlns:a16="http://schemas.microsoft.com/office/drawing/2014/main" id="{55552A33-3E3C-4035-8249-E9CE66AE79C7}"/>
               </a:ext>
             </a:extLst>
           </p:cNvPr>
@@ -3462,7 +3462,7 @@
           <p:cNvPr id="42" name="">
             <a:extLst xmlns:a="http://schemas.openxmlformats.org/drawingml/2006/main">
               <a:ext uri="{FF2B5EF4-FFF2-40B4-BE49-F238E27FC236}">
-                <a16:creationId xmlns:a16="http://schemas.microsoft.com/office/drawing/2014/main" id="{A69F5183-DB13-48D6-9968-E8D5419746F3}"/>
+                <a16:creationId xmlns:a16="http://schemas.microsoft.com/office/drawing/2014/main" id="{9BE7CF7B-EC7D-4FBF-B77D-7551FF941130}"/>
               </a:ext>
             </a:extLst>
           </p:cNvPr>
@@ -3519,7 +3519,7 @@
           <p:cNvPr id="43" name="">
             <a:extLst xmlns:a="http://schemas.openxmlformats.org/drawingml/2006/main">
               <a:ext uri="{FF2B5EF4-FFF2-40B4-BE49-F238E27FC236}">
-                <a16:creationId xmlns:a16="http://schemas.microsoft.com/office/drawing/2014/main" id="{C2E63BA2-2B91-4A2D-8D41-16D3857D331B}"/>
+                <a16:creationId xmlns:a16="http://schemas.microsoft.com/office/drawing/2014/main" id="{177A346C-D80D-4054-9061-F4F862BC450D}"/>
               </a:ext>
             </a:extLst>
           </p:cNvPr>
@@ -3576,7 +3576,7 @@
           <p:cNvPr id="44" name="">
             <a:extLst xmlns:a="http://schemas.openxmlformats.org/drawingml/2006/main">
               <a:ext uri="{FF2B5EF4-FFF2-40B4-BE49-F238E27FC236}">
-                <a16:creationId xmlns:a16="http://schemas.microsoft.com/office/drawing/2014/main" id="{48F832E6-7611-4A42-8D0B-73B27931DE05}"/>
+                <a16:creationId xmlns:a16="http://schemas.microsoft.com/office/drawing/2014/main" id="{FBD81843-0609-4956-9DCA-672878A7C9FD}"/>
               </a:ext>
             </a:extLst>
           </p:cNvPr>
@@ -3633,7 +3633,7 @@
           <p:cNvPr id="45" name="">
             <a:extLst xmlns:a="http://schemas.openxmlformats.org/drawingml/2006/main">
               <a:ext uri="{FF2B5EF4-FFF2-40B4-BE49-F238E27FC236}">
-                <a16:creationId xmlns:a16="http://schemas.microsoft.com/office/drawing/2014/main" id="{1E665663-3CAA-4259-A26C-69BD336221AA}"/>
+                <a16:creationId xmlns:a16="http://schemas.microsoft.com/office/drawing/2014/main" id="{31F2B103-8604-4633-BDED-9F89DC079152}"/>
               </a:ext>
             </a:extLst>
           </p:cNvPr>
@@ -3690,7 +3690,7 @@
           <p:cNvPr id="46" name="">
             <a:extLst xmlns:a="http://schemas.openxmlformats.org/drawingml/2006/main">
               <a:ext uri="{FF2B5EF4-FFF2-40B4-BE49-F238E27FC236}">
-                <a16:creationId xmlns:a16="http://schemas.microsoft.com/office/drawing/2014/main" id="{1AD9FE05-590D-4A4F-8B78-C2B5DC5C7617}"/>
+                <a16:creationId xmlns:a16="http://schemas.microsoft.com/office/drawing/2014/main" id="{A56F9957-6060-4F30-952F-BDD96D7FC90F}"/>
               </a:ext>
             </a:extLst>
           </p:cNvPr>
@@ -3753,7 +3753,7 @@
           <p:cNvPr id="47" name="">
             <a:extLst xmlns:a="http://schemas.openxmlformats.org/drawingml/2006/main">
               <a:ext uri="{FF2B5EF4-FFF2-40B4-BE49-F238E27FC236}">
-                <a16:creationId xmlns:a16="http://schemas.microsoft.com/office/drawing/2014/main" id="{71AE8EFA-2B98-4203-A779-4AC13724FFA5}"/>
+                <a16:creationId xmlns:a16="http://schemas.microsoft.com/office/drawing/2014/main" id="{776B5167-43B9-4C31-8C53-C91009E0390B}"/>
               </a:ext>
             </a:extLst>
           </p:cNvPr>
@@ -3806,7 +3806,7 @@
                 <a:ea typeface="Consolas"/>
                 <a:cs typeface="Consolas"/>
               </a:rPr>
-              <a:t>«.\filtrar.bat»</a:t>
+              <a:t>.\filtrar.bat</a:t>
             </a:r>
             <a:r>
               <a:rPr sz="1500" b="0">
@@ -3828,7 +3828,7 @@
                 <a:ea typeface="Consolas"/>
                 <a:cs typeface="Consolas"/>
               </a:rPr>
-              <a:t>«.\comparar.bat»</a:t>
+              <a:t>.\comparar.bat</a:t>
             </a:r>
             <a:r>
               <a:rPr sz="1500" b="0">
@@ -3849,7 +3849,7 @@
           <p:cNvPr id="48" name="">
             <a:extLst xmlns:a="http://schemas.openxmlformats.org/drawingml/2006/main">
               <a:ext uri="{FF2B5EF4-FFF2-40B4-BE49-F238E27FC236}">
-                <a16:creationId xmlns:a16="http://schemas.microsoft.com/office/drawing/2014/main" id="{89D9D700-9E02-4CF9-A879-DE80D4BA5AD5}"/>
+                <a16:creationId xmlns:a16="http://schemas.microsoft.com/office/drawing/2014/main" id="{FDBE1ACB-E783-4C76-83AB-726C5B619687}"/>
               </a:ext>
             </a:extLst>
           </p:cNvPr>
@@ -3913,7 +3913,7 @@
                 <a:ea typeface="Consolas"/>
                 <a:cs typeface="Consolas"/>
               </a:rPr>
-              <a:t>«salidas/»</a:t>
+              <a:t>salidas/</a:t>
             </a:r>
             <a:r>
               <a:rPr sz="1500" b="0">
@@ -3934,7 +3934,7 @@
           <p:cNvPr id="49" name="">
             <a:extLst xmlns:a="http://schemas.openxmlformats.org/drawingml/2006/main">
               <a:ext uri="{FF2B5EF4-FFF2-40B4-BE49-F238E27FC236}">
-                <a16:creationId xmlns:a16="http://schemas.microsoft.com/office/drawing/2014/main" id="{610C997E-2CB1-4CFB-9074-FC42AEF7019C}"/>
+                <a16:creationId xmlns:a16="http://schemas.microsoft.com/office/drawing/2014/main" id="{D752DA41-F69E-4768-B286-2CD23F6CC802}"/>
               </a:ext>
             </a:extLst>
           </p:cNvPr>
@@ -3968,7 +3968,7 @@
           <p:cNvPr id="50" name="">
             <a:extLst xmlns:a="http://schemas.openxmlformats.org/drawingml/2006/main">
               <a:ext uri="{FF2B5EF4-FFF2-40B4-BE49-F238E27FC236}">
-                <a16:creationId xmlns:a16="http://schemas.microsoft.com/office/drawing/2014/main" id="{7329BFD2-BCF0-4105-9FDE-74701B7D46D2}"/>
+                <a16:creationId xmlns:a16="http://schemas.microsoft.com/office/drawing/2014/main" id="{03A82BD1-FE22-4BD8-A847-E14D5574C800}"/>
               </a:ext>
             </a:extLst>
           </p:cNvPr>
@@ -4032,7 +4032,7 @@
                 <a:ea typeface="Consolas"/>
                 <a:cs typeface="Consolas"/>
               </a:rPr>
-              <a:t>«salidas/»</a:t>
+              <a:t>salidas/</a:t>
             </a:r>
           </a:p>
         </p:txBody>
@@ -4042,7 +4042,7 @@
           <p:cNvPr id="51" name="">
             <a:extLst xmlns:a="http://schemas.openxmlformats.org/drawingml/2006/main">
               <a:ext uri="{FF2B5EF4-FFF2-40B4-BE49-F238E27FC236}">
-                <a16:creationId xmlns:a16="http://schemas.microsoft.com/office/drawing/2014/main" id="{EA2C6206-D386-4782-852B-27F3A553E616}"/>
+                <a16:creationId xmlns:a16="http://schemas.microsoft.com/office/drawing/2014/main" id="{77843E50-C807-4C23-91D5-14C08E91E2E8}"/>
               </a:ext>
             </a:extLst>
           </p:cNvPr>
@@ -4106,7 +4106,7 @@
                 <a:ea typeface="Consolas"/>
                 <a:cs typeface="Consolas"/>
               </a:rPr>
-              <a:t>«RESULTADO»</a:t>
+              <a:t>RESULTADO</a:t>
             </a:r>
             <a:r>
               <a:rPr sz="1500" b="0">
@@ -4128,7 +4128,7 @@
                 <a:ea typeface="Consolas"/>
                 <a:cs typeface="Consolas"/>
               </a:rPr>
-              <a:t>«HALLAZGOS»</a:t>
+              <a:t>HALLAZGOS</a:t>
             </a:r>
             <a:r>
               <a:rPr sz="1500" b="0">
@@ -4150,7 +4150,7 @@
                 <a:ea typeface="Consolas"/>
                 <a:cs typeface="Consolas"/>
               </a:rPr>
-              <a:t>«VERIFICACIÓN MANUAL»</a:t>
+              <a:t>VERIFICACIÓN MANUAL</a:t>
             </a:r>
             <a:r>
               <a:rPr sz="1500" b="0">
@@ -4171,7 +4171,7 @@
           <p:cNvPr id="52" name="">
             <a:extLst xmlns:a="http://schemas.openxmlformats.org/drawingml/2006/main">
               <a:ext uri="{FF2B5EF4-FFF2-40B4-BE49-F238E27FC236}">
-                <a16:creationId xmlns:a16="http://schemas.microsoft.com/office/drawing/2014/main" id="{A9AAC26E-3A92-4F6C-A8CC-431FADCC7D42}"/>
+                <a16:creationId xmlns:a16="http://schemas.microsoft.com/office/drawing/2014/main" id="{E73ED317-709D-42C0-89F5-5F3DE5C25935}"/>
               </a:ext>
             </a:extLst>
           </p:cNvPr>
@@ -4234,7 +4234,7 @@
           <p:cNvPr id="53" name="">
             <a:extLst xmlns:a="http://schemas.openxmlformats.org/drawingml/2006/main">
               <a:ext uri="{FF2B5EF4-FFF2-40B4-BE49-F238E27FC236}">
-                <a16:creationId xmlns:a16="http://schemas.microsoft.com/office/drawing/2014/main" id="{9074CDA5-ED1D-49C2-801A-4FE141BEFCD3}"/>
+                <a16:creationId xmlns:a16="http://schemas.microsoft.com/office/drawing/2014/main" id="{0EC0E13E-8DA1-474A-878B-6FE06C1836E2}"/>
               </a:ext>
             </a:extLst>
           </p:cNvPr>
@@ -4295,7 +4295,7 @@
     </p:spTree>
     <p:extLst>
       <p:ext uri="{BB962C8B-B14F-4D97-AF65-F5344CB8AC3E}">
-        <p14:creationId xmlns:p14="http://schemas.microsoft.com/office/powerpoint/2010/main" val="377695479"/>
+        <p14:creationId xmlns:p14="http://schemas.microsoft.com/office/powerpoint/2010/main" val="1777581896"/>
       </p:ext>
     </p:extLst>
   </p:cSld>
@@ -4326,7 +4326,7 @@
           <p:cNvPr id="47" name="">
             <a:extLst xmlns:a="http://schemas.openxmlformats.org/drawingml/2006/main">
               <a:ext uri="{FF2B5EF4-FFF2-40B4-BE49-F238E27FC236}">
-                <a16:creationId xmlns:a16="http://schemas.microsoft.com/office/drawing/2014/main" id="{8B5D8236-0C85-4FD7-807E-0CAC672916DF}"/>
+                <a16:creationId xmlns:a16="http://schemas.microsoft.com/office/drawing/2014/main" id="{80699C8D-6DA7-4B5E-85C3-22CAA534015A}"/>
               </a:ext>
             </a:extLst>
           </p:cNvPr>
@@ -4370,7 +4370,7 @@
           <p:cNvPr id="2" name="">
             <a:extLst xmlns:a="http://schemas.openxmlformats.org/drawingml/2006/main">
               <a:ext uri="{FF2B5EF4-FFF2-40B4-BE49-F238E27FC236}">
-                <a16:creationId xmlns:a16="http://schemas.microsoft.com/office/drawing/2014/main" id="{90C6B5DB-4859-49D3-B3BE-D70D9E24B48F}"/>
+                <a16:creationId xmlns:a16="http://schemas.microsoft.com/office/drawing/2014/main" id="{39845B63-D3CF-4D90-9C03-E7EE60CE0918}"/>
               </a:ext>
             </a:extLst>
           </p:cNvPr>
@@ -4427,7 +4427,7 @@
           <p:cNvPr id="3" name="">
             <a:extLst xmlns:a="http://schemas.openxmlformats.org/drawingml/2006/main">
               <a:ext uri="{FF2B5EF4-FFF2-40B4-BE49-F238E27FC236}">
-                <a16:creationId xmlns:a16="http://schemas.microsoft.com/office/drawing/2014/main" id="{F963EE00-0F19-40C7-A2E3-05574DC07350}"/>
+                <a16:creationId xmlns:a16="http://schemas.microsoft.com/office/drawing/2014/main" id="{A97163D2-DFE2-4DFA-B15E-E5DFC0B9BF69}"/>
               </a:ext>
             </a:extLst>
           </p:cNvPr>
@@ -4457,7 +4457,7 @@
           <p:cNvPr id="4" name="">
             <a:extLst xmlns:a="http://schemas.openxmlformats.org/drawingml/2006/main">
               <a:ext uri="{FF2B5EF4-FFF2-40B4-BE49-F238E27FC236}">
-                <a16:creationId xmlns:a16="http://schemas.microsoft.com/office/drawing/2014/main" id="{DE9C7DA9-9163-4E25-B422-75F763B1D685}"/>
+                <a16:creationId xmlns:a16="http://schemas.microsoft.com/office/drawing/2014/main" id="{81B19129-4D59-4A79-B8A8-6FD43801D907}"/>
               </a:ext>
             </a:extLst>
           </p:cNvPr>
@@ -4514,7 +4514,7 @@
           <p:cNvPr id="5" name="">
             <a:extLst xmlns:a="http://schemas.openxmlformats.org/drawingml/2006/main">
               <a:ext uri="{FF2B5EF4-FFF2-40B4-BE49-F238E27FC236}">
-                <a16:creationId xmlns:a16="http://schemas.microsoft.com/office/drawing/2014/main" id="{67BF5CA1-110D-400B-8810-B2C6D814B3DA}"/>
+                <a16:creationId xmlns:a16="http://schemas.microsoft.com/office/drawing/2014/main" id="{D7C282B6-1583-4C6F-B33C-2DF2959F6ED4}"/>
               </a:ext>
             </a:extLst>
           </p:cNvPr>
@@ -4575,7 +4575,7 @@
           <p:nvPr/>
         </p:nvPicPr>
         <p:blipFill>
-          <a:blip xmlns:r="http://schemas.openxmlformats.org/officeDocument/2006/relationships" xmlns:a="http://schemas.openxmlformats.org/drawingml/2006/main" r:embed="R16e0294429bd41fc"/>
+          <a:blip xmlns:r="http://schemas.openxmlformats.org/officeDocument/2006/relationships" xmlns:a="http://schemas.openxmlformats.org/drawingml/2006/main" r:embed="Re99ba0c8456d4574"/>
           <a:stretch xmlns:a="http://schemas.openxmlformats.org/drawingml/2006/main"/>
         </p:blipFill>
         <p:spPr>
@@ -4593,7 +4593,7 @@
           <p:cNvPr id="7" name="">
             <a:extLst xmlns:a="http://schemas.openxmlformats.org/drawingml/2006/main">
               <a:ext uri="{FF2B5EF4-FFF2-40B4-BE49-F238E27FC236}">
-                <a16:creationId xmlns:a16="http://schemas.microsoft.com/office/drawing/2014/main" id="{56FA5EDE-D62D-482D-AD8A-28D09F6733F0}"/>
+                <a16:creationId xmlns:a16="http://schemas.microsoft.com/office/drawing/2014/main" id="{DA2139D2-63BF-4D03-AEB9-0C4E2BAA9161}"/>
               </a:ext>
             </a:extLst>
           </p:cNvPr>
@@ -4635,7 +4635,7 @@
           <p:nvPr/>
         </p:nvPicPr>
         <p:blipFill>
-          <a:blip xmlns:r="http://schemas.openxmlformats.org/officeDocument/2006/relationships" xmlns:a="http://schemas.openxmlformats.org/drawingml/2006/main" r:embed="R975c22e855944887"/>
+          <a:blip xmlns:r="http://schemas.openxmlformats.org/officeDocument/2006/relationships" xmlns:a="http://schemas.openxmlformats.org/drawingml/2006/main" r:embed="R050e7aeadfc44424"/>
           <a:stretch xmlns:a="http://schemas.openxmlformats.org/drawingml/2006/main"/>
         </p:blipFill>
         <p:spPr>
@@ -4653,7 +4653,7 @@
           <p:cNvPr id="9" name="">
             <a:extLst xmlns:a="http://schemas.openxmlformats.org/drawingml/2006/main">
               <a:ext uri="{FF2B5EF4-FFF2-40B4-BE49-F238E27FC236}">
-                <a16:creationId xmlns:a16="http://schemas.microsoft.com/office/drawing/2014/main" id="{98A8F3DA-A2E6-4BB7-8189-C572972BC33A}"/>
+                <a16:creationId xmlns:a16="http://schemas.microsoft.com/office/drawing/2014/main" id="{D9BB01E8-A6C4-4E92-AC27-D099C141D70A}"/>
               </a:ext>
             </a:extLst>
           </p:cNvPr>
@@ -4710,7 +4710,7 @@
           <p:cNvPr id="10" name="">
             <a:extLst xmlns:a="http://schemas.openxmlformats.org/drawingml/2006/main">
               <a:ext uri="{FF2B5EF4-FFF2-40B4-BE49-F238E27FC236}">
-                <a16:creationId xmlns:a16="http://schemas.microsoft.com/office/drawing/2014/main" id="{CD7D9F1B-E1F3-409E-9BBC-F17047887DFE}"/>
+                <a16:creationId xmlns:a16="http://schemas.microsoft.com/office/drawing/2014/main" id="{34E1D224-D2DB-4A0A-A91F-BC7EFAC53733}"/>
               </a:ext>
             </a:extLst>
           </p:cNvPr>
@@ -4767,7 +4767,7 @@
           <p:cNvPr id="11" name="">
             <a:extLst xmlns:a="http://schemas.openxmlformats.org/drawingml/2006/main">
               <a:ext uri="{FF2B5EF4-FFF2-40B4-BE49-F238E27FC236}">
-                <a16:creationId xmlns:a16="http://schemas.microsoft.com/office/drawing/2014/main" id="{D3380F69-CF8A-402A-9814-1882110255B0}"/>
+                <a16:creationId xmlns:a16="http://schemas.microsoft.com/office/drawing/2014/main" id="{1778D20A-A63A-45B8-AA8E-A3A1B44DF55D}"/>
               </a:ext>
             </a:extLst>
           </p:cNvPr>
@@ -4831,7 +4831,7 @@
                 <a:ea typeface="Consolas"/>
                 <a:cs typeface="Consolas"/>
               </a:rPr>
-              <a:t>«config/discrepancias.yaml»</a:t>
+              <a:t>config/discrepancias.yaml</a:t>
             </a:r>
             <a:r>
               <a:rPr sz="1500" b="0">
@@ -4852,7 +4852,7 @@
           <p:cNvPr id="12" name="">
             <a:extLst xmlns:a="http://schemas.openxmlformats.org/drawingml/2006/main">
               <a:ext uri="{FF2B5EF4-FFF2-40B4-BE49-F238E27FC236}">
-                <a16:creationId xmlns:a16="http://schemas.microsoft.com/office/drawing/2014/main" id="{C9A85CEF-64E4-461E-873F-FD867563D7B1}"/>
+                <a16:creationId xmlns:a16="http://schemas.microsoft.com/office/drawing/2014/main" id="{34139542-4351-4F70-9D34-D8BC5F0C6B36}"/>
               </a:ext>
             </a:extLst>
           </p:cNvPr>
@@ -4915,7 +4915,7 @@
           <p:cNvPr id="13" name="">
             <a:extLst xmlns:a="http://schemas.openxmlformats.org/drawingml/2006/main">
               <a:ext uri="{FF2B5EF4-FFF2-40B4-BE49-F238E27FC236}">
-                <a16:creationId xmlns:a16="http://schemas.microsoft.com/office/drawing/2014/main" id="{FDECA70E-63DB-4C87-98D3-B4866229ACB7}"/>
+                <a16:creationId xmlns:a16="http://schemas.microsoft.com/office/drawing/2014/main" id="{7EC7DF0E-8E76-405C-820F-9CC1416EDBBD}"/>
               </a:ext>
             </a:extLst>
           </p:cNvPr>
@@ -4949,7 +4949,7 @@
           <p:cNvPr id="14" name="">
             <a:extLst xmlns:a="http://schemas.openxmlformats.org/drawingml/2006/main">
               <a:ext uri="{FF2B5EF4-FFF2-40B4-BE49-F238E27FC236}">
-                <a16:creationId xmlns:a16="http://schemas.microsoft.com/office/drawing/2014/main" id="{F5E34B67-B08A-4088-9972-66E5A5B82480}"/>
+                <a16:creationId xmlns:a16="http://schemas.microsoft.com/office/drawing/2014/main" id="{37BC4162-BE17-4C34-A55E-09E3919AD5E0}"/>
               </a:ext>
             </a:extLst>
           </p:cNvPr>
@@ -4981,7 +4981,7 @@
           <p:cNvPr id="15" name="">
             <a:extLst xmlns:a="http://schemas.openxmlformats.org/drawingml/2006/main">
               <a:ext uri="{FF2B5EF4-FFF2-40B4-BE49-F238E27FC236}">
-                <a16:creationId xmlns:a16="http://schemas.microsoft.com/office/drawing/2014/main" id="{0D55A62F-3754-47F7-9E6F-74E0EA16B53B}"/>
+                <a16:creationId xmlns:a16="http://schemas.microsoft.com/office/drawing/2014/main" id="{3F6015EB-5E6D-48F0-BA01-ED778D2E3108}"/>
               </a:ext>
             </a:extLst>
           </p:cNvPr>
@@ -5038,7 +5038,7 @@
           <p:cNvPr id="16" name="">
             <a:extLst xmlns:a="http://schemas.openxmlformats.org/drawingml/2006/main">
               <a:ext uri="{FF2B5EF4-FFF2-40B4-BE49-F238E27FC236}">
-                <a16:creationId xmlns:a16="http://schemas.microsoft.com/office/drawing/2014/main" id="{3E9B683D-A3A6-4B93-90B1-8A50BEB91B05}"/>
+                <a16:creationId xmlns:a16="http://schemas.microsoft.com/office/drawing/2014/main" id="{AFE33941-F38C-44D1-8605-022F7CF2A214}"/>
               </a:ext>
             </a:extLst>
           </p:cNvPr>
@@ -5095,7 +5095,7 @@
           <p:cNvPr id="17" name="">
             <a:extLst xmlns:a="http://schemas.openxmlformats.org/drawingml/2006/main">
               <a:ext uri="{FF2B5EF4-FFF2-40B4-BE49-F238E27FC236}">
-                <a16:creationId xmlns:a16="http://schemas.microsoft.com/office/drawing/2014/main" id="{2D9D2505-5EC0-41BA-8ED7-FDD8ACE7D42B}"/>
+                <a16:creationId xmlns:a16="http://schemas.microsoft.com/office/drawing/2014/main" id="{D65EEEB2-CDA3-43DB-A1FE-34AF97099CC4}"/>
               </a:ext>
             </a:extLst>
           </p:cNvPr>
@@ -5158,7 +5158,7 @@
           <p:cNvPr id="18" name="">
             <a:extLst xmlns:a="http://schemas.openxmlformats.org/drawingml/2006/main">
               <a:ext uri="{FF2B5EF4-FFF2-40B4-BE49-F238E27FC236}">
-                <a16:creationId xmlns:a16="http://schemas.microsoft.com/office/drawing/2014/main" id="{4ED695A1-97AD-49E1-968A-8B40AF37F8D6}"/>
+                <a16:creationId xmlns:a16="http://schemas.microsoft.com/office/drawing/2014/main" id="{2B3EE5C8-DF69-47A1-B8B0-62756711E075}"/>
               </a:ext>
             </a:extLst>
           </p:cNvPr>
@@ -5192,7 +5192,7 @@
           <p:cNvPr id="19" name="">
             <a:extLst xmlns:a="http://schemas.openxmlformats.org/drawingml/2006/main">
               <a:ext uri="{FF2B5EF4-FFF2-40B4-BE49-F238E27FC236}">
-                <a16:creationId xmlns:a16="http://schemas.microsoft.com/office/drawing/2014/main" id="{A9CDC461-D5B6-4F96-99ED-ACBA7EC54DA4}"/>
+                <a16:creationId xmlns:a16="http://schemas.microsoft.com/office/drawing/2014/main" id="{4B38BE7D-5160-4B5C-8EB8-7C36FE5FE700}"/>
               </a:ext>
             </a:extLst>
           </p:cNvPr>
@@ -5249,7 +5249,7 @@
           <p:cNvPr id="20" name="">
             <a:extLst xmlns:a="http://schemas.openxmlformats.org/drawingml/2006/main">
               <a:ext uri="{FF2B5EF4-FFF2-40B4-BE49-F238E27FC236}">
-                <a16:creationId xmlns:a16="http://schemas.microsoft.com/office/drawing/2014/main" id="{BFC1C84B-FF0C-47B1-A2F1-6E65612572CD}"/>
+                <a16:creationId xmlns:a16="http://schemas.microsoft.com/office/drawing/2014/main" id="{7380691A-C63B-4E19-88AF-06AD7AC197E9}"/>
               </a:ext>
             </a:extLst>
           </p:cNvPr>
@@ -5306,7 +5306,7 @@
           <p:cNvPr id="21" name="">
             <a:extLst xmlns:a="http://schemas.openxmlformats.org/drawingml/2006/main">
               <a:ext uri="{FF2B5EF4-FFF2-40B4-BE49-F238E27FC236}">
-                <a16:creationId xmlns:a16="http://schemas.microsoft.com/office/drawing/2014/main" id="{EBA6A38A-23C5-4DF4-A911-926A57005FF2}"/>
+                <a16:creationId xmlns:a16="http://schemas.microsoft.com/office/drawing/2014/main" id="{B904224D-BE0F-47F4-816A-6AE65162E832}"/>
               </a:ext>
             </a:extLst>
           </p:cNvPr>
@@ -5363,7 +5363,7 @@
           <p:cNvPr id="22" name="">
             <a:extLst xmlns:a="http://schemas.openxmlformats.org/drawingml/2006/main">
               <a:ext uri="{FF2B5EF4-FFF2-40B4-BE49-F238E27FC236}">
-                <a16:creationId xmlns:a16="http://schemas.microsoft.com/office/drawing/2014/main" id="{E5BDCCFD-2134-46EE-B8E7-AE2A53904752}"/>
+                <a16:creationId xmlns:a16="http://schemas.microsoft.com/office/drawing/2014/main" id="{6725EBC8-0013-49C2-8F8B-FEC65FEB128A}"/>
               </a:ext>
             </a:extLst>
           </p:cNvPr>
@@ -5420,7 +5420,7 @@
           <p:cNvPr id="23" name="">
             <a:extLst xmlns:a="http://schemas.openxmlformats.org/drawingml/2006/main">
               <a:ext uri="{FF2B5EF4-FFF2-40B4-BE49-F238E27FC236}">
-                <a16:creationId xmlns:a16="http://schemas.microsoft.com/office/drawing/2014/main" id="{8509D1AC-0696-44FE-9111-46CAC53AB679}"/>
+                <a16:creationId xmlns:a16="http://schemas.microsoft.com/office/drawing/2014/main" id="{DE7F4D12-FA2B-41A1-958A-6EEFC39B527D}"/>
               </a:ext>
             </a:extLst>
           </p:cNvPr>
@@ -5477,7 +5477,7 @@
           <p:cNvPr id="24" name="">
             <a:extLst xmlns:a="http://schemas.openxmlformats.org/drawingml/2006/main">
               <a:ext uri="{FF2B5EF4-FFF2-40B4-BE49-F238E27FC236}">
-                <a16:creationId xmlns:a16="http://schemas.microsoft.com/office/drawing/2014/main" id="{0AEB6E39-140E-42D7-A570-1F0102DFDF6B}"/>
+                <a16:creationId xmlns:a16="http://schemas.microsoft.com/office/drawing/2014/main" id="{50DC17A0-8EE4-4E31-B6FB-94AD60044D3F}"/>
               </a:ext>
             </a:extLst>
           </p:cNvPr>
@@ -5534,7 +5534,7 @@
           <p:cNvPr id="25" name="">
             <a:extLst xmlns:a="http://schemas.openxmlformats.org/drawingml/2006/main">
               <a:ext uri="{FF2B5EF4-FFF2-40B4-BE49-F238E27FC236}">
-                <a16:creationId xmlns:a16="http://schemas.microsoft.com/office/drawing/2014/main" id="{01718EFA-AD02-4842-ACC4-DBC509F255CA}"/>
+                <a16:creationId xmlns:a16="http://schemas.microsoft.com/office/drawing/2014/main" id="{671F0E59-36B5-480C-984D-2D4B2DF6D5DE}"/>
               </a:ext>
             </a:extLst>
           </p:cNvPr>
@@ -5568,7 +5568,7 @@
           <p:cNvPr id="26" name="">
             <a:extLst xmlns:a="http://schemas.openxmlformats.org/drawingml/2006/main">
               <a:ext uri="{FF2B5EF4-FFF2-40B4-BE49-F238E27FC236}">
-                <a16:creationId xmlns:a16="http://schemas.microsoft.com/office/drawing/2014/main" id="{A6FDA4FA-225A-436C-BD79-E2073527A634}"/>
+                <a16:creationId xmlns:a16="http://schemas.microsoft.com/office/drawing/2014/main" id="{FE4F5D19-C0BD-4F51-AC12-2F0D9810C278}"/>
               </a:ext>
             </a:extLst>
           </p:cNvPr>
@@ -5600,7 +5600,7 @@
           <p:cNvPr id="27" name="">
             <a:extLst xmlns:a="http://schemas.openxmlformats.org/drawingml/2006/main">
               <a:ext uri="{FF2B5EF4-FFF2-40B4-BE49-F238E27FC236}">
-                <a16:creationId xmlns:a16="http://schemas.microsoft.com/office/drawing/2014/main" id="{DC9084E9-37BC-4BDE-A433-853342081436}"/>
+                <a16:creationId xmlns:a16="http://schemas.microsoft.com/office/drawing/2014/main" id="{808729DF-ED13-475B-B016-C910967B7D3F}"/>
               </a:ext>
             </a:extLst>
           </p:cNvPr>
@@ -5657,7 +5657,7 @@
           <p:cNvPr id="28" name="">
             <a:extLst xmlns:a="http://schemas.openxmlformats.org/drawingml/2006/main">
               <a:ext uri="{FF2B5EF4-FFF2-40B4-BE49-F238E27FC236}">
-                <a16:creationId xmlns:a16="http://schemas.microsoft.com/office/drawing/2014/main" id="{3C757ACB-0468-4113-A91F-7D6EB3D21D1D}"/>
+                <a16:creationId xmlns:a16="http://schemas.microsoft.com/office/drawing/2014/main" id="{2DC142A8-01B7-453A-AB20-8E6D28E2B930}"/>
               </a:ext>
             </a:extLst>
           </p:cNvPr>
@@ -5714,7 +5714,7 @@
           <p:cNvPr id="29" name="">
             <a:extLst xmlns:a="http://schemas.openxmlformats.org/drawingml/2006/main">
               <a:ext uri="{FF2B5EF4-FFF2-40B4-BE49-F238E27FC236}">
-                <a16:creationId xmlns:a16="http://schemas.microsoft.com/office/drawing/2014/main" id="{75B9ADCC-09A3-40EA-A2E7-729F319A1096}"/>
+                <a16:creationId xmlns:a16="http://schemas.microsoft.com/office/drawing/2014/main" id="{2021653F-B966-480A-BCDA-BD6ED9CA3A85}"/>
               </a:ext>
             </a:extLst>
           </p:cNvPr>
@@ -5777,7 +5777,7 @@
           <p:cNvPr id="30" name="">
             <a:extLst xmlns:a="http://schemas.openxmlformats.org/drawingml/2006/main">
               <a:ext uri="{FF2B5EF4-FFF2-40B4-BE49-F238E27FC236}">
-                <a16:creationId xmlns:a16="http://schemas.microsoft.com/office/drawing/2014/main" id="{F9B4ECE9-F498-4C63-9966-39DD96D3582F}"/>
+                <a16:creationId xmlns:a16="http://schemas.microsoft.com/office/drawing/2014/main" id="{E8E60985-093B-40A0-80D9-C4EC12A0964C}"/>
               </a:ext>
             </a:extLst>
           </p:cNvPr>
@@ -5811,7 +5811,7 @@
           <p:cNvPr id="31" name="">
             <a:extLst xmlns:a="http://schemas.openxmlformats.org/drawingml/2006/main">
               <a:ext uri="{FF2B5EF4-FFF2-40B4-BE49-F238E27FC236}">
-                <a16:creationId xmlns:a16="http://schemas.microsoft.com/office/drawing/2014/main" id="{56294792-2CFD-432C-B396-709D21C77F6E}"/>
+                <a16:creationId xmlns:a16="http://schemas.microsoft.com/office/drawing/2014/main" id="{39FA5729-8BBD-40DC-947A-7CB3AD2F4557}"/>
               </a:ext>
             </a:extLst>
           </p:cNvPr>
@@ -5868,7 +5868,7 @@
           <p:cNvPr id="32" name="">
             <a:extLst xmlns:a="http://schemas.openxmlformats.org/drawingml/2006/main">
               <a:ext uri="{FF2B5EF4-FFF2-40B4-BE49-F238E27FC236}">
-                <a16:creationId xmlns:a16="http://schemas.microsoft.com/office/drawing/2014/main" id="{8BA5ABFB-771F-4996-8CC3-09F24DF895CC}"/>
+                <a16:creationId xmlns:a16="http://schemas.microsoft.com/office/drawing/2014/main" id="{AC3E85CB-F1AA-427A-805B-30040AF958B3}"/>
               </a:ext>
             </a:extLst>
           </p:cNvPr>
@@ -5925,7 +5925,7 @@
           <p:cNvPr id="33" name="">
             <a:extLst xmlns:a="http://schemas.openxmlformats.org/drawingml/2006/main">
               <a:ext uri="{FF2B5EF4-FFF2-40B4-BE49-F238E27FC236}">
-                <a16:creationId xmlns:a16="http://schemas.microsoft.com/office/drawing/2014/main" id="{3D9FE7F8-88DA-453A-95A9-1FBBDCED39EC}"/>
+                <a16:creationId xmlns:a16="http://schemas.microsoft.com/office/drawing/2014/main" id="{17201ED4-00BB-447D-B98F-D113BDCC8E6E}"/>
               </a:ext>
             </a:extLst>
           </p:cNvPr>
@@ -5989,7 +5989,7 @@
                 <a:ea typeface="Consolas"/>
                 <a:cs typeface="Consolas"/>
               </a:rPr>
-              <a:t>«false»</a:t>
+              <a:t>false</a:t>
             </a:r>
             <a:r>
               <a:rPr sz="1500" b="0">
@@ -6011,7 +6011,7 @@
                 <a:ea typeface="Consolas"/>
                 <a:cs typeface="Consolas"/>
               </a:rPr>
-              <a:t>«true»</a:t>
+              <a:t>true</a:t>
             </a:r>
             <a:r>
               <a:rPr sz="1500" b="0">
@@ -6032,7 +6032,7 @@
           <p:cNvPr id="34" name="">
             <a:extLst xmlns:a="http://schemas.openxmlformats.org/drawingml/2006/main">
               <a:ext uri="{FF2B5EF4-FFF2-40B4-BE49-F238E27FC236}">
-                <a16:creationId xmlns:a16="http://schemas.microsoft.com/office/drawing/2014/main" id="{892AB47E-AF86-4182-B732-829FC49CEDE8}"/>
+                <a16:creationId xmlns:a16="http://schemas.microsoft.com/office/drawing/2014/main" id="{E5BB0DFD-6920-450B-95D9-F79DA8A4E424}"/>
               </a:ext>
             </a:extLst>
           </p:cNvPr>
@@ -6085,7 +6085,7 @@
                 <a:ea typeface="Consolas"/>
                 <a:cs typeface="Consolas"/>
               </a:rPr>
-              <a:t>«activo: false»</a:t>
+              <a:t>activo: false</a:t>
             </a:r>
             <a:r>
               <a:rPr sz="1500" b="0">
@@ -6107,7 +6107,7 @@
                 <a:ea typeface="Consolas"/>
                 <a:cs typeface="Consolas"/>
               </a:rPr>
-              <a:t>«reglas:»</a:t>
+              <a:t>reglas:</a:t>
             </a:r>
             <a:r>
               <a:rPr sz="1500" b="0">
@@ -6128,7 +6128,7 @@
           <p:cNvPr id="35" name="">
             <a:extLst xmlns:a="http://schemas.openxmlformats.org/drawingml/2006/main">
               <a:ext uri="{FF2B5EF4-FFF2-40B4-BE49-F238E27FC236}">
-                <a16:creationId xmlns:a16="http://schemas.microsoft.com/office/drawing/2014/main" id="{3A94953A-5A85-4AD7-9FAF-43A59E40B2CB}"/>
+                <a16:creationId xmlns:a16="http://schemas.microsoft.com/office/drawing/2014/main" id="{0B27C218-EC7E-468D-9D8A-0D67B638FB5A}"/>
               </a:ext>
             </a:extLst>
           </p:cNvPr>
@@ -6162,7 +6162,7 @@
           <p:cNvPr id="36" name="">
             <a:extLst xmlns:a="http://schemas.openxmlformats.org/drawingml/2006/main">
               <a:ext uri="{FF2B5EF4-FFF2-40B4-BE49-F238E27FC236}">
-                <a16:creationId xmlns:a16="http://schemas.microsoft.com/office/drawing/2014/main" id="{2EB29053-1D2D-46AA-9412-6CFB32705760}"/>
+                <a16:creationId xmlns:a16="http://schemas.microsoft.com/office/drawing/2014/main" id="{1F16C247-A63D-4900-97AB-0323BF537E4A}"/>
               </a:ext>
             </a:extLst>
           </p:cNvPr>
@@ -6194,7 +6194,7 @@
           <p:cNvPr id="37" name="">
             <a:extLst xmlns:a="http://schemas.openxmlformats.org/drawingml/2006/main">
               <a:ext uri="{FF2B5EF4-FFF2-40B4-BE49-F238E27FC236}">
-                <a16:creationId xmlns:a16="http://schemas.microsoft.com/office/drawing/2014/main" id="{CD55C0BD-869E-42D7-90E0-EF5A6D21424A}"/>
+                <a16:creationId xmlns:a16="http://schemas.microsoft.com/office/drawing/2014/main" id="{DE5F3930-AF20-4364-AF18-F119E2CAB6B8}"/>
               </a:ext>
             </a:extLst>
           </p:cNvPr>
@@ -6251,7 +6251,7 @@
           <p:cNvPr id="38" name="">
             <a:extLst xmlns:a="http://schemas.openxmlformats.org/drawingml/2006/main">
               <a:ext uri="{FF2B5EF4-FFF2-40B4-BE49-F238E27FC236}">
-                <a16:creationId xmlns:a16="http://schemas.microsoft.com/office/drawing/2014/main" id="{048C072B-4F41-4D30-AE2D-A409467F9B50}"/>
+                <a16:creationId xmlns:a16="http://schemas.microsoft.com/office/drawing/2014/main" id="{60DE76DB-0B84-4A55-9465-113362CD6191}"/>
               </a:ext>
             </a:extLst>
           </p:cNvPr>
@@ -6386,7 +6386,7 @@
                           <a:ea typeface="Consolas"/>
                           <a:cs typeface="Consolas"/>
                         </a:rPr>
-                        <a:t>«CRITICA», «NO CRITICA», «REVISAR»</a:t>
+                        <a:t>CRITICA, NO CRITICA, REVISAR</a:t>
                       </a:r>
                     </a:p>
                   </a:txBody>
@@ -6436,7 +6436,7 @@
                           <a:ea typeface="Consolas"/>
                           <a:cs typeface="Consolas"/>
                         </a:rPr>
-                        <a:t>«CONSULTAR MANUAL»</a:t>
+                        <a:t>CONSULTAR MANUAL</a:t>
                       </a:r>
                     </a:p>
                   </a:txBody>
@@ -6486,7 +6486,7 @@
                           <a:ea typeface="Consolas"/>
                           <a:cs typeface="Consolas"/>
                         </a:rPr>
-                        <a:t>«SIN FUENTE»</a:t>
+                        <a:t>SIN FUENTE</a:t>
                       </a:r>
                     </a:p>
                   </a:txBody>
@@ -6536,7 +6536,7 @@
                           <a:ea typeface="Consolas"/>
                           <a:cs typeface="Consolas"/>
                         </a:rPr>
-                        <a:t>«OBSERVACION»</a:t>
+                        <a:t>OBSERVACION</a:t>
                       </a:r>
                     </a:p>
                   </a:txBody>
@@ -6580,7 +6580,7 @@
           <p:cNvPr id="40" name="">
             <a:extLst xmlns:a="http://schemas.openxmlformats.org/drawingml/2006/main">
               <a:ext uri="{FF2B5EF4-FFF2-40B4-BE49-F238E27FC236}">
-                <a16:creationId xmlns:a16="http://schemas.microsoft.com/office/drawing/2014/main" id="{31D58CB5-7545-47DD-8FD5-4F43F8BAFA53}"/>
+                <a16:creationId xmlns:a16="http://schemas.microsoft.com/office/drawing/2014/main" id="{750B06F4-A056-4D7E-BA61-3B9CFFEAA304}"/>
               </a:ext>
             </a:extLst>
           </p:cNvPr>
@@ -6643,7 +6643,7 @@
           <p:cNvPr id="41" name="">
             <a:extLst xmlns:a="http://schemas.openxmlformats.org/drawingml/2006/main">
               <a:ext uri="{FF2B5EF4-FFF2-40B4-BE49-F238E27FC236}">
-                <a16:creationId xmlns:a16="http://schemas.microsoft.com/office/drawing/2014/main" id="{6568522C-9A78-492D-BCDB-04028634C21D}"/>
+                <a16:creationId xmlns:a16="http://schemas.microsoft.com/office/drawing/2014/main" id="{B5025B66-528E-4F70-BD0B-0679ACFA3886}"/>
               </a:ext>
             </a:extLst>
           </p:cNvPr>
@@ -6677,7 +6677,7 @@
           <p:cNvPr id="42" name="">
             <a:extLst xmlns:a="http://schemas.openxmlformats.org/drawingml/2006/main">
               <a:ext uri="{FF2B5EF4-FFF2-40B4-BE49-F238E27FC236}">
-                <a16:creationId xmlns:a16="http://schemas.microsoft.com/office/drawing/2014/main" id="{05560625-BA90-455A-9107-8D2D7EB6CDC2}"/>
+                <a16:creationId xmlns:a16="http://schemas.microsoft.com/office/drawing/2014/main" id="{0A18CF09-D7D6-442E-8F08-75F22C2FA0EC}"/>
               </a:ext>
             </a:extLst>
           </p:cNvPr>
@@ -6740,7 +6740,7 @@
           <p:cNvPr id="43" name="">
             <a:extLst xmlns:a="http://schemas.openxmlformats.org/drawingml/2006/main">
               <a:ext uri="{FF2B5EF4-FFF2-40B4-BE49-F238E27FC236}">
-                <a16:creationId xmlns:a16="http://schemas.microsoft.com/office/drawing/2014/main" id="{D167C6C4-DFE3-490F-B8AD-596F7997A1E1}"/>
+                <a16:creationId xmlns:a16="http://schemas.microsoft.com/office/drawing/2014/main" id="{BBB48AEB-264D-4524-933D-BFB0D50E1406}"/>
               </a:ext>
             </a:extLst>
           </p:cNvPr>
@@ -6803,7 +6803,7 @@
           <p:cNvPr id="44" name="">
             <a:extLst xmlns:a="http://schemas.openxmlformats.org/drawingml/2006/main">
               <a:ext uri="{FF2B5EF4-FFF2-40B4-BE49-F238E27FC236}">
-                <a16:creationId xmlns:a16="http://schemas.microsoft.com/office/drawing/2014/main" id="{9BE121AB-3845-4397-826C-B9A45BEBF2C2}"/>
+                <a16:creationId xmlns:a16="http://schemas.microsoft.com/office/drawing/2014/main" id="{49154F35-66D6-4062-8368-BE7E4B6B8961}"/>
               </a:ext>
             </a:extLst>
           </p:cNvPr>
@@ -6837,7 +6837,7 @@
           <p:cNvPr id="45" name="">
             <a:extLst xmlns:a="http://schemas.openxmlformats.org/drawingml/2006/main">
               <a:ext uri="{FF2B5EF4-FFF2-40B4-BE49-F238E27FC236}">
-                <a16:creationId xmlns:a16="http://schemas.microsoft.com/office/drawing/2014/main" id="{120F2A87-0BBF-452C-882D-5FA1C0436831}"/>
+                <a16:creationId xmlns:a16="http://schemas.microsoft.com/office/drawing/2014/main" id="{97C122BB-4B83-4D03-AEE6-81EE00E2C07F}"/>
               </a:ext>
             </a:extLst>
           </p:cNvPr>
@@ -6894,7 +6894,7 @@
           <p:cNvPr id="46" name="">
             <a:extLst xmlns:a="http://schemas.openxmlformats.org/drawingml/2006/main">
               <a:ext uri="{FF2B5EF4-FFF2-40B4-BE49-F238E27FC236}">
-                <a16:creationId xmlns:a16="http://schemas.microsoft.com/office/drawing/2014/main" id="{44814AE5-938A-44BB-A936-C4233943609C}"/>
+                <a16:creationId xmlns:a16="http://schemas.microsoft.com/office/drawing/2014/main" id="{E113B20D-F369-454C-BB48-2B6E8E898EF8}"/>
               </a:ext>
             </a:extLst>
           </p:cNvPr>
@@ -6949,7 +6949,7 @@
     </p:spTree>
     <p:extLst>
       <p:ext uri="{BB962C8B-B14F-4D97-AF65-F5344CB8AC3E}">
-        <p14:creationId xmlns:p14="http://schemas.microsoft.com/office/powerpoint/2010/main" val="875949720"/>
+        <p14:creationId xmlns:p14="http://schemas.microsoft.com/office/powerpoint/2010/main" val="962406598"/>
       </p:ext>
     </p:extLst>
   </p:cSld>
@@ -6980,7 +6980,7 @@
           <p:cNvPr id="54" name="">
             <a:extLst xmlns:a="http://schemas.openxmlformats.org/drawingml/2006/main">
               <a:ext uri="{FF2B5EF4-FFF2-40B4-BE49-F238E27FC236}">
-                <a16:creationId xmlns:a16="http://schemas.microsoft.com/office/drawing/2014/main" id="{A403EDA0-DCFB-4D84-BA7B-533259BA0608}"/>
+                <a16:creationId xmlns:a16="http://schemas.microsoft.com/office/drawing/2014/main" id="{A2F8B790-F913-4593-B7BF-5FFE2035B9B8}"/>
               </a:ext>
             </a:extLst>
           </p:cNvPr>
@@ -7024,7 +7024,7 @@
           <p:cNvPr id="2" name="">
             <a:extLst xmlns:a="http://schemas.openxmlformats.org/drawingml/2006/main">
               <a:ext uri="{FF2B5EF4-FFF2-40B4-BE49-F238E27FC236}">
-                <a16:creationId xmlns:a16="http://schemas.microsoft.com/office/drawing/2014/main" id="{DA6F7C8B-782C-4716-BC50-BD3410202330}"/>
+                <a16:creationId xmlns:a16="http://schemas.microsoft.com/office/drawing/2014/main" id="{28AF0888-D184-4B23-B6B7-784A61B97CD4}"/>
               </a:ext>
             </a:extLst>
           </p:cNvPr>
@@ -7081,7 +7081,7 @@
           <p:cNvPr id="3" name="">
             <a:extLst xmlns:a="http://schemas.openxmlformats.org/drawingml/2006/main">
               <a:ext uri="{FF2B5EF4-FFF2-40B4-BE49-F238E27FC236}">
-                <a16:creationId xmlns:a16="http://schemas.microsoft.com/office/drawing/2014/main" id="{8D4BD071-A80C-45D2-9C74-711E381156C7}"/>
+                <a16:creationId xmlns:a16="http://schemas.microsoft.com/office/drawing/2014/main" id="{0C32B6E8-AD5D-4907-80A2-6EA8ED2689A6}"/>
               </a:ext>
             </a:extLst>
           </p:cNvPr>
@@ -7111,7 +7111,7 @@
           <p:cNvPr id="4" name="">
             <a:extLst xmlns:a="http://schemas.openxmlformats.org/drawingml/2006/main">
               <a:ext uri="{FF2B5EF4-FFF2-40B4-BE49-F238E27FC236}">
-                <a16:creationId xmlns:a16="http://schemas.microsoft.com/office/drawing/2014/main" id="{D8E218CF-ABA9-49AF-9E58-DBFA01031777}"/>
+                <a16:creationId xmlns:a16="http://schemas.microsoft.com/office/drawing/2014/main" id="{6D4745B2-D6D9-4A60-A378-F0B9233255BB}"/>
               </a:ext>
             </a:extLst>
           </p:cNvPr>
@@ -7168,7 +7168,7 @@
           <p:cNvPr id="5" name="">
             <a:extLst xmlns:a="http://schemas.openxmlformats.org/drawingml/2006/main">
               <a:ext uri="{FF2B5EF4-FFF2-40B4-BE49-F238E27FC236}">
-                <a16:creationId xmlns:a16="http://schemas.microsoft.com/office/drawing/2014/main" id="{B55FE1BB-BBC1-4DE7-B22D-5DB2F74EC262}"/>
+                <a16:creationId xmlns:a16="http://schemas.microsoft.com/office/drawing/2014/main" id="{BE445A6B-C766-4C92-88DC-45D4124953C5}"/>
               </a:ext>
             </a:extLst>
           </p:cNvPr>
@@ -7229,7 +7229,7 @@
           <p:nvPr/>
         </p:nvPicPr>
         <p:blipFill>
-          <a:blip xmlns:r="http://schemas.openxmlformats.org/officeDocument/2006/relationships" xmlns:a="http://schemas.openxmlformats.org/drawingml/2006/main" r:embed="R8abfcb6fe4374f6d"/>
+          <a:blip xmlns:r="http://schemas.openxmlformats.org/officeDocument/2006/relationships" xmlns:a="http://schemas.openxmlformats.org/drawingml/2006/main" r:embed="Re50610684f30480b"/>
           <a:stretch xmlns:a="http://schemas.openxmlformats.org/drawingml/2006/main"/>
         </p:blipFill>
         <p:spPr>
@@ -7247,7 +7247,7 @@
           <p:cNvPr id="7" name="">
             <a:extLst xmlns:a="http://schemas.openxmlformats.org/drawingml/2006/main">
               <a:ext uri="{FF2B5EF4-FFF2-40B4-BE49-F238E27FC236}">
-                <a16:creationId xmlns:a16="http://schemas.microsoft.com/office/drawing/2014/main" id="{FF717C87-D395-4AD3-AC75-2F7BC95AA41D}"/>
+                <a16:creationId xmlns:a16="http://schemas.microsoft.com/office/drawing/2014/main" id="{8A7E4D5E-476F-46EB-96F8-95C6DF33577D}"/>
               </a:ext>
             </a:extLst>
           </p:cNvPr>
@@ -7289,7 +7289,7 @@
           <p:nvPr/>
         </p:nvPicPr>
         <p:blipFill>
-          <a:blip xmlns:r="http://schemas.openxmlformats.org/officeDocument/2006/relationships" xmlns:a="http://schemas.openxmlformats.org/drawingml/2006/main" r:embed="R1628748fc84a4db6"/>
+          <a:blip xmlns:r="http://schemas.openxmlformats.org/officeDocument/2006/relationships" xmlns:a="http://schemas.openxmlformats.org/drawingml/2006/main" r:embed="Rc5a119aa649e4080"/>
           <a:stretch xmlns:a="http://schemas.openxmlformats.org/drawingml/2006/main"/>
         </p:blipFill>
         <p:spPr>
@@ -7307,7 +7307,7 @@
           <p:cNvPr id="9" name="">
             <a:extLst xmlns:a="http://schemas.openxmlformats.org/drawingml/2006/main">
               <a:ext uri="{FF2B5EF4-FFF2-40B4-BE49-F238E27FC236}">
-                <a16:creationId xmlns:a16="http://schemas.microsoft.com/office/drawing/2014/main" id="{673C1E4F-B2AC-4673-A663-3A29D359FE3E}"/>
+                <a16:creationId xmlns:a16="http://schemas.microsoft.com/office/drawing/2014/main" id="{F96A0CA4-9563-42C1-8E8C-78AF35422231}"/>
               </a:ext>
             </a:extLst>
           </p:cNvPr>
@@ -7364,7 +7364,7 @@
           <p:cNvPr id="10" name="">
             <a:extLst xmlns:a="http://schemas.openxmlformats.org/drawingml/2006/main">
               <a:ext uri="{FF2B5EF4-FFF2-40B4-BE49-F238E27FC236}">
-                <a16:creationId xmlns:a16="http://schemas.microsoft.com/office/drawing/2014/main" id="{0E27F679-03EE-483D-BCE7-0D9B33905DA3}"/>
+                <a16:creationId xmlns:a16="http://schemas.microsoft.com/office/drawing/2014/main" id="{D45D0D17-5E1C-437D-9A82-C3DD9045A821}"/>
               </a:ext>
             </a:extLst>
           </p:cNvPr>
@@ -7421,7 +7421,7 @@
           <p:cNvPr id="11" name="">
             <a:extLst xmlns:a="http://schemas.openxmlformats.org/drawingml/2006/main">
               <a:ext uri="{FF2B5EF4-FFF2-40B4-BE49-F238E27FC236}">
-                <a16:creationId xmlns:a16="http://schemas.microsoft.com/office/drawing/2014/main" id="{59999B7D-C63F-474F-8483-D129EBA3A53D}"/>
+                <a16:creationId xmlns:a16="http://schemas.microsoft.com/office/drawing/2014/main" id="{217A92FB-3281-4EE5-88DF-6085608B9DDE}"/>
               </a:ext>
             </a:extLst>
           </p:cNvPr>
@@ -7485,7 +7485,7 @@
                 <a:ea typeface="Consolas"/>
                 <a:cs typeface="Consolas"/>
               </a:rPr>
-              <a:t>«TA»</a:t>
+              <a:t>TA</a:t>
             </a:r>
             <a:r>
               <a:rPr sz="1500" b="0">
@@ -7507,7 +7507,7 @@
                 <a:ea typeface="Consolas"/>
                 <a:cs typeface="Consolas"/>
               </a:rPr>
-              <a:t>«RIR»</a:t>
+              <a:t>RIR</a:t>
             </a:r>
             <a:r>
               <a:rPr sz="1500" b="0">
@@ -7529,7 +7529,7 @@
                 <a:ea typeface="Consolas"/>
                 <a:cs typeface="Consolas"/>
               </a:rPr>
-              <a:t>«Parent Assembly»</a:t>
+              <a:t>Parent Assembly</a:t>
             </a:r>
             <a:r>
               <a:rPr sz="1500" b="0">
@@ -7550,7 +7550,7 @@
           <p:cNvPr id="12" name="">
             <a:extLst xmlns:a="http://schemas.openxmlformats.org/drawingml/2006/main">
               <a:ext uri="{FF2B5EF4-FFF2-40B4-BE49-F238E27FC236}">
-                <a16:creationId xmlns:a16="http://schemas.microsoft.com/office/drawing/2014/main" id="{5D76EDA2-B4F9-4777-BE41-5204082C0242}"/>
+                <a16:creationId xmlns:a16="http://schemas.microsoft.com/office/drawing/2014/main" id="{27BD6084-E62B-492E-A1F0-41BCE072B589}"/>
               </a:ext>
             </a:extLst>
           </p:cNvPr>
@@ -7613,7 +7613,7 @@
           <p:cNvPr id="13" name="">
             <a:extLst xmlns:a="http://schemas.openxmlformats.org/drawingml/2006/main">
               <a:ext uri="{FF2B5EF4-FFF2-40B4-BE49-F238E27FC236}">
-                <a16:creationId xmlns:a16="http://schemas.microsoft.com/office/drawing/2014/main" id="{D3E150EA-9F33-41FE-8A7F-0E28CA3F2C4A}"/>
+                <a16:creationId xmlns:a16="http://schemas.microsoft.com/office/drawing/2014/main" id="{D73F9418-C691-4284-8BC8-6A670068F99C}"/>
               </a:ext>
             </a:extLst>
           </p:cNvPr>
@@ -7647,7 +7647,7 @@
           <p:cNvPr id="14" name="">
             <a:extLst xmlns:a="http://schemas.openxmlformats.org/drawingml/2006/main">
               <a:ext uri="{FF2B5EF4-FFF2-40B4-BE49-F238E27FC236}">
-                <a16:creationId xmlns:a16="http://schemas.microsoft.com/office/drawing/2014/main" id="{E206A03A-26AB-48F9-ACF9-84A6DF58791F}"/>
+                <a16:creationId xmlns:a16="http://schemas.microsoft.com/office/drawing/2014/main" id="{B317DEC3-76E3-4C6B-9911-798DBD406568}"/>
               </a:ext>
             </a:extLst>
           </p:cNvPr>
@@ -7679,7 +7679,7 @@
           <p:cNvPr id="15" name="">
             <a:extLst xmlns:a="http://schemas.openxmlformats.org/drawingml/2006/main">
               <a:ext uri="{FF2B5EF4-FFF2-40B4-BE49-F238E27FC236}">
-                <a16:creationId xmlns:a16="http://schemas.microsoft.com/office/drawing/2014/main" id="{9C52F485-C9A8-45F1-A149-7A5276D228D6}"/>
+                <a16:creationId xmlns:a16="http://schemas.microsoft.com/office/drawing/2014/main" id="{EB484BB9-315A-4D4D-BC90-957F0D842275}"/>
               </a:ext>
             </a:extLst>
           </p:cNvPr>
@@ -7736,7 +7736,7 @@
           <p:cNvPr id="16" name="">
             <a:extLst xmlns:a="http://schemas.openxmlformats.org/drawingml/2006/main">
               <a:ext uri="{FF2B5EF4-FFF2-40B4-BE49-F238E27FC236}">
-                <a16:creationId xmlns:a16="http://schemas.microsoft.com/office/drawing/2014/main" id="{16EED032-CCB9-4D06-9AD5-0EF3946C8267}"/>
+                <a16:creationId xmlns:a16="http://schemas.microsoft.com/office/drawing/2014/main" id="{DB67B5BE-38D7-401B-AC1A-D284F72A1556}"/>
               </a:ext>
             </a:extLst>
           </p:cNvPr>
@@ -7793,7 +7793,7 @@
           <p:cNvPr id="17" name="">
             <a:extLst xmlns:a="http://schemas.openxmlformats.org/drawingml/2006/main">
               <a:ext uri="{FF2B5EF4-FFF2-40B4-BE49-F238E27FC236}">
-                <a16:creationId xmlns:a16="http://schemas.microsoft.com/office/drawing/2014/main" id="{33B6F493-B629-4DFF-8F01-EBCA87D49B2D}"/>
+                <a16:creationId xmlns:a16="http://schemas.microsoft.com/office/drawing/2014/main" id="{EFA97164-35EE-4B8E-B98E-C080CC2EAF9A}"/>
               </a:ext>
             </a:extLst>
           </p:cNvPr>
@@ -7857,7 +7857,7 @@
                 <a:ea typeface="Consolas"/>
                 <a:cs typeface="Consolas"/>
               </a:rPr>
-              <a:t>«DIPs References.xlsx»</a:t>
+              <a:t>DIPs References.xlsx</a:t>
             </a:r>
             <a:r>
               <a:rPr sz="1500" b="1">
@@ -7878,7 +7878,7 @@
           <p:cNvPr id="18" name="">
             <a:extLst xmlns:a="http://schemas.openxmlformats.org/drawingml/2006/main">
               <a:ext uri="{FF2B5EF4-FFF2-40B4-BE49-F238E27FC236}">
-                <a16:creationId xmlns:a16="http://schemas.microsoft.com/office/drawing/2014/main" id="{01943735-A14C-4F2D-9D20-B1545747031F}"/>
+                <a16:creationId xmlns:a16="http://schemas.microsoft.com/office/drawing/2014/main" id="{51A5D4A2-F416-4A63-AC35-A86B03BC4725}"/>
               </a:ext>
             </a:extLst>
           </p:cNvPr>
@@ -7942,7 +7942,7 @@
                 <a:ea typeface="Consolas"/>
                 <a:cs typeface="Consolas"/>
               </a:rPr>
-              <a:t>«References»</a:t>
+              <a:t>References</a:t>
             </a:r>
             <a:r>
               <a:rPr sz="1500" b="1">
@@ -7963,7 +7963,7 @@
           <p:cNvPr id="19" name="">
             <a:extLst xmlns:a="http://schemas.openxmlformats.org/drawingml/2006/main">
               <a:ext uri="{FF2B5EF4-FFF2-40B4-BE49-F238E27FC236}">
-                <a16:creationId xmlns:a16="http://schemas.microsoft.com/office/drawing/2014/main" id="{DC9827DB-3A24-4AA6-9E8E-7E82C26247DF}"/>
+                <a16:creationId xmlns:a16="http://schemas.microsoft.com/office/drawing/2014/main" id="{FDFE9F00-B593-4D4B-BBDF-3981D32883C6}"/>
               </a:ext>
             </a:extLst>
           </p:cNvPr>
@@ -8009,7 +8009,7 @@
                 <a:latin typeface="Arial"/>
                 <a:ea typeface="Arial"/>
                 <a:cs typeface="Arial"/>
-                <a:hlinkClick xmlns:r="http://schemas.openxmlformats.org/officeDocument/2006/relationships" r:id="R91bc23a4be764bf3"/>
+                <a:hlinkClick xmlns:r="http://schemas.openxmlformats.org/officeDocument/2006/relationships" r:id="R13fc056b8dc640fe"/>
               </a:rPr>
               <a:t>Abrir DIPs References.xlsx en SharePoint</a:t>
             </a:r>
@@ -8021,7 +8021,7 @@
           <p:cNvPr id="20" name="">
             <a:extLst xmlns:a="http://schemas.openxmlformats.org/drawingml/2006/main">
               <a:ext uri="{FF2B5EF4-FFF2-40B4-BE49-F238E27FC236}">
-                <a16:creationId xmlns:a16="http://schemas.microsoft.com/office/drawing/2014/main" id="{D9875F0A-F4B9-421E-8728-CEA67A7399E0}"/>
+                <a16:creationId xmlns:a16="http://schemas.microsoft.com/office/drawing/2014/main" id="{74A91BE2-5DEB-457A-99CF-F27577F4CDE1}"/>
               </a:ext>
             </a:extLst>
           </p:cNvPr>
@@ -8085,7 +8085,7 @@
                 <a:ea typeface="Consolas"/>
                 <a:cs typeface="Consolas"/>
               </a:rPr>
-              <a:t>«config/config.yaml»</a:t>
+              <a:t>config/config.yaml</a:t>
             </a:r>
             <a:r>
               <a:rPr sz="1500" b="0">
@@ -8107,7 +8107,7 @@
                 <a:ea typeface="Consolas"/>
                 <a:cs typeface="Consolas"/>
               </a:rPr>
-              <a:t>«referencias»</a:t>
+              <a:t>referencias</a:t>
             </a:r>
             <a:r>
               <a:rPr sz="1500" b="0">
@@ -8128,7 +8128,7 @@
           <p:cNvPr id="21" name="">
             <a:extLst xmlns:a="http://schemas.openxmlformats.org/drawingml/2006/main">
               <a:ext uri="{FF2B5EF4-FFF2-40B4-BE49-F238E27FC236}">
-                <a16:creationId xmlns:a16="http://schemas.microsoft.com/office/drawing/2014/main" id="{DED699CF-BCA7-44B5-9EC7-CB3CD780A35D}"/>
+                <a16:creationId xmlns:a16="http://schemas.microsoft.com/office/drawing/2014/main" id="{894F9442-0E57-4B3C-B943-2CF848E2FAA7}"/>
               </a:ext>
             </a:extLst>
           </p:cNvPr>
@@ -8181,7 +8181,7 @@
                 <a:ea typeface="Consolas"/>
                 <a:cs typeface="Consolas"/>
               </a:rPr>
-              <a:t>«hoja_referencias»</a:t>
+              <a:t>hoja_referencias</a:t>
             </a:r>
             <a:r>
               <a:rPr sz="1500" b="0">
@@ -8203,7 +8203,7 @@
                 <a:ea typeface="Consolas"/>
                 <a:cs typeface="Consolas"/>
               </a:rPr>
-              <a:t>«referencias_sharepoint»</a:t>
+              <a:t>referencias_sharepoint</a:t>
             </a:r>
             <a:r>
               <a:rPr sz="1500" b="0">
@@ -8224,7 +8224,7 @@
           <p:cNvPr id="22" name="">
             <a:extLst xmlns:a="http://schemas.openxmlformats.org/drawingml/2006/main">
               <a:ext uri="{FF2B5EF4-FFF2-40B4-BE49-F238E27FC236}">
-                <a16:creationId xmlns:a16="http://schemas.microsoft.com/office/drawing/2014/main" id="{B23A48A6-4C3B-40AA-8A3F-8BDC52C885A1}"/>
+                <a16:creationId xmlns:a16="http://schemas.microsoft.com/office/drawing/2014/main" id="{F7E20B76-DA4E-4BD7-86E4-063C3EAD3767}"/>
               </a:ext>
             </a:extLst>
           </p:cNvPr>
@@ -8287,7 +8287,7 @@
           <p:cNvPr id="23" name="">
             <a:extLst xmlns:a="http://schemas.openxmlformats.org/drawingml/2006/main">
               <a:ext uri="{FF2B5EF4-FFF2-40B4-BE49-F238E27FC236}">
-                <a16:creationId xmlns:a16="http://schemas.microsoft.com/office/drawing/2014/main" id="{2D9AC585-0AF6-4296-A306-243DB738E98E}"/>
+                <a16:creationId xmlns:a16="http://schemas.microsoft.com/office/drawing/2014/main" id="{4A23846A-5DF7-46F0-8D58-549E3D040AE4}"/>
               </a:ext>
             </a:extLst>
           </p:cNvPr>
@@ -8321,7 +8321,7 @@
           <p:cNvPr id="24" name="">
             <a:extLst xmlns:a="http://schemas.openxmlformats.org/drawingml/2006/main">
               <a:ext uri="{FF2B5EF4-FFF2-40B4-BE49-F238E27FC236}">
-                <a16:creationId xmlns:a16="http://schemas.microsoft.com/office/drawing/2014/main" id="{FC00C34E-E4AD-4E5B-BB17-896B16433A2E}"/>
+                <a16:creationId xmlns:a16="http://schemas.microsoft.com/office/drawing/2014/main" id="{25A7AA5C-49CA-435A-94AE-A3A809D0E39E}"/>
               </a:ext>
             </a:extLst>
           </p:cNvPr>
@@ -8353,7 +8353,7 @@
           <p:cNvPr id="25" name="">
             <a:extLst xmlns:a="http://schemas.openxmlformats.org/drawingml/2006/main">
               <a:ext uri="{FF2B5EF4-FFF2-40B4-BE49-F238E27FC236}">
-                <a16:creationId xmlns:a16="http://schemas.microsoft.com/office/drawing/2014/main" id="{AAB76985-C7F0-4A79-B629-A3B0B9E88A60}"/>
+                <a16:creationId xmlns:a16="http://schemas.microsoft.com/office/drawing/2014/main" id="{B7A79390-BEA8-419D-83F2-F29AFE5B0DE1}"/>
               </a:ext>
             </a:extLst>
           </p:cNvPr>
@@ -8410,7 +8410,7 @@
           <p:cNvPr id="26" name="">
             <a:extLst xmlns:a="http://schemas.openxmlformats.org/drawingml/2006/main">
               <a:ext uri="{FF2B5EF4-FFF2-40B4-BE49-F238E27FC236}">
-                <a16:creationId xmlns:a16="http://schemas.microsoft.com/office/drawing/2014/main" id="{FCDAC997-15CC-4BB3-AD10-4FBC8530D0DB}"/>
+                <a16:creationId xmlns:a16="http://schemas.microsoft.com/office/drawing/2014/main" id="{7A134558-D11E-403E-8A39-B98882832778}"/>
               </a:ext>
             </a:extLst>
           </p:cNvPr>
@@ -8467,7 +8467,7 @@
           <p:cNvPr id="27" name="">
             <a:extLst xmlns:a="http://schemas.openxmlformats.org/drawingml/2006/main">
               <a:ext uri="{FF2B5EF4-FFF2-40B4-BE49-F238E27FC236}">
-                <a16:creationId xmlns:a16="http://schemas.microsoft.com/office/drawing/2014/main" id="{08E6FAFC-3B87-4548-925D-522D9356A9A7}"/>
+                <a16:creationId xmlns:a16="http://schemas.microsoft.com/office/drawing/2014/main" id="{1FFCA973-BEF5-487F-A4FD-F39F6D00044A}"/>
               </a:ext>
             </a:extLst>
           </p:cNvPr>
@@ -8530,7 +8530,7 @@
           <p:cNvPr id="28" name="">
             <a:extLst xmlns:a="http://schemas.openxmlformats.org/drawingml/2006/main">
               <a:ext uri="{FF2B5EF4-FFF2-40B4-BE49-F238E27FC236}">
-                <a16:creationId xmlns:a16="http://schemas.microsoft.com/office/drawing/2014/main" id="{D66EAD33-335E-4374-9735-AE6BC3953E16}"/>
+                <a16:creationId xmlns:a16="http://schemas.microsoft.com/office/drawing/2014/main" id="{95EF531C-2848-49E9-B275-FB0A3965C058}"/>
               </a:ext>
             </a:extLst>
           </p:cNvPr>
@@ -8594,7 +8594,7 @@
                 <a:ea typeface="Consolas"/>
                 <a:cs typeface="Consolas"/>
               </a:rPr>
-              <a:t>«DESCRIPTION»</a:t>
+              <a:t>DESCRIPTION</a:t>
             </a:r>
             <a:r>
               <a:rPr sz="1500" b="0">
@@ -8615,7 +8615,7 @@
           <p:cNvPr id="29" name="">
             <a:extLst xmlns:a="http://schemas.openxmlformats.org/drawingml/2006/main">
               <a:ext uri="{FF2B5EF4-FFF2-40B4-BE49-F238E27FC236}">
-                <a16:creationId xmlns:a16="http://schemas.microsoft.com/office/drawing/2014/main" id="{7D469D48-9866-4D69-A957-A7D6240FB6D0}"/>
+                <a16:creationId xmlns:a16="http://schemas.microsoft.com/office/drawing/2014/main" id="{F42B1270-2055-47AC-9915-83F502C3A260}"/>
               </a:ext>
             </a:extLst>
           </p:cNvPr>
@@ -8649,7 +8649,7 @@
           <p:cNvPr id="30" name="">
             <a:extLst xmlns:a="http://schemas.openxmlformats.org/drawingml/2006/main">
               <a:ext uri="{FF2B5EF4-FFF2-40B4-BE49-F238E27FC236}">
-                <a16:creationId xmlns:a16="http://schemas.microsoft.com/office/drawing/2014/main" id="{2635C9EB-50D9-47A4-8B9F-26C0A519FCB6}"/>
+                <a16:creationId xmlns:a16="http://schemas.microsoft.com/office/drawing/2014/main" id="{FFBC927D-02BD-4139-83F3-B667E73A9E3F}"/>
               </a:ext>
             </a:extLst>
           </p:cNvPr>
@@ -8706,7 +8706,7 @@
           <p:cNvPr id="31" name="">
             <a:extLst xmlns:a="http://schemas.openxmlformats.org/drawingml/2006/main">
               <a:ext uri="{FF2B5EF4-FFF2-40B4-BE49-F238E27FC236}">
-                <a16:creationId xmlns:a16="http://schemas.microsoft.com/office/drawing/2014/main" id="{57498087-7E7A-4B02-BA47-F41D0D254FB6}"/>
+                <a16:creationId xmlns:a16="http://schemas.microsoft.com/office/drawing/2014/main" id="{57F9B7CB-BEB1-4B4C-ACBF-A574673091E2}"/>
               </a:ext>
             </a:extLst>
           </p:cNvPr>
@@ -8763,7 +8763,7 @@
           <p:cNvPr id="32" name="">
             <a:extLst xmlns:a="http://schemas.openxmlformats.org/drawingml/2006/main">
               <a:ext uri="{FF2B5EF4-FFF2-40B4-BE49-F238E27FC236}">
-                <a16:creationId xmlns:a16="http://schemas.microsoft.com/office/drawing/2014/main" id="{3531B9F1-5131-4EC2-A443-2FE2617BEA94}"/>
+                <a16:creationId xmlns:a16="http://schemas.microsoft.com/office/drawing/2014/main" id="{428364B5-B3A3-4DA9-9AF2-7B22BA3C9069}"/>
               </a:ext>
             </a:extLst>
           </p:cNvPr>
@@ -8820,7 +8820,7 @@
           <p:cNvPr id="33" name="">
             <a:extLst xmlns:a="http://schemas.openxmlformats.org/drawingml/2006/main">
               <a:ext uri="{FF2B5EF4-FFF2-40B4-BE49-F238E27FC236}">
-                <a16:creationId xmlns:a16="http://schemas.microsoft.com/office/drawing/2014/main" id="{73359115-E36C-4A2B-B380-986C2E6C1589}"/>
+                <a16:creationId xmlns:a16="http://schemas.microsoft.com/office/drawing/2014/main" id="{5E6C43AE-253B-4E4C-8E1A-523ED7E53CFB}"/>
               </a:ext>
             </a:extLst>
           </p:cNvPr>
@@ -8873,7 +8873,7 @@
                 <a:ea typeface="Consolas"/>
                 <a:cs typeface="Consolas"/>
               </a:rPr>
-              <a:t>«TA»</a:t>
+              <a:t>TA</a:t>
             </a:r>
             <a:r>
               <a:rPr sz="1500" b="0">
@@ -8895,7 +8895,7 @@
                 <a:ea typeface="Consolas"/>
                 <a:cs typeface="Consolas"/>
               </a:rPr>
-              <a:t>«RIR»</a:t>
+              <a:t>RIR</a:t>
             </a:r>
             <a:r>
               <a:rPr sz="1500" b="0">
@@ -8917,7 +8917,7 @@
                 <a:ea typeface="Consolas"/>
                 <a:cs typeface="Consolas"/>
               </a:rPr>
-              <a:t>«30 DAYS»</a:t>
+              <a:t>30 DAYS</a:t>
             </a:r>
             <a:r>
               <a:rPr sz="1500" b="0">
@@ -8938,7 +8938,7 @@
           <p:cNvPr id="34" name="">
             <a:extLst xmlns:a="http://schemas.openxmlformats.org/drawingml/2006/main">
               <a:ext uri="{FF2B5EF4-FFF2-40B4-BE49-F238E27FC236}">
-                <a16:creationId xmlns:a16="http://schemas.microsoft.com/office/drawing/2014/main" id="{0D87F612-A027-4B69-8741-C3C4631CAC1C}"/>
+                <a16:creationId xmlns:a16="http://schemas.microsoft.com/office/drawing/2014/main" id="{42880230-015C-4DD4-B791-FA9CF8223B61}"/>
               </a:ext>
             </a:extLst>
           </p:cNvPr>
@@ -8972,7 +8972,7 @@
           <p:cNvPr id="35" name="">
             <a:extLst xmlns:a="http://schemas.openxmlformats.org/drawingml/2006/main">
               <a:ext uri="{FF2B5EF4-FFF2-40B4-BE49-F238E27FC236}">
-                <a16:creationId xmlns:a16="http://schemas.microsoft.com/office/drawing/2014/main" id="{05D10B4F-C441-4087-BF45-875D8DB17331}"/>
+                <a16:creationId xmlns:a16="http://schemas.microsoft.com/office/drawing/2014/main" id="{DB0A6557-86BF-4B22-B382-24C95921AADE}"/>
               </a:ext>
             </a:extLst>
           </p:cNvPr>
@@ -9004,7 +9004,7 @@
           <p:cNvPr id="36" name="">
             <a:extLst xmlns:a="http://schemas.openxmlformats.org/drawingml/2006/main">
               <a:ext uri="{FF2B5EF4-FFF2-40B4-BE49-F238E27FC236}">
-                <a16:creationId xmlns:a16="http://schemas.microsoft.com/office/drawing/2014/main" id="{E5BB6997-F242-463F-A8C6-1DD04E9DD7E3}"/>
+                <a16:creationId xmlns:a16="http://schemas.microsoft.com/office/drawing/2014/main" id="{76C145E7-672B-470C-8FDD-92023049B580}"/>
               </a:ext>
             </a:extLst>
           </p:cNvPr>
@@ -9061,7 +9061,7 @@
           <p:cNvPr id="37" name="">
             <a:extLst xmlns:a="http://schemas.openxmlformats.org/drawingml/2006/main">
               <a:ext uri="{FF2B5EF4-FFF2-40B4-BE49-F238E27FC236}">
-                <a16:creationId xmlns:a16="http://schemas.microsoft.com/office/drawing/2014/main" id="{D8898476-FAA3-45AC-B231-D32A4F043D50}"/>
+                <a16:creationId xmlns:a16="http://schemas.microsoft.com/office/drawing/2014/main" id="{9D813C75-563C-4511-835A-A1DD064F9289}"/>
               </a:ext>
             </a:extLst>
           </p:cNvPr>
@@ -9118,7 +9118,7 @@
           <p:cNvPr id="38" name="">
             <a:extLst xmlns:a="http://schemas.openxmlformats.org/drawingml/2006/main">
               <a:ext uri="{FF2B5EF4-FFF2-40B4-BE49-F238E27FC236}">
-                <a16:creationId xmlns:a16="http://schemas.microsoft.com/office/drawing/2014/main" id="{2BAF737F-3EE0-4A4E-865C-928C81C5BCB0}"/>
+                <a16:creationId xmlns:a16="http://schemas.microsoft.com/office/drawing/2014/main" id="{D956FBB2-DAF4-4985-8074-5A06C4CE06F3}"/>
               </a:ext>
             </a:extLst>
           </p:cNvPr>
@@ -9181,7 +9181,7 @@
           <p:cNvPr id="39" name="">
             <a:extLst xmlns:a="http://schemas.openxmlformats.org/drawingml/2006/main">
               <a:ext uri="{FF2B5EF4-FFF2-40B4-BE49-F238E27FC236}">
-                <a16:creationId xmlns:a16="http://schemas.microsoft.com/office/drawing/2014/main" id="{D9599D63-006C-4DA2-BE9A-76227C35B139}"/>
+                <a16:creationId xmlns:a16="http://schemas.microsoft.com/office/drawing/2014/main" id="{5AF0B989-DD3D-43F1-AC46-6DEC0E825A7E}"/>
               </a:ext>
             </a:extLst>
           </p:cNvPr>
@@ -9244,7 +9244,7 @@
           <p:cNvPr id="40" name="">
             <a:extLst xmlns:a="http://schemas.openxmlformats.org/drawingml/2006/main">
               <a:ext uri="{FF2B5EF4-FFF2-40B4-BE49-F238E27FC236}">
-                <a16:creationId xmlns:a16="http://schemas.microsoft.com/office/drawing/2014/main" id="{86025F52-B011-4C95-8942-648C2989867A}"/>
+                <a16:creationId xmlns:a16="http://schemas.microsoft.com/office/drawing/2014/main" id="{CF927B1B-FC14-4B08-A577-D56048D4AED0}"/>
               </a:ext>
             </a:extLst>
           </p:cNvPr>
@@ -9307,7 +9307,7 @@
           <p:cNvPr id="41" name="">
             <a:extLst xmlns:a="http://schemas.openxmlformats.org/drawingml/2006/main">
               <a:ext uri="{FF2B5EF4-FFF2-40B4-BE49-F238E27FC236}">
-                <a16:creationId xmlns:a16="http://schemas.microsoft.com/office/drawing/2014/main" id="{07E648B0-0CD9-4903-AF8F-B1110EC0733E}"/>
+                <a16:creationId xmlns:a16="http://schemas.microsoft.com/office/drawing/2014/main" id="{1D6D44A7-64BB-40D3-9FC5-9B7F3765B5AA}"/>
               </a:ext>
             </a:extLst>
           </p:cNvPr>
@@ -9370,7 +9370,7 @@
           <p:cNvPr id="42" name="">
             <a:extLst xmlns:a="http://schemas.openxmlformats.org/drawingml/2006/main">
               <a:ext uri="{FF2B5EF4-FFF2-40B4-BE49-F238E27FC236}">
-                <a16:creationId xmlns:a16="http://schemas.microsoft.com/office/drawing/2014/main" id="{205CA4CB-7510-4609-ADC0-BE5DE5D10C17}"/>
+                <a16:creationId xmlns:a16="http://schemas.microsoft.com/office/drawing/2014/main" id="{115230B6-F78A-4641-8722-9225A967E46F}"/>
               </a:ext>
             </a:extLst>
           </p:cNvPr>
@@ -9404,7 +9404,7 @@
           <p:cNvPr id="43" name="">
             <a:extLst xmlns:a="http://schemas.openxmlformats.org/drawingml/2006/main">
               <a:ext uri="{FF2B5EF4-FFF2-40B4-BE49-F238E27FC236}">
-                <a16:creationId xmlns:a16="http://schemas.microsoft.com/office/drawing/2014/main" id="{C6680D67-1268-40E8-A76B-7BC8446EDC79}"/>
+                <a16:creationId xmlns:a16="http://schemas.microsoft.com/office/drawing/2014/main" id="{A209C746-1425-448B-A3C6-54C11166A289}"/>
               </a:ext>
             </a:extLst>
           </p:cNvPr>
@@ -9436,7 +9436,7 @@
           <p:cNvPr id="44" name="">
             <a:extLst xmlns:a="http://schemas.openxmlformats.org/drawingml/2006/main">
               <a:ext uri="{FF2B5EF4-FFF2-40B4-BE49-F238E27FC236}">
-                <a16:creationId xmlns:a16="http://schemas.microsoft.com/office/drawing/2014/main" id="{80F34B26-CB2E-4EB4-A803-06A1A6519498}"/>
+                <a16:creationId xmlns:a16="http://schemas.microsoft.com/office/drawing/2014/main" id="{A680717F-9ECE-467D-8919-2CFD256F1A1E}"/>
               </a:ext>
             </a:extLst>
           </p:cNvPr>
@@ -9493,7 +9493,7 @@
           <p:cNvPr id="45" name="">
             <a:extLst xmlns:a="http://schemas.openxmlformats.org/drawingml/2006/main">
               <a:ext uri="{FF2B5EF4-FFF2-40B4-BE49-F238E27FC236}">
-                <a16:creationId xmlns:a16="http://schemas.microsoft.com/office/drawing/2014/main" id="{F9C39265-C447-4761-9FF5-E8F0857CA0F4}"/>
+                <a16:creationId xmlns:a16="http://schemas.microsoft.com/office/drawing/2014/main" id="{86DB2083-A2E1-49DD-84B1-9227D63B5B8F}"/>
               </a:ext>
             </a:extLst>
           </p:cNvPr>
@@ -9550,7 +9550,7 @@
           <p:cNvPr id="46" name="">
             <a:extLst xmlns:a="http://schemas.openxmlformats.org/drawingml/2006/main">
               <a:ext uri="{FF2B5EF4-FFF2-40B4-BE49-F238E27FC236}">
-                <a16:creationId xmlns:a16="http://schemas.microsoft.com/office/drawing/2014/main" id="{A668BBCD-E34F-4476-9640-992207A01BF0}"/>
+                <a16:creationId xmlns:a16="http://schemas.microsoft.com/office/drawing/2014/main" id="{D226D4A4-C163-4088-B9C6-E98F77574BCC}"/>
               </a:ext>
             </a:extLst>
           </p:cNvPr>
@@ -9613,7 +9613,7 @@
           <p:cNvPr id="47" name="">
             <a:extLst xmlns:a="http://schemas.openxmlformats.org/drawingml/2006/main">
               <a:ext uri="{FF2B5EF4-FFF2-40B4-BE49-F238E27FC236}">
-                <a16:creationId xmlns:a16="http://schemas.microsoft.com/office/drawing/2014/main" id="{1E11B67A-121E-419C-8A81-BC3E2C7A3D1A}"/>
+                <a16:creationId xmlns:a16="http://schemas.microsoft.com/office/drawing/2014/main" id="{0A8B285E-3720-41F9-86E3-E7988B23BD49}"/>
               </a:ext>
             </a:extLst>
           </p:cNvPr>
@@ -9647,7 +9647,7 @@
           <p:cNvPr id="48" name="">
             <a:extLst xmlns:a="http://schemas.openxmlformats.org/drawingml/2006/main">
               <a:ext uri="{FF2B5EF4-FFF2-40B4-BE49-F238E27FC236}">
-                <a16:creationId xmlns:a16="http://schemas.microsoft.com/office/drawing/2014/main" id="{93E6088B-7B48-4AF1-9912-D130EC85AC5B}"/>
+                <a16:creationId xmlns:a16="http://schemas.microsoft.com/office/drawing/2014/main" id="{F27D21B5-C578-40DD-A16D-FC6B42E8A64B}"/>
               </a:ext>
             </a:extLst>
           </p:cNvPr>
@@ -9704,7 +9704,7 @@
           <p:cNvPr id="49" name="">
             <a:extLst xmlns:a="http://schemas.openxmlformats.org/drawingml/2006/main">
               <a:ext uri="{FF2B5EF4-FFF2-40B4-BE49-F238E27FC236}">
-                <a16:creationId xmlns:a16="http://schemas.microsoft.com/office/drawing/2014/main" id="{58C11A7F-9ABE-46F6-9D5D-B389E4274C02}"/>
+                <a16:creationId xmlns:a16="http://schemas.microsoft.com/office/drawing/2014/main" id="{0F1356B4-9C20-4C06-A1C5-25F3BF545E3E}"/>
               </a:ext>
             </a:extLst>
           </p:cNvPr>
@@ -9761,7 +9761,7 @@
           <p:cNvPr id="50" name="">
             <a:extLst xmlns:a="http://schemas.openxmlformats.org/drawingml/2006/main">
               <a:ext uri="{FF2B5EF4-FFF2-40B4-BE49-F238E27FC236}">
-                <a16:creationId xmlns:a16="http://schemas.microsoft.com/office/drawing/2014/main" id="{A808E94D-618E-415A-A1F0-EA96F8945B41}"/>
+                <a16:creationId xmlns:a16="http://schemas.microsoft.com/office/drawing/2014/main" id="{BF7C1F58-A30D-4765-B9CC-7FECD839414C}"/>
               </a:ext>
             </a:extLst>
           </p:cNvPr>
@@ -9825,7 +9825,7 @@
                 <a:ea typeface="Consolas"/>
                 <a:cs typeface="Consolas"/>
               </a:rPr>
-              <a:t>«config/config.yaml»</a:t>
+              <a:t>config/config.yaml</a:t>
             </a:r>
             <a:r>
               <a:rPr sz="1500" b="0">
@@ -9846,7 +9846,7 @@
           <p:cNvPr id="51" name="">
             <a:extLst xmlns:a="http://schemas.openxmlformats.org/drawingml/2006/main">
               <a:ext uri="{FF2B5EF4-FFF2-40B4-BE49-F238E27FC236}">
-                <a16:creationId xmlns:a16="http://schemas.microsoft.com/office/drawing/2014/main" id="{8EFA65A2-F2CA-43B2-B1A8-0FBE13E085DB}"/>
+                <a16:creationId xmlns:a16="http://schemas.microsoft.com/office/drawing/2014/main" id="{9168140A-8C1B-47E8-85F1-4950B44C4F24}"/>
               </a:ext>
             </a:extLst>
           </p:cNvPr>
@@ -9880,7 +9880,7 @@
           <p:cNvPr id="52" name="">
             <a:extLst xmlns:a="http://schemas.openxmlformats.org/drawingml/2006/main">
               <a:ext uri="{FF2B5EF4-FFF2-40B4-BE49-F238E27FC236}">
-                <a16:creationId xmlns:a16="http://schemas.microsoft.com/office/drawing/2014/main" id="{51DE920D-B009-4912-B6AF-00FA9D276652}"/>
+                <a16:creationId xmlns:a16="http://schemas.microsoft.com/office/drawing/2014/main" id="{703F0217-235F-4AD4-9CF5-DD324D73B824}"/>
               </a:ext>
             </a:extLst>
           </p:cNvPr>
@@ -9937,7 +9937,7 @@
           <p:cNvPr id="53" name="">
             <a:extLst xmlns:a="http://schemas.openxmlformats.org/drawingml/2006/main">
               <a:ext uri="{FF2B5EF4-FFF2-40B4-BE49-F238E27FC236}">
-                <a16:creationId xmlns:a16="http://schemas.microsoft.com/office/drawing/2014/main" id="{935018F6-002E-4EF7-8657-C3DDE12E19D0}"/>
+                <a16:creationId xmlns:a16="http://schemas.microsoft.com/office/drawing/2014/main" id="{B9C7466D-BDDF-48DC-A12A-E4A42BED5478}"/>
               </a:ext>
             </a:extLst>
           </p:cNvPr>
@@ -9992,7 +9992,7 @@
     </p:spTree>
     <p:extLst>
       <p:ext uri="{BB962C8B-B14F-4D97-AF65-F5344CB8AC3E}">
-        <p14:creationId xmlns:p14="http://schemas.microsoft.com/office/powerpoint/2010/main" val="450310512"/>
+        <p14:creationId xmlns:p14="http://schemas.microsoft.com/office/powerpoint/2010/main" val="370422669"/>
       </p:ext>
     </p:extLst>
   </p:cSld>

</xml_diff>

<commit_message>
Ajusta la guia DIPS segun los comentarios de revision
</commit_message>
<xml_diff>
--- a/docs/Guia_DIPS_reglas_referencias.pptx
+++ b/docs/Guia_DIPS_reglas_referencias.pptx
@@ -2,15 +2,15 @@
 <file path=ppt/presentation.xml><?xml version="1.0" encoding="utf-8"?>
 <p:presentation xmlns:p="http://schemas.openxmlformats.org/presentationml/2006/main">
   <p:sldMasterIdLst>
-    <p:sldMasterId xmlns:r="http://schemas.openxmlformats.org/officeDocument/2006/relationships" id="2147483648" r:id="R4b51cc8ae8274d38"/>
+    <p:sldMasterId xmlns:r="http://schemas.openxmlformats.org/officeDocument/2006/relationships" id="2147483648" r:id="R31581204a7d148a9"/>
   </p:sldMasterIdLst>
   <p:notesMasterIdLst>
-    <p:notesMasterId xmlns:r="http://schemas.openxmlformats.org/officeDocument/2006/relationships" r:id="R2193b590df1347c8"/>
+    <p:notesMasterId xmlns:r="http://schemas.openxmlformats.org/officeDocument/2006/relationships" r:id="R5fbe364494374f9a"/>
   </p:notesMasterIdLst>
   <p:sldIdLst>
-    <p:sldId xmlns:r="http://schemas.openxmlformats.org/officeDocument/2006/relationships" id="256" r:id="R5962c71fc3a74b7b"/>
-    <p:sldId xmlns:r="http://schemas.openxmlformats.org/officeDocument/2006/relationships" id="257" r:id="Rd23aa237bfd5414d"/>
-    <p:sldId xmlns:r="http://schemas.openxmlformats.org/officeDocument/2006/relationships" id="258" r:id="R01e1b1ebe54146dc"/>
+    <p:sldId xmlns:r="http://schemas.openxmlformats.org/officeDocument/2006/relationships" id="256" r:id="R9fdbd077b76e49b1"/>
+    <p:sldId xmlns:r="http://schemas.openxmlformats.org/officeDocument/2006/relationships" id="257" r:id="R3c4cd354c10f488b"/>
+    <p:sldId xmlns:r="http://schemas.openxmlformats.org/officeDocument/2006/relationships" id="258" r:id="Rb747c7c1feb84fa5"/>
   </p:sldIdLst>
   <p:sldSz cx="9753600" cy="14630400"/>
   <p:notesSz cx="6858000" cy="9144000"/>
@@ -652,7 +652,7 @@
   </p:cSld>
   <p:clrMap bg1="lt1" tx1="dk1" bg2="lt2" tx2="dk2" accent1="accent1" accent2="accent2" accent3="accent3" accent4="accent4" accent5="accent5" accent6="accent6" hlink="hlink" folHlink="folHlink"/>
   <p:sldLayoutIdLst>
-    <p:sldLayoutId xmlns:r="http://schemas.openxmlformats.org/officeDocument/2006/relationships" id="2147483649" r:id="Re62864cbfec141a0"/>
+    <p:sldLayoutId xmlns:r="http://schemas.openxmlformats.org/officeDocument/2006/relationships" id="2147483649" r:id="R69dea106c29b4087"/>
   </p:sldLayoutIdLst>
   <p:txStyles>
     <p:titleStyle>
@@ -1200,10 +1200,10 @@
       </p:grpSpPr>
       <p:sp>
         <p:nvSpPr>
-          <p:cNvPr id="54" name="">
-            <a:extLst xmlns:a="http://schemas.openxmlformats.org/drawingml/2006/main">
-              <a:ext uri="{FF2B5EF4-FFF2-40B4-BE49-F238E27FC236}">
-                <a16:creationId xmlns:a16="http://schemas.microsoft.com/office/drawing/2014/main" id="{3947AC8A-9F55-423C-ACC9-CCA0B90E64E9}"/>
+          <p:cNvPr id="51" name="">
+            <a:extLst xmlns:a="http://schemas.openxmlformats.org/drawingml/2006/main">
+              <a:ext uri="{FF2B5EF4-FFF2-40B4-BE49-F238E27FC236}">
+                <a16:creationId xmlns:a16="http://schemas.microsoft.com/office/drawing/2014/main" id="{BFF2F0F8-8344-452E-A759-16A3667843C1}"/>
               </a:ext>
             </a:extLst>
           </p:cNvPr>
@@ -1247,7 +1247,7 @@
           <p:cNvPr id="2" name="">
             <a:extLst xmlns:a="http://schemas.openxmlformats.org/drawingml/2006/main">
               <a:ext uri="{FF2B5EF4-FFF2-40B4-BE49-F238E27FC236}">
-                <a16:creationId xmlns:a16="http://schemas.microsoft.com/office/drawing/2014/main" id="{81D4B7D2-977E-4BC5-AFA4-23AA0A2C841A}"/>
+                <a16:creationId xmlns:a16="http://schemas.microsoft.com/office/drawing/2014/main" id="{992BE106-8AD0-4A35-8FC0-D00D0B0FDF7A}"/>
               </a:ext>
             </a:extLst>
           </p:cNvPr>
@@ -1304,7 +1304,7 @@
           <p:cNvPr id="3" name="">
             <a:extLst xmlns:a="http://schemas.openxmlformats.org/drawingml/2006/main">
               <a:ext uri="{FF2B5EF4-FFF2-40B4-BE49-F238E27FC236}">
-                <a16:creationId xmlns:a16="http://schemas.microsoft.com/office/drawing/2014/main" id="{E1AE5A72-F8CE-442E-A985-AE9A044D344A}"/>
+                <a16:creationId xmlns:a16="http://schemas.microsoft.com/office/drawing/2014/main" id="{59229787-FF74-46BF-B7F1-2A53960C8B0F}"/>
               </a:ext>
             </a:extLst>
           </p:cNvPr>
@@ -1334,7 +1334,7 @@
           <p:cNvPr id="4" name="">
             <a:extLst xmlns:a="http://schemas.openxmlformats.org/drawingml/2006/main">
               <a:ext uri="{FF2B5EF4-FFF2-40B4-BE49-F238E27FC236}">
-                <a16:creationId xmlns:a16="http://schemas.microsoft.com/office/drawing/2014/main" id="{4624110B-135B-414F-A6E4-3FF9A5283AE2}"/>
+                <a16:creationId xmlns:a16="http://schemas.microsoft.com/office/drawing/2014/main" id="{0FBE60D1-A261-4664-854B-7D954D0E3E28}"/>
               </a:ext>
             </a:extLst>
           </p:cNvPr>
@@ -1391,7 +1391,7 @@
           <p:cNvPr id="5" name="">
             <a:extLst xmlns:a="http://schemas.openxmlformats.org/drawingml/2006/main">
               <a:ext uri="{FF2B5EF4-FFF2-40B4-BE49-F238E27FC236}">
-                <a16:creationId xmlns:a16="http://schemas.microsoft.com/office/drawing/2014/main" id="{2CA43DF9-52B2-455E-9792-33662BE6AF37}"/>
+                <a16:creationId xmlns:a16="http://schemas.microsoft.com/office/drawing/2014/main" id="{8AE0F789-D394-4A04-AC07-C0BE9DC039FC}"/>
               </a:ext>
             </a:extLst>
           </p:cNvPr>
@@ -1445,14 +1445,14 @@
       </p:sp>
       <p:pic>
         <p:nvPicPr>
-          <p:cNvPr id="59" name=""/>
+          <p:cNvPr id="56" name=""/>
           <p:cNvPicPr>
             <a:picLocks xmlns:a="http://schemas.openxmlformats.org/drawingml/2006/main" noChangeAspect="1"/>
           </p:cNvPicPr>
           <p:nvPr/>
         </p:nvPicPr>
         <p:blipFill>
-          <a:blip xmlns:r="http://schemas.openxmlformats.org/officeDocument/2006/relationships" xmlns:a="http://schemas.openxmlformats.org/drawingml/2006/main" r:embed="R14ad780f4b584656"/>
+          <a:blip xmlns:r="http://schemas.openxmlformats.org/officeDocument/2006/relationships" xmlns:a="http://schemas.openxmlformats.org/drawingml/2006/main" r:embed="R4da05ed52fa64037"/>
           <a:stretch xmlns:a="http://schemas.openxmlformats.org/drawingml/2006/main"/>
         </p:blipFill>
         <p:spPr>
@@ -1470,7 +1470,7 @@
           <p:cNvPr id="7" name="">
             <a:extLst xmlns:a="http://schemas.openxmlformats.org/drawingml/2006/main">
               <a:ext uri="{FF2B5EF4-FFF2-40B4-BE49-F238E27FC236}">
-                <a16:creationId xmlns:a16="http://schemas.microsoft.com/office/drawing/2014/main" id="{71BC520D-B5F9-4AAE-8F85-5F41951D8182}"/>
+                <a16:creationId xmlns:a16="http://schemas.microsoft.com/office/drawing/2014/main" id="{03DEF34F-8C43-41EF-8384-0EC5BF69D2CC}"/>
               </a:ext>
             </a:extLst>
           </p:cNvPr>
@@ -1505,14 +1505,14 @@
       </p:sp>
       <p:pic>
         <p:nvPicPr>
-          <p:cNvPr id="61" name=""/>
+          <p:cNvPr id="58" name=""/>
           <p:cNvPicPr>
             <a:picLocks xmlns:a="http://schemas.openxmlformats.org/drawingml/2006/main" noChangeAspect="1"/>
           </p:cNvPicPr>
           <p:nvPr/>
         </p:nvPicPr>
         <p:blipFill>
-          <a:blip xmlns:r="http://schemas.openxmlformats.org/officeDocument/2006/relationships" xmlns:a="http://schemas.openxmlformats.org/drawingml/2006/main" r:embed="R0a6e65a7e1bb4626"/>
+          <a:blip xmlns:r="http://schemas.openxmlformats.org/officeDocument/2006/relationships" xmlns:a="http://schemas.openxmlformats.org/drawingml/2006/main" r:embed="R67e7f37db75e4835"/>
           <a:stretch xmlns:a="http://schemas.openxmlformats.org/drawingml/2006/main"/>
         </p:blipFill>
         <p:spPr>
@@ -1530,7 +1530,7 @@
           <p:cNvPr id="9" name="">
             <a:extLst xmlns:a="http://schemas.openxmlformats.org/drawingml/2006/main">
               <a:ext uri="{FF2B5EF4-FFF2-40B4-BE49-F238E27FC236}">
-                <a16:creationId xmlns:a16="http://schemas.microsoft.com/office/drawing/2014/main" id="{EC2F37D0-55D0-42B0-8D66-7D9A324F2F1A}"/>
+                <a16:creationId xmlns:a16="http://schemas.microsoft.com/office/drawing/2014/main" id="{66380BE5-8A58-4426-8962-125FE2A72DFC}"/>
               </a:ext>
             </a:extLst>
           </p:cNvPr>
@@ -1587,7 +1587,7 @@
           <p:cNvPr id="10" name="">
             <a:extLst xmlns:a="http://schemas.openxmlformats.org/drawingml/2006/main">
               <a:ext uri="{FF2B5EF4-FFF2-40B4-BE49-F238E27FC236}">
-                <a16:creationId xmlns:a16="http://schemas.microsoft.com/office/drawing/2014/main" id="{1926262D-0E95-4861-BBC2-572D04DC40B5}"/>
+                <a16:creationId xmlns:a16="http://schemas.microsoft.com/office/drawing/2014/main" id="{9677939B-2FDB-4F30-9C19-8D440827F7C9}"/>
               </a:ext>
             </a:extLst>
           </p:cNvPr>
@@ -1644,7 +1644,7 @@
           <p:cNvPr id="11" name="">
             <a:extLst xmlns:a="http://schemas.openxmlformats.org/drawingml/2006/main">
               <a:ext uri="{FF2B5EF4-FFF2-40B4-BE49-F238E27FC236}">
-                <a16:creationId xmlns:a16="http://schemas.microsoft.com/office/drawing/2014/main" id="{771D88FD-AC66-41BE-ACF5-5CE1FCAC516F}"/>
+                <a16:creationId xmlns:a16="http://schemas.microsoft.com/office/drawing/2014/main" id="{2939CACB-AB02-4050-9B2B-66D06EF04DA4}"/>
               </a:ext>
             </a:extLst>
           </p:cNvPr>
@@ -1707,7 +1707,7 @@
           <p:cNvPr id="12" name="">
             <a:extLst xmlns:a="http://schemas.openxmlformats.org/drawingml/2006/main">
               <a:ext uri="{FF2B5EF4-FFF2-40B4-BE49-F238E27FC236}">
-                <a16:creationId xmlns:a16="http://schemas.microsoft.com/office/drawing/2014/main" id="{604F4BA0-AD34-45C6-83A3-4025361D1352}"/>
+                <a16:creationId xmlns:a16="http://schemas.microsoft.com/office/drawing/2014/main" id="{16029D9D-725F-429E-A33A-2CC886E65915}"/>
               </a:ext>
             </a:extLst>
           </p:cNvPr>
@@ -1792,7 +1792,7 @@
           <p:cNvPr id="13" name="">
             <a:extLst xmlns:a="http://schemas.openxmlformats.org/drawingml/2006/main">
               <a:ext uri="{FF2B5EF4-FFF2-40B4-BE49-F238E27FC236}">
-                <a16:creationId xmlns:a16="http://schemas.microsoft.com/office/drawing/2014/main" id="{55E646A6-7924-4302-AAAD-FFD3B0CB65C1}"/>
+                <a16:creationId xmlns:a16="http://schemas.microsoft.com/office/drawing/2014/main" id="{EF65040E-E27E-4D6A-8C20-1B154AA73579}"/>
               </a:ext>
             </a:extLst>
           </p:cNvPr>
@@ -1877,7 +1877,7 @@
           <p:cNvPr id="14" name="">
             <a:extLst xmlns:a="http://schemas.openxmlformats.org/drawingml/2006/main">
               <a:ext uri="{FF2B5EF4-FFF2-40B4-BE49-F238E27FC236}">
-                <a16:creationId xmlns:a16="http://schemas.microsoft.com/office/drawing/2014/main" id="{2DD9EB5E-E811-4353-9376-34211DC28779}"/>
+                <a16:creationId xmlns:a16="http://schemas.microsoft.com/office/drawing/2014/main" id="{79845543-D062-4A6A-9511-AA8E0C87F049}"/>
               </a:ext>
             </a:extLst>
           </p:cNvPr>
@@ -1911,7 +1911,7 @@
           <p:cNvPr id="15" name="">
             <a:extLst xmlns:a="http://schemas.openxmlformats.org/drawingml/2006/main">
               <a:ext uri="{FF2B5EF4-FFF2-40B4-BE49-F238E27FC236}">
-                <a16:creationId xmlns:a16="http://schemas.microsoft.com/office/drawing/2014/main" id="{2BB7F5A4-F72B-4CDB-BB49-9AA823956F1C}"/>
+                <a16:creationId xmlns:a16="http://schemas.microsoft.com/office/drawing/2014/main" id="{0E9238D4-5219-4067-A628-69FAF7EBE334}"/>
               </a:ext>
             </a:extLst>
           </p:cNvPr>
@@ -1943,7 +1943,7 @@
           <p:cNvPr id="16" name="">
             <a:extLst xmlns:a="http://schemas.openxmlformats.org/drawingml/2006/main">
               <a:ext uri="{FF2B5EF4-FFF2-40B4-BE49-F238E27FC236}">
-                <a16:creationId xmlns:a16="http://schemas.microsoft.com/office/drawing/2014/main" id="{C396360C-7014-4284-988C-CFA0B2954D29}"/>
+                <a16:creationId xmlns:a16="http://schemas.microsoft.com/office/drawing/2014/main" id="{C02CF061-179D-4724-8894-28B23CD5D808}"/>
               </a:ext>
             </a:extLst>
           </p:cNvPr>
@@ -2000,7 +2000,7 @@
           <p:cNvPr id="17" name="">
             <a:extLst xmlns:a="http://schemas.openxmlformats.org/drawingml/2006/main">
               <a:ext uri="{FF2B5EF4-FFF2-40B4-BE49-F238E27FC236}">
-                <a16:creationId xmlns:a16="http://schemas.microsoft.com/office/drawing/2014/main" id="{7A9F96FE-DB6C-4F56-B9AB-A1E6809A731C}"/>
+                <a16:creationId xmlns:a16="http://schemas.microsoft.com/office/drawing/2014/main" id="{457EF477-7EB8-410A-B750-C8E27EC30F32}"/>
               </a:ext>
             </a:extLst>
           </p:cNvPr>
@@ -2057,7 +2057,7 @@
           <p:cNvPr id="18" name="">
             <a:extLst xmlns:a="http://schemas.openxmlformats.org/drawingml/2006/main">
               <a:ext uri="{FF2B5EF4-FFF2-40B4-BE49-F238E27FC236}">
-                <a16:creationId xmlns:a16="http://schemas.microsoft.com/office/drawing/2014/main" id="{5465A2D1-ED85-48C4-A59F-3CCBE702EC32}"/>
+                <a16:creationId xmlns:a16="http://schemas.microsoft.com/office/drawing/2014/main" id="{43B996E2-7B09-4772-8C99-D9D5E8BFB011}"/>
               </a:ext>
             </a:extLst>
           </p:cNvPr>
@@ -2142,7 +2142,7 @@
           <p:cNvPr id="19" name="">
             <a:extLst xmlns:a="http://schemas.openxmlformats.org/drawingml/2006/main">
               <a:ext uri="{FF2B5EF4-FFF2-40B4-BE49-F238E27FC236}">
-                <a16:creationId xmlns:a16="http://schemas.microsoft.com/office/drawing/2014/main" id="{ADE4A140-9965-4892-8B09-FC816E431ADC}"/>
+                <a16:creationId xmlns:a16="http://schemas.microsoft.com/office/drawing/2014/main" id="{A447A6D0-936C-4751-BE7D-C22310508CEE}"/>
               </a:ext>
             </a:extLst>
           </p:cNvPr>
@@ -2227,7 +2227,7 @@
           <p:cNvPr id="20" name="">
             <a:extLst xmlns:a="http://schemas.openxmlformats.org/drawingml/2006/main">
               <a:ext uri="{FF2B5EF4-FFF2-40B4-BE49-F238E27FC236}">
-                <a16:creationId xmlns:a16="http://schemas.microsoft.com/office/drawing/2014/main" id="{C534BC60-5030-4D40-9071-8C91659E92D6}"/>
+                <a16:creationId xmlns:a16="http://schemas.microsoft.com/office/drawing/2014/main" id="{91A40A9C-90B0-414A-9343-5C4F693391D1}"/>
               </a:ext>
             </a:extLst>
           </p:cNvPr>
@@ -2261,7 +2261,7 @@
           <p:cNvPr id="21" name="">
             <a:extLst xmlns:a="http://schemas.openxmlformats.org/drawingml/2006/main">
               <a:ext uri="{FF2B5EF4-FFF2-40B4-BE49-F238E27FC236}">
-                <a16:creationId xmlns:a16="http://schemas.microsoft.com/office/drawing/2014/main" id="{4E9A7E7B-DBAE-4556-8D4B-FEF0C0D20D33}"/>
+                <a16:creationId xmlns:a16="http://schemas.microsoft.com/office/drawing/2014/main" id="{62B229DF-992A-412E-BAA6-D06300245FB3}"/>
               </a:ext>
             </a:extLst>
           </p:cNvPr>
@@ -2318,7 +2318,7 @@
           <p:cNvPr id="22" name="">
             <a:extLst xmlns:a="http://schemas.openxmlformats.org/drawingml/2006/main">
               <a:ext uri="{FF2B5EF4-FFF2-40B4-BE49-F238E27FC236}">
-                <a16:creationId xmlns:a16="http://schemas.microsoft.com/office/drawing/2014/main" id="{0FCFC611-52C2-4D33-A245-0308AD26F089}"/>
+                <a16:creationId xmlns:a16="http://schemas.microsoft.com/office/drawing/2014/main" id="{FD0AFA40-858C-4377-BD27-3F6DDB1EFBF0}"/>
               </a:ext>
             </a:extLst>
           </p:cNvPr>
@@ -2375,7 +2375,7 @@
           <p:cNvPr id="23" name="">
             <a:extLst xmlns:a="http://schemas.openxmlformats.org/drawingml/2006/main">
               <a:ext uri="{FF2B5EF4-FFF2-40B4-BE49-F238E27FC236}">
-                <a16:creationId xmlns:a16="http://schemas.microsoft.com/office/drawing/2014/main" id="{DE5B1BBC-5C96-4D12-B8AC-62551E27E6AB}"/>
+                <a16:creationId xmlns:a16="http://schemas.microsoft.com/office/drawing/2014/main" id="{E78B8CB3-1BA1-4B86-B701-8674A9624C9E}"/>
               </a:ext>
             </a:extLst>
           </p:cNvPr>
@@ -2432,7 +2432,7 @@
           <p:cNvPr id="24" name="">
             <a:extLst xmlns:a="http://schemas.openxmlformats.org/drawingml/2006/main">
               <a:ext uri="{FF2B5EF4-FFF2-40B4-BE49-F238E27FC236}">
-                <a16:creationId xmlns:a16="http://schemas.microsoft.com/office/drawing/2014/main" id="{C76D2E2B-4B61-406A-A3FA-38E9289C8A1E}"/>
+                <a16:creationId xmlns:a16="http://schemas.microsoft.com/office/drawing/2014/main" id="{A5C80422-6612-4407-AE7A-C0D4CDF73B5C}"/>
               </a:ext>
             </a:extLst>
           </p:cNvPr>
@@ -2444,11 +2444,11 @@
         <p:spPr>
           <a:xfrm xmlns:a="http://schemas.openxmlformats.org/drawingml/2006/main">
             <a:off x="304800" y="5391150"/>
-            <a:ext cx="9144000" cy="3314700"/>
+            <a:ext cx="9144000" cy="2705100"/>
           </a:xfrm>
           <a:prstGeom xmlns:a="http://schemas.openxmlformats.org/drawingml/2006/main" prst="roundRect">
             <a:avLst>
-              <a:gd name="adj" fmla="val 4023"/>
+              <a:gd name="adj" fmla="val 4930"/>
             </a:avLst>
           </a:prstGeom>
           <a:solidFill xmlns:a="http://schemas.openxmlformats.org/drawingml/2006/main">
@@ -2466,7 +2466,7 @@
           <p:cNvPr id="25" name="">
             <a:extLst xmlns:a="http://schemas.openxmlformats.org/drawingml/2006/main">
               <a:ext uri="{FF2B5EF4-FFF2-40B4-BE49-F238E27FC236}">
-                <a16:creationId xmlns:a16="http://schemas.microsoft.com/office/drawing/2014/main" id="{34421262-AF73-415E-B38D-243D6A105048}"/>
+                <a16:creationId xmlns:a16="http://schemas.microsoft.com/office/drawing/2014/main" id="{631F4924-7910-435D-A113-C69E3E5C8EAF}"/>
               </a:ext>
             </a:extLst>
           </p:cNvPr>
@@ -2498,7 +2498,7 @@
           <p:cNvPr id="26" name="">
             <a:extLst xmlns:a="http://schemas.openxmlformats.org/drawingml/2006/main">
               <a:ext uri="{FF2B5EF4-FFF2-40B4-BE49-F238E27FC236}">
-                <a16:creationId xmlns:a16="http://schemas.microsoft.com/office/drawing/2014/main" id="{2694DB42-FE26-4D8B-977D-F9D4469B104D}"/>
+                <a16:creationId xmlns:a16="http://schemas.microsoft.com/office/drawing/2014/main" id="{0BD990DC-6990-4881-8474-803EE31217B0}"/>
               </a:ext>
             </a:extLst>
           </p:cNvPr>
@@ -2555,7 +2555,7 @@
           <p:cNvPr id="27" name="">
             <a:extLst xmlns:a="http://schemas.openxmlformats.org/drawingml/2006/main">
               <a:ext uri="{FF2B5EF4-FFF2-40B4-BE49-F238E27FC236}">
-                <a16:creationId xmlns:a16="http://schemas.microsoft.com/office/drawing/2014/main" id="{3ED5CAAA-AF1B-4545-A7D8-431317A19BE0}"/>
+                <a16:creationId xmlns:a16="http://schemas.microsoft.com/office/drawing/2014/main" id="{B5E5B093-AD59-4417-94F0-035D27626EFB}"/>
               </a:ext>
             </a:extLst>
           </p:cNvPr>
@@ -2612,7 +2612,7 @@
           <p:cNvPr id="28" name="">
             <a:extLst xmlns:a="http://schemas.openxmlformats.org/drawingml/2006/main">
               <a:ext uri="{FF2B5EF4-FFF2-40B4-BE49-F238E27FC236}">
-                <a16:creationId xmlns:a16="http://schemas.microsoft.com/office/drawing/2014/main" id="{31807BB4-A898-44AD-A793-291F51BAAA8C}"/>
+                <a16:creationId xmlns:a16="http://schemas.microsoft.com/office/drawing/2014/main" id="{27155B97-C986-445C-BB46-0DEEB089FADD}"/>
               </a:ext>
             </a:extLst>
           </p:cNvPr>
@@ -2646,7 +2646,7 @@
           <p:cNvPr id="29" name="">
             <a:extLst xmlns:a="http://schemas.openxmlformats.org/drawingml/2006/main">
               <a:ext uri="{FF2B5EF4-FFF2-40B4-BE49-F238E27FC236}">
-                <a16:creationId xmlns:a16="http://schemas.microsoft.com/office/drawing/2014/main" id="{9F40DF52-F8F3-47BE-95E6-D35050D5355D}"/>
+                <a16:creationId xmlns:a16="http://schemas.microsoft.com/office/drawing/2014/main" id="{03B0C92E-9165-47BC-ABC0-69680BD4849B}"/>
               </a:ext>
             </a:extLst>
           </p:cNvPr>
@@ -2703,7 +2703,7 @@
           <p:cNvPr id="30" name="">
             <a:extLst xmlns:a="http://schemas.openxmlformats.org/drawingml/2006/main">
               <a:ext uri="{FF2B5EF4-FFF2-40B4-BE49-F238E27FC236}">
-                <a16:creationId xmlns:a16="http://schemas.microsoft.com/office/drawing/2014/main" id="{C6ACFDED-8299-4AE8-913C-EA140738CE69}"/>
+                <a16:creationId xmlns:a16="http://schemas.microsoft.com/office/drawing/2014/main" id="{22FADFE3-73F7-4EB5-834B-649F3322B9B3}"/>
               </a:ext>
             </a:extLst>
           </p:cNvPr>
@@ -2760,7 +2760,7 @@
           <p:cNvPr id="31" name="">
             <a:extLst xmlns:a="http://schemas.openxmlformats.org/drawingml/2006/main">
               <a:ext uri="{FF2B5EF4-FFF2-40B4-BE49-F238E27FC236}">
-                <a16:creationId xmlns:a16="http://schemas.microsoft.com/office/drawing/2014/main" id="{9769471A-61CB-45EE-9837-3A0024869FC1}"/>
+                <a16:creationId xmlns:a16="http://schemas.microsoft.com/office/drawing/2014/main" id="{4EBF5970-A726-4A87-BAE9-4D9293CC9209}"/>
               </a:ext>
             </a:extLst>
           </p:cNvPr>
@@ -2834,18 +2834,18 @@
           <p:cNvPr id="32" name="">
             <a:extLst xmlns:a="http://schemas.openxmlformats.org/drawingml/2006/main">
               <a:ext uri="{FF2B5EF4-FFF2-40B4-BE49-F238E27FC236}">
-                <a16:creationId xmlns:a16="http://schemas.microsoft.com/office/drawing/2014/main" id="{6E7DDAEB-4300-41FD-B8C9-B312A6957F24}"/>
-              </a:ext>
-            </a:extLst>
-          </p:cNvPr>
-          <p:cNvSpPr>
-            <a:spLocks xmlns:a="http://schemas.openxmlformats.org/drawingml/2006/main" noGrp="1"/>
-          </p:cNvSpPr>
-          <p:nvPr/>
-        </p:nvSpPr>
-        <p:spPr>
-          <a:xfrm xmlns:a="http://schemas.openxmlformats.org/drawingml/2006/main">
-            <a:off x="533400" y="7067550"/>
+                <a16:creationId xmlns:a16="http://schemas.microsoft.com/office/drawing/2014/main" id="{1AE29782-F9A5-4AEE-B6EB-12FE4CD16A8C}"/>
+              </a:ext>
+            </a:extLst>
+          </p:cNvPr>
+          <p:cNvSpPr>
+            <a:spLocks xmlns:a="http://schemas.openxmlformats.org/drawingml/2006/main" noGrp="1"/>
+          </p:cNvSpPr>
+          <p:nvPr/>
+        </p:nvSpPr>
+        <p:spPr>
+          <a:xfrm xmlns:a="http://schemas.openxmlformats.org/drawingml/2006/main">
+            <a:off x="533400" y="7219950"/>
             <a:ext cx="8686800" cy="228600"/>
           </a:xfrm>
           <a:prstGeom xmlns:a="http://schemas.openxmlformats.org/drawingml/2006/main" prst="rect">
@@ -2879,17 +2879,6 @@
               </a:defRPr>
             </a:pPr>
             <a:r>
-              <a:rPr sz="1500" b="0">
-                <a:solidFill>
-                  <a:srgbClr val="142D48"/>
-                </a:solidFill>
-                <a:latin typeface="Arial"/>
-                <a:ea typeface="Arial"/>
-                <a:cs typeface="Arial"/>
-              </a:rPr>
-              <a:t>Agregue </a:t>
-            </a:r>
-            <a:r>
               <a:rPr sz="1350" b="0">
                 <a:solidFill>
                   <a:srgbClr val="073C78"/>
@@ -2898,7 +2887,7 @@
                 <a:ea typeface="Consolas"/>
                 <a:cs typeface="Consolas"/>
               </a:rPr>
-              <a:t>--no-cache</a:t>
+              <a:t>--pendientes</a:t>
             </a:r>
             <a:r>
               <a:rPr sz="1500" b="0">
@@ -2909,7 +2898,7 @@
                 <a:ea typeface="Arial"/>
                 <a:cs typeface="Arial"/>
               </a:rPr>
-              <a:t> para volver a leer todos los DIPs.</a:t>
+              <a:t> deja ACTV sin DIP Open Audit User y</a:t>
             </a:r>
           </a:p>
         </p:txBody>
@@ -2919,7 +2908,7 @@
           <p:cNvPr id="33" name="">
             <a:extLst xmlns:a="http://schemas.openxmlformats.org/drawingml/2006/main">
               <a:ext uri="{FF2B5EF4-FFF2-40B4-BE49-F238E27FC236}">
-                <a16:creationId xmlns:a16="http://schemas.microsoft.com/office/drawing/2014/main" id="{CDBDFFB9-45A3-4813-9FAA-385321FD6C05}"/>
+                <a16:creationId xmlns:a16="http://schemas.microsoft.com/office/drawing/2014/main" id="{06DDA3BB-8A79-4F69-98F3-A0C58A83E52D}"/>
               </a:ext>
             </a:extLst>
           </p:cNvPr>
@@ -2964,17 +2953,6 @@
               </a:defRPr>
             </a:pPr>
             <a:r>
-              <a:rPr sz="1350" b="0">
-                <a:solidFill>
-                  <a:srgbClr val="073C78"/>
-                </a:solidFill>
-                <a:latin typeface="Consolas"/>
-                <a:ea typeface="Consolas"/>
-                <a:cs typeface="Consolas"/>
-              </a:rPr>
-              <a:t>--pendientes</a:t>
-            </a:r>
-            <a:r>
               <a:rPr sz="1500" b="0">
                 <a:solidFill>
                   <a:srgbClr val="142D48"/>
@@ -2983,29 +2961,7 @@
                 <a:ea typeface="Arial"/>
                 <a:cs typeface="Arial"/>
               </a:rPr>
-              <a:t> deja ACTV sin </a:t>
-            </a:r>
-            <a:r>
-              <a:rPr sz="1350" b="0">
-                <a:solidFill>
-                  <a:srgbClr val="073C78"/>
-                </a:solidFill>
-                <a:latin typeface="Consolas"/>
-                <a:ea typeface="Consolas"/>
-                <a:cs typeface="Consolas"/>
-              </a:rPr>
-              <a:t>DIP Open Audit User</a:t>
-            </a:r>
-            <a:r>
-              <a:rPr sz="1500" b="0">
-                <a:solidFill>
-                  <a:srgbClr val="142D48"/>
-                </a:solidFill>
-                <a:latin typeface="Arial"/>
-                <a:ea typeface="Arial"/>
-                <a:cs typeface="Arial"/>
-              </a:rPr>
-              <a:t> y</a:t>
+              <a:t>COMPLETE sin DIP Closed Audit User. Quite la opción para auditar todos.</a:t>
             </a:r>
           </a:p>
         </p:txBody>
@@ -3015,7 +2971,7 @@
           <p:cNvPr id="34" name="">
             <a:extLst xmlns:a="http://schemas.openxmlformats.org/drawingml/2006/main">
               <a:ext uri="{FF2B5EF4-FFF2-40B4-BE49-F238E27FC236}">
-                <a16:creationId xmlns:a16="http://schemas.microsoft.com/office/drawing/2014/main" id="{441E7CBF-6162-4924-AB99-9A1801D1A1B5}"/>
+                <a16:creationId xmlns:a16="http://schemas.microsoft.com/office/drawing/2014/main" id="{C8F396D7-4C97-4ED3-84B4-C8A2A981F555}"/>
               </a:ext>
             </a:extLst>
           </p:cNvPr>
@@ -3068,7 +3024,7 @@
                 <a:ea typeface="Arial"/>
                 <a:cs typeface="Arial"/>
               </a:rPr>
-              <a:t>COMPLETE sin </a:t>
+              <a:t>Crea una copia </a:t>
             </a:r>
             <a:r>
               <a:rPr sz="1350" b="0">
@@ -3079,7 +3035,7 @@
                 <a:ea typeface="Consolas"/>
                 <a:cs typeface="Consolas"/>
               </a:rPr>
-              <a:t>DIP Closed Audit User</a:t>
+              <a:t>FILTERED.xlsx</a:t>
             </a:r>
             <a:r>
               <a:rPr sz="1500" b="0">
@@ -3090,7 +3046,7 @@
                 <a:ea typeface="Arial"/>
                 <a:cs typeface="Arial"/>
               </a:rPr>
-              <a:t>. Quite la opción para auditar todos.</a:t>
+              <a:t> junto al archivo original.</a:t>
             </a:r>
           </a:p>
         </p:txBody>
@@ -3100,18 +3056,198 @@
           <p:cNvPr id="35" name="">
             <a:extLst xmlns:a="http://schemas.openxmlformats.org/drawingml/2006/main">
               <a:ext uri="{FF2B5EF4-FFF2-40B4-BE49-F238E27FC236}">
-                <a16:creationId xmlns:a16="http://schemas.microsoft.com/office/drawing/2014/main" id="{17332B80-7953-4FAD-9E08-BA9898CB1421}"/>
-              </a:ext>
-            </a:extLst>
-          </p:cNvPr>
-          <p:cNvSpPr>
-            <a:spLocks xmlns:a="http://schemas.openxmlformats.org/drawingml/2006/main" noGrp="1"/>
-          </p:cNvSpPr>
-          <p:nvPr/>
-        </p:nvSpPr>
-        <p:spPr>
-          <a:xfrm xmlns:a="http://schemas.openxmlformats.org/drawingml/2006/main">
-            <a:off x="533400" y="8058150"/>
+                <a16:creationId xmlns:a16="http://schemas.microsoft.com/office/drawing/2014/main" id="{16A1E759-9EF4-4BAC-834B-0BCD475D2270}"/>
+              </a:ext>
+            </a:extLst>
+          </p:cNvPr>
+          <p:cNvSpPr>
+            <a:spLocks xmlns:a="http://schemas.openxmlformats.org/drawingml/2006/main" noGrp="1"/>
+          </p:cNvSpPr>
+          <p:nvPr/>
+        </p:nvSpPr>
+        <p:spPr>
+          <a:xfrm xmlns:a="http://schemas.openxmlformats.org/drawingml/2006/main">
+            <a:off x="304800" y="8324850"/>
+            <a:ext cx="9144000" cy="2705100"/>
+          </a:xfrm>
+          <a:prstGeom xmlns:a="http://schemas.openxmlformats.org/drawingml/2006/main" prst="roundRect">
+            <a:avLst>
+              <a:gd name="adj" fmla="val 4930"/>
+            </a:avLst>
+          </a:prstGeom>
+          <a:solidFill xmlns:a="http://schemas.openxmlformats.org/drawingml/2006/main">
+            <a:srgbClr val="FFFFFF"/>
+          </a:solidFill>
+          <a:ln xmlns:a="http://schemas.openxmlformats.org/drawingml/2006/main" w="9525">
+            <a:solidFill>
+              <a:srgbClr val="ADD0E8"/>
+            </a:solidFill>
+          </a:ln>
+        </p:spPr>
+      </p:sp>
+      <p:sp>
+        <p:nvSpPr>
+          <p:cNvPr id="36" name="">
+            <a:extLst xmlns:a="http://schemas.openxmlformats.org/drawingml/2006/main">
+              <a:ext uri="{FF2B5EF4-FFF2-40B4-BE49-F238E27FC236}">
+                <a16:creationId xmlns:a16="http://schemas.microsoft.com/office/drawing/2014/main" id="{F7048897-F14B-4BBF-B069-299AA93F3AA3}"/>
+              </a:ext>
+            </a:extLst>
+          </p:cNvPr>
+          <p:cNvSpPr>
+            <a:spLocks xmlns:a="http://schemas.openxmlformats.org/drawingml/2006/main" noGrp="1"/>
+          </p:cNvSpPr>
+          <p:nvPr/>
+        </p:nvSpPr>
+        <p:spPr>
+          <a:xfrm xmlns:a="http://schemas.openxmlformats.org/drawingml/2006/main">
+            <a:off x="304800" y="8324850"/>
+            <a:ext cx="9144000" cy="457200"/>
+          </a:xfrm>
+          <a:prstGeom xmlns:a="http://schemas.openxmlformats.org/drawingml/2006/main" prst="roundRect">
+            <a:avLst>
+              <a:gd name="adj" fmla="val 29167"/>
+            </a:avLst>
+          </a:prstGeom>
+          <a:solidFill xmlns:a="http://schemas.openxmlformats.org/drawingml/2006/main">
+            <a:srgbClr val="006BBE"/>
+          </a:solidFill>
+          <a:ln xmlns:a="http://schemas.openxmlformats.org/drawingml/2006/main" w="0">
+            <a:noFill/>
+          </a:ln>
+        </p:spPr>
+      </p:sp>
+      <p:sp>
+        <p:nvSpPr>
+          <p:cNvPr id="37" name="">
+            <a:extLst xmlns:a="http://schemas.openxmlformats.org/drawingml/2006/main">
+              <a:ext uri="{FF2B5EF4-FFF2-40B4-BE49-F238E27FC236}">
+                <a16:creationId xmlns:a16="http://schemas.microsoft.com/office/drawing/2014/main" id="{5915FD33-7E83-47B2-A0C6-67B1A1D8CA79}"/>
+              </a:ext>
+            </a:extLst>
+          </p:cNvPr>
+          <p:cNvSpPr>
+            <a:spLocks xmlns:a="http://schemas.openxmlformats.org/drawingml/2006/main" noGrp="1"/>
+          </p:cNvSpPr>
+          <p:nvPr/>
+        </p:nvSpPr>
+        <p:spPr>
+          <a:xfrm xmlns:a="http://schemas.openxmlformats.org/drawingml/2006/main">
+            <a:off x="533400" y="8420100"/>
+            <a:ext cx="323850" cy="323850"/>
+          </a:xfrm>
+          <a:prstGeom xmlns:a="http://schemas.openxmlformats.org/drawingml/2006/main" prst="rect">
+            <a:avLst/>
+          </a:prstGeom>
+          <a:noFill xmlns:a="http://schemas.openxmlformats.org/drawingml/2006/main"/>
+          <a:ln xmlns:a="http://schemas.openxmlformats.org/drawingml/2006/main" w="0">
+            <a:noFill/>
+          </a:ln>
+        </p:spPr>
+        <p:txBody>
+          <a:bodyPr xmlns:a="http://schemas.openxmlformats.org/drawingml/2006/main" wrap="none" lIns="0" tIns="0" rIns="0" bIns="0" anchor="t">
+            <a:noAutofit/>
+          </a:bodyPr>
+          <a:lstStyle xmlns:a="http://schemas.openxmlformats.org/drawingml/2006/main"/>
+          <a:p xmlns:a="http://schemas.openxmlformats.org/drawingml/2006/main">
+            <a:pPr>
+              <a:defRPr sz="2025" b="1">
+                <a:solidFill>
+                  <a:srgbClr val="FFFFFF"/>
+                </a:solidFill>
+                <a:latin typeface="Arial"/>
+                <a:ea typeface="Arial"/>
+                <a:cs typeface="Arial"/>
+              </a:defRPr>
+            </a:pPr>
+            <a:r>
+              <a:rPr sz="2025" b="1">
+                <a:solidFill>
+                  <a:srgbClr val="FFFFFF"/>
+                </a:solidFill>
+                <a:latin typeface="Arial"/>
+                <a:ea typeface="Arial"/>
+                <a:cs typeface="Arial"/>
+              </a:rPr>
+              <a:t>3</a:t>
+            </a:r>
+          </a:p>
+        </p:txBody>
+      </p:sp>
+      <p:sp>
+        <p:nvSpPr>
+          <p:cNvPr id="38" name="">
+            <a:extLst xmlns:a="http://schemas.openxmlformats.org/drawingml/2006/main">
+              <a:ext uri="{FF2B5EF4-FFF2-40B4-BE49-F238E27FC236}">
+                <a16:creationId xmlns:a16="http://schemas.microsoft.com/office/drawing/2014/main" id="{0D1147BB-F3B0-4D7E-AD1B-8F511FE6C2A9}"/>
+              </a:ext>
+            </a:extLst>
+          </p:cNvPr>
+          <p:cNvSpPr>
+            <a:spLocks xmlns:a="http://schemas.openxmlformats.org/drawingml/2006/main" noGrp="1"/>
+          </p:cNvSpPr>
+          <p:nvPr/>
+        </p:nvSpPr>
+        <p:spPr>
+          <a:xfrm xmlns:a="http://schemas.openxmlformats.org/drawingml/2006/main">
+            <a:off x="933450" y="8448675"/>
+            <a:ext cx="8286750" cy="276225"/>
+          </a:xfrm>
+          <a:prstGeom xmlns:a="http://schemas.openxmlformats.org/drawingml/2006/main" prst="rect">
+            <a:avLst/>
+          </a:prstGeom>
+          <a:noFill xmlns:a="http://schemas.openxmlformats.org/drawingml/2006/main"/>
+          <a:ln xmlns:a="http://schemas.openxmlformats.org/drawingml/2006/main" w="0">
+            <a:noFill/>
+          </a:ln>
+        </p:spPr>
+        <p:txBody>
+          <a:bodyPr xmlns:a="http://schemas.openxmlformats.org/drawingml/2006/main" wrap="none" lIns="0" tIns="0" rIns="0" bIns="0" anchor="t">
+            <a:noAutofit/>
+          </a:bodyPr>
+          <a:lstStyle xmlns:a="http://schemas.openxmlformats.org/drawingml/2006/main"/>
+          <a:p xmlns:a="http://schemas.openxmlformats.org/drawingml/2006/main">
+            <a:pPr>
+              <a:defRPr sz="1650" b="1">
+                <a:solidFill>
+                  <a:srgbClr val="FFFFFF"/>
+                </a:solidFill>
+                <a:latin typeface="Arial"/>
+                <a:ea typeface="Arial"/>
+                <a:cs typeface="Arial"/>
+              </a:defRPr>
+            </a:pPr>
+            <a:r>
+              <a:rPr sz="1650" b="1">
+                <a:solidFill>
+                  <a:srgbClr val="FFFFFF"/>
+                </a:solidFill>
+                <a:latin typeface="Arial"/>
+                <a:ea typeface="Arial"/>
+                <a:cs typeface="Arial"/>
+              </a:rPr>
+              <a:t>CONSULTA POR BARCODE</a:t>
+            </a:r>
+          </a:p>
+        </p:txBody>
+      </p:sp>
+      <p:sp>
+        <p:nvSpPr>
+          <p:cNvPr id="39" name="">
+            <a:extLst xmlns:a="http://schemas.openxmlformats.org/drawingml/2006/main">
+              <a:ext uri="{FF2B5EF4-FFF2-40B4-BE49-F238E27FC236}">
+                <a16:creationId xmlns:a16="http://schemas.microsoft.com/office/drawing/2014/main" id="{023071D4-9D2E-43F6-B875-0527A1124B9E}"/>
+              </a:ext>
+            </a:extLst>
+          </p:cNvPr>
+          <p:cNvSpPr>
+            <a:spLocks xmlns:a="http://schemas.openxmlformats.org/drawingml/2006/main" noGrp="1"/>
+          </p:cNvSpPr>
+          <p:nvPr/>
+        </p:nvSpPr>
+        <p:spPr>
+          <a:xfrm xmlns:a="http://schemas.openxmlformats.org/drawingml/2006/main">
+            <a:off x="533400" y="8972550"/>
             <a:ext cx="8686800" cy="228600"/>
           </a:xfrm>
           <a:prstGeom xmlns:a="http://schemas.openxmlformats.org/drawingml/2006/main" prst="rect">
@@ -3153,50 +3289,28 @@
                 <a:ea typeface="Arial"/>
                 <a:cs typeface="Arial"/>
               </a:rPr>
-              <a:t>Crea una copia </a:t>
-            </a:r>
-            <a:r>
-              <a:rPr sz="1350" b="0">
-                <a:solidFill>
-                  <a:srgbClr val="073C78"/>
-                </a:solidFill>
-                <a:latin typeface="Consolas"/>
-                <a:ea typeface="Consolas"/>
-                <a:cs typeface="Consolas"/>
-              </a:rPr>
-              <a:t>FILTERED.xlsx</a:t>
-            </a:r>
-            <a:r>
-              <a:rPr sz="1500" b="0">
-                <a:solidFill>
-                  <a:srgbClr val="142D48"/>
-                </a:solidFill>
-                <a:latin typeface="Arial"/>
-                <a:ea typeface="Arial"/>
-                <a:cs typeface="Arial"/>
-              </a:rPr>
-              <a:t> junto al archivo original.</a:t>
-            </a:r>
-          </a:p>
-        </p:txBody>
-      </p:sp>
-      <p:sp>
-        <p:nvSpPr>
-          <p:cNvPr id="36" name="">
-            <a:extLst xmlns:a="http://schemas.openxmlformats.org/drawingml/2006/main">
-              <a:ext uri="{FF2B5EF4-FFF2-40B4-BE49-F238E27FC236}">
-                <a16:creationId xmlns:a16="http://schemas.microsoft.com/office/drawing/2014/main" id="{1B75EA88-F2B0-47F0-8FB8-445DFDC5785A}"/>
-              </a:ext>
-            </a:extLst>
-          </p:cNvPr>
-          <p:cNvSpPr>
-            <a:spLocks xmlns:a="http://schemas.openxmlformats.org/drawingml/2006/main" noGrp="1"/>
-          </p:cNvSpPr>
-          <p:nvPr/>
-        </p:nvSpPr>
-        <p:spPr>
-          <a:xfrm xmlns:a="http://schemas.openxmlformats.org/drawingml/2006/main">
-            <a:off x="533400" y="8286750"/>
+              <a:t>Consulte un DIP en ICAM sin cargar un Excel.</a:t>
+            </a:r>
+          </a:p>
+        </p:txBody>
+      </p:sp>
+      <p:sp>
+        <p:nvSpPr>
+          <p:cNvPr id="40" name="">
+            <a:extLst xmlns:a="http://schemas.openxmlformats.org/drawingml/2006/main">
+              <a:ext uri="{FF2B5EF4-FFF2-40B4-BE49-F238E27FC236}">
+                <a16:creationId xmlns:a16="http://schemas.microsoft.com/office/drawing/2014/main" id="{DE05FCB9-A5C8-4003-BA58-1231D33D9FC1}"/>
+              </a:ext>
+            </a:extLst>
+          </p:cNvPr>
+          <p:cNvSpPr>
+            <a:spLocks xmlns:a="http://schemas.openxmlformats.org/drawingml/2006/main" noGrp="1"/>
+          </p:cNvSpPr>
+          <p:nvPr/>
+        </p:nvSpPr>
+        <p:spPr>
+          <a:xfrm xmlns:a="http://schemas.openxmlformats.org/drawingml/2006/main">
+            <a:off x="533400" y="9201150"/>
             <a:ext cx="8686800" cy="228600"/>
           </a:xfrm>
           <a:prstGeom xmlns:a="http://schemas.openxmlformats.org/drawingml/2006/main" prst="rect">
@@ -3238,213 +3352,33 @@
                 <a:ea typeface="Arial"/>
                 <a:cs typeface="Arial"/>
               </a:rPr>
-              <a:t>Las lecturas de ICAM de la última hora pueden reutilizarse.</a:t>
-            </a:r>
-          </a:p>
-        </p:txBody>
-      </p:sp>
-      <p:sp>
-        <p:nvSpPr>
-          <p:cNvPr id="37" name="">
-            <a:extLst xmlns:a="http://schemas.openxmlformats.org/drawingml/2006/main">
-              <a:ext uri="{FF2B5EF4-FFF2-40B4-BE49-F238E27FC236}">
-                <a16:creationId xmlns:a16="http://schemas.microsoft.com/office/drawing/2014/main" id="{4615B768-FA4D-454D-AF01-F8F4435B5BE6}"/>
-              </a:ext>
-            </a:extLst>
-          </p:cNvPr>
-          <p:cNvSpPr>
-            <a:spLocks xmlns:a="http://schemas.openxmlformats.org/drawingml/2006/main" noGrp="1"/>
-          </p:cNvSpPr>
-          <p:nvPr/>
-        </p:nvSpPr>
-        <p:spPr>
-          <a:xfrm xmlns:a="http://schemas.openxmlformats.org/drawingml/2006/main">
-            <a:off x="304800" y="8934450"/>
-            <a:ext cx="9144000" cy="2781300"/>
+              <a:t>Sustituya el barcode de ejemplo por el barcode real.</a:t>
+            </a:r>
+          </a:p>
+        </p:txBody>
+      </p:sp>
+      <p:sp>
+        <p:nvSpPr>
+          <p:cNvPr id="41" name="">
+            <a:extLst xmlns:a="http://schemas.openxmlformats.org/drawingml/2006/main">
+              <a:ext uri="{FF2B5EF4-FFF2-40B4-BE49-F238E27FC236}">
+                <a16:creationId xmlns:a16="http://schemas.microsoft.com/office/drawing/2014/main" id="{E741B29F-AE21-4034-82C6-D5B6AAD54074}"/>
+              </a:ext>
+            </a:extLst>
+          </p:cNvPr>
+          <p:cNvSpPr>
+            <a:spLocks xmlns:a="http://schemas.openxmlformats.org/drawingml/2006/main" noGrp="1"/>
+          </p:cNvSpPr>
+          <p:nvPr/>
+        </p:nvSpPr>
+        <p:spPr>
+          <a:xfrm xmlns:a="http://schemas.openxmlformats.org/drawingml/2006/main">
+            <a:off x="533400" y="9582150"/>
+            <a:ext cx="8686800" cy="647700"/>
           </a:xfrm>
           <a:prstGeom xmlns:a="http://schemas.openxmlformats.org/drawingml/2006/main" prst="roundRect">
             <a:avLst>
-              <a:gd name="adj" fmla="val 4795"/>
-            </a:avLst>
-          </a:prstGeom>
-          <a:solidFill xmlns:a="http://schemas.openxmlformats.org/drawingml/2006/main">
-            <a:srgbClr val="FFFFFF"/>
-          </a:solidFill>
-          <a:ln xmlns:a="http://schemas.openxmlformats.org/drawingml/2006/main" w="9525">
-            <a:solidFill>
-              <a:srgbClr val="ADD0E8"/>
-            </a:solidFill>
-          </a:ln>
-        </p:spPr>
-      </p:sp>
-      <p:sp>
-        <p:nvSpPr>
-          <p:cNvPr id="38" name="">
-            <a:extLst xmlns:a="http://schemas.openxmlformats.org/drawingml/2006/main">
-              <a:ext uri="{FF2B5EF4-FFF2-40B4-BE49-F238E27FC236}">
-                <a16:creationId xmlns:a16="http://schemas.microsoft.com/office/drawing/2014/main" id="{7FE16594-7148-4BF9-86EE-601F3DFC8AC5}"/>
-              </a:ext>
-            </a:extLst>
-          </p:cNvPr>
-          <p:cNvSpPr>
-            <a:spLocks xmlns:a="http://schemas.openxmlformats.org/drawingml/2006/main" noGrp="1"/>
-          </p:cNvSpPr>
-          <p:nvPr/>
-        </p:nvSpPr>
-        <p:spPr>
-          <a:xfrm xmlns:a="http://schemas.openxmlformats.org/drawingml/2006/main">
-            <a:off x="304800" y="8934450"/>
-            <a:ext cx="9144000" cy="457200"/>
-          </a:xfrm>
-          <a:prstGeom xmlns:a="http://schemas.openxmlformats.org/drawingml/2006/main" prst="roundRect">
-            <a:avLst>
-              <a:gd name="adj" fmla="val 29167"/>
-            </a:avLst>
-          </a:prstGeom>
-          <a:solidFill xmlns:a="http://schemas.openxmlformats.org/drawingml/2006/main">
-            <a:srgbClr val="006BBE"/>
-          </a:solidFill>
-          <a:ln xmlns:a="http://schemas.openxmlformats.org/drawingml/2006/main" w="0">
-            <a:noFill/>
-          </a:ln>
-        </p:spPr>
-      </p:sp>
-      <p:sp>
-        <p:nvSpPr>
-          <p:cNvPr id="39" name="">
-            <a:extLst xmlns:a="http://schemas.openxmlformats.org/drawingml/2006/main">
-              <a:ext uri="{FF2B5EF4-FFF2-40B4-BE49-F238E27FC236}">
-                <a16:creationId xmlns:a16="http://schemas.microsoft.com/office/drawing/2014/main" id="{9BA4FB4B-3212-4A98-84FB-4D62B808F2F9}"/>
-              </a:ext>
-            </a:extLst>
-          </p:cNvPr>
-          <p:cNvSpPr>
-            <a:spLocks xmlns:a="http://schemas.openxmlformats.org/drawingml/2006/main" noGrp="1"/>
-          </p:cNvSpPr>
-          <p:nvPr/>
-        </p:nvSpPr>
-        <p:spPr>
-          <a:xfrm xmlns:a="http://schemas.openxmlformats.org/drawingml/2006/main">
-            <a:off x="533400" y="9029700"/>
-            <a:ext cx="323850" cy="323850"/>
-          </a:xfrm>
-          <a:prstGeom xmlns:a="http://schemas.openxmlformats.org/drawingml/2006/main" prst="rect">
-            <a:avLst/>
-          </a:prstGeom>
-          <a:noFill xmlns:a="http://schemas.openxmlformats.org/drawingml/2006/main"/>
-          <a:ln xmlns:a="http://schemas.openxmlformats.org/drawingml/2006/main" w="0">
-            <a:noFill/>
-          </a:ln>
-        </p:spPr>
-        <p:txBody>
-          <a:bodyPr xmlns:a="http://schemas.openxmlformats.org/drawingml/2006/main" wrap="none" lIns="0" tIns="0" rIns="0" bIns="0" anchor="t">
-            <a:noAutofit/>
-          </a:bodyPr>
-          <a:lstStyle xmlns:a="http://schemas.openxmlformats.org/drawingml/2006/main"/>
-          <a:p xmlns:a="http://schemas.openxmlformats.org/drawingml/2006/main">
-            <a:pPr>
-              <a:defRPr sz="2025" b="1">
-                <a:solidFill>
-                  <a:srgbClr val="FFFFFF"/>
-                </a:solidFill>
-                <a:latin typeface="Arial"/>
-                <a:ea typeface="Arial"/>
-                <a:cs typeface="Arial"/>
-              </a:defRPr>
-            </a:pPr>
-            <a:r>
-              <a:rPr sz="2025" b="1">
-                <a:solidFill>
-                  <a:srgbClr val="FFFFFF"/>
-                </a:solidFill>
-                <a:latin typeface="Arial"/>
-                <a:ea typeface="Arial"/>
-                <a:cs typeface="Arial"/>
-              </a:rPr>
-              <a:t>3</a:t>
-            </a:r>
-          </a:p>
-        </p:txBody>
-      </p:sp>
-      <p:sp>
-        <p:nvSpPr>
-          <p:cNvPr id="40" name="">
-            <a:extLst xmlns:a="http://schemas.openxmlformats.org/drawingml/2006/main">
-              <a:ext uri="{FF2B5EF4-FFF2-40B4-BE49-F238E27FC236}">
-                <a16:creationId xmlns:a16="http://schemas.microsoft.com/office/drawing/2014/main" id="{43FB390B-5218-4236-8370-6CD45910BCEE}"/>
-              </a:ext>
-            </a:extLst>
-          </p:cNvPr>
-          <p:cNvSpPr>
-            <a:spLocks xmlns:a="http://schemas.openxmlformats.org/drawingml/2006/main" noGrp="1"/>
-          </p:cNvSpPr>
-          <p:nvPr/>
-        </p:nvSpPr>
-        <p:spPr>
-          <a:xfrm xmlns:a="http://schemas.openxmlformats.org/drawingml/2006/main">
-            <a:off x="933450" y="9058275"/>
-            <a:ext cx="8286750" cy="276225"/>
-          </a:xfrm>
-          <a:prstGeom xmlns:a="http://schemas.openxmlformats.org/drawingml/2006/main" prst="rect">
-            <a:avLst/>
-          </a:prstGeom>
-          <a:noFill xmlns:a="http://schemas.openxmlformats.org/drawingml/2006/main"/>
-          <a:ln xmlns:a="http://schemas.openxmlformats.org/drawingml/2006/main" w="0">
-            <a:noFill/>
-          </a:ln>
-        </p:spPr>
-        <p:txBody>
-          <a:bodyPr xmlns:a="http://schemas.openxmlformats.org/drawingml/2006/main" wrap="none" lIns="0" tIns="0" rIns="0" bIns="0" anchor="t">
-            <a:noAutofit/>
-          </a:bodyPr>
-          <a:lstStyle xmlns:a="http://schemas.openxmlformats.org/drawingml/2006/main"/>
-          <a:p xmlns:a="http://schemas.openxmlformats.org/drawingml/2006/main">
-            <a:pPr>
-              <a:defRPr sz="1650" b="1">
-                <a:solidFill>
-                  <a:srgbClr val="FFFFFF"/>
-                </a:solidFill>
-                <a:latin typeface="Arial"/>
-                <a:ea typeface="Arial"/>
-                <a:cs typeface="Arial"/>
-              </a:defRPr>
-            </a:pPr>
-            <a:r>
-              <a:rPr sz="1650" b="1">
-                <a:solidFill>
-                  <a:srgbClr val="FFFFFF"/>
-                </a:solidFill>
-                <a:latin typeface="Arial"/>
-                <a:ea typeface="Arial"/>
-                <a:cs typeface="Arial"/>
-              </a:rPr>
-              <a:t>OTRAS FUNCIONES</a:t>
-            </a:r>
-          </a:p>
-        </p:txBody>
-      </p:sp>
-      <p:sp>
-        <p:nvSpPr>
-          <p:cNvPr id="41" name="">
-            <a:extLst xmlns:a="http://schemas.openxmlformats.org/drawingml/2006/main">
-              <a:ext uri="{FF2B5EF4-FFF2-40B4-BE49-F238E27FC236}">
-                <a16:creationId xmlns:a16="http://schemas.microsoft.com/office/drawing/2014/main" id="{55552A33-3E3C-4035-8249-E9CE66AE79C7}"/>
-              </a:ext>
-            </a:extLst>
-          </p:cNvPr>
-          <p:cNvSpPr>
-            <a:spLocks xmlns:a="http://schemas.openxmlformats.org/drawingml/2006/main" noGrp="1"/>
-          </p:cNvSpPr>
-          <p:nvPr/>
-        </p:nvSpPr>
-        <p:spPr>
-          <a:xfrm xmlns:a="http://schemas.openxmlformats.org/drawingml/2006/main">
-            <a:off x="533400" y="9582150"/>
-            <a:ext cx="8686800" cy="1066800"/>
-          </a:xfrm>
-          <a:prstGeom xmlns:a="http://schemas.openxmlformats.org/drawingml/2006/main" prst="roundRect">
-            <a:avLst>
-              <a:gd name="adj" fmla="val 5357"/>
+              <a:gd name="adj" fmla="val 8824"/>
             </a:avLst>
           </a:prstGeom>
           <a:solidFill xmlns:a="http://schemas.openxmlformats.org/drawingml/2006/main">
@@ -3462,7 +3396,7 @@
           <p:cNvPr id="42" name="">
             <a:extLst xmlns:a="http://schemas.openxmlformats.org/drawingml/2006/main">
               <a:ext uri="{FF2B5EF4-FFF2-40B4-BE49-F238E27FC236}">
-                <a16:creationId xmlns:a16="http://schemas.microsoft.com/office/drawing/2014/main" id="{9BE7CF7B-EC7D-4FBF-B77D-7551FF941130}"/>
+                <a16:creationId xmlns:a16="http://schemas.microsoft.com/office/drawing/2014/main" id="{A109FB56-A320-4FFC-B8BF-B29A2C5DA6FC}"/>
               </a:ext>
             </a:extLst>
           </p:cNvPr>
@@ -3519,7 +3453,7 @@
           <p:cNvPr id="43" name="">
             <a:extLst xmlns:a="http://schemas.openxmlformats.org/drawingml/2006/main">
               <a:ext uri="{FF2B5EF4-FFF2-40B4-BE49-F238E27FC236}">
-                <a16:creationId xmlns:a16="http://schemas.microsoft.com/office/drawing/2014/main" id="{177A346C-D80D-4054-9061-F4F862BC450D}"/>
+                <a16:creationId xmlns:a16="http://schemas.microsoft.com/office/drawing/2014/main" id="{54D23A8A-FB69-4ECC-8886-2F065FFE5EB8}"/>
               </a:ext>
             </a:extLst>
           </p:cNvPr>
@@ -3576,132 +3510,18 @@
           <p:cNvPr id="44" name="">
             <a:extLst xmlns:a="http://schemas.openxmlformats.org/drawingml/2006/main">
               <a:ext uri="{FF2B5EF4-FFF2-40B4-BE49-F238E27FC236}">
-                <a16:creationId xmlns:a16="http://schemas.microsoft.com/office/drawing/2014/main" id="{FBD81843-0609-4956-9DCA-672878A7C9FD}"/>
-              </a:ext>
-            </a:extLst>
-          </p:cNvPr>
-          <p:cNvSpPr>
-            <a:spLocks xmlns:a="http://schemas.openxmlformats.org/drawingml/2006/main" noGrp="1"/>
-          </p:cNvSpPr>
-          <p:nvPr/>
-        </p:nvSpPr>
-        <p:spPr>
-          <a:xfrm xmlns:a="http://schemas.openxmlformats.org/drawingml/2006/main">
-            <a:off x="704850" y="10115550"/>
-            <a:ext cx="8343900" cy="209550"/>
-          </a:xfrm>
-          <a:prstGeom xmlns:a="http://schemas.openxmlformats.org/drawingml/2006/main" prst="rect">
-            <a:avLst/>
-          </a:prstGeom>
-          <a:noFill xmlns:a="http://schemas.openxmlformats.org/drawingml/2006/main"/>
-          <a:ln xmlns:a="http://schemas.openxmlformats.org/drawingml/2006/main" w="0">
-            <a:noFill/>
-          </a:ln>
-        </p:spPr>
-        <p:txBody>
-          <a:bodyPr xmlns:a="http://schemas.openxmlformats.org/drawingml/2006/main" wrap="none" lIns="0" tIns="0" rIns="0" bIns="0" anchor="t">
-            <a:noAutofit/>
-          </a:bodyPr>
-          <a:lstStyle xmlns:a="http://schemas.openxmlformats.org/drawingml/2006/main"/>
-          <a:p xmlns:a="http://schemas.openxmlformats.org/drawingml/2006/main">
-            <a:pPr>
-              <a:defRPr sz="1350" b="0">
-                <a:solidFill>
-                  <a:srgbClr val="142D48"/>
-                </a:solidFill>
-                <a:latin typeface="Consolas"/>
-                <a:ea typeface="Consolas"/>
-                <a:cs typeface="Consolas"/>
-              </a:defRPr>
-            </a:pPr>
-            <a:r>
-              <a:rPr sz="1350" b="0">
-                <a:solidFill>
-                  <a:srgbClr val="142D48"/>
-                </a:solidFill>
-                <a:latin typeface="Consolas"/>
-                <a:ea typeface="Consolas"/>
-                <a:cs typeface="Consolas"/>
-              </a:rPr>
-              <a:t>$ .\filtrar.bat "entrada.xlsx"</a:t>
-            </a:r>
-          </a:p>
-        </p:txBody>
-      </p:sp>
-      <p:sp>
-        <p:nvSpPr>
-          <p:cNvPr id="45" name="">
-            <a:extLst xmlns:a="http://schemas.openxmlformats.org/drawingml/2006/main">
-              <a:ext uri="{FF2B5EF4-FFF2-40B4-BE49-F238E27FC236}">
-                <a16:creationId xmlns:a16="http://schemas.microsoft.com/office/drawing/2014/main" id="{31F2B103-8604-4633-BDED-9F89DC079152}"/>
-              </a:ext>
-            </a:extLst>
-          </p:cNvPr>
-          <p:cNvSpPr>
-            <a:spLocks xmlns:a="http://schemas.openxmlformats.org/drawingml/2006/main" noGrp="1"/>
-          </p:cNvSpPr>
-          <p:nvPr/>
-        </p:nvSpPr>
-        <p:spPr>
-          <a:xfrm xmlns:a="http://schemas.openxmlformats.org/drawingml/2006/main">
-            <a:off x="704850" y="10325100"/>
-            <a:ext cx="8343900" cy="209550"/>
-          </a:xfrm>
-          <a:prstGeom xmlns:a="http://schemas.openxmlformats.org/drawingml/2006/main" prst="rect">
-            <a:avLst/>
-          </a:prstGeom>
-          <a:noFill xmlns:a="http://schemas.openxmlformats.org/drawingml/2006/main"/>
-          <a:ln xmlns:a="http://schemas.openxmlformats.org/drawingml/2006/main" w="0">
-            <a:noFill/>
-          </a:ln>
-        </p:spPr>
-        <p:txBody>
-          <a:bodyPr xmlns:a="http://schemas.openxmlformats.org/drawingml/2006/main" wrap="none" lIns="0" tIns="0" rIns="0" bIns="0" anchor="t">
-            <a:noAutofit/>
-          </a:bodyPr>
-          <a:lstStyle xmlns:a="http://schemas.openxmlformats.org/drawingml/2006/main"/>
-          <a:p xmlns:a="http://schemas.openxmlformats.org/drawingml/2006/main">
-            <a:pPr>
-              <a:defRPr sz="1350" b="0">
-                <a:solidFill>
-                  <a:srgbClr val="142D48"/>
-                </a:solidFill>
-                <a:latin typeface="Consolas"/>
-                <a:ea typeface="Consolas"/>
-                <a:cs typeface="Consolas"/>
-              </a:defRPr>
-            </a:pPr>
-            <a:r>
-              <a:rPr sz="1350" b="0">
-                <a:solidFill>
-                  <a:srgbClr val="142D48"/>
-                </a:solidFill>
-                <a:latin typeface="Consolas"/>
-                <a:ea typeface="Consolas"/>
-                <a:cs typeface="Consolas"/>
-              </a:rPr>
-              <a:t>$ .\comparar.bat "entrada.xlsx" --icam</a:t>
-            </a:r>
-          </a:p>
-        </p:txBody>
-      </p:sp>
-      <p:sp>
-        <p:nvSpPr>
-          <p:cNvPr id="46" name="">
-            <a:extLst xmlns:a="http://schemas.openxmlformats.org/drawingml/2006/main">
-              <a:ext uri="{FF2B5EF4-FFF2-40B4-BE49-F238E27FC236}">
-                <a16:creationId xmlns:a16="http://schemas.microsoft.com/office/drawing/2014/main" id="{A56F9957-6060-4F30-952F-BDD96D7FC90F}"/>
-              </a:ext>
-            </a:extLst>
-          </p:cNvPr>
-          <p:cNvSpPr>
-            <a:spLocks xmlns:a="http://schemas.openxmlformats.org/drawingml/2006/main" noGrp="1"/>
-          </p:cNvSpPr>
-          <p:nvPr/>
-        </p:nvSpPr>
-        <p:spPr>
-          <a:xfrm xmlns:a="http://schemas.openxmlformats.org/drawingml/2006/main">
-            <a:off x="533400" y="10839450"/>
+                <a16:creationId xmlns:a16="http://schemas.microsoft.com/office/drawing/2014/main" id="{DC696CE1-E525-4E55-ABAF-68B61D364CD0}"/>
+              </a:ext>
+            </a:extLst>
+          </p:cNvPr>
+          <p:cNvSpPr>
+            <a:spLocks xmlns:a="http://schemas.openxmlformats.org/drawingml/2006/main" noGrp="1"/>
+          </p:cNvSpPr>
+          <p:nvPr/>
+        </p:nvSpPr>
+        <p:spPr>
+          <a:xfrm xmlns:a="http://schemas.openxmlformats.org/drawingml/2006/main">
+            <a:off x="533400" y="10382250"/>
             <a:ext cx="8686800" cy="228600"/>
           </a:xfrm>
           <a:prstGeom xmlns:a="http://schemas.openxmlformats.org/drawingml/2006/main" prst="rect">
@@ -3743,28 +3563,28 @@
                 <a:ea typeface="Arial"/>
                 <a:cs typeface="Arial"/>
               </a:rPr>
-              <a:t>Un DIP por barcode real: resultado en terminal.</a:t>
-            </a:r>
-          </a:p>
-        </p:txBody>
-      </p:sp>
-      <p:sp>
-        <p:nvSpPr>
-          <p:cNvPr id="47" name="">
-            <a:extLst xmlns:a="http://schemas.openxmlformats.org/drawingml/2006/main">
-              <a:ext uri="{FF2B5EF4-FFF2-40B4-BE49-F238E27FC236}">
-                <a16:creationId xmlns:a16="http://schemas.microsoft.com/office/drawing/2014/main" id="{776B5167-43B9-4C31-8C53-C91009E0390B}"/>
-              </a:ext>
-            </a:extLst>
-          </p:cNvPr>
-          <p:cNvSpPr>
-            <a:spLocks xmlns:a="http://schemas.openxmlformats.org/drawingml/2006/main" noGrp="1"/>
-          </p:cNvSpPr>
-          <p:nvPr/>
-        </p:nvSpPr>
-        <p:spPr>
-          <a:xfrm xmlns:a="http://schemas.openxmlformats.org/drawingml/2006/main">
-            <a:off x="533400" y="11068050"/>
+              <a:t>El programa muestra los datos, el resultado y los hallazgos</a:t>
+            </a:r>
+          </a:p>
+        </p:txBody>
+      </p:sp>
+      <p:sp>
+        <p:nvSpPr>
+          <p:cNvPr id="45" name="">
+            <a:extLst xmlns:a="http://schemas.openxmlformats.org/drawingml/2006/main">
+              <a:ext uri="{FF2B5EF4-FFF2-40B4-BE49-F238E27FC236}">
+                <a16:creationId xmlns:a16="http://schemas.microsoft.com/office/drawing/2014/main" id="{4A8BDCFA-C739-4A74-BC77-B7647FB3B2B9}"/>
+              </a:ext>
+            </a:extLst>
+          </p:cNvPr>
+          <p:cNvSpPr>
+            <a:spLocks xmlns:a="http://schemas.openxmlformats.org/drawingml/2006/main" noGrp="1"/>
+          </p:cNvSpPr>
+          <p:nvPr/>
+        </p:nvSpPr>
+        <p:spPr>
+          <a:xfrm xmlns:a="http://schemas.openxmlformats.org/drawingml/2006/main">
+            <a:off x="533400" y="10610850"/>
             <a:ext cx="8686800" cy="228600"/>
           </a:xfrm>
           <a:prstGeom xmlns:a="http://schemas.openxmlformats.org/drawingml/2006/main" prst="rect">
@@ -3798,7 +3618,115 @@
               </a:defRPr>
             </a:pPr>
             <a:r>
-              <a:rPr sz="1350" b="0">
+              <a:rPr sz="1500" b="0">
+                <a:solidFill>
+                  <a:srgbClr val="142D48"/>
+                </a:solidFill>
+                <a:latin typeface="Arial"/>
+                <a:ea typeface="Arial"/>
+                <a:cs typeface="Arial"/>
+              </a:rPr>
+              <a:t>en la terminal. Esta consulta no genera un Excel de resultado.</a:t>
+            </a:r>
+          </a:p>
+        </p:txBody>
+      </p:sp>
+      <p:sp>
+        <p:nvSpPr>
+          <p:cNvPr id="46" name="">
+            <a:extLst xmlns:a="http://schemas.openxmlformats.org/drawingml/2006/main">
+              <a:ext uri="{FF2B5EF4-FFF2-40B4-BE49-F238E27FC236}">
+                <a16:creationId xmlns:a16="http://schemas.microsoft.com/office/drawing/2014/main" id="{6A35579B-BA03-4962-8DBA-D6C26DFDA40E}"/>
+              </a:ext>
+            </a:extLst>
+          </p:cNvPr>
+          <p:cNvSpPr>
+            <a:spLocks xmlns:a="http://schemas.openxmlformats.org/drawingml/2006/main" noGrp="1"/>
+          </p:cNvSpPr>
+          <p:nvPr/>
+        </p:nvSpPr>
+        <p:spPr>
+          <a:xfrm xmlns:a="http://schemas.openxmlformats.org/drawingml/2006/main">
+            <a:off x="304800" y="11258550"/>
+            <a:ext cx="9144000" cy="1457325"/>
+          </a:xfrm>
+          <a:prstGeom xmlns:a="http://schemas.openxmlformats.org/drawingml/2006/main" prst="roundRect">
+            <a:avLst>
+              <a:gd name="adj" fmla="val 9150"/>
+            </a:avLst>
+          </a:prstGeom>
+          <a:solidFill xmlns:a="http://schemas.openxmlformats.org/drawingml/2006/main">
+            <a:srgbClr val="DDEFFC"/>
+          </a:solidFill>
+          <a:ln xmlns:a="http://schemas.openxmlformats.org/drawingml/2006/main" w="9525">
+            <a:solidFill>
+              <a:srgbClr val="ADD0E8"/>
+            </a:solidFill>
+          </a:ln>
+        </p:spPr>
+      </p:sp>
+      <p:sp>
+        <p:nvSpPr>
+          <p:cNvPr id="47" name="">
+            <a:extLst xmlns:a="http://schemas.openxmlformats.org/drawingml/2006/main">
+              <a:ext uri="{FF2B5EF4-FFF2-40B4-BE49-F238E27FC236}">
+                <a16:creationId xmlns:a16="http://schemas.microsoft.com/office/drawing/2014/main" id="{EF3D96DF-171C-45C9-9518-B92B39FD9276}"/>
+              </a:ext>
+            </a:extLst>
+          </p:cNvPr>
+          <p:cNvSpPr>
+            <a:spLocks xmlns:a="http://schemas.openxmlformats.org/drawingml/2006/main" noGrp="1"/>
+          </p:cNvSpPr>
+          <p:nvPr/>
+        </p:nvSpPr>
+        <p:spPr>
+          <a:xfrm xmlns:a="http://schemas.openxmlformats.org/drawingml/2006/main">
+            <a:off x="533400" y="11449050"/>
+            <a:ext cx="8686800" cy="276225"/>
+          </a:xfrm>
+          <a:prstGeom xmlns:a="http://schemas.openxmlformats.org/drawingml/2006/main" prst="rect">
+            <a:avLst/>
+          </a:prstGeom>
+          <a:noFill xmlns:a="http://schemas.openxmlformats.org/drawingml/2006/main"/>
+          <a:ln xmlns:a="http://schemas.openxmlformats.org/drawingml/2006/main" w="0">
+            <a:noFill/>
+          </a:ln>
+        </p:spPr>
+        <p:txBody>
+          <a:bodyPr xmlns:a="http://schemas.openxmlformats.org/drawingml/2006/main" wrap="none" lIns="0" tIns="0" rIns="0" bIns="0" anchor="t">
+            <a:noAutofit/>
+          </a:bodyPr>
+          <a:lstStyle xmlns:a="http://schemas.openxmlformats.org/drawingml/2006/main"/>
+          <a:p xmlns:a="http://schemas.openxmlformats.org/drawingml/2006/main">
+            <a:pPr>
+              <a:spcBef>
+                <a:spcPts val="0"/>
+              </a:spcBef>
+              <a:spcAft>
+                <a:spcPts val="0"/>
+              </a:spcAft>
+              <a:defRPr sz="1800" b="1">
+                <a:solidFill>
+                  <a:srgbClr val="073C78"/>
+                </a:solidFill>
+                <a:latin typeface="Arial"/>
+                <a:ea typeface="Arial"/>
+                <a:cs typeface="Arial"/>
+              </a:defRPr>
+            </a:pPr>
+            <a:r>
+              <a:rPr sz="1800" b="1">
+                <a:solidFill>
+                  <a:srgbClr val="073C78"/>
+                </a:solidFill>
+                <a:latin typeface="Arial"/>
+                <a:ea typeface="Arial"/>
+                <a:cs typeface="Arial"/>
+              </a:rPr>
+              <a:t>Resultado: carpeta </a:t>
+            </a:r>
+            <a:r>
+              <a:rPr sz="1650" b="0">
                 <a:solidFill>
                   <a:srgbClr val="073C78"/>
                 </a:solidFill>
@@ -3806,40 +3734,7 @@
                 <a:ea typeface="Consolas"/>
                 <a:cs typeface="Consolas"/>
               </a:rPr>
-              <a:t>.\filtrar.bat</a:t>
-            </a:r>
-            <a:r>
-              <a:rPr sz="1500" b="0">
-                <a:solidFill>
-                  <a:srgbClr val="142D48"/>
-                </a:solidFill>
-                <a:latin typeface="Arial"/>
-                <a:ea typeface="Arial"/>
-                <a:cs typeface="Arial"/>
-              </a:rPr>
-              <a:t>: solo pendientes. </a:t>
-            </a:r>
-            <a:r>
-              <a:rPr sz="1350" b="0">
-                <a:solidFill>
-                  <a:srgbClr val="073C78"/>
-                </a:solidFill>
-                <a:latin typeface="Consolas"/>
-                <a:ea typeface="Consolas"/>
-                <a:cs typeface="Consolas"/>
-              </a:rPr>
-              <a:t>.\comparar.bat</a:t>
-            </a:r>
-            <a:r>
-              <a:rPr sz="1500" b="0">
-                <a:solidFill>
-                  <a:srgbClr val="142D48"/>
-                </a:solidFill>
-                <a:latin typeface="Arial"/>
-                <a:ea typeface="Arial"/>
-                <a:cs typeface="Arial"/>
-              </a:rPr>
-              <a:t>: comparación</a:t>
+              <a:t>salidas/</a:t>
             </a:r>
           </a:p>
         </p:txBody>
@@ -3849,18 +3744,18 @@
           <p:cNvPr id="48" name="">
             <a:extLst xmlns:a="http://schemas.openxmlformats.org/drawingml/2006/main">
               <a:ext uri="{FF2B5EF4-FFF2-40B4-BE49-F238E27FC236}">
-                <a16:creationId xmlns:a16="http://schemas.microsoft.com/office/drawing/2014/main" id="{FDBE1ACB-E783-4C76-83AB-726C5B619687}"/>
-              </a:ext>
-            </a:extLst>
-          </p:cNvPr>
-          <p:cNvSpPr>
-            <a:spLocks xmlns:a="http://schemas.openxmlformats.org/drawingml/2006/main" noGrp="1"/>
-          </p:cNvSpPr>
-          <p:nvPr/>
-        </p:nvSpPr>
-        <p:spPr>
-          <a:xfrm xmlns:a="http://schemas.openxmlformats.org/drawingml/2006/main">
-            <a:off x="533400" y="11296650"/>
+                <a16:creationId xmlns:a16="http://schemas.microsoft.com/office/drawing/2014/main" id="{AB284CF0-9F41-410B-92E3-09E0126B59CF}"/>
+              </a:ext>
+            </a:extLst>
+          </p:cNvPr>
+          <p:cNvSpPr>
+            <a:spLocks xmlns:a="http://schemas.openxmlformats.org/drawingml/2006/main" noGrp="1"/>
+          </p:cNvSpPr>
+          <p:nvPr/>
+        </p:nvSpPr>
+        <p:spPr>
+          <a:xfrm xmlns:a="http://schemas.openxmlformats.org/drawingml/2006/main">
+            <a:off x="533400" y="11839575"/>
             <a:ext cx="8686800" cy="228600"/>
           </a:xfrm>
           <a:prstGeom xmlns:a="http://schemas.openxmlformats.org/drawingml/2006/main" prst="rect">
@@ -3902,7 +3797,7 @@
                 <a:ea typeface="Arial"/>
                 <a:cs typeface="Arial"/>
               </a:rPr>
-              <a:t>con la auditoría manual, en un Excel dentro de </a:t>
+              <a:t>Revise </a:t>
             </a:r>
             <a:r>
               <a:rPr sz="1350" b="0">
@@ -3913,7 +3808,7 @@
                 <a:ea typeface="Consolas"/>
                 <a:cs typeface="Consolas"/>
               </a:rPr>
-              <a:t>salidas/</a:t>
+              <a:t>RESULTADO</a:t>
             </a:r>
             <a:r>
               <a:rPr sz="1500" b="0">
@@ -3924,107 +3819,10 @@
                 <a:ea typeface="Arial"/>
                 <a:cs typeface="Arial"/>
               </a:rPr>
-              <a:t>.</a:t>
-            </a:r>
-          </a:p>
-        </p:txBody>
-      </p:sp>
-      <p:sp>
-        <p:nvSpPr>
-          <p:cNvPr id="49" name="">
-            <a:extLst xmlns:a="http://schemas.openxmlformats.org/drawingml/2006/main">
-              <a:ext uri="{FF2B5EF4-FFF2-40B4-BE49-F238E27FC236}">
-                <a16:creationId xmlns:a16="http://schemas.microsoft.com/office/drawing/2014/main" id="{D752DA41-F69E-4768-B286-2CD23F6CC802}"/>
-              </a:ext>
-            </a:extLst>
-          </p:cNvPr>
-          <p:cNvSpPr>
-            <a:spLocks xmlns:a="http://schemas.openxmlformats.org/drawingml/2006/main" noGrp="1"/>
-          </p:cNvSpPr>
-          <p:nvPr/>
-        </p:nvSpPr>
-        <p:spPr>
-          <a:xfrm xmlns:a="http://schemas.openxmlformats.org/drawingml/2006/main">
-            <a:off x="304800" y="11944350"/>
-            <a:ext cx="9144000" cy="1457325"/>
-          </a:xfrm>
-          <a:prstGeom xmlns:a="http://schemas.openxmlformats.org/drawingml/2006/main" prst="roundRect">
-            <a:avLst>
-              <a:gd name="adj" fmla="val 9150"/>
-            </a:avLst>
-          </a:prstGeom>
-          <a:solidFill xmlns:a="http://schemas.openxmlformats.org/drawingml/2006/main">
-            <a:srgbClr val="DDEFFC"/>
-          </a:solidFill>
-          <a:ln xmlns:a="http://schemas.openxmlformats.org/drawingml/2006/main" w="9525">
-            <a:solidFill>
-              <a:srgbClr val="ADD0E8"/>
-            </a:solidFill>
-          </a:ln>
-        </p:spPr>
-      </p:sp>
-      <p:sp>
-        <p:nvSpPr>
-          <p:cNvPr id="50" name="">
-            <a:extLst xmlns:a="http://schemas.openxmlformats.org/drawingml/2006/main">
-              <a:ext uri="{FF2B5EF4-FFF2-40B4-BE49-F238E27FC236}">
-                <a16:creationId xmlns:a16="http://schemas.microsoft.com/office/drawing/2014/main" id="{03A82BD1-FE22-4BD8-A847-E14D5574C800}"/>
-              </a:ext>
-            </a:extLst>
-          </p:cNvPr>
-          <p:cNvSpPr>
-            <a:spLocks xmlns:a="http://schemas.openxmlformats.org/drawingml/2006/main" noGrp="1"/>
-          </p:cNvSpPr>
-          <p:nvPr/>
-        </p:nvSpPr>
-        <p:spPr>
-          <a:xfrm xmlns:a="http://schemas.openxmlformats.org/drawingml/2006/main">
-            <a:off x="533400" y="12134850"/>
-            <a:ext cx="8686800" cy="276225"/>
-          </a:xfrm>
-          <a:prstGeom xmlns:a="http://schemas.openxmlformats.org/drawingml/2006/main" prst="rect">
-            <a:avLst/>
-          </a:prstGeom>
-          <a:noFill xmlns:a="http://schemas.openxmlformats.org/drawingml/2006/main"/>
-          <a:ln xmlns:a="http://schemas.openxmlformats.org/drawingml/2006/main" w="0">
-            <a:noFill/>
-          </a:ln>
-        </p:spPr>
-        <p:txBody>
-          <a:bodyPr xmlns:a="http://schemas.openxmlformats.org/drawingml/2006/main" wrap="none" lIns="0" tIns="0" rIns="0" bIns="0" anchor="t">
-            <a:noAutofit/>
-          </a:bodyPr>
-          <a:lstStyle xmlns:a="http://schemas.openxmlformats.org/drawingml/2006/main"/>
-          <a:p xmlns:a="http://schemas.openxmlformats.org/drawingml/2006/main">
-            <a:pPr>
-              <a:spcBef>
-                <a:spcPts val="0"/>
-              </a:spcBef>
-              <a:spcAft>
-                <a:spcPts val="0"/>
-              </a:spcAft>
-              <a:defRPr sz="1800" b="1">
-                <a:solidFill>
-                  <a:srgbClr val="073C78"/>
-                </a:solidFill>
-                <a:latin typeface="Arial"/>
-                <a:ea typeface="Arial"/>
-                <a:cs typeface="Arial"/>
-              </a:defRPr>
-            </a:pPr>
-            <a:r>
-              <a:rPr sz="1800" b="1">
-                <a:solidFill>
-                  <a:srgbClr val="073C78"/>
-                </a:solidFill>
-                <a:latin typeface="Arial"/>
-                <a:ea typeface="Arial"/>
-                <a:cs typeface="Arial"/>
-              </a:rPr>
-              <a:t>Resultado: carpeta </a:t>
-            </a:r>
-            <a:r>
-              <a:rPr sz="1650" b="0">
+              <a:t>, </a:t>
+            </a:r>
+            <a:r>
+              <a:rPr sz="1350" b="0">
                 <a:solidFill>
                   <a:srgbClr val="073C78"/>
                 </a:solidFill>
@@ -4032,28 +3830,61 @@
                 <a:ea typeface="Consolas"/>
                 <a:cs typeface="Consolas"/>
               </a:rPr>
-              <a:t>salidas/</a:t>
-            </a:r>
-          </a:p>
-        </p:txBody>
-      </p:sp>
-      <p:sp>
-        <p:nvSpPr>
-          <p:cNvPr id="51" name="">
-            <a:extLst xmlns:a="http://schemas.openxmlformats.org/drawingml/2006/main">
-              <a:ext uri="{FF2B5EF4-FFF2-40B4-BE49-F238E27FC236}">
-                <a16:creationId xmlns:a16="http://schemas.microsoft.com/office/drawing/2014/main" id="{77843E50-C807-4C23-91D5-14C08E91E2E8}"/>
-              </a:ext>
-            </a:extLst>
-          </p:cNvPr>
-          <p:cNvSpPr>
-            <a:spLocks xmlns:a="http://schemas.openxmlformats.org/drawingml/2006/main" noGrp="1"/>
-          </p:cNvSpPr>
-          <p:nvPr/>
-        </p:nvSpPr>
-        <p:spPr>
-          <a:xfrm xmlns:a="http://schemas.openxmlformats.org/drawingml/2006/main">
-            <a:off x="533400" y="12525375"/>
+              <a:t>HALLAZGOS</a:t>
+            </a:r>
+            <a:r>
+              <a:rPr sz="1500" b="0">
+                <a:solidFill>
+                  <a:srgbClr val="142D48"/>
+                </a:solidFill>
+                <a:latin typeface="Arial"/>
+                <a:ea typeface="Arial"/>
+                <a:cs typeface="Arial"/>
+              </a:rPr>
+              <a:t> y </a:t>
+            </a:r>
+            <a:r>
+              <a:rPr sz="1350" b="0">
+                <a:solidFill>
+                  <a:srgbClr val="073C78"/>
+                </a:solidFill>
+                <a:latin typeface="Consolas"/>
+                <a:ea typeface="Consolas"/>
+                <a:cs typeface="Consolas"/>
+              </a:rPr>
+              <a:t>VERIFICACIÓN MANUAL</a:t>
+            </a:r>
+            <a:r>
+              <a:rPr sz="1500" b="0">
+                <a:solidFill>
+                  <a:srgbClr val="142D48"/>
+                </a:solidFill>
+                <a:latin typeface="Arial"/>
+                <a:ea typeface="Arial"/>
+                <a:cs typeface="Arial"/>
+              </a:rPr>
+              <a:t>.</a:t>
+            </a:r>
+          </a:p>
+        </p:txBody>
+      </p:sp>
+      <p:sp>
+        <p:nvSpPr>
+          <p:cNvPr id="49" name="">
+            <a:extLst xmlns:a="http://schemas.openxmlformats.org/drawingml/2006/main">
+              <a:ext uri="{FF2B5EF4-FFF2-40B4-BE49-F238E27FC236}">
+                <a16:creationId xmlns:a16="http://schemas.microsoft.com/office/drawing/2014/main" id="{333F2CE8-81DE-4737-B097-6387EF1643DA}"/>
+              </a:ext>
+            </a:extLst>
+          </p:cNvPr>
+          <p:cNvSpPr>
+            <a:spLocks xmlns:a="http://schemas.openxmlformats.org/drawingml/2006/main" noGrp="1"/>
+          </p:cNvSpPr>
+          <p:nvPr/>
+        </p:nvSpPr>
+        <p:spPr>
+          <a:xfrm xmlns:a="http://schemas.openxmlformats.org/drawingml/2006/main">
+            <a:off x="533400" y="12068175"/>
             <a:ext cx="8686800" cy="228600"/>
           </a:xfrm>
           <a:prstGeom xmlns:a="http://schemas.openxmlformats.org/drawingml/2006/main" prst="rect">
@@ -4095,94 +3926,28 @@
                 <a:ea typeface="Arial"/>
                 <a:cs typeface="Arial"/>
               </a:rPr>
-              <a:t>Revise </a:t>
-            </a:r>
-            <a:r>
-              <a:rPr sz="1350" b="0">
-                <a:solidFill>
-                  <a:srgbClr val="073C78"/>
-                </a:solidFill>
-                <a:latin typeface="Consolas"/>
-                <a:ea typeface="Consolas"/>
-                <a:cs typeface="Consolas"/>
-              </a:rPr>
-              <a:t>RESULTADO</a:t>
-            </a:r>
-            <a:r>
-              <a:rPr sz="1500" b="0">
-                <a:solidFill>
-                  <a:srgbClr val="142D48"/>
-                </a:solidFill>
-                <a:latin typeface="Arial"/>
-                <a:ea typeface="Arial"/>
-                <a:cs typeface="Arial"/>
-              </a:rPr>
-              <a:t>, </a:t>
-            </a:r>
-            <a:r>
-              <a:rPr sz="1350" b="0">
-                <a:solidFill>
-                  <a:srgbClr val="073C78"/>
-                </a:solidFill>
-                <a:latin typeface="Consolas"/>
-                <a:ea typeface="Consolas"/>
-                <a:cs typeface="Consolas"/>
-              </a:rPr>
-              <a:t>HALLAZGOS</a:t>
-            </a:r>
-            <a:r>
-              <a:rPr sz="1500" b="0">
-                <a:solidFill>
-                  <a:srgbClr val="142D48"/>
-                </a:solidFill>
-                <a:latin typeface="Arial"/>
-                <a:ea typeface="Arial"/>
-                <a:cs typeface="Arial"/>
-              </a:rPr>
-              <a:t> y </a:t>
-            </a:r>
-            <a:r>
-              <a:rPr sz="1350" b="0">
-                <a:solidFill>
-                  <a:srgbClr val="073C78"/>
-                </a:solidFill>
-                <a:latin typeface="Consolas"/>
-                <a:ea typeface="Consolas"/>
-                <a:cs typeface="Consolas"/>
-              </a:rPr>
-              <a:t>VERIFICACIÓN MANUAL</a:t>
-            </a:r>
-            <a:r>
-              <a:rPr sz="1500" b="0">
-                <a:solidFill>
-                  <a:srgbClr val="142D48"/>
-                </a:solidFill>
-                <a:latin typeface="Arial"/>
-                <a:ea typeface="Arial"/>
-                <a:cs typeface="Arial"/>
-              </a:rPr>
-              <a:t>.</a:t>
-            </a:r>
-          </a:p>
-        </p:txBody>
-      </p:sp>
-      <p:sp>
-        <p:nvSpPr>
-          <p:cNvPr id="52" name="">
-            <a:extLst xmlns:a="http://schemas.openxmlformats.org/drawingml/2006/main">
-              <a:ext uri="{FF2B5EF4-FFF2-40B4-BE49-F238E27FC236}">
-                <a16:creationId xmlns:a16="http://schemas.microsoft.com/office/drawing/2014/main" id="{E73ED317-709D-42C0-89F5-5F3DE5C25935}"/>
-              </a:ext>
-            </a:extLst>
-          </p:cNvPr>
-          <p:cNvSpPr>
-            <a:spLocks xmlns:a="http://schemas.openxmlformats.org/drawingml/2006/main" noGrp="1"/>
-          </p:cNvSpPr>
-          <p:nvPr/>
-        </p:nvSpPr>
-        <p:spPr>
-          <a:xfrm xmlns:a="http://schemas.openxmlformats.org/drawingml/2006/main">
-            <a:off x="533400" y="12753975"/>
+              <a:t>POSIBLE DISCREPANCIA: leer hallazgo. REVISAR: consultar manual.</a:t>
+            </a:r>
+          </a:p>
+        </p:txBody>
+      </p:sp>
+      <p:sp>
+        <p:nvSpPr>
+          <p:cNvPr id="50" name="">
+            <a:extLst xmlns:a="http://schemas.openxmlformats.org/drawingml/2006/main">
+              <a:ext uri="{FF2B5EF4-FFF2-40B4-BE49-F238E27FC236}">
+                <a16:creationId xmlns:a16="http://schemas.microsoft.com/office/drawing/2014/main" id="{8971A8E9-0C91-40C9-9E5C-A7434CA7320E}"/>
+              </a:ext>
+            </a:extLst>
+          </p:cNvPr>
+          <p:cNvSpPr>
+            <a:spLocks xmlns:a="http://schemas.openxmlformats.org/drawingml/2006/main" noGrp="1"/>
+          </p:cNvSpPr>
+          <p:nvPr/>
+        </p:nvSpPr>
+        <p:spPr>
+          <a:xfrm xmlns:a="http://schemas.openxmlformats.org/drawingml/2006/main">
+            <a:off x="533400" y="12296775"/>
             <a:ext cx="8686800" cy="228600"/>
           </a:xfrm>
           <a:prstGeom xmlns:a="http://schemas.openxmlformats.org/drawingml/2006/main" prst="rect">
@@ -4224,69 +3989,6 @@
                 <a:ea typeface="Arial"/>
                 <a:cs typeface="Arial"/>
               </a:rPr>
-              <a:t>POSIBLE DISCREPANCIA: leer hallazgo. REVISAR: consultar manual.</a:t>
-            </a:r>
-          </a:p>
-        </p:txBody>
-      </p:sp>
-      <p:sp>
-        <p:nvSpPr>
-          <p:cNvPr id="53" name="">
-            <a:extLst xmlns:a="http://schemas.openxmlformats.org/drawingml/2006/main">
-              <a:ext uri="{FF2B5EF4-FFF2-40B4-BE49-F238E27FC236}">
-                <a16:creationId xmlns:a16="http://schemas.microsoft.com/office/drawing/2014/main" id="{0EC0E13E-8DA1-474A-878B-6FE06C1836E2}"/>
-              </a:ext>
-            </a:extLst>
-          </p:cNvPr>
-          <p:cNvSpPr>
-            <a:spLocks xmlns:a="http://schemas.openxmlformats.org/drawingml/2006/main" noGrp="1"/>
-          </p:cNvSpPr>
-          <p:nvPr/>
-        </p:nvSpPr>
-        <p:spPr>
-          <a:xfrm xmlns:a="http://schemas.openxmlformats.org/drawingml/2006/main">
-            <a:off x="533400" y="12982575"/>
-            <a:ext cx="8686800" cy="228600"/>
-          </a:xfrm>
-          <a:prstGeom xmlns:a="http://schemas.openxmlformats.org/drawingml/2006/main" prst="rect">
-            <a:avLst/>
-          </a:prstGeom>
-          <a:noFill xmlns:a="http://schemas.openxmlformats.org/drawingml/2006/main"/>
-          <a:ln xmlns:a="http://schemas.openxmlformats.org/drawingml/2006/main" w="0">
-            <a:noFill/>
-          </a:ln>
-        </p:spPr>
-        <p:txBody>
-          <a:bodyPr xmlns:a="http://schemas.openxmlformats.org/drawingml/2006/main" wrap="none" lIns="0" tIns="0" rIns="0" bIns="0" anchor="t">
-            <a:noAutofit/>
-          </a:bodyPr>
-          <a:lstStyle xmlns:a="http://schemas.openxmlformats.org/drawingml/2006/main"/>
-          <a:p xmlns:a="http://schemas.openxmlformats.org/drawingml/2006/main">
-            <a:pPr>
-              <a:spcBef>
-                <a:spcPts val="0"/>
-              </a:spcBef>
-              <a:spcAft>
-                <a:spcPts val="0"/>
-              </a:spcAft>
-              <a:defRPr sz="1500" b="0">
-                <a:solidFill>
-                  <a:srgbClr val="142D48"/>
-                </a:solidFill>
-                <a:latin typeface="Arial"/>
-                <a:ea typeface="Arial"/>
-                <a:cs typeface="Arial"/>
-              </a:defRPr>
-            </a:pPr>
-            <a:r>
-              <a:rPr sz="1500" b="0">
-                <a:solidFill>
-                  <a:srgbClr val="142D48"/>
-                </a:solidFill>
-                <a:latin typeface="Arial"/>
-                <a:ea typeface="Arial"/>
-                <a:cs typeface="Arial"/>
-              </a:rPr>
               <a:t>SIN FUENTE: verificar referencia. OK: completar revisión manual.</a:t>
             </a:r>
           </a:p>
@@ -4295,7 +3997,7 @@
     </p:spTree>
     <p:extLst>
       <p:ext uri="{BB962C8B-B14F-4D97-AF65-F5344CB8AC3E}">
-        <p14:creationId xmlns:p14="http://schemas.microsoft.com/office/powerpoint/2010/main" val="1777581896"/>
+        <p14:creationId xmlns:p14="http://schemas.microsoft.com/office/powerpoint/2010/main" val="458506376"/>
       </p:ext>
     </p:extLst>
   </p:cSld>
@@ -4323,10 +4025,10 @@
       </p:grpSpPr>
       <p:sp>
         <p:nvSpPr>
-          <p:cNvPr id="47" name="">
-            <a:extLst xmlns:a="http://schemas.openxmlformats.org/drawingml/2006/main">
-              <a:ext uri="{FF2B5EF4-FFF2-40B4-BE49-F238E27FC236}">
-                <a16:creationId xmlns:a16="http://schemas.microsoft.com/office/drawing/2014/main" id="{80699C8D-6DA7-4B5E-85C3-22CAA534015A}"/>
+          <p:cNvPr id="46" name="">
+            <a:extLst xmlns:a="http://schemas.openxmlformats.org/drawingml/2006/main">
+              <a:ext uri="{FF2B5EF4-FFF2-40B4-BE49-F238E27FC236}">
+                <a16:creationId xmlns:a16="http://schemas.microsoft.com/office/drawing/2014/main" id="{B2D39CFF-7B1C-4597-9CD3-13E1CB15573D}"/>
               </a:ext>
             </a:extLst>
           </p:cNvPr>
@@ -4370,7 +4072,7 @@
           <p:cNvPr id="2" name="">
             <a:extLst xmlns:a="http://schemas.openxmlformats.org/drawingml/2006/main">
               <a:ext uri="{FF2B5EF4-FFF2-40B4-BE49-F238E27FC236}">
-                <a16:creationId xmlns:a16="http://schemas.microsoft.com/office/drawing/2014/main" id="{39845B63-D3CF-4D90-9C03-E7EE60CE0918}"/>
+                <a16:creationId xmlns:a16="http://schemas.microsoft.com/office/drawing/2014/main" id="{B67726E5-319B-4885-A80B-F9A97A8B0BA2}"/>
               </a:ext>
             </a:extLst>
           </p:cNvPr>
@@ -4427,7 +4129,7 @@
           <p:cNvPr id="3" name="">
             <a:extLst xmlns:a="http://schemas.openxmlformats.org/drawingml/2006/main">
               <a:ext uri="{FF2B5EF4-FFF2-40B4-BE49-F238E27FC236}">
-                <a16:creationId xmlns:a16="http://schemas.microsoft.com/office/drawing/2014/main" id="{A97163D2-DFE2-4DFA-B15E-E5DFC0B9BF69}"/>
+                <a16:creationId xmlns:a16="http://schemas.microsoft.com/office/drawing/2014/main" id="{888B8E23-CA1F-4EAE-8381-B85017BFB04C}"/>
               </a:ext>
             </a:extLst>
           </p:cNvPr>
@@ -4457,7 +4159,7 @@
           <p:cNvPr id="4" name="">
             <a:extLst xmlns:a="http://schemas.openxmlformats.org/drawingml/2006/main">
               <a:ext uri="{FF2B5EF4-FFF2-40B4-BE49-F238E27FC236}">
-                <a16:creationId xmlns:a16="http://schemas.microsoft.com/office/drawing/2014/main" id="{81B19129-4D59-4A79-B8A8-6FD43801D907}"/>
+                <a16:creationId xmlns:a16="http://schemas.microsoft.com/office/drawing/2014/main" id="{13DE3794-3139-46DF-8FFD-4CB53F908E06}"/>
               </a:ext>
             </a:extLst>
           </p:cNvPr>
@@ -4514,7 +4216,7 @@
           <p:cNvPr id="5" name="">
             <a:extLst xmlns:a="http://schemas.openxmlformats.org/drawingml/2006/main">
               <a:ext uri="{FF2B5EF4-FFF2-40B4-BE49-F238E27FC236}">
-                <a16:creationId xmlns:a16="http://schemas.microsoft.com/office/drawing/2014/main" id="{D7C282B6-1583-4C6F-B33C-2DF2959F6ED4}"/>
+                <a16:creationId xmlns:a16="http://schemas.microsoft.com/office/drawing/2014/main" id="{22719B84-EB48-4195-B6E6-679E3A926AFB}"/>
               </a:ext>
             </a:extLst>
           </p:cNvPr>
@@ -4568,14 +4270,14 @@
       </p:sp>
       <p:pic>
         <p:nvPicPr>
-          <p:cNvPr id="52" name=""/>
+          <p:cNvPr id="51" name=""/>
           <p:cNvPicPr>
             <a:picLocks xmlns:a="http://schemas.openxmlformats.org/drawingml/2006/main" noChangeAspect="1"/>
           </p:cNvPicPr>
           <p:nvPr/>
         </p:nvPicPr>
         <p:blipFill>
-          <a:blip xmlns:r="http://schemas.openxmlformats.org/officeDocument/2006/relationships" xmlns:a="http://schemas.openxmlformats.org/drawingml/2006/main" r:embed="Re99ba0c8456d4574"/>
+          <a:blip xmlns:r="http://schemas.openxmlformats.org/officeDocument/2006/relationships" xmlns:a="http://schemas.openxmlformats.org/drawingml/2006/main" r:embed="Ra3404a10c3e143fd"/>
           <a:stretch xmlns:a="http://schemas.openxmlformats.org/drawingml/2006/main"/>
         </p:blipFill>
         <p:spPr>
@@ -4593,7 +4295,7 @@
           <p:cNvPr id="7" name="">
             <a:extLst xmlns:a="http://schemas.openxmlformats.org/drawingml/2006/main">
               <a:ext uri="{FF2B5EF4-FFF2-40B4-BE49-F238E27FC236}">
-                <a16:creationId xmlns:a16="http://schemas.microsoft.com/office/drawing/2014/main" id="{DA2139D2-63BF-4D03-AEB9-0C4E2BAA9161}"/>
+                <a16:creationId xmlns:a16="http://schemas.microsoft.com/office/drawing/2014/main" id="{F741244C-2DF0-4361-A191-0BF4F805EA1E}"/>
               </a:ext>
             </a:extLst>
           </p:cNvPr>
@@ -4628,14 +4330,14 @@
       </p:sp>
       <p:pic>
         <p:nvPicPr>
-          <p:cNvPr id="54" name=""/>
+          <p:cNvPr id="53" name=""/>
           <p:cNvPicPr>
             <a:picLocks xmlns:a="http://schemas.openxmlformats.org/drawingml/2006/main" noChangeAspect="1"/>
           </p:cNvPicPr>
           <p:nvPr/>
         </p:nvPicPr>
         <p:blipFill>
-          <a:blip xmlns:r="http://schemas.openxmlformats.org/officeDocument/2006/relationships" xmlns:a="http://schemas.openxmlformats.org/drawingml/2006/main" r:embed="R050e7aeadfc44424"/>
+          <a:blip xmlns:r="http://schemas.openxmlformats.org/officeDocument/2006/relationships" xmlns:a="http://schemas.openxmlformats.org/drawingml/2006/main" r:embed="Re45c7ae809334aac"/>
           <a:stretch xmlns:a="http://schemas.openxmlformats.org/drawingml/2006/main"/>
         </p:blipFill>
         <p:spPr>
@@ -4653,7 +4355,7 @@
           <p:cNvPr id="9" name="">
             <a:extLst xmlns:a="http://schemas.openxmlformats.org/drawingml/2006/main">
               <a:ext uri="{FF2B5EF4-FFF2-40B4-BE49-F238E27FC236}">
-                <a16:creationId xmlns:a16="http://schemas.microsoft.com/office/drawing/2014/main" id="{D9BB01E8-A6C4-4E92-AC27-D099C141D70A}"/>
+                <a16:creationId xmlns:a16="http://schemas.microsoft.com/office/drawing/2014/main" id="{93AD527D-3D95-41E4-9CF0-40A79EF7F7D3}"/>
               </a:ext>
             </a:extLst>
           </p:cNvPr>
@@ -4710,7 +4412,7 @@
           <p:cNvPr id="10" name="">
             <a:extLst xmlns:a="http://schemas.openxmlformats.org/drawingml/2006/main">
               <a:ext uri="{FF2B5EF4-FFF2-40B4-BE49-F238E27FC236}">
-                <a16:creationId xmlns:a16="http://schemas.microsoft.com/office/drawing/2014/main" id="{34E1D224-D2DB-4A0A-A91F-BC7EFAC53733}"/>
+                <a16:creationId xmlns:a16="http://schemas.microsoft.com/office/drawing/2014/main" id="{77C263DD-7493-462B-AD9D-C1639BB5D3F3}"/>
               </a:ext>
             </a:extLst>
           </p:cNvPr>
@@ -4767,7 +4469,7 @@
           <p:cNvPr id="11" name="">
             <a:extLst xmlns:a="http://schemas.openxmlformats.org/drawingml/2006/main">
               <a:ext uri="{FF2B5EF4-FFF2-40B4-BE49-F238E27FC236}">
-                <a16:creationId xmlns:a16="http://schemas.microsoft.com/office/drawing/2014/main" id="{1778D20A-A63A-45B8-AA8E-A3A1B44DF55D}"/>
+                <a16:creationId xmlns:a16="http://schemas.microsoft.com/office/drawing/2014/main" id="{F6D2934E-CF3C-4F20-B313-05144196F826}"/>
               </a:ext>
             </a:extLst>
           </p:cNvPr>
@@ -4852,7 +4554,7 @@
           <p:cNvPr id="12" name="">
             <a:extLst xmlns:a="http://schemas.openxmlformats.org/drawingml/2006/main">
               <a:ext uri="{FF2B5EF4-FFF2-40B4-BE49-F238E27FC236}">
-                <a16:creationId xmlns:a16="http://schemas.microsoft.com/office/drawing/2014/main" id="{34139542-4351-4F70-9D34-D8BC5F0C6B36}"/>
+                <a16:creationId xmlns:a16="http://schemas.microsoft.com/office/drawing/2014/main" id="{E4E14BA7-CF7E-412D-A1D6-1D21EC3FCB00}"/>
               </a:ext>
             </a:extLst>
           </p:cNvPr>
@@ -4915,7 +4617,7 @@
           <p:cNvPr id="13" name="">
             <a:extLst xmlns:a="http://schemas.openxmlformats.org/drawingml/2006/main">
               <a:ext uri="{FF2B5EF4-FFF2-40B4-BE49-F238E27FC236}">
-                <a16:creationId xmlns:a16="http://schemas.microsoft.com/office/drawing/2014/main" id="{7EC7DF0E-8E76-405C-820F-9CC1416EDBBD}"/>
+                <a16:creationId xmlns:a16="http://schemas.microsoft.com/office/drawing/2014/main" id="{E023E71B-E5BE-49A5-B153-0495E4C0EE8E}"/>
               </a:ext>
             </a:extLst>
           </p:cNvPr>
@@ -4949,7 +4651,7 @@
           <p:cNvPr id="14" name="">
             <a:extLst xmlns:a="http://schemas.openxmlformats.org/drawingml/2006/main">
               <a:ext uri="{FF2B5EF4-FFF2-40B4-BE49-F238E27FC236}">
-                <a16:creationId xmlns:a16="http://schemas.microsoft.com/office/drawing/2014/main" id="{37BC4162-BE17-4C34-A55E-09E3919AD5E0}"/>
+                <a16:creationId xmlns:a16="http://schemas.microsoft.com/office/drawing/2014/main" id="{387C7881-9D3F-4BB7-8716-79D3145D06E1}"/>
               </a:ext>
             </a:extLst>
           </p:cNvPr>
@@ -4981,7 +4683,7 @@
           <p:cNvPr id="15" name="">
             <a:extLst xmlns:a="http://schemas.openxmlformats.org/drawingml/2006/main">
               <a:ext uri="{FF2B5EF4-FFF2-40B4-BE49-F238E27FC236}">
-                <a16:creationId xmlns:a16="http://schemas.microsoft.com/office/drawing/2014/main" id="{3F6015EB-5E6D-48F0-BA01-ED778D2E3108}"/>
+                <a16:creationId xmlns:a16="http://schemas.microsoft.com/office/drawing/2014/main" id="{D1D33C60-17FD-47FA-9560-CE1AC1B824F1}"/>
               </a:ext>
             </a:extLst>
           </p:cNvPr>
@@ -5038,7 +4740,7 @@
           <p:cNvPr id="16" name="">
             <a:extLst xmlns:a="http://schemas.openxmlformats.org/drawingml/2006/main">
               <a:ext uri="{FF2B5EF4-FFF2-40B4-BE49-F238E27FC236}">
-                <a16:creationId xmlns:a16="http://schemas.microsoft.com/office/drawing/2014/main" id="{AFE33941-F38C-44D1-8605-022F7CF2A214}"/>
+                <a16:creationId xmlns:a16="http://schemas.microsoft.com/office/drawing/2014/main" id="{BF7636DE-0988-49F2-81DC-EF0537458482}"/>
               </a:ext>
             </a:extLst>
           </p:cNvPr>
@@ -5095,7 +4797,7 @@
           <p:cNvPr id="17" name="">
             <a:extLst xmlns:a="http://schemas.openxmlformats.org/drawingml/2006/main">
               <a:ext uri="{FF2B5EF4-FFF2-40B4-BE49-F238E27FC236}">
-                <a16:creationId xmlns:a16="http://schemas.microsoft.com/office/drawing/2014/main" id="{D65EEEB2-CDA3-43DB-A1FE-34AF97099CC4}"/>
+                <a16:creationId xmlns:a16="http://schemas.microsoft.com/office/drawing/2014/main" id="{7533645C-803A-4EFE-86AD-9B6E36A92D58}"/>
               </a:ext>
             </a:extLst>
           </p:cNvPr>
@@ -5158,7 +4860,7 @@
           <p:cNvPr id="18" name="">
             <a:extLst xmlns:a="http://schemas.openxmlformats.org/drawingml/2006/main">
               <a:ext uri="{FF2B5EF4-FFF2-40B4-BE49-F238E27FC236}">
-                <a16:creationId xmlns:a16="http://schemas.microsoft.com/office/drawing/2014/main" id="{2B3EE5C8-DF69-47A1-B8B0-62756711E075}"/>
+                <a16:creationId xmlns:a16="http://schemas.microsoft.com/office/drawing/2014/main" id="{12B6075C-F610-42F6-B13C-9030592E639C}"/>
               </a:ext>
             </a:extLst>
           </p:cNvPr>
@@ -5192,7 +4894,7 @@
           <p:cNvPr id="19" name="">
             <a:extLst xmlns:a="http://schemas.openxmlformats.org/drawingml/2006/main">
               <a:ext uri="{FF2B5EF4-FFF2-40B4-BE49-F238E27FC236}">
-                <a16:creationId xmlns:a16="http://schemas.microsoft.com/office/drawing/2014/main" id="{4B38BE7D-5160-4B5C-8EB8-7C36FE5FE700}"/>
+                <a16:creationId xmlns:a16="http://schemas.microsoft.com/office/drawing/2014/main" id="{A5E869CE-78F6-41B5-8777-7C7B884AE3D5}"/>
               </a:ext>
             </a:extLst>
           </p:cNvPr>
@@ -5249,7 +4951,7 @@
           <p:cNvPr id="20" name="">
             <a:extLst xmlns:a="http://schemas.openxmlformats.org/drawingml/2006/main">
               <a:ext uri="{FF2B5EF4-FFF2-40B4-BE49-F238E27FC236}">
-                <a16:creationId xmlns:a16="http://schemas.microsoft.com/office/drawing/2014/main" id="{7380691A-C63B-4E19-88AF-06AD7AC197E9}"/>
+                <a16:creationId xmlns:a16="http://schemas.microsoft.com/office/drawing/2014/main" id="{E9D96FED-4817-44F4-8107-DB4B3C6D0A72}"/>
               </a:ext>
             </a:extLst>
           </p:cNvPr>
@@ -5306,7 +5008,7 @@
           <p:cNvPr id="21" name="">
             <a:extLst xmlns:a="http://schemas.openxmlformats.org/drawingml/2006/main">
               <a:ext uri="{FF2B5EF4-FFF2-40B4-BE49-F238E27FC236}">
-                <a16:creationId xmlns:a16="http://schemas.microsoft.com/office/drawing/2014/main" id="{B904224D-BE0F-47F4-816A-6AE65162E832}"/>
+                <a16:creationId xmlns:a16="http://schemas.microsoft.com/office/drawing/2014/main" id="{A21441CE-9FED-405B-997F-2FFE8D7C2100}"/>
               </a:ext>
             </a:extLst>
           </p:cNvPr>
@@ -5363,7 +5065,7 @@
           <p:cNvPr id="22" name="">
             <a:extLst xmlns:a="http://schemas.openxmlformats.org/drawingml/2006/main">
               <a:ext uri="{FF2B5EF4-FFF2-40B4-BE49-F238E27FC236}">
-                <a16:creationId xmlns:a16="http://schemas.microsoft.com/office/drawing/2014/main" id="{6725EBC8-0013-49C2-8F8B-FEC65FEB128A}"/>
+                <a16:creationId xmlns:a16="http://schemas.microsoft.com/office/drawing/2014/main" id="{DD0BB699-DAE1-4200-968A-CF8CAE2AA230}"/>
               </a:ext>
             </a:extLst>
           </p:cNvPr>
@@ -5420,7 +5122,7 @@
           <p:cNvPr id="23" name="">
             <a:extLst xmlns:a="http://schemas.openxmlformats.org/drawingml/2006/main">
               <a:ext uri="{FF2B5EF4-FFF2-40B4-BE49-F238E27FC236}">
-                <a16:creationId xmlns:a16="http://schemas.microsoft.com/office/drawing/2014/main" id="{DE7F4D12-FA2B-41A1-958A-6EEFC39B527D}"/>
+                <a16:creationId xmlns:a16="http://schemas.microsoft.com/office/drawing/2014/main" id="{47C1B7E7-4894-4C99-9B38-F26542D52A7E}"/>
               </a:ext>
             </a:extLst>
           </p:cNvPr>
@@ -5477,7 +5179,7 @@
           <p:cNvPr id="24" name="">
             <a:extLst xmlns:a="http://schemas.openxmlformats.org/drawingml/2006/main">
               <a:ext uri="{FF2B5EF4-FFF2-40B4-BE49-F238E27FC236}">
-                <a16:creationId xmlns:a16="http://schemas.microsoft.com/office/drawing/2014/main" id="{50DC17A0-8EE4-4E31-B6FB-94AD60044D3F}"/>
+                <a16:creationId xmlns:a16="http://schemas.microsoft.com/office/drawing/2014/main" id="{02BA99C6-E7DD-48DB-8758-EC384DD28BB9}"/>
               </a:ext>
             </a:extLst>
           </p:cNvPr>
@@ -5534,7 +5236,7 @@
           <p:cNvPr id="25" name="">
             <a:extLst xmlns:a="http://schemas.openxmlformats.org/drawingml/2006/main">
               <a:ext uri="{FF2B5EF4-FFF2-40B4-BE49-F238E27FC236}">
-                <a16:creationId xmlns:a16="http://schemas.microsoft.com/office/drawing/2014/main" id="{671F0E59-36B5-480C-984D-2D4B2DF6D5DE}"/>
+                <a16:creationId xmlns:a16="http://schemas.microsoft.com/office/drawing/2014/main" id="{3788FE10-1E56-4804-90B0-4FBE0048FEA0}"/>
               </a:ext>
             </a:extLst>
           </p:cNvPr>
@@ -5568,7 +5270,7 @@
           <p:cNvPr id="26" name="">
             <a:extLst xmlns:a="http://schemas.openxmlformats.org/drawingml/2006/main">
               <a:ext uri="{FF2B5EF4-FFF2-40B4-BE49-F238E27FC236}">
-                <a16:creationId xmlns:a16="http://schemas.microsoft.com/office/drawing/2014/main" id="{FE4F5D19-C0BD-4F51-AC12-2F0D9810C278}"/>
+                <a16:creationId xmlns:a16="http://schemas.microsoft.com/office/drawing/2014/main" id="{FED834A7-78A3-43EF-A8FC-1DF309A063EE}"/>
               </a:ext>
             </a:extLst>
           </p:cNvPr>
@@ -5600,7 +5302,7 @@
           <p:cNvPr id="27" name="">
             <a:extLst xmlns:a="http://schemas.openxmlformats.org/drawingml/2006/main">
               <a:ext uri="{FF2B5EF4-FFF2-40B4-BE49-F238E27FC236}">
-                <a16:creationId xmlns:a16="http://schemas.microsoft.com/office/drawing/2014/main" id="{808729DF-ED13-475B-B016-C910967B7D3F}"/>
+                <a16:creationId xmlns:a16="http://schemas.microsoft.com/office/drawing/2014/main" id="{4B14DDD2-85A7-43B4-85F0-50913AE33513}"/>
               </a:ext>
             </a:extLst>
           </p:cNvPr>
@@ -5657,7 +5359,7 @@
           <p:cNvPr id="28" name="">
             <a:extLst xmlns:a="http://schemas.openxmlformats.org/drawingml/2006/main">
               <a:ext uri="{FF2B5EF4-FFF2-40B4-BE49-F238E27FC236}">
-                <a16:creationId xmlns:a16="http://schemas.microsoft.com/office/drawing/2014/main" id="{2DC142A8-01B7-453A-AB20-8E6D28E2B930}"/>
+                <a16:creationId xmlns:a16="http://schemas.microsoft.com/office/drawing/2014/main" id="{589A9C03-353F-4F09-B320-73E654F59747}"/>
               </a:ext>
             </a:extLst>
           </p:cNvPr>
@@ -5714,7 +5416,7 @@
           <p:cNvPr id="29" name="">
             <a:extLst xmlns:a="http://schemas.openxmlformats.org/drawingml/2006/main">
               <a:ext uri="{FF2B5EF4-FFF2-40B4-BE49-F238E27FC236}">
-                <a16:creationId xmlns:a16="http://schemas.microsoft.com/office/drawing/2014/main" id="{2021653F-B966-480A-BCDA-BD6ED9CA3A85}"/>
+                <a16:creationId xmlns:a16="http://schemas.microsoft.com/office/drawing/2014/main" id="{6A9EA73E-719A-46A5-84E3-2A6251AD4BF5}"/>
               </a:ext>
             </a:extLst>
           </p:cNvPr>
@@ -5777,7 +5479,7 @@
           <p:cNvPr id="30" name="">
             <a:extLst xmlns:a="http://schemas.openxmlformats.org/drawingml/2006/main">
               <a:ext uri="{FF2B5EF4-FFF2-40B4-BE49-F238E27FC236}">
-                <a16:creationId xmlns:a16="http://schemas.microsoft.com/office/drawing/2014/main" id="{E8E60985-093B-40A0-80D9-C4EC12A0964C}"/>
+                <a16:creationId xmlns:a16="http://schemas.microsoft.com/office/drawing/2014/main" id="{A8E4FE49-792B-4B3D-8BF0-898F052F3421}"/>
               </a:ext>
             </a:extLst>
           </p:cNvPr>
@@ -5811,7 +5513,7 @@
           <p:cNvPr id="31" name="">
             <a:extLst xmlns:a="http://schemas.openxmlformats.org/drawingml/2006/main">
               <a:ext uri="{FF2B5EF4-FFF2-40B4-BE49-F238E27FC236}">
-                <a16:creationId xmlns:a16="http://schemas.microsoft.com/office/drawing/2014/main" id="{39FA5729-8BBD-40DC-947A-7CB3AD2F4557}"/>
+                <a16:creationId xmlns:a16="http://schemas.microsoft.com/office/drawing/2014/main" id="{5F9DECB5-58C0-44CC-9227-AE3F21034C1D}"/>
               </a:ext>
             </a:extLst>
           </p:cNvPr>
@@ -5868,7 +5570,7 @@
           <p:cNvPr id="32" name="">
             <a:extLst xmlns:a="http://schemas.openxmlformats.org/drawingml/2006/main">
               <a:ext uri="{FF2B5EF4-FFF2-40B4-BE49-F238E27FC236}">
-                <a16:creationId xmlns:a16="http://schemas.microsoft.com/office/drawing/2014/main" id="{AC3E85CB-F1AA-427A-805B-30040AF958B3}"/>
+                <a16:creationId xmlns:a16="http://schemas.microsoft.com/office/drawing/2014/main" id="{0A74D1F7-FE5C-47B8-89A7-757D217E660E}"/>
               </a:ext>
             </a:extLst>
           </p:cNvPr>
@@ -5925,7 +5627,7 @@
           <p:cNvPr id="33" name="">
             <a:extLst xmlns:a="http://schemas.openxmlformats.org/drawingml/2006/main">
               <a:ext uri="{FF2B5EF4-FFF2-40B4-BE49-F238E27FC236}">
-                <a16:creationId xmlns:a16="http://schemas.microsoft.com/office/drawing/2014/main" id="{17201ED4-00BB-447D-B98F-D113BDCC8E6E}"/>
+                <a16:creationId xmlns:a16="http://schemas.microsoft.com/office/drawing/2014/main" id="{FD68ABA4-B2FE-4992-84CC-B28D934D552C}"/>
               </a:ext>
             </a:extLst>
           </p:cNvPr>
@@ -6032,7 +5734,7 @@
           <p:cNvPr id="34" name="">
             <a:extLst xmlns:a="http://schemas.openxmlformats.org/drawingml/2006/main">
               <a:ext uri="{FF2B5EF4-FFF2-40B4-BE49-F238E27FC236}">
-                <a16:creationId xmlns:a16="http://schemas.microsoft.com/office/drawing/2014/main" id="{E5BB0DFD-6920-450B-95D9-F79DA8A4E424}"/>
+                <a16:creationId xmlns:a16="http://schemas.microsoft.com/office/drawing/2014/main" id="{EA05F0D9-92A6-4CBF-B945-ACAFC05DBF75}"/>
               </a:ext>
             </a:extLst>
           </p:cNvPr>
@@ -6128,7 +5830,7 @@
           <p:cNvPr id="35" name="">
             <a:extLst xmlns:a="http://schemas.openxmlformats.org/drawingml/2006/main">
               <a:ext uri="{FF2B5EF4-FFF2-40B4-BE49-F238E27FC236}">
-                <a16:creationId xmlns:a16="http://schemas.microsoft.com/office/drawing/2014/main" id="{0B27C218-EC7E-468D-9D8A-0D67B638FB5A}"/>
+                <a16:creationId xmlns:a16="http://schemas.microsoft.com/office/drawing/2014/main" id="{1788D1D6-2EE2-46C8-B034-59CCE9E4E430}"/>
               </a:ext>
             </a:extLst>
           </p:cNvPr>
@@ -6162,7 +5864,7 @@
           <p:cNvPr id="36" name="">
             <a:extLst xmlns:a="http://schemas.openxmlformats.org/drawingml/2006/main">
               <a:ext uri="{FF2B5EF4-FFF2-40B4-BE49-F238E27FC236}">
-                <a16:creationId xmlns:a16="http://schemas.microsoft.com/office/drawing/2014/main" id="{1F16C247-A63D-4900-97AB-0323BF537E4A}"/>
+                <a16:creationId xmlns:a16="http://schemas.microsoft.com/office/drawing/2014/main" id="{5CDE0965-EA19-4016-AD32-A9D66E09394C}"/>
               </a:ext>
             </a:extLst>
           </p:cNvPr>
@@ -6194,7 +5896,7 @@
           <p:cNvPr id="37" name="">
             <a:extLst xmlns:a="http://schemas.openxmlformats.org/drawingml/2006/main">
               <a:ext uri="{FF2B5EF4-FFF2-40B4-BE49-F238E27FC236}">
-                <a16:creationId xmlns:a16="http://schemas.microsoft.com/office/drawing/2014/main" id="{DE5F3930-AF20-4364-AF18-F119E2CAB6B8}"/>
+                <a16:creationId xmlns:a16="http://schemas.microsoft.com/office/drawing/2014/main" id="{A8B6F440-527A-4615-8566-4E6EDB3019C3}"/>
               </a:ext>
             </a:extLst>
           </p:cNvPr>
@@ -6251,7 +5953,7 @@
           <p:cNvPr id="38" name="">
             <a:extLst xmlns:a="http://schemas.openxmlformats.org/drawingml/2006/main">
               <a:ext uri="{FF2B5EF4-FFF2-40B4-BE49-F238E27FC236}">
-                <a16:creationId xmlns:a16="http://schemas.microsoft.com/office/drawing/2014/main" id="{60DE76DB-0B84-4A55-9465-113362CD6191}"/>
+                <a16:creationId xmlns:a16="http://schemas.microsoft.com/office/drawing/2014/main" id="{A560161B-305E-467D-8405-E6859D4D3842}"/>
               </a:ext>
             </a:extLst>
           </p:cNvPr>
@@ -6305,7 +6007,7 @@
       </p:sp>
       <p:graphicFrame>
         <p:nvGraphicFramePr>
-          <p:cNvPr id="85" name=""/>
+          <p:cNvPr id="84" name=""/>
           <p:cNvGraphicFramePr/>
           <p:nvPr/>
         </p:nvGraphicFramePr>
@@ -6580,7 +6282,7 @@
           <p:cNvPr id="40" name="">
             <a:extLst xmlns:a="http://schemas.openxmlformats.org/drawingml/2006/main">
               <a:ext uri="{FF2B5EF4-FFF2-40B4-BE49-F238E27FC236}">
-                <a16:creationId xmlns:a16="http://schemas.microsoft.com/office/drawing/2014/main" id="{750B06F4-A056-4D7E-BA61-3B9CFFEAA304}"/>
+                <a16:creationId xmlns:a16="http://schemas.microsoft.com/office/drawing/2014/main" id="{D7F25720-BB60-413D-A5CC-2864BB2BDBCF}"/>
               </a:ext>
             </a:extLst>
           </p:cNvPr>
@@ -6643,7 +6345,7 @@
           <p:cNvPr id="41" name="">
             <a:extLst xmlns:a="http://schemas.openxmlformats.org/drawingml/2006/main">
               <a:ext uri="{FF2B5EF4-FFF2-40B4-BE49-F238E27FC236}">
-                <a16:creationId xmlns:a16="http://schemas.microsoft.com/office/drawing/2014/main" id="{B5025B66-528E-4F70-BD0B-0679ACFA3886}"/>
+                <a16:creationId xmlns:a16="http://schemas.microsoft.com/office/drawing/2014/main" id="{C87781D5-10D8-4F41-9AC0-274A484C1150}"/>
               </a:ext>
             </a:extLst>
           </p:cNvPr>
@@ -6655,11 +6357,11 @@
         <p:spPr>
           <a:xfrm xmlns:a="http://schemas.openxmlformats.org/drawingml/2006/main">
             <a:off x="304800" y="11811000"/>
-            <a:ext cx="9144000" cy="1638300"/>
+            <a:ext cx="9144000" cy="1457325"/>
           </a:xfrm>
           <a:prstGeom xmlns:a="http://schemas.openxmlformats.org/drawingml/2006/main" prst="roundRect">
             <a:avLst>
-              <a:gd name="adj" fmla="val 8140"/>
+              <a:gd name="adj" fmla="val 9150"/>
             </a:avLst>
           </a:prstGeom>
           <a:solidFill xmlns:a="http://schemas.openxmlformats.org/drawingml/2006/main">
@@ -6677,7 +6379,7 @@
           <p:cNvPr id="42" name="">
             <a:extLst xmlns:a="http://schemas.openxmlformats.org/drawingml/2006/main">
               <a:ext uri="{FF2B5EF4-FFF2-40B4-BE49-F238E27FC236}">
-                <a16:creationId xmlns:a16="http://schemas.microsoft.com/office/drawing/2014/main" id="{0A18CF09-D7D6-442E-8F08-75F22C2FA0EC}"/>
+                <a16:creationId xmlns:a16="http://schemas.microsoft.com/office/drawing/2014/main" id="{0457297C-EBE3-48A1-83E4-DE4A929CD001}"/>
               </a:ext>
             </a:extLst>
           </p:cNvPr>
@@ -6689,6 +6391,69 @@
         <p:spPr>
           <a:xfrm xmlns:a="http://schemas.openxmlformats.org/drawingml/2006/main">
             <a:off x="533400" y="12001500"/>
+            <a:ext cx="8686800" cy="276225"/>
+          </a:xfrm>
+          <a:prstGeom xmlns:a="http://schemas.openxmlformats.org/drawingml/2006/main" prst="rect">
+            <a:avLst/>
+          </a:prstGeom>
+          <a:noFill xmlns:a="http://schemas.openxmlformats.org/drawingml/2006/main"/>
+          <a:ln xmlns:a="http://schemas.openxmlformats.org/drawingml/2006/main" w="0">
+            <a:noFill/>
+          </a:ln>
+        </p:spPr>
+        <p:txBody>
+          <a:bodyPr xmlns:a="http://schemas.openxmlformats.org/drawingml/2006/main" wrap="none" lIns="0" tIns="0" rIns="0" bIns="0" anchor="t">
+            <a:noAutofit/>
+          </a:bodyPr>
+          <a:lstStyle xmlns:a="http://schemas.openxmlformats.org/drawingml/2006/main"/>
+          <a:p xmlns:a="http://schemas.openxmlformats.org/drawingml/2006/main">
+            <a:pPr>
+              <a:spcBef>
+                <a:spcPts val="0"/>
+              </a:spcBef>
+              <a:spcAft>
+                <a:spcPts val="0"/>
+              </a:spcAft>
+              <a:defRPr sz="1800" b="1">
+                <a:solidFill>
+                  <a:srgbClr val="073C78"/>
+                </a:solidFill>
+                <a:latin typeface="Arial"/>
+                <a:ea typeface="Arial"/>
+                <a:cs typeface="Arial"/>
+              </a:defRPr>
+            </a:pPr>
+            <a:r>
+              <a:rPr sz="1800" b="1">
+                <a:solidFill>
+                  <a:srgbClr val="073C78"/>
+                </a:solidFill>
+                <a:latin typeface="Arial"/>
+                <a:ea typeface="Arial"/>
+                <a:cs typeface="Arial"/>
+              </a:rPr>
+              <a:t>Configuración desde el YAML</a:t>
+            </a:r>
+          </a:p>
+        </p:txBody>
+      </p:sp>
+      <p:sp>
+        <p:nvSpPr>
+          <p:cNvPr id="43" name="">
+            <a:extLst xmlns:a="http://schemas.openxmlformats.org/drawingml/2006/main">
+              <a:ext uri="{FF2B5EF4-FFF2-40B4-BE49-F238E27FC236}">
+                <a16:creationId xmlns:a16="http://schemas.microsoft.com/office/drawing/2014/main" id="{70E48DCF-525C-48F4-AAA2-919A9FEDBD1A}"/>
+              </a:ext>
+            </a:extLst>
+          </p:cNvPr>
+          <p:cNvSpPr>
+            <a:spLocks xmlns:a="http://schemas.openxmlformats.org/drawingml/2006/main" noGrp="1"/>
+          </p:cNvSpPr>
+          <p:nvPr/>
+        </p:nvSpPr>
+        <p:spPr>
+          <a:xfrm xmlns:a="http://schemas.openxmlformats.org/drawingml/2006/main">
+            <a:off x="533400" y="12392025"/>
             <a:ext cx="8686800" cy="228600"/>
           </a:xfrm>
           <a:prstGeom xmlns:a="http://schemas.openxmlformats.org/drawingml/2006/main" prst="rect">
@@ -6730,28 +6495,28 @@
                 <a:ea typeface="Arial"/>
                 <a:cs typeface="Arial"/>
               </a:rPr>
-              <a:t>Tipos nuevos: mueva reglas existentes sin repetir códigos.</a:t>
-            </a:r>
-          </a:p>
-        </p:txBody>
-      </p:sp>
-      <p:sp>
-        <p:nvSpPr>
-          <p:cNvPr id="43" name="">
-            <a:extLst xmlns:a="http://schemas.openxmlformats.org/drawingml/2006/main">
-              <a:ext uri="{FF2B5EF4-FFF2-40B4-BE49-F238E27FC236}">
-                <a16:creationId xmlns:a16="http://schemas.microsoft.com/office/drawing/2014/main" id="{BBB48AEB-264D-4524-933D-BFB0D50E1406}"/>
-              </a:ext>
-            </a:extLst>
-          </p:cNvPr>
-          <p:cNvSpPr>
-            <a:spLocks xmlns:a="http://schemas.openxmlformats.org/drawingml/2006/main" noGrp="1"/>
-          </p:cNvSpPr>
-          <p:nvPr/>
-        </p:nvSpPr>
-        <p:spPr>
-          <a:xfrm xmlns:a="http://schemas.openxmlformats.org/drawingml/2006/main">
-            <a:off x="533400" y="12230100"/>
+              <a:t>El YAML configura qué chequeos disponibles se informan y su severidad.</a:t>
+            </a:r>
+          </a:p>
+        </p:txBody>
+      </p:sp>
+      <p:sp>
+        <p:nvSpPr>
+          <p:cNvPr id="44" name="">
+            <a:extLst xmlns:a="http://schemas.openxmlformats.org/drawingml/2006/main">
+              <a:ext uri="{FF2B5EF4-FFF2-40B4-BE49-F238E27FC236}">
+                <a16:creationId xmlns:a16="http://schemas.microsoft.com/office/drawing/2014/main" id="{02907284-B347-40B8-808B-82758E33D172}"/>
+              </a:ext>
+            </a:extLst>
+          </p:cNvPr>
+          <p:cNvSpPr>
+            <a:spLocks xmlns:a="http://schemas.openxmlformats.org/drawingml/2006/main" noGrp="1"/>
+          </p:cNvSpPr>
+          <p:nvPr/>
+        </p:nvSpPr>
+        <p:spPr>
+          <a:xfrm xmlns:a="http://schemas.openxmlformats.org/drawingml/2006/main">
+            <a:off x="533400" y="12620625"/>
             <a:ext cx="8686800" cy="228600"/>
           </a:xfrm>
           <a:prstGeom xmlns:a="http://schemas.openxmlformats.org/drawingml/2006/main" prst="rect">
@@ -6793,63 +6558,51 @@
                 <a:ea typeface="Arial"/>
                 <a:cs typeface="Arial"/>
               </a:rPr>
-              <a:t>Una detección nueva requiere que el mantenedor la implemente.</a:t>
-            </a:r>
-          </a:p>
-        </p:txBody>
-      </p:sp>
-      <p:sp>
-        <p:nvSpPr>
-          <p:cNvPr id="44" name="">
-            <a:extLst xmlns:a="http://schemas.openxmlformats.org/drawingml/2006/main">
-              <a:ext uri="{FF2B5EF4-FFF2-40B4-BE49-F238E27FC236}">
-                <a16:creationId xmlns:a16="http://schemas.microsoft.com/office/drawing/2014/main" id="{49154F35-66D6-4062-8368-BE7E4B6B8961}"/>
-              </a:ext>
-            </a:extLst>
-          </p:cNvPr>
-          <p:cNvSpPr>
-            <a:spLocks xmlns:a="http://schemas.openxmlformats.org/drawingml/2006/main" noGrp="1"/>
-          </p:cNvSpPr>
-          <p:nvPr/>
-        </p:nvSpPr>
-        <p:spPr>
-          <a:xfrm xmlns:a="http://schemas.openxmlformats.org/drawingml/2006/main">
-            <a:off x="533400" y="12611100"/>
-            <a:ext cx="8686800" cy="647700"/>
-          </a:xfrm>
-          <a:prstGeom xmlns:a="http://schemas.openxmlformats.org/drawingml/2006/main" prst="roundRect">
-            <a:avLst>
-              <a:gd name="adj" fmla="val 8824"/>
-            </a:avLst>
-          </a:prstGeom>
-          <a:solidFill xmlns:a="http://schemas.openxmlformats.org/drawingml/2006/main">
-            <a:srgbClr val="F4F9FD"/>
-          </a:solidFill>
-          <a:ln xmlns:a="http://schemas.openxmlformats.org/drawingml/2006/main" w="9525">
-            <a:solidFill>
-              <a:srgbClr val="ADD0E8"/>
-            </a:solidFill>
-          </a:ln>
-        </p:spPr>
+              <a:t>Edite </a:t>
+            </a:r>
+            <a:r>
+              <a:rPr sz="1350" b="0">
+                <a:solidFill>
+                  <a:srgbClr val="073C78"/>
+                </a:solidFill>
+                <a:latin typeface="Consolas"/>
+                <a:ea typeface="Consolas"/>
+                <a:cs typeface="Consolas"/>
+              </a:rPr>
+              <a:t>config/discrepancias.yaml</a:t>
+            </a:r>
+            <a:r>
+              <a:rPr sz="1500" b="0">
+                <a:solidFill>
+                  <a:srgbClr val="142D48"/>
+                </a:solidFill>
+                <a:latin typeface="Arial"/>
+                <a:ea typeface="Arial"/>
+                <a:cs typeface="Arial"/>
+              </a:rPr>
+              <a:t> y guarde.</a:t>
+            </a:r>
+          </a:p>
+        </p:txBody>
       </p:sp>
       <p:sp>
         <p:nvSpPr>
           <p:cNvPr id="45" name="">
             <a:extLst xmlns:a="http://schemas.openxmlformats.org/drawingml/2006/main">
               <a:ext uri="{FF2B5EF4-FFF2-40B4-BE49-F238E27FC236}">
-                <a16:creationId xmlns:a16="http://schemas.microsoft.com/office/drawing/2014/main" id="{97C122BB-4B83-4D03-AEE6-81EE00E2C07F}"/>
-              </a:ext>
-            </a:extLst>
-          </p:cNvPr>
-          <p:cNvSpPr>
-            <a:spLocks xmlns:a="http://schemas.openxmlformats.org/drawingml/2006/main" noGrp="1"/>
-          </p:cNvSpPr>
-          <p:nvPr/>
-        </p:nvSpPr>
-        <p:spPr>
-          <a:xfrm xmlns:a="http://schemas.openxmlformats.org/drawingml/2006/main">
-            <a:off x="704850" y="12706350"/>
-            <a:ext cx="8343900" cy="171450"/>
+                <a16:creationId xmlns:a16="http://schemas.microsoft.com/office/drawing/2014/main" id="{22A2339D-BF86-4CD7-85EE-15655ECDD096}"/>
+              </a:ext>
+            </a:extLst>
+          </p:cNvPr>
+          <p:cNvSpPr>
+            <a:spLocks xmlns:a="http://schemas.openxmlformats.org/drawingml/2006/main" noGrp="1"/>
+          </p:cNvSpPr>
+          <p:nvPr/>
+        </p:nvSpPr>
+        <p:spPr>
+          <a:xfrm xmlns:a="http://schemas.openxmlformats.org/drawingml/2006/main">
+            <a:off x="533400" y="12849225"/>
+            <a:ext cx="8686800" cy="228600"/>
           </a:xfrm>
           <a:prstGeom xmlns:a="http://schemas.openxmlformats.org/drawingml/2006/main" prst="rect">
             <a:avLst/>
@@ -6866,9 +6619,15 @@
           <a:lstStyle xmlns:a="http://schemas.openxmlformats.org/drawingml/2006/main"/>
           <a:p xmlns:a="http://schemas.openxmlformats.org/drawingml/2006/main">
             <a:pPr>
-              <a:defRPr sz="1125" b="1">
-                <a:solidFill>
-                  <a:srgbClr val="006BBE"/>
+              <a:spcBef>
+                <a:spcPts val="0"/>
+              </a:spcBef>
+              <a:spcAft>
+                <a:spcPts val="0"/>
+              </a:spcAft>
+              <a:defRPr sz="1500" b="0">
+                <a:solidFill>
+                  <a:srgbClr val="142D48"/>
                 </a:solidFill>
                 <a:latin typeface="Arial"/>
                 <a:ea typeface="Arial"/>
@@ -6876,72 +6635,15 @@
               </a:defRPr>
             </a:pPr>
             <a:r>
-              <a:rPr sz="1125" b="1">
-                <a:solidFill>
-                  <a:srgbClr val="006BBE"/>
-                </a:solidFill>
-                <a:latin typeface="Arial"/>
-                <a:ea typeface="Arial"/>
-                <a:cs typeface="Arial"/>
-              </a:rPr>
-              <a:t>Terminal (validación opcional)</a:t>
-            </a:r>
-          </a:p>
-        </p:txBody>
-      </p:sp>
-      <p:sp>
-        <p:nvSpPr>
-          <p:cNvPr id="46" name="">
-            <a:extLst xmlns:a="http://schemas.openxmlformats.org/drawingml/2006/main">
-              <a:ext uri="{FF2B5EF4-FFF2-40B4-BE49-F238E27FC236}">
-                <a16:creationId xmlns:a16="http://schemas.microsoft.com/office/drawing/2014/main" id="{E113B20D-F369-454C-BB48-2B6E8E898EF8}"/>
-              </a:ext>
-            </a:extLst>
-          </p:cNvPr>
-          <p:cNvSpPr>
-            <a:spLocks xmlns:a="http://schemas.openxmlformats.org/drawingml/2006/main" noGrp="1"/>
-          </p:cNvSpPr>
-          <p:nvPr/>
-        </p:nvSpPr>
-        <p:spPr>
-          <a:xfrm xmlns:a="http://schemas.openxmlformats.org/drawingml/2006/main">
-            <a:off x="704850" y="12934950"/>
-            <a:ext cx="8343900" cy="209550"/>
-          </a:xfrm>
-          <a:prstGeom xmlns:a="http://schemas.openxmlformats.org/drawingml/2006/main" prst="rect">
-            <a:avLst/>
-          </a:prstGeom>
-          <a:noFill xmlns:a="http://schemas.openxmlformats.org/drawingml/2006/main"/>
-          <a:ln xmlns:a="http://schemas.openxmlformats.org/drawingml/2006/main" w="0">
-            <a:noFill/>
-          </a:ln>
-        </p:spPr>
-        <p:txBody>
-          <a:bodyPr xmlns:a="http://schemas.openxmlformats.org/drawingml/2006/main" wrap="none" lIns="0" tIns="0" rIns="0" bIns="0" anchor="t">
-            <a:noAutofit/>
-          </a:bodyPr>
-          <a:lstStyle xmlns:a="http://schemas.openxmlformats.org/drawingml/2006/main"/>
-          <a:p xmlns:a="http://schemas.openxmlformats.org/drawingml/2006/main">
-            <a:pPr>
-              <a:defRPr sz="1350" b="0">
-                <a:solidFill>
-                  <a:srgbClr val="142D48"/>
-                </a:solidFill>
-                <a:latin typeface="Consolas"/>
-                <a:ea typeface="Consolas"/>
-                <a:cs typeface="Consolas"/>
-              </a:defRPr>
-            </a:pPr>
-            <a:r>
-              <a:rPr sz="1350" b="0">
-                <a:solidFill>
-                  <a:srgbClr val="142D48"/>
-                </a:solidFill>
-                <a:latin typeface="Consolas"/>
-                <a:ea typeface="Consolas"/>
-                <a:cs typeface="Consolas"/>
-              </a:rPr>
-              <a:t>$ .\.venv\Scripts\python -m dips_audit validar-reglas</a:t>
+              <a:rPr sz="1500" b="0">
+                <a:solidFill>
+                  <a:srgbClr val="142D48"/>
+                </a:solidFill>
+                <a:latin typeface="Arial"/>
+                <a:ea typeface="Arial"/>
+                <a:cs typeface="Arial"/>
+              </a:rPr>
+              <a:t>La siguiente auditoría utiliza esta configuración.</a:t>
             </a:r>
           </a:p>
         </p:txBody>
@@ -6949,7 +6651,7 @@
     </p:spTree>
     <p:extLst>
       <p:ext uri="{BB962C8B-B14F-4D97-AF65-F5344CB8AC3E}">
-        <p14:creationId xmlns:p14="http://schemas.microsoft.com/office/powerpoint/2010/main" val="962406598"/>
+        <p14:creationId xmlns:p14="http://schemas.microsoft.com/office/powerpoint/2010/main" val="1731080152"/>
       </p:ext>
     </p:extLst>
   </p:cSld>
@@ -6977,10 +6679,10 @@
       </p:grpSpPr>
       <p:sp>
         <p:nvSpPr>
-          <p:cNvPr id="54" name="">
-            <a:extLst xmlns:a="http://schemas.openxmlformats.org/drawingml/2006/main">
-              <a:ext uri="{FF2B5EF4-FFF2-40B4-BE49-F238E27FC236}">
-                <a16:creationId xmlns:a16="http://schemas.microsoft.com/office/drawing/2014/main" id="{A2F8B790-F913-4593-B7BF-5FFE2035B9B8}"/>
+          <p:cNvPr id="42" name="">
+            <a:extLst xmlns:a="http://schemas.openxmlformats.org/drawingml/2006/main">
+              <a:ext uri="{FF2B5EF4-FFF2-40B4-BE49-F238E27FC236}">
+                <a16:creationId xmlns:a16="http://schemas.microsoft.com/office/drawing/2014/main" id="{6D9253AA-8B26-489D-A3C8-4B13BDFE30BC}"/>
               </a:ext>
             </a:extLst>
           </p:cNvPr>
@@ -7024,7 +6726,7 @@
           <p:cNvPr id="2" name="">
             <a:extLst xmlns:a="http://schemas.openxmlformats.org/drawingml/2006/main">
               <a:ext uri="{FF2B5EF4-FFF2-40B4-BE49-F238E27FC236}">
-                <a16:creationId xmlns:a16="http://schemas.microsoft.com/office/drawing/2014/main" id="{28AF0888-D184-4B23-B6B7-784A61B97CD4}"/>
+                <a16:creationId xmlns:a16="http://schemas.microsoft.com/office/drawing/2014/main" id="{0FA11C36-C722-40B0-9459-ADD6C84344F3}"/>
               </a:ext>
             </a:extLst>
           </p:cNvPr>
@@ -7081,7 +6783,7 @@
           <p:cNvPr id="3" name="">
             <a:extLst xmlns:a="http://schemas.openxmlformats.org/drawingml/2006/main">
               <a:ext uri="{FF2B5EF4-FFF2-40B4-BE49-F238E27FC236}">
-                <a16:creationId xmlns:a16="http://schemas.microsoft.com/office/drawing/2014/main" id="{0C32B6E8-AD5D-4907-80A2-6EA8ED2689A6}"/>
+                <a16:creationId xmlns:a16="http://schemas.microsoft.com/office/drawing/2014/main" id="{5CF1E3BD-D43F-4A74-B481-1B6F6A313290}"/>
               </a:ext>
             </a:extLst>
           </p:cNvPr>
@@ -7111,7 +6813,7 @@
           <p:cNvPr id="4" name="">
             <a:extLst xmlns:a="http://schemas.openxmlformats.org/drawingml/2006/main">
               <a:ext uri="{FF2B5EF4-FFF2-40B4-BE49-F238E27FC236}">
-                <a16:creationId xmlns:a16="http://schemas.microsoft.com/office/drawing/2014/main" id="{6D4745B2-D6D9-4A60-A378-F0B9233255BB}"/>
+                <a16:creationId xmlns:a16="http://schemas.microsoft.com/office/drawing/2014/main" id="{74E53601-3BC3-41D5-B6F8-76C91682FCE5}"/>
               </a:ext>
             </a:extLst>
           </p:cNvPr>
@@ -7168,7 +6870,7 @@
           <p:cNvPr id="5" name="">
             <a:extLst xmlns:a="http://schemas.openxmlformats.org/drawingml/2006/main">
               <a:ext uri="{FF2B5EF4-FFF2-40B4-BE49-F238E27FC236}">
-                <a16:creationId xmlns:a16="http://schemas.microsoft.com/office/drawing/2014/main" id="{BE445A6B-C766-4C92-88DC-45D4124953C5}"/>
+                <a16:creationId xmlns:a16="http://schemas.microsoft.com/office/drawing/2014/main" id="{8F32472A-27E2-4C3D-ADED-41A32F31D1F1}"/>
               </a:ext>
             </a:extLst>
           </p:cNvPr>
@@ -7222,14 +6924,14 @@
       </p:sp>
       <p:pic>
         <p:nvPicPr>
-          <p:cNvPr id="59" name=""/>
+          <p:cNvPr id="47" name=""/>
           <p:cNvPicPr>
             <a:picLocks xmlns:a="http://schemas.openxmlformats.org/drawingml/2006/main" noChangeAspect="1"/>
           </p:cNvPicPr>
           <p:nvPr/>
         </p:nvPicPr>
         <p:blipFill>
-          <a:blip xmlns:r="http://schemas.openxmlformats.org/officeDocument/2006/relationships" xmlns:a="http://schemas.openxmlformats.org/drawingml/2006/main" r:embed="Re50610684f30480b"/>
+          <a:blip xmlns:r="http://schemas.openxmlformats.org/officeDocument/2006/relationships" xmlns:a="http://schemas.openxmlformats.org/drawingml/2006/main" r:embed="R7e801b9c87484194"/>
           <a:stretch xmlns:a="http://schemas.openxmlformats.org/drawingml/2006/main"/>
         </p:blipFill>
         <p:spPr>
@@ -7247,7 +6949,7 @@
           <p:cNvPr id="7" name="">
             <a:extLst xmlns:a="http://schemas.openxmlformats.org/drawingml/2006/main">
               <a:ext uri="{FF2B5EF4-FFF2-40B4-BE49-F238E27FC236}">
-                <a16:creationId xmlns:a16="http://schemas.microsoft.com/office/drawing/2014/main" id="{8A7E4D5E-476F-46EB-96F8-95C6DF33577D}"/>
+                <a16:creationId xmlns:a16="http://schemas.microsoft.com/office/drawing/2014/main" id="{29ABF6DB-D2D1-4962-8067-BA975E970DD0}"/>
               </a:ext>
             </a:extLst>
           </p:cNvPr>
@@ -7282,14 +6984,14 @@
       </p:sp>
       <p:pic>
         <p:nvPicPr>
-          <p:cNvPr id="61" name=""/>
+          <p:cNvPr id="49" name=""/>
           <p:cNvPicPr>
             <a:picLocks xmlns:a="http://schemas.openxmlformats.org/drawingml/2006/main" noChangeAspect="1"/>
           </p:cNvPicPr>
           <p:nvPr/>
         </p:nvPicPr>
         <p:blipFill>
-          <a:blip xmlns:r="http://schemas.openxmlformats.org/officeDocument/2006/relationships" xmlns:a="http://schemas.openxmlformats.org/drawingml/2006/main" r:embed="Rc5a119aa649e4080"/>
+          <a:blip xmlns:r="http://schemas.openxmlformats.org/officeDocument/2006/relationships" xmlns:a="http://schemas.openxmlformats.org/drawingml/2006/main" r:embed="Rc1e75211d9ed4b29"/>
           <a:stretch xmlns:a="http://schemas.openxmlformats.org/drawingml/2006/main"/>
         </p:blipFill>
         <p:spPr>
@@ -7307,7 +7009,7 @@
           <p:cNvPr id="9" name="">
             <a:extLst xmlns:a="http://schemas.openxmlformats.org/drawingml/2006/main">
               <a:ext uri="{FF2B5EF4-FFF2-40B4-BE49-F238E27FC236}">
-                <a16:creationId xmlns:a16="http://schemas.microsoft.com/office/drawing/2014/main" id="{F96A0CA4-9563-42C1-8E8C-78AF35422231}"/>
+                <a16:creationId xmlns:a16="http://schemas.microsoft.com/office/drawing/2014/main" id="{0A3DED55-6C39-4758-A368-CC89308F0687}"/>
               </a:ext>
             </a:extLst>
           </p:cNvPr>
@@ -7364,7 +7066,7 @@
           <p:cNvPr id="10" name="">
             <a:extLst xmlns:a="http://schemas.openxmlformats.org/drawingml/2006/main">
               <a:ext uri="{FF2B5EF4-FFF2-40B4-BE49-F238E27FC236}">
-                <a16:creationId xmlns:a16="http://schemas.microsoft.com/office/drawing/2014/main" id="{D45D0D17-5E1C-437D-9A82-C3DD9045A821}"/>
+                <a16:creationId xmlns:a16="http://schemas.microsoft.com/office/drawing/2014/main" id="{3A9AE4EC-A1F7-4595-8DE5-69FA9133093B}"/>
               </a:ext>
             </a:extLst>
           </p:cNvPr>
@@ -7421,7 +7123,7 @@
           <p:cNvPr id="11" name="">
             <a:extLst xmlns:a="http://schemas.openxmlformats.org/drawingml/2006/main">
               <a:ext uri="{FF2B5EF4-FFF2-40B4-BE49-F238E27FC236}">
-                <a16:creationId xmlns:a16="http://schemas.microsoft.com/office/drawing/2014/main" id="{217A92FB-3281-4EE5-88DF-6085608B9DDE}"/>
+                <a16:creationId xmlns:a16="http://schemas.microsoft.com/office/drawing/2014/main" id="{DB26B8B8-4745-4EFF-847E-FA6D419A0164}"/>
               </a:ext>
             </a:extLst>
           </p:cNvPr>
@@ -7550,7 +7252,7 @@
           <p:cNvPr id="12" name="">
             <a:extLst xmlns:a="http://schemas.openxmlformats.org/drawingml/2006/main">
               <a:ext uri="{FF2B5EF4-FFF2-40B4-BE49-F238E27FC236}">
-                <a16:creationId xmlns:a16="http://schemas.microsoft.com/office/drawing/2014/main" id="{27BD6084-E62B-492E-A1F0-41BCE072B589}"/>
+                <a16:creationId xmlns:a16="http://schemas.microsoft.com/office/drawing/2014/main" id="{66CCBEAA-4FDF-4F65-A2B2-0DAF47A975AA}"/>
               </a:ext>
             </a:extLst>
           </p:cNvPr>
@@ -7613,7 +7315,7 @@
           <p:cNvPr id="13" name="">
             <a:extLst xmlns:a="http://schemas.openxmlformats.org/drawingml/2006/main">
               <a:ext uri="{FF2B5EF4-FFF2-40B4-BE49-F238E27FC236}">
-                <a16:creationId xmlns:a16="http://schemas.microsoft.com/office/drawing/2014/main" id="{D73F9418-C691-4284-8BC8-6A670068F99C}"/>
+                <a16:creationId xmlns:a16="http://schemas.microsoft.com/office/drawing/2014/main" id="{60DA66A4-C75B-49DF-8839-3A0372C76DA6}"/>
               </a:ext>
             </a:extLst>
           </p:cNvPr>
@@ -7647,7 +7349,7 @@
           <p:cNvPr id="14" name="">
             <a:extLst xmlns:a="http://schemas.openxmlformats.org/drawingml/2006/main">
               <a:ext uri="{FF2B5EF4-FFF2-40B4-BE49-F238E27FC236}">
-                <a16:creationId xmlns:a16="http://schemas.microsoft.com/office/drawing/2014/main" id="{B317DEC3-76E3-4C6B-9911-798DBD406568}"/>
+                <a16:creationId xmlns:a16="http://schemas.microsoft.com/office/drawing/2014/main" id="{E6ED7A76-D2E6-4B7E-B59E-66EA4978C58E}"/>
               </a:ext>
             </a:extLst>
           </p:cNvPr>
@@ -7679,7 +7381,7 @@
           <p:cNvPr id="15" name="">
             <a:extLst xmlns:a="http://schemas.openxmlformats.org/drawingml/2006/main">
               <a:ext uri="{FF2B5EF4-FFF2-40B4-BE49-F238E27FC236}">
-                <a16:creationId xmlns:a16="http://schemas.microsoft.com/office/drawing/2014/main" id="{EB484BB9-315A-4D4D-BC90-957F0D842275}"/>
+                <a16:creationId xmlns:a16="http://schemas.microsoft.com/office/drawing/2014/main" id="{7E8DD4E8-AC0C-4181-B73D-1C649E30D718}"/>
               </a:ext>
             </a:extLst>
           </p:cNvPr>
@@ -7736,7 +7438,7 @@
           <p:cNvPr id="16" name="">
             <a:extLst xmlns:a="http://schemas.openxmlformats.org/drawingml/2006/main">
               <a:ext uri="{FF2B5EF4-FFF2-40B4-BE49-F238E27FC236}">
-                <a16:creationId xmlns:a16="http://schemas.microsoft.com/office/drawing/2014/main" id="{DB67B5BE-38D7-401B-AC1A-D284F72A1556}"/>
+                <a16:creationId xmlns:a16="http://schemas.microsoft.com/office/drawing/2014/main" id="{C45D8B15-4892-499C-B522-560344B6F8C4}"/>
               </a:ext>
             </a:extLst>
           </p:cNvPr>
@@ -7793,7 +7495,7 @@
           <p:cNvPr id="17" name="">
             <a:extLst xmlns:a="http://schemas.openxmlformats.org/drawingml/2006/main">
               <a:ext uri="{FF2B5EF4-FFF2-40B4-BE49-F238E27FC236}">
-                <a16:creationId xmlns:a16="http://schemas.microsoft.com/office/drawing/2014/main" id="{EFA97164-35EE-4B8E-B98E-C080CC2EAF9A}"/>
+                <a16:creationId xmlns:a16="http://schemas.microsoft.com/office/drawing/2014/main" id="{13B325F5-B479-4EAF-ADF1-BDBA1E056CB0}"/>
               </a:ext>
             </a:extLst>
           </p:cNvPr>
@@ -7878,7 +7580,7 @@
           <p:cNvPr id="18" name="">
             <a:extLst xmlns:a="http://schemas.openxmlformats.org/drawingml/2006/main">
               <a:ext uri="{FF2B5EF4-FFF2-40B4-BE49-F238E27FC236}">
-                <a16:creationId xmlns:a16="http://schemas.microsoft.com/office/drawing/2014/main" id="{51A5D4A2-F416-4A63-AC35-A86B03BC4725}"/>
+                <a16:creationId xmlns:a16="http://schemas.microsoft.com/office/drawing/2014/main" id="{888B9309-5244-4F20-82AA-717732F9689D}"/>
               </a:ext>
             </a:extLst>
           </p:cNvPr>
@@ -7963,7 +7665,7 @@
           <p:cNvPr id="19" name="">
             <a:extLst xmlns:a="http://schemas.openxmlformats.org/drawingml/2006/main">
               <a:ext uri="{FF2B5EF4-FFF2-40B4-BE49-F238E27FC236}">
-                <a16:creationId xmlns:a16="http://schemas.microsoft.com/office/drawing/2014/main" id="{FDFE9F00-B593-4D4B-BBDF-3981D32883C6}"/>
+                <a16:creationId xmlns:a16="http://schemas.microsoft.com/office/drawing/2014/main" id="{C0161E03-A3A5-492E-9FF8-607C95A79460}"/>
               </a:ext>
             </a:extLst>
           </p:cNvPr>
@@ -8009,7 +7711,7 @@
                 <a:latin typeface="Arial"/>
                 <a:ea typeface="Arial"/>
                 <a:cs typeface="Arial"/>
-                <a:hlinkClick xmlns:r="http://schemas.openxmlformats.org/officeDocument/2006/relationships" r:id="R13fc056b8dc640fe"/>
+                <a:hlinkClick xmlns:r="http://schemas.openxmlformats.org/officeDocument/2006/relationships" r:id="R0858a2c1247c4312"/>
               </a:rPr>
               <a:t>Abrir DIPs References.xlsx en SharePoint</a:t>
             </a:r>
@@ -8021,7 +7723,7 @@
           <p:cNvPr id="20" name="">
             <a:extLst xmlns:a="http://schemas.openxmlformats.org/drawingml/2006/main">
               <a:ext uri="{FF2B5EF4-FFF2-40B4-BE49-F238E27FC236}">
-                <a16:creationId xmlns:a16="http://schemas.microsoft.com/office/drawing/2014/main" id="{74A91BE2-5DEB-457A-99CF-F27577F4CDE1}"/>
+                <a16:creationId xmlns:a16="http://schemas.microsoft.com/office/drawing/2014/main" id="{7182650D-6E84-413A-B044-C71AD2422BEE}"/>
               </a:ext>
             </a:extLst>
           </p:cNvPr>
@@ -8128,7 +7830,7 @@
           <p:cNvPr id="21" name="">
             <a:extLst xmlns:a="http://schemas.openxmlformats.org/drawingml/2006/main">
               <a:ext uri="{FF2B5EF4-FFF2-40B4-BE49-F238E27FC236}">
-                <a16:creationId xmlns:a16="http://schemas.microsoft.com/office/drawing/2014/main" id="{894F9442-0E57-4B3C-B943-2CF848E2FAA7}"/>
+                <a16:creationId xmlns:a16="http://schemas.microsoft.com/office/drawing/2014/main" id="{F2EACC44-84D0-453B-A7C4-7CE20E374416}"/>
               </a:ext>
             </a:extLst>
           </p:cNvPr>
@@ -8224,7 +7926,7 @@
           <p:cNvPr id="22" name="">
             <a:extLst xmlns:a="http://schemas.openxmlformats.org/drawingml/2006/main">
               <a:ext uri="{FF2B5EF4-FFF2-40B4-BE49-F238E27FC236}">
-                <a16:creationId xmlns:a16="http://schemas.microsoft.com/office/drawing/2014/main" id="{F7E20B76-DA4E-4BD7-86E4-063C3EAD3767}"/>
+                <a16:creationId xmlns:a16="http://schemas.microsoft.com/office/drawing/2014/main" id="{A1526123-F8B7-4EAE-82EA-D818D37AD630}"/>
               </a:ext>
             </a:extLst>
           </p:cNvPr>
@@ -8287,7 +7989,7 @@
           <p:cNvPr id="23" name="">
             <a:extLst xmlns:a="http://schemas.openxmlformats.org/drawingml/2006/main">
               <a:ext uri="{FF2B5EF4-FFF2-40B4-BE49-F238E27FC236}">
-                <a16:creationId xmlns:a16="http://schemas.microsoft.com/office/drawing/2014/main" id="{4A23846A-5DF7-46F0-8D58-549E3D040AE4}"/>
+                <a16:creationId xmlns:a16="http://schemas.microsoft.com/office/drawing/2014/main" id="{368EE9A5-6530-4946-9B2F-CF209F3060F0}"/>
               </a:ext>
             </a:extLst>
           </p:cNvPr>
@@ -8321,7 +8023,7 @@
           <p:cNvPr id="24" name="">
             <a:extLst xmlns:a="http://schemas.openxmlformats.org/drawingml/2006/main">
               <a:ext uri="{FF2B5EF4-FFF2-40B4-BE49-F238E27FC236}">
-                <a16:creationId xmlns:a16="http://schemas.microsoft.com/office/drawing/2014/main" id="{25A7AA5C-49CA-435A-94AE-A3A809D0E39E}"/>
+                <a16:creationId xmlns:a16="http://schemas.microsoft.com/office/drawing/2014/main" id="{3202230A-692A-4DF0-B904-6C48D0618F12}"/>
               </a:ext>
             </a:extLst>
           </p:cNvPr>
@@ -8353,7 +8055,7 @@
           <p:cNvPr id="25" name="">
             <a:extLst xmlns:a="http://schemas.openxmlformats.org/drawingml/2006/main">
               <a:ext uri="{FF2B5EF4-FFF2-40B4-BE49-F238E27FC236}">
-                <a16:creationId xmlns:a16="http://schemas.microsoft.com/office/drawing/2014/main" id="{B7A79390-BEA8-419D-83F2-F29AFE5B0DE1}"/>
+                <a16:creationId xmlns:a16="http://schemas.microsoft.com/office/drawing/2014/main" id="{F5E000AE-1798-43C0-B359-9CA9C5C9C543}"/>
               </a:ext>
             </a:extLst>
           </p:cNvPr>
@@ -8410,7 +8112,7 @@
           <p:cNvPr id="26" name="">
             <a:extLst xmlns:a="http://schemas.openxmlformats.org/drawingml/2006/main">
               <a:ext uri="{FF2B5EF4-FFF2-40B4-BE49-F238E27FC236}">
-                <a16:creationId xmlns:a16="http://schemas.microsoft.com/office/drawing/2014/main" id="{7A134558-D11E-403E-8A39-B98882832778}"/>
+                <a16:creationId xmlns:a16="http://schemas.microsoft.com/office/drawing/2014/main" id="{29E12035-EB8A-4C66-B669-D21008827605}"/>
               </a:ext>
             </a:extLst>
           </p:cNvPr>
@@ -8467,7 +8169,7 @@
           <p:cNvPr id="27" name="">
             <a:extLst xmlns:a="http://schemas.openxmlformats.org/drawingml/2006/main">
               <a:ext uri="{FF2B5EF4-FFF2-40B4-BE49-F238E27FC236}">
-                <a16:creationId xmlns:a16="http://schemas.microsoft.com/office/drawing/2014/main" id="{1FFCA973-BEF5-487F-A4FD-F39F6D00044A}"/>
+                <a16:creationId xmlns:a16="http://schemas.microsoft.com/office/drawing/2014/main" id="{66ACE785-68B2-4446-B6CD-C45461BDD249}"/>
               </a:ext>
             </a:extLst>
           </p:cNvPr>
@@ -8530,7 +8232,7 @@
           <p:cNvPr id="28" name="">
             <a:extLst xmlns:a="http://schemas.openxmlformats.org/drawingml/2006/main">
               <a:ext uri="{FF2B5EF4-FFF2-40B4-BE49-F238E27FC236}">
-                <a16:creationId xmlns:a16="http://schemas.microsoft.com/office/drawing/2014/main" id="{95EF531C-2848-49E9-B275-FB0A3965C058}"/>
+                <a16:creationId xmlns:a16="http://schemas.microsoft.com/office/drawing/2014/main" id="{CD9025F1-9FB6-4DDD-91A0-C83A58966191}"/>
               </a:ext>
             </a:extLst>
           </p:cNvPr>
@@ -8615,7 +8317,7 @@
           <p:cNvPr id="29" name="">
             <a:extLst xmlns:a="http://schemas.openxmlformats.org/drawingml/2006/main">
               <a:ext uri="{FF2B5EF4-FFF2-40B4-BE49-F238E27FC236}">
-                <a16:creationId xmlns:a16="http://schemas.microsoft.com/office/drawing/2014/main" id="{F42B1270-2055-47AC-9915-83F502C3A260}"/>
+                <a16:creationId xmlns:a16="http://schemas.microsoft.com/office/drawing/2014/main" id="{5058A368-A712-4A73-B182-151F68F0E11C}"/>
               </a:ext>
             </a:extLst>
           </p:cNvPr>
@@ -8649,7 +8351,7 @@
           <p:cNvPr id="30" name="">
             <a:extLst xmlns:a="http://schemas.openxmlformats.org/drawingml/2006/main">
               <a:ext uri="{FF2B5EF4-FFF2-40B4-BE49-F238E27FC236}">
-                <a16:creationId xmlns:a16="http://schemas.microsoft.com/office/drawing/2014/main" id="{FFBC927D-02BD-4139-83F3-B667E73A9E3F}"/>
+                <a16:creationId xmlns:a16="http://schemas.microsoft.com/office/drawing/2014/main" id="{480FF2C1-91B7-48B5-B1E4-8EFC773ACF92}"/>
               </a:ext>
             </a:extLst>
           </p:cNvPr>
@@ -8706,7 +8408,7 @@
           <p:cNvPr id="31" name="">
             <a:extLst xmlns:a="http://schemas.openxmlformats.org/drawingml/2006/main">
               <a:ext uri="{FF2B5EF4-FFF2-40B4-BE49-F238E27FC236}">
-                <a16:creationId xmlns:a16="http://schemas.microsoft.com/office/drawing/2014/main" id="{57F9B7CB-BEB1-4B4C-ACBF-A574673091E2}"/>
+                <a16:creationId xmlns:a16="http://schemas.microsoft.com/office/drawing/2014/main" id="{D93FA11F-2427-4B40-81A0-EBCCA6359213}"/>
               </a:ext>
             </a:extLst>
           </p:cNvPr>
@@ -8763,7 +8465,7 @@
           <p:cNvPr id="32" name="">
             <a:extLst xmlns:a="http://schemas.openxmlformats.org/drawingml/2006/main">
               <a:ext uri="{FF2B5EF4-FFF2-40B4-BE49-F238E27FC236}">
-                <a16:creationId xmlns:a16="http://schemas.microsoft.com/office/drawing/2014/main" id="{428364B5-B3A3-4DA9-9AF2-7B22BA3C9069}"/>
+                <a16:creationId xmlns:a16="http://schemas.microsoft.com/office/drawing/2014/main" id="{E0E3B225-9B35-492F-A4E7-486BFD6B808B}"/>
               </a:ext>
             </a:extLst>
           </p:cNvPr>
@@ -8820,7 +8522,7 @@
           <p:cNvPr id="33" name="">
             <a:extLst xmlns:a="http://schemas.openxmlformats.org/drawingml/2006/main">
               <a:ext uri="{FF2B5EF4-FFF2-40B4-BE49-F238E27FC236}">
-                <a16:creationId xmlns:a16="http://schemas.microsoft.com/office/drawing/2014/main" id="{5E6C43AE-253B-4E4C-8E1A-523ED7E53CFB}"/>
+                <a16:creationId xmlns:a16="http://schemas.microsoft.com/office/drawing/2014/main" id="{527B0391-DFA3-42A6-862C-DE21608AFED6}"/>
               </a:ext>
             </a:extLst>
           </p:cNvPr>
@@ -8938,7 +8640,7 @@
           <p:cNvPr id="34" name="">
             <a:extLst xmlns:a="http://schemas.openxmlformats.org/drawingml/2006/main">
               <a:ext uri="{FF2B5EF4-FFF2-40B4-BE49-F238E27FC236}">
-                <a16:creationId xmlns:a16="http://schemas.microsoft.com/office/drawing/2014/main" id="{42880230-015C-4DD4-B791-FA9CF8223B61}"/>
+                <a16:creationId xmlns:a16="http://schemas.microsoft.com/office/drawing/2014/main" id="{55DCB041-956E-4BB4-88AF-D5052910B708}"/>
               </a:ext>
             </a:extLst>
           </p:cNvPr>
@@ -8972,7 +8674,7 @@
           <p:cNvPr id="35" name="">
             <a:extLst xmlns:a="http://schemas.openxmlformats.org/drawingml/2006/main">
               <a:ext uri="{FF2B5EF4-FFF2-40B4-BE49-F238E27FC236}">
-                <a16:creationId xmlns:a16="http://schemas.microsoft.com/office/drawing/2014/main" id="{DB0A6557-86BF-4B22-B382-24C95921AADE}"/>
+                <a16:creationId xmlns:a16="http://schemas.microsoft.com/office/drawing/2014/main" id="{F2B2ED0C-F033-499E-B7C5-2387C221C2A7}"/>
               </a:ext>
             </a:extLst>
           </p:cNvPr>
@@ -9004,7 +8706,7 @@
           <p:cNvPr id="36" name="">
             <a:extLst xmlns:a="http://schemas.openxmlformats.org/drawingml/2006/main">
               <a:ext uri="{FF2B5EF4-FFF2-40B4-BE49-F238E27FC236}">
-                <a16:creationId xmlns:a16="http://schemas.microsoft.com/office/drawing/2014/main" id="{76C145E7-672B-470C-8FDD-92023049B580}"/>
+                <a16:creationId xmlns:a16="http://schemas.microsoft.com/office/drawing/2014/main" id="{9D64D8BF-3063-4485-AC58-21441CF27A2F}"/>
               </a:ext>
             </a:extLst>
           </p:cNvPr>
@@ -9061,7 +8763,7 @@
           <p:cNvPr id="37" name="">
             <a:extLst xmlns:a="http://schemas.openxmlformats.org/drawingml/2006/main">
               <a:ext uri="{FF2B5EF4-FFF2-40B4-BE49-F238E27FC236}">
-                <a16:creationId xmlns:a16="http://schemas.microsoft.com/office/drawing/2014/main" id="{9D813C75-563C-4511-835A-A1DD064F9289}"/>
+                <a16:creationId xmlns:a16="http://schemas.microsoft.com/office/drawing/2014/main" id="{F917E4C6-1DFD-4B56-A3C1-BCB031CB7E53}"/>
               </a:ext>
             </a:extLst>
           </p:cNvPr>
@@ -9118,7 +8820,7 @@
           <p:cNvPr id="38" name="">
             <a:extLst xmlns:a="http://schemas.openxmlformats.org/drawingml/2006/main">
               <a:ext uri="{FF2B5EF4-FFF2-40B4-BE49-F238E27FC236}">
-                <a16:creationId xmlns:a16="http://schemas.microsoft.com/office/drawing/2014/main" id="{D956FBB2-DAF4-4985-8074-5A06C4CE06F3}"/>
+                <a16:creationId xmlns:a16="http://schemas.microsoft.com/office/drawing/2014/main" id="{0BE64C7F-9544-4C00-A0F6-C2DB908E5C3A}"/>
               </a:ext>
             </a:extLst>
           </p:cNvPr>
@@ -9181,7 +8883,7 @@
           <p:cNvPr id="39" name="">
             <a:extLst xmlns:a="http://schemas.openxmlformats.org/drawingml/2006/main">
               <a:ext uri="{FF2B5EF4-FFF2-40B4-BE49-F238E27FC236}">
-                <a16:creationId xmlns:a16="http://schemas.microsoft.com/office/drawing/2014/main" id="{5AF0B989-DD3D-43F1-AC46-6DEC0E825A7E}"/>
+                <a16:creationId xmlns:a16="http://schemas.microsoft.com/office/drawing/2014/main" id="{D9B88017-074F-47AA-8409-5D55AA3283C3}"/>
               </a:ext>
             </a:extLst>
           </p:cNvPr>
@@ -9244,7 +8946,7 @@
           <p:cNvPr id="40" name="">
             <a:extLst xmlns:a="http://schemas.openxmlformats.org/drawingml/2006/main">
               <a:ext uri="{FF2B5EF4-FFF2-40B4-BE49-F238E27FC236}">
-                <a16:creationId xmlns:a16="http://schemas.microsoft.com/office/drawing/2014/main" id="{CF927B1B-FC14-4B08-A577-D56048D4AED0}"/>
+                <a16:creationId xmlns:a16="http://schemas.microsoft.com/office/drawing/2014/main" id="{39A713D8-FD5F-4B35-860E-106853272E86}"/>
               </a:ext>
             </a:extLst>
           </p:cNvPr>
@@ -9307,7 +9009,7 @@
           <p:cNvPr id="41" name="">
             <a:extLst xmlns:a="http://schemas.openxmlformats.org/drawingml/2006/main">
               <a:ext uri="{FF2B5EF4-FFF2-40B4-BE49-F238E27FC236}">
-                <a16:creationId xmlns:a16="http://schemas.microsoft.com/office/drawing/2014/main" id="{1D6D44A7-64BB-40D3-9FC5-9B7F3765B5AA}"/>
+                <a16:creationId xmlns:a16="http://schemas.microsoft.com/office/drawing/2014/main" id="{F71442E4-8A97-4DFB-8262-DE4748695A86}"/>
               </a:ext>
             </a:extLst>
           </p:cNvPr>
@@ -9365,634 +9067,10 @@
           </a:p>
         </p:txBody>
       </p:sp>
-      <p:sp>
-        <p:nvSpPr>
-          <p:cNvPr id="42" name="">
-            <a:extLst xmlns:a="http://schemas.openxmlformats.org/drawingml/2006/main">
-              <a:ext uri="{FF2B5EF4-FFF2-40B4-BE49-F238E27FC236}">
-                <a16:creationId xmlns:a16="http://schemas.microsoft.com/office/drawing/2014/main" id="{115230B6-F78A-4641-8722-9225A967E46F}"/>
-              </a:ext>
-            </a:extLst>
-          </p:cNvPr>
-          <p:cNvSpPr>
-            <a:spLocks xmlns:a="http://schemas.openxmlformats.org/drawingml/2006/main" noGrp="1"/>
-          </p:cNvSpPr>
-          <p:nvPr/>
-        </p:nvSpPr>
-        <p:spPr>
-          <a:xfrm xmlns:a="http://schemas.openxmlformats.org/drawingml/2006/main">
-            <a:off x="304800" y="10420350"/>
-            <a:ext cx="9144000" cy="3048000"/>
-          </a:xfrm>
-          <a:prstGeom xmlns:a="http://schemas.openxmlformats.org/drawingml/2006/main" prst="roundRect">
-            <a:avLst>
-              <a:gd name="adj" fmla="val 4375"/>
-            </a:avLst>
-          </a:prstGeom>
-          <a:solidFill xmlns:a="http://schemas.openxmlformats.org/drawingml/2006/main">
-            <a:srgbClr val="FFFFFF"/>
-          </a:solidFill>
-          <a:ln xmlns:a="http://schemas.openxmlformats.org/drawingml/2006/main" w="9525">
-            <a:solidFill>
-              <a:srgbClr val="ADD0E8"/>
-            </a:solidFill>
-          </a:ln>
-        </p:spPr>
-      </p:sp>
-      <p:sp>
-        <p:nvSpPr>
-          <p:cNvPr id="43" name="">
-            <a:extLst xmlns:a="http://schemas.openxmlformats.org/drawingml/2006/main">
-              <a:ext uri="{FF2B5EF4-FFF2-40B4-BE49-F238E27FC236}">
-                <a16:creationId xmlns:a16="http://schemas.microsoft.com/office/drawing/2014/main" id="{A209C746-1425-448B-A3C6-54C11166A289}"/>
-              </a:ext>
-            </a:extLst>
-          </p:cNvPr>
-          <p:cNvSpPr>
-            <a:spLocks xmlns:a="http://schemas.openxmlformats.org/drawingml/2006/main" noGrp="1"/>
-          </p:cNvSpPr>
-          <p:nvPr/>
-        </p:nvSpPr>
-        <p:spPr>
-          <a:xfrm xmlns:a="http://schemas.openxmlformats.org/drawingml/2006/main">
-            <a:off x="304800" y="10420350"/>
-            <a:ext cx="9144000" cy="457200"/>
-          </a:xfrm>
-          <a:prstGeom xmlns:a="http://schemas.openxmlformats.org/drawingml/2006/main" prst="roundRect">
-            <a:avLst>
-              <a:gd name="adj" fmla="val 29167"/>
-            </a:avLst>
-          </a:prstGeom>
-          <a:solidFill xmlns:a="http://schemas.openxmlformats.org/drawingml/2006/main">
-            <a:srgbClr val="006BBE"/>
-          </a:solidFill>
-          <a:ln xmlns:a="http://schemas.openxmlformats.org/drawingml/2006/main" w="0">
-            <a:noFill/>
-          </a:ln>
-        </p:spPr>
-      </p:sp>
-      <p:sp>
-        <p:nvSpPr>
-          <p:cNvPr id="44" name="">
-            <a:extLst xmlns:a="http://schemas.openxmlformats.org/drawingml/2006/main">
-              <a:ext uri="{FF2B5EF4-FFF2-40B4-BE49-F238E27FC236}">
-                <a16:creationId xmlns:a16="http://schemas.microsoft.com/office/drawing/2014/main" id="{A680717F-9ECE-467D-8919-2CFD256F1A1E}"/>
-              </a:ext>
-            </a:extLst>
-          </p:cNvPr>
-          <p:cNvSpPr>
-            <a:spLocks xmlns:a="http://schemas.openxmlformats.org/drawingml/2006/main" noGrp="1"/>
-          </p:cNvSpPr>
-          <p:nvPr/>
-        </p:nvSpPr>
-        <p:spPr>
-          <a:xfrm xmlns:a="http://schemas.openxmlformats.org/drawingml/2006/main">
-            <a:off x="533400" y="10515600"/>
-            <a:ext cx="323850" cy="323850"/>
-          </a:xfrm>
-          <a:prstGeom xmlns:a="http://schemas.openxmlformats.org/drawingml/2006/main" prst="rect">
-            <a:avLst/>
-          </a:prstGeom>
-          <a:noFill xmlns:a="http://schemas.openxmlformats.org/drawingml/2006/main"/>
-          <a:ln xmlns:a="http://schemas.openxmlformats.org/drawingml/2006/main" w="0">
-            <a:noFill/>
-          </a:ln>
-        </p:spPr>
-        <p:txBody>
-          <a:bodyPr xmlns:a="http://schemas.openxmlformats.org/drawingml/2006/main" wrap="none" lIns="0" tIns="0" rIns="0" bIns="0" anchor="t">
-            <a:noAutofit/>
-          </a:bodyPr>
-          <a:lstStyle xmlns:a="http://schemas.openxmlformats.org/drawingml/2006/main"/>
-          <a:p xmlns:a="http://schemas.openxmlformats.org/drawingml/2006/main">
-            <a:pPr>
-              <a:defRPr sz="2025" b="1">
-                <a:solidFill>
-                  <a:srgbClr val="FFFFFF"/>
-                </a:solidFill>
-                <a:latin typeface="Arial"/>
-                <a:ea typeface="Arial"/>
-                <a:cs typeface="Arial"/>
-              </a:defRPr>
-            </a:pPr>
-            <a:r>
-              <a:rPr sz="2025" b="1">
-                <a:solidFill>
-                  <a:srgbClr val="FFFFFF"/>
-                </a:solidFill>
-                <a:latin typeface="Arial"/>
-                <a:ea typeface="Arial"/>
-                <a:cs typeface="Arial"/>
-              </a:rPr>
-              <a:t>4</a:t>
-            </a:r>
-          </a:p>
-        </p:txBody>
-      </p:sp>
-      <p:sp>
-        <p:nvSpPr>
-          <p:cNvPr id="45" name="">
-            <a:extLst xmlns:a="http://schemas.openxmlformats.org/drawingml/2006/main">
-              <a:ext uri="{FF2B5EF4-FFF2-40B4-BE49-F238E27FC236}">
-                <a16:creationId xmlns:a16="http://schemas.microsoft.com/office/drawing/2014/main" id="{86DB2083-A2E1-49DD-84B1-9227D63B5B8F}"/>
-              </a:ext>
-            </a:extLst>
-          </p:cNvPr>
-          <p:cNvSpPr>
-            <a:spLocks xmlns:a="http://schemas.openxmlformats.org/drawingml/2006/main" noGrp="1"/>
-          </p:cNvSpPr>
-          <p:nvPr/>
-        </p:nvSpPr>
-        <p:spPr>
-          <a:xfrm xmlns:a="http://schemas.openxmlformats.org/drawingml/2006/main">
-            <a:off x="933450" y="10544175"/>
-            <a:ext cx="8286750" cy="276225"/>
-          </a:xfrm>
-          <a:prstGeom xmlns:a="http://schemas.openxmlformats.org/drawingml/2006/main" prst="rect">
-            <a:avLst/>
-          </a:prstGeom>
-          <a:noFill xmlns:a="http://schemas.openxmlformats.org/drawingml/2006/main"/>
-          <a:ln xmlns:a="http://schemas.openxmlformats.org/drawingml/2006/main" w="0">
-            <a:noFill/>
-          </a:ln>
-        </p:spPr>
-        <p:txBody>
-          <a:bodyPr xmlns:a="http://schemas.openxmlformats.org/drawingml/2006/main" wrap="none" lIns="0" tIns="0" rIns="0" bIns="0" anchor="t">
-            <a:noAutofit/>
-          </a:bodyPr>
-          <a:lstStyle xmlns:a="http://schemas.openxmlformats.org/drawingml/2006/main"/>
-          <a:p xmlns:a="http://schemas.openxmlformats.org/drawingml/2006/main">
-            <a:pPr>
-              <a:defRPr sz="1650" b="1">
-                <a:solidFill>
-                  <a:srgbClr val="FFFFFF"/>
-                </a:solidFill>
-                <a:latin typeface="Arial"/>
-                <a:ea typeface="Arial"/>
-                <a:cs typeface="Arial"/>
-              </a:defRPr>
-            </a:pPr>
-            <a:r>
-              <a:rPr sz="1650" b="1">
-                <a:solidFill>
-                  <a:srgbClr val="FFFFFF"/>
-                </a:solidFill>
-                <a:latin typeface="Arial"/>
-                <a:ea typeface="Arial"/>
-                <a:cs typeface="Arial"/>
-              </a:rPr>
-              <a:t>ELEGIR EL ARCHIVO LOCAL</a:t>
-            </a:r>
-          </a:p>
-        </p:txBody>
-      </p:sp>
-      <p:sp>
-        <p:nvSpPr>
-          <p:cNvPr id="46" name="">
-            <a:extLst xmlns:a="http://schemas.openxmlformats.org/drawingml/2006/main">
-              <a:ext uri="{FF2B5EF4-FFF2-40B4-BE49-F238E27FC236}">
-                <a16:creationId xmlns:a16="http://schemas.microsoft.com/office/drawing/2014/main" id="{D226D4A4-C163-4088-B9C6-E98F77574BCC}"/>
-              </a:ext>
-            </a:extLst>
-          </p:cNvPr>
-          <p:cNvSpPr>
-            <a:spLocks xmlns:a="http://schemas.openxmlformats.org/drawingml/2006/main" noGrp="1"/>
-          </p:cNvSpPr>
-          <p:nvPr/>
-        </p:nvSpPr>
-        <p:spPr>
-          <a:xfrm xmlns:a="http://schemas.openxmlformats.org/drawingml/2006/main">
-            <a:off x="533400" y="11068050"/>
-            <a:ext cx="8686800" cy="228600"/>
-          </a:xfrm>
-          <a:prstGeom xmlns:a="http://schemas.openxmlformats.org/drawingml/2006/main" prst="rect">
-            <a:avLst/>
-          </a:prstGeom>
-          <a:noFill xmlns:a="http://schemas.openxmlformats.org/drawingml/2006/main"/>
-          <a:ln xmlns:a="http://schemas.openxmlformats.org/drawingml/2006/main" w="0">
-            <a:noFill/>
-          </a:ln>
-        </p:spPr>
-        <p:txBody>
-          <a:bodyPr xmlns:a="http://schemas.openxmlformats.org/drawingml/2006/main" wrap="none" lIns="0" tIns="0" rIns="0" bIns="0" anchor="t">
-            <a:noAutofit/>
-          </a:bodyPr>
-          <a:lstStyle xmlns:a="http://schemas.openxmlformats.org/drawingml/2006/main"/>
-          <a:p xmlns:a="http://schemas.openxmlformats.org/drawingml/2006/main">
-            <a:pPr>
-              <a:spcBef>
-                <a:spcPts val="0"/>
-              </a:spcBef>
-              <a:spcAft>
-                <a:spcPts val="0"/>
-              </a:spcAft>
-              <a:defRPr sz="1500" b="0">
-                <a:solidFill>
-                  <a:srgbClr val="142D48"/>
-                </a:solidFill>
-                <a:latin typeface="Arial"/>
-                <a:ea typeface="Arial"/>
-                <a:cs typeface="Arial"/>
-              </a:defRPr>
-            </a:pPr>
-            <a:r>
-              <a:rPr sz="1500" b="0">
-                <a:solidFill>
-                  <a:srgbClr val="142D48"/>
-                </a:solidFill>
-                <a:latin typeface="Arial"/>
-                <a:ea typeface="Arial"/>
-                <a:cs typeface="Arial"/>
-              </a:rPr>
-              <a:t>Solo para una auditoría:</a:t>
-            </a:r>
-          </a:p>
-        </p:txBody>
-      </p:sp>
-      <p:sp>
-        <p:nvSpPr>
-          <p:cNvPr id="47" name="">
-            <a:extLst xmlns:a="http://schemas.openxmlformats.org/drawingml/2006/main">
-              <a:ext uri="{FF2B5EF4-FFF2-40B4-BE49-F238E27FC236}">
-                <a16:creationId xmlns:a16="http://schemas.microsoft.com/office/drawing/2014/main" id="{0A8B285E-3720-41F9-86E3-E7988B23BD49}"/>
-              </a:ext>
-            </a:extLst>
-          </p:cNvPr>
-          <p:cNvSpPr>
-            <a:spLocks xmlns:a="http://schemas.openxmlformats.org/drawingml/2006/main" noGrp="1"/>
-          </p:cNvSpPr>
-          <p:nvPr/>
-        </p:nvSpPr>
-        <p:spPr>
-          <a:xfrm xmlns:a="http://schemas.openxmlformats.org/drawingml/2006/main">
-            <a:off x="533400" y="11449050"/>
-            <a:ext cx="8686800" cy="647700"/>
-          </a:xfrm>
-          <a:prstGeom xmlns:a="http://schemas.openxmlformats.org/drawingml/2006/main" prst="roundRect">
-            <a:avLst>
-              <a:gd name="adj" fmla="val 8824"/>
-            </a:avLst>
-          </a:prstGeom>
-          <a:solidFill xmlns:a="http://schemas.openxmlformats.org/drawingml/2006/main">
-            <a:srgbClr val="F4F9FD"/>
-          </a:solidFill>
-          <a:ln xmlns:a="http://schemas.openxmlformats.org/drawingml/2006/main" w="9525">
-            <a:solidFill>
-              <a:srgbClr val="ADD0E8"/>
-            </a:solidFill>
-          </a:ln>
-        </p:spPr>
-      </p:sp>
-      <p:sp>
-        <p:nvSpPr>
-          <p:cNvPr id="48" name="">
-            <a:extLst xmlns:a="http://schemas.openxmlformats.org/drawingml/2006/main">
-              <a:ext uri="{FF2B5EF4-FFF2-40B4-BE49-F238E27FC236}">
-                <a16:creationId xmlns:a16="http://schemas.microsoft.com/office/drawing/2014/main" id="{F27D21B5-C578-40DD-A16D-FC6B42E8A64B}"/>
-              </a:ext>
-            </a:extLst>
-          </p:cNvPr>
-          <p:cNvSpPr>
-            <a:spLocks xmlns:a="http://schemas.openxmlformats.org/drawingml/2006/main" noGrp="1"/>
-          </p:cNvSpPr>
-          <p:nvPr/>
-        </p:nvSpPr>
-        <p:spPr>
-          <a:xfrm xmlns:a="http://schemas.openxmlformats.org/drawingml/2006/main">
-            <a:off x="704850" y="11544300"/>
-            <a:ext cx="8343900" cy="171450"/>
-          </a:xfrm>
-          <a:prstGeom xmlns:a="http://schemas.openxmlformats.org/drawingml/2006/main" prst="rect">
-            <a:avLst/>
-          </a:prstGeom>
-          <a:noFill xmlns:a="http://schemas.openxmlformats.org/drawingml/2006/main"/>
-          <a:ln xmlns:a="http://schemas.openxmlformats.org/drawingml/2006/main" w="0">
-            <a:noFill/>
-          </a:ln>
-        </p:spPr>
-        <p:txBody>
-          <a:bodyPr xmlns:a="http://schemas.openxmlformats.org/drawingml/2006/main" wrap="none" lIns="0" tIns="0" rIns="0" bIns="0" anchor="t">
-            <a:noAutofit/>
-          </a:bodyPr>
-          <a:lstStyle xmlns:a="http://schemas.openxmlformats.org/drawingml/2006/main"/>
-          <a:p xmlns:a="http://schemas.openxmlformats.org/drawingml/2006/main">
-            <a:pPr>
-              <a:defRPr sz="1125" b="1">
-                <a:solidFill>
-                  <a:srgbClr val="006BBE"/>
-                </a:solidFill>
-                <a:latin typeface="Arial"/>
-                <a:ea typeface="Arial"/>
-                <a:cs typeface="Arial"/>
-              </a:defRPr>
-            </a:pPr>
-            <a:r>
-              <a:rPr sz="1125" b="1">
-                <a:solidFill>
-                  <a:srgbClr val="006BBE"/>
-                </a:solidFill>
-                <a:latin typeface="Arial"/>
-                <a:ea typeface="Arial"/>
-                <a:cs typeface="Arial"/>
-              </a:rPr>
-              <a:t>Terminal</a:t>
-            </a:r>
-          </a:p>
-        </p:txBody>
-      </p:sp>
-      <p:sp>
-        <p:nvSpPr>
-          <p:cNvPr id="49" name="">
-            <a:extLst xmlns:a="http://schemas.openxmlformats.org/drawingml/2006/main">
-              <a:ext uri="{FF2B5EF4-FFF2-40B4-BE49-F238E27FC236}">
-                <a16:creationId xmlns:a16="http://schemas.microsoft.com/office/drawing/2014/main" id="{0F1356B4-9C20-4C06-A1C5-25F3BF545E3E}"/>
-              </a:ext>
-            </a:extLst>
-          </p:cNvPr>
-          <p:cNvSpPr>
-            <a:spLocks xmlns:a="http://schemas.openxmlformats.org/drawingml/2006/main" noGrp="1"/>
-          </p:cNvSpPr>
-          <p:nvPr/>
-        </p:nvSpPr>
-        <p:spPr>
-          <a:xfrm xmlns:a="http://schemas.openxmlformats.org/drawingml/2006/main">
-            <a:off x="704850" y="11772900"/>
-            <a:ext cx="8343900" cy="209550"/>
-          </a:xfrm>
-          <a:prstGeom xmlns:a="http://schemas.openxmlformats.org/drawingml/2006/main" prst="rect">
-            <a:avLst/>
-          </a:prstGeom>
-          <a:noFill xmlns:a="http://schemas.openxmlformats.org/drawingml/2006/main"/>
-          <a:ln xmlns:a="http://schemas.openxmlformats.org/drawingml/2006/main" w="0">
-            <a:noFill/>
-          </a:ln>
-        </p:spPr>
-        <p:txBody>
-          <a:bodyPr xmlns:a="http://schemas.openxmlformats.org/drawingml/2006/main" wrap="none" lIns="0" tIns="0" rIns="0" bIns="0" anchor="t">
-            <a:noAutofit/>
-          </a:bodyPr>
-          <a:lstStyle xmlns:a="http://schemas.openxmlformats.org/drawingml/2006/main"/>
-          <a:p xmlns:a="http://schemas.openxmlformats.org/drawingml/2006/main">
-            <a:pPr>
-              <a:defRPr sz="1350" b="0">
-                <a:solidFill>
-                  <a:srgbClr val="142D48"/>
-                </a:solidFill>
-                <a:latin typeface="Consolas"/>
-                <a:ea typeface="Consolas"/>
-                <a:cs typeface="Consolas"/>
-              </a:defRPr>
-            </a:pPr>
-            <a:r>
-              <a:rPr sz="1350" b="0">
-                <a:solidFill>
-                  <a:srgbClr val="142D48"/>
-                </a:solidFill>
-                <a:latin typeface="Consolas"/>
-                <a:ea typeface="Consolas"/>
-                <a:cs typeface="Consolas"/>
-              </a:rPr>
-              <a:t>$ .\auditar.bat "entrada.xlsx" --referencias "DIPs References.xlsx"</a:t>
-            </a:r>
-          </a:p>
-        </p:txBody>
-      </p:sp>
-      <p:sp>
-        <p:nvSpPr>
-          <p:cNvPr id="50" name="">
-            <a:extLst xmlns:a="http://schemas.openxmlformats.org/drawingml/2006/main">
-              <a:ext uri="{FF2B5EF4-FFF2-40B4-BE49-F238E27FC236}">
-                <a16:creationId xmlns:a16="http://schemas.microsoft.com/office/drawing/2014/main" id="{BF7C1F58-A30D-4765-B9CC-7FECD839414C}"/>
-              </a:ext>
-            </a:extLst>
-          </p:cNvPr>
-          <p:cNvSpPr>
-            <a:spLocks xmlns:a="http://schemas.openxmlformats.org/drawingml/2006/main" noGrp="1"/>
-          </p:cNvSpPr>
-          <p:nvPr/>
-        </p:nvSpPr>
-        <p:spPr>
-          <a:xfrm xmlns:a="http://schemas.openxmlformats.org/drawingml/2006/main">
-            <a:off x="533400" y="12249150"/>
-            <a:ext cx="8686800" cy="228600"/>
-          </a:xfrm>
-          <a:prstGeom xmlns:a="http://schemas.openxmlformats.org/drawingml/2006/main" prst="rect">
-            <a:avLst/>
-          </a:prstGeom>
-          <a:noFill xmlns:a="http://schemas.openxmlformats.org/drawingml/2006/main"/>
-          <a:ln xmlns:a="http://schemas.openxmlformats.org/drawingml/2006/main" w="0">
-            <a:noFill/>
-          </a:ln>
-        </p:spPr>
-        <p:txBody>
-          <a:bodyPr xmlns:a="http://schemas.openxmlformats.org/drawingml/2006/main" wrap="none" lIns="0" tIns="0" rIns="0" bIns="0" anchor="t">
-            <a:noAutofit/>
-          </a:bodyPr>
-          <a:lstStyle xmlns:a="http://schemas.openxmlformats.org/drawingml/2006/main"/>
-          <a:p xmlns:a="http://schemas.openxmlformats.org/drawingml/2006/main">
-            <a:pPr>
-              <a:spcBef>
-                <a:spcPts val="0"/>
-              </a:spcBef>
-              <a:spcAft>
-                <a:spcPts val="0"/>
-              </a:spcAft>
-              <a:defRPr sz="1500" b="0">
-                <a:solidFill>
-                  <a:srgbClr val="142D48"/>
-                </a:solidFill>
-                <a:latin typeface="Arial"/>
-                <a:ea typeface="Arial"/>
-                <a:cs typeface="Arial"/>
-              </a:defRPr>
-            </a:pPr>
-            <a:r>
-              <a:rPr sz="1500" b="0">
-                <a:solidFill>
-                  <a:srgbClr val="142D48"/>
-                </a:solidFill>
-                <a:latin typeface="Arial"/>
-                <a:ea typeface="Arial"/>
-                <a:cs typeface="Arial"/>
-              </a:rPr>
-              <a:t>Uso local fijo: guarde en </a:t>
-            </a:r>
-            <a:r>
-              <a:rPr sz="1350" b="0">
-                <a:solidFill>
-                  <a:srgbClr val="073C78"/>
-                </a:solidFill>
-                <a:latin typeface="Consolas"/>
-                <a:ea typeface="Consolas"/>
-                <a:cs typeface="Consolas"/>
-              </a:rPr>
-              <a:t>config/config.yaml</a:t>
-            </a:r>
-            <a:r>
-              <a:rPr sz="1500" b="0">
-                <a:solidFill>
-                  <a:srgbClr val="142D48"/>
-                </a:solidFill>
-                <a:latin typeface="Arial"/>
-                <a:ea typeface="Arial"/>
-                <a:cs typeface="Arial"/>
-              </a:rPr>
-              <a:t>:</a:t>
-            </a:r>
-          </a:p>
-        </p:txBody>
-      </p:sp>
-      <p:sp>
-        <p:nvSpPr>
-          <p:cNvPr id="51" name="">
-            <a:extLst xmlns:a="http://schemas.openxmlformats.org/drawingml/2006/main">
-              <a:ext uri="{FF2B5EF4-FFF2-40B4-BE49-F238E27FC236}">
-                <a16:creationId xmlns:a16="http://schemas.microsoft.com/office/drawing/2014/main" id="{9168140A-8C1B-47E8-85F1-4950B44C4F24}"/>
-              </a:ext>
-            </a:extLst>
-          </p:cNvPr>
-          <p:cNvSpPr>
-            <a:spLocks xmlns:a="http://schemas.openxmlformats.org/drawingml/2006/main" noGrp="1"/>
-          </p:cNvSpPr>
-          <p:nvPr/>
-        </p:nvSpPr>
-        <p:spPr>
-          <a:xfrm xmlns:a="http://schemas.openxmlformats.org/drawingml/2006/main">
-            <a:off x="533400" y="12630150"/>
-            <a:ext cx="8686800" cy="647700"/>
-          </a:xfrm>
-          <a:prstGeom xmlns:a="http://schemas.openxmlformats.org/drawingml/2006/main" prst="roundRect">
-            <a:avLst>
-              <a:gd name="adj" fmla="val 8824"/>
-            </a:avLst>
-          </a:prstGeom>
-          <a:solidFill xmlns:a="http://schemas.openxmlformats.org/drawingml/2006/main">
-            <a:srgbClr val="F4F9FD"/>
-          </a:solidFill>
-          <a:ln xmlns:a="http://schemas.openxmlformats.org/drawingml/2006/main" w="9525">
-            <a:solidFill>
-              <a:srgbClr val="ADD0E8"/>
-            </a:solidFill>
-          </a:ln>
-        </p:spPr>
-      </p:sp>
-      <p:sp>
-        <p:nvSpPr>
-          <p:cNvPr id="52" name="">
-            <a:extLst xmlns:a="http://schemas.openxmlformats.org/drawingml/2006/main">
-              <a:ext uri="{FF2B5EF4-FFF2-40B4-BE49-F238E27FC236}">
-                <a16:creationId xmlns:a16="http://schemas.microsoft.com/office/drawing/2014/main" id="{703F0217-235F-4AD4-9CF5-DD324D73B824}"/>
-              </a:ext>
-            </a:extLst>
-          </p:cNvPr>
-          <p:cNvSpPr>
-            <a:spLocks xmlns:a="http://schemas.openxmlformats.org/drawingml/2006/main" noGrp="1"/>
-          </p:cNvSpPr>
-          <p:nvPr/>
-        </p:nvSpPr>
-        <p:spPr>
-          <a:xfrm xmlns:a="http://schemas.openxmlformats.org/drawingml/2006/main">
-            <a:off x="704850" y="12725400"/>
-            <a:ext cx="8343900" cy="171450"/>
-          </a:xfrm>
-          <a:prstGeom xmlns:a="http://schemas.openxmlformats.org/drawingml/2006/main" prst="rect">
-            <a:avLst/>
-          </a:prstGeom>
-          <a:noFill xmlns:a="http://schemas.openxmlformats.org/drawingml/2006/main"/>
-          <a:ln xmlns:a="http://schemas.openxmlformats.org/drawingml/2006/main" w="0">
-            <a:noFill/>
-          </a:ln>
-        </p:spPr>
-        <p:txBody>
-          <a:bodyPr xmlns:a="http://schemas.openxmlformats.org/drawingml/2006/main" wrap="none" lIns="0" tIns="0" rIns="0" bIns="0" anchor="t">
-            <a:noAutofit/>
-          </a:bodyPr>
-          <a:lstStyle xmlns:a="http://schemas.openxmlformats.org/drawingml/2006/main"/>
-          <a:p xmlns:a="http://schemas.openxmlformats.org/drawingml/2006/main">
-            <a:pPr>
-              <a:defRPr sz="1125" b="1">
-                <a:solidFill>
-                  <a:srgbClr val="006BBE"/>
-                </a:solidFill>
-                <a:latin typeface="Arial"/>
-                <a:ea typeface="Arial"/>
-                <a:cs typeface="Arial"/>
-              </a:defRPr>
-            </a:pPr>
-            <a:r>
-              <a:rPr sz="1125" b="1">
-                <a:solidFill>
-                  <a:srgbClr val="006BBE"/>
-                </a:solidFill>
-                <a:latin typeface="Arial"/>
-                <a:ea typeface="Arial"/>
-                <a:cs typeface="Arial"/>
-              </a:rPr>
-              <a:t>YAML</a:t>
-            </a:r>
-          </a:p>
-        </p:txBody>
-      </p:sp>
-      <p:sp>
-        <p:nvSpPr>
-          <p:cNvPr id="53" name="">
-            <a:extLst xmlns:a="http://schemas.openxmlformats.org/drawingml/2006/main">
-              <a:ext uri="{FF2B5EF4-FFF2-40B4-BE49-F238E27FC236}">
-                <a16:creationId xmlns:a16="http://schemas.microsoft.com/office/drawing/2014/main" id="{B9C7466D-BDDF-48DC-A12A-E4A42BED5478}"/>
-              </a:ext>
-            </a:extLst>
-          </p:cNvPr>
-          <p:cNvSpPr>
-            <a:spLocks xmlns:a="http://schemas.openxmlformats.org/drawingml/2006/main" noGrp="1"/>
-          </p:cNvSpPr>
-          <p:nvPr/>
-        </p:nvSpPr>
-        <p:spPr>
-          <a:xfrm xmlns:a="http://schemas.openxmlformats.org/drawingml/2006/main">
-            <a:off x="704850" y="12954000"/>
-            <a:ext cx="8343900" cy="209550"/>
-          </a:xfrm>
-          <a:prstGeom xmlns:a="http://schemas.openxmlformats.org/drawingml/2006/main" prst="rect">
-            <a:avLst/>
-          </a:prstGeom>
-          <a:noFill xmlns:a="http://schemas.openxmlformats.org/drawingml/2006/main"/>
-          <a:ln xmlns:a="http://schemas.openxmlformats.org/drawingml/2006/main" w="0">
-            <a:noFill/>
-          </a:ln>
-        </p:spPr>
-        <p:txBody>
-          <a:bodyPr xmlns:a="http://schemas.openxmlformats.org/drawingml/2006/main" wrap="none" lIns="0" tIns="0" rIns="0" bIns="0" anchor="t">
-            <a:noAutofit/>
-          </a:bodyPr>
-          <a:lstStyle xmlns:a="http://schemas.openxmlformats.org/drawingml/2006/main"/>
-          <a:p xmlns:a="http://schemas.openxmlformats.org/drawingml/2006/main">
-            <a:pPr>
-              <a:defRPr sz="1350" b="0">
-                <a:solidFill>
-                  <a:srgbClr val="142D48"/>
-                </a:solidFill>
-                <a:latin typeface="Consolas"/>
-                <a:ea typeface="Consolas"/>
-                <a:cs typeface="Consolas"/>
-              </a:defRPr>
-            </a:pPr>
-            <a:r>
-              <a:rPr sz="1350" b="0">
-                <a:solidFill>
-                  <a:srgbClr val="142D48"/>
-                </a:solidFill>
-                <a:latin typeface="Consolas"/>
-                <a:ea typeface="Consolas"/>
-                <a:cs typeface="Consolas"/>
-              </a:rPr>
-              <a:t>referencias_sharepoint: ""</a:t>
-            </a:r>
-          </a:p>
-        </p:txBody>
-      </p:sp>
     </p:spTree>
     <p:extLst>
       <p:ext uri="{BB962C8B-B14F-4D97-AF65-F5344CB8AC3E}">
-        <p14:creationId xmlns:p14="http://schemas.microsoft.com/office/powerpoint/2010/main" val="370422669"/>
+        <p14:creationId xmlns:p14="http://schemas.microsoft.com/office/powerpoint/2010/main" val="1433484881"/>
       </p:ext>
     </p:extLst>
   </p:cSld>

</xml_diff>

<commit_message>
Unifica las discrepancias con los resultados actuales de auditoría
</commit_message>
<xml_diff>
--- a/docs/Guia_DIPS_reglas_referencias.pptx
+++ b/docs/Guia_DIPS_reglas_referencias.pptx
@@ -2,15 +2,15 @@
 <file path=ppt/presentation.xml><?xml version="1.0" encoding="utf-8"?>
 <p:presentation xmlns:p="http://schemas.openxmlformats.org/presentationml/2006/main">
   <p:sldMasterIdLst>
-    <p:sldMasterId xmlns:r="http://schemas.openxmlformats.org/officeDocument/2006/relationships" id="2147483648" r:id="R31581204a7d148a9"/>
+    <p:sldMasterId xmlns:r="http://schemas.openxmlformats.org/officeDocument/2006/relationships" id="2147483648" r:id="Rd9f84b851fb04261"/>
   </p:sldMasterIdLst>
   <p:notesMasterIdLst>
-    <p:notesMasterId xmlns:r="http://schemas.openxmlformats.org/officeDocument/2006/relationships" r:id="R5fbe364494374f9a"/>
+    <p:notesMasterId xmlns:r="http://schemas.openxmlformats.org/officeDocument/2006/relationships" r:id="R7a7b749c24db4fe7"/>
   </p:notesMasterIdLst>
   <p:sldIdLst>
-    <p:sldId xmlns:r="http://schemas.openxmlformats.org/officeDocument/2006/relationships" id="256" r:id="R9fdbd077b76e49b1"/>
-    <p:sldId xmlns:r="http://schemas.openxmlformats.org/officeDocument/2006/relationships" id="257" r:id="R3c4cd354c10f488b"/>
-    <p:sldId xmlns:r="http://schemas.openxmlformats.org/officeDocument/2006/relationships" id="258" r:id="Rb747c7c1feb84fa5"/>
+    <p:sldId xmlns:r="http://schemas.openxmlformats.org/officeDocument/2006/relationships" id="256" r:id="Rc4b42ffcceb042be"/>
+    <p:sldId xmlns:r="http://schemas.openxmlformats.org/officeDocument/2006/relationships" id="257" r:id="Rbad0a0b8a0b84da2"/>
+    <p:sldId xmlns:r="http://schemas.openxmlformats.org/officeDocument/2006/relationships" id="258" r:id="Rc3cbef05f1714dc2"/>
   </p:sldIdLst>
   <p:sldSz cx="9753600" cy="14630400"/>
   <p:notesSz cx="6858000" cy="9144000"/>
@@ -652,7 +652,7 @@
   </p:cSld>
   <p:clrMap bg1="lt1" tx1="dk1" bg2="lt2" tx2="dk2" accent1="accent1" accent2="accent2" accent3="accent3" accent4="accent4" accent5="accent5" accent6="accent6" hlink="hlink" folHlink="folHlink"/>
   <p:sldLayoutIdLst>
-    <p:sldLayoutId xmlns:r="http://schemas.openxmlformats.org/officeDocument/2006/relationships" id="2147483649" r:id="R69dea106c29b4087"/>
+    <p:sldLayoutId xmlns:r="http://schemas.openxmlformats.org/officeDocument/2006/relationships" id="2147483649" r:id="R77aae3c7c14843c1"/>
   </p:sldLayoutIdLst>
   <p:txStyles>
     <p:titleStyle>
@@ -1276,6 +1276,7 @@
           <a:lstStyle xmlns:a="http://schemas.openxmlformats.org/drawingml/2006/main"/>
           <a:p xmlns:a="http://schemas.openxmlformats.org/drawingml/2006/main">
             <a:pPr>
+              <a:buNone/>
               <a:defRPr sz="3450" b="1">
                 <a:solidFill>
                   <a:srgbClr val="FFFFFF"/>
@@ -1363,6 +1364,7 @@
           <a:lstStyle xmlns:a="http://schemas.openxmlformats.org/drawingml/2006/main"/>
           <a:p xmlns:a="http://schemas.openxmlformats.org/drawingml/2006/main">
             <a:pPr>
+              <a:buNone/>
               <a:defRPr sz="3000" b="1">
                 <a:solidFill>
                   <a:srgbClr val="FFFFFF"/>
@@ -1420,6 +1422,7 @@
           <a:lstStyle xmlns:a="http://schemas.openxmlformats.org/drawingml/2006/main"/>
           <a:p xmlns:a="http://schemas.openxmlformats.org/drawingml/2006/main">
             <a:pPr>
+              <a:buNone/>
               <a:defRPr sz="1650" b="1">
                 <a:solidFill>
                   <a:srgbClr val="FFFFFF"/>
@@ -1445,14 +1448,14 @@
       </p:sp>
       <p:pic>
         <p:nvPicPr>
-          <p:cNvPr id="56" name=""/>
+          <p:cNvPr id="60" name=""/>
           <p:cNvPicPr>
             <a:picLocks xmlns:a="http://schemas.openxmlformats.org/drawingml/2006/main" noChangeAspect="1"/>
           </p:cNvPicPr>
           <p:nvPr/>
         </p:nvPicPr>
         <p:blipFill>
-          <a:blip xmlns:r="http://schemas.openxmlformats.org/officeDocument/2006/relationships" xmlns:a="http://schemas.openxmlformats.org/drawingml/2006/main" r:embed="R4da05ed52fa64037"/>
+          <a:blip xmlns:r="http://schemas.openxmlformats.org/officeDocument/2006/relationships" xmlns:a="http://schemas.openxmlformats.org/drawingml/2006/main" r:embed="R20f9ef8d25eb43ad"/>
           <a:stretch xmlns:a="http://schemas.openxmlformats.org/drawingml/2006/main"/>
         </p:blipFill>
         <p:spPr>
@@ -1505,14 +1508,14 @@
       </p:sp>
       <p:pic>
         <p:nvPicPr>
-          <p:cNvPr id="58" name=""/>
+          <p:cNvPr id="62" name=""/>
           <p:cNvPicPr>
             <a:picLocks xmlns:a="http://schemas.openxmlformats.org/drawingml/2006/main" noChangeAspect="1"/>
           </p:cNvPicPr>
           <p:nvPr/>
         </p:nvPicPr>
         <p:blipFill>
-          <a:blip xmlns:r="http://schemas.openxmlformats.org/officeDocument/2006/relationships" xmlns:a="http://schemas.openxmlformats.org/drawingml/2006/main" r:embed="R67e7f37db75e4835"/>
+          <a:blip xmlns:r="http://schemas.openxmlformats.org/officeDocument/2006/relationships" xmlns:a="http://schemas.openxmlformats.org/drawingml/2006/main" r:embed="R444cc8f8a0194550"/>
           <a:stretch xmlns:a="http://schemas.openxmlformats.org/drawingml/2006/main"/>
         </p:blipFill>
         <p:spPr>
@@ -1559,6 +1562,7 @@
           <a:lstStyle xmlns:a="http://schemas.openxmlformats.org/drawingml/2006/main"/>
           <a:p xmlns:a="http://schemas.openxmlformats.org/drawingml/2006/main">
             <a:pPr>
+              <a:buNone/>
               <a:defRPr sz="2250" b="1">
                 <a:solidFill>
                   <a:srgbClr val="FFFFFF"/>
@@ -1616,6 +1620,7 @@
           <a:lstStyle xmlns:a="http://schemas.openxmlformats.org/drawingml/2006/main"/>
           <a:p xmlns:a="http://schemas.openxmlformats.org/drawingml/2006/main">
             <a:pPr>
+              <a:buNone/>
               <a:defRPr sz="1500" b="0">
                 <a:solidFill>
                   <a:srgbClr val="FFFFFF"/>
@@ -1679,6 +1684,7 @@
               <a:spcAft>
                 <a:spcPts val="0"/>
               </a:spcAft>
+              <a:buNone/>
               <a:defRPr sz="1500" b="0">
                 <a:solidFill>
                   <a:srgbClr val="142D48"/>
@@ -1742,6 +1748,7 @@
               <a:spcAft>
                 <a:spcPts val="0"/>
               </a:spcAft>
+              <a:buNone/>
               <a:defRPr sz="1500" b="0">
                 <a:solidFill>
                   <a:srgbClr val="142D48"/>
@@ -1827,6 +1834,7 @@
               <a:spcAft>
                 <a:spcPts val="0"/>
               </a:spcAft>
+              <a:buNone/>
               <a:defRPr sz="1500" b="0">
                 <a:solidFill>
                   <a:srgbClr val="142D48"/>
@@ -1972,6 +1980,7 @@
           <a:lstStyle xmlns:a="http://schemas.openxmlformats.org/drawingml/2006/main"/>
           <a:p xmlns:a="http://schemas.openxmlformats.org/drawingml/2006/main">
             <a:pPr>
+              <a:buNone/>
               <a:defRPr sz="2025" b="1">
                 <a:solidFill>
                   <a:srgbClr val="FFFFFF"/>
@@ -2029,6 +2038,7 @@
           <a:lstStyle xmlns:a="http://schemas.openxmlformats.org/drawingml/2006/main"/>
           <a:p xmlns:a="http://schemas.openxmlformats.org/drawingml/2006/main">
             <a:pPr>
+              <a:buNone/>
               <a:defRPr sz="1650" b="1">
                 <a:solidFill>
                   <a:srgbClr val="FFFFFF"/>
@@ -2092,6 +2102,7 @@
               <a:spcAft>
                 <a:spcPts val="0"/>
               </a:spcAft>
+              <a:buNone/>
               <a:defRPr sz="1500" b="0">
                 <a:solidFill>
                   <a:srgbClr val="142D48"/>
@@ -2177,6 +2188,7 @@
               <a:spcAft>
                 <a:spcPts val="0"/>
               </a:spcAft>
+              <a:buNone/>
               <a:defRPr sz="1500" b="0">
                 <a:solidFill>
                   <a:srgbClr val="142D48"/>
@@ -2290,6 +2302,7 @@
           <a:lstStyle xmlns:a="http://schemas.openxmlformats.org/drawingml/2006/main"/>
           <a:p xmlns:a="http://schemas.openxmlformats.org/drawingml/2006/main">
             <a:pPr>
+              <a:buNone/>
               <a:defRPr sz="1125" b="1">
                 <a:solidFill>
                   <a:srgbClr val="006BBE"/>
@@ -2347,6 +2360,7 @@
           <a:lstStyle xmlns:a="http://schemas.openxmlformats.org/drawingml/2006/main"/>
           <a:p xmlns:a="http://schemas.openxmlformats.org/drawingml/2006/main">
             <a:pPr>
+              <a:buNone/>
               <a:defRPr sz="1350" b="0">
                 <a:solidFill>
                   <a:srgbClr val="142D48"/>
@@ -2404,6 +2418,7 @@
           <a:lstStyle xmlns:a="http://schemas.openxmlformats.org/drawingml/2006/main"/>
           <a:p xmlns:a="http://schemas.openxmlformats.org/drawingml/2006/main">
             <a:pPr>
+              <a:buNone/>
               <a:defRPr sz="1350" b="0">
                 <a:solidFill>
                   <a:srgbClr val="142D48"/>
@@ -2527,6 +2542,7 @@
           <a:lstStyle xmlns:a="http://schemas.openxmlformats.org/drawingml/2006/main"/>
           <a:p xmlns:a="http://schemas.openxmlformats.org/drawingml/2006/main">
             <a:pPr>
+              <a:buNone/>
               <a:defRPr sz="2025" b="1">
                 <a:solidFill>
                   <a:srgbClr val="FFFFFF"/>
@@ -2584,6 +2600,7 @@
           <a:lstStyle xmlns:a="http://schemas.openxmlformats.org/drawingml/2006/main"/>
           <a:p xmlns:a="http://schemas.openxmlformats.org/drawingml/2006/main">
             <a:pPr>
+              <a:buNone/>
               <a:defRPr sz="1650" b="1">
                 <a:solidFill>
                   <a:srgbClr val="FFFFFF"/>
@@ -2675,6 +2692,7 @@
           <a:lstStyle xmlns:a="http://schemas.openxmlformats.org/drawingml/2006/main"/>
           <a:p xmlns:a="http://schemas.openxmlformats.org/drawingml/2006/main">
             <a:pPr>
+              <a:buNone/>
               <a:defRPr sz="1125" b="1">
                 <a:solidFill>
                   <a:srgbClr val="006BBE"/>
@@ -2732,6 +2750,7 @@
           <a:lstStyle xmlns:a="http://schemas.openxmlformats.org/drawingml/2006/main"/>
           <a:p xmlns:a="http://schemas.openxmlformats.org/drawingml/2006/main">
             <a:pPr>
+              <a:buNone/>
               <a:defRPr sz="1350" b="0">
                 <a:solidFill>
                   <a:srgbClr val="142D48"/>
@@ -2795,6 +2814,7 @@
               <a:spcAft>
                 <a:spcPts val="0"/>
               </a:spcAft>
+              <a:buNone/>
               <a:defRPr sz="1500" b="0">
                 <a:solidFill>
                   <a:srgbClr val="142D48"/>
@@ -2869,6 +2889,7 @@
               <a:spcAft>
                 <a:spcPts val="0"/>
               </a:spcAft>
+              <a:buNone/>
               <a:defRPr sz="1500" b="0">
                 <a:solidFill>
                   <a:srgbClr val="142D48"/>
@@ -2943,6 +2964,7 @@
               <a:spcAft>
                 <a:spcPts val="0"/>
               </a:spcAft>
+              <a:buNone/>
               <a:defRPr sz="1500" b="0">
                 <a:solidFill>
                   <a:srgbClr val="142D48"/>
@@ -3006,6 +3028,7 @@
               <a:spcAft>
                 <a:spcPts val="0"/>
               </a:spcAft>
+              <a:buNone/>
               <a:defRPr sz="1500" b="0">
                 <a:solidFill>
                   <a:srgbClr val="142D48"/>
@@ -3151,6 +3174,7 @@
           <a:lstStyle xmlns:a="http://schemas.openxmlformats.org/drawingml/2006/main"/>
           <a:p xmlns:a="http://schemas.openxmlformats.org/drawingml/2006/main">
             <a:pPr>
+              <a:buNone/>
               <a:defRPr sz="2025" b="1">
                 <a:solidFill>
                   <a:srgbClr val="FFFFFF"/>
@@ -3208,6 +3232,7 @@
           <a:lstStyle xmlns:a="http://schemas.openxmlformats.org/drawingml/2006/main"/>
           <a:p xmlns:a="http://schemas.openxmlformats.org/drawingml/2006/main">
             <a:pPr>
+              <a:buNone/>
               <a:defRPr sz="1650" b="1">
                 <a:solidFill>
                   <a:srgbClr val="FFFFFF"/>
@@ -3271,6 +3296,7 @@
               <a:spcAft>
                 <a:spcPts val="0"/>
               </a:spcAft>
+              <a:buNone/>
               <a:defRPr sz="1500" b="0">
                 <a:solidFill>
                   <a:srgbClr val="142D48"/>
@@ -3334,6 +3360,7 @@
               <a:spcAft>
                 <a:spcPts val="0"/>
               </a:spcAft>
+              <a:buNone/>
               <a:defRPr sz="1500" b="0">
                 <a:solidFill>
                   <a:srgbClr val="142D48"/>
@@ -3425,6 +3452,7 @@
           <a:lstStyle xmlns:a="http://schemas.openxmlformats.org/drawingml/2006/main"/>
           <a:p xmlns:a="http://schemas.openxmlformats.org/drawingml/2006/main">
             <a:pPr>
+              <a:buNone/>
               <a:defRPr sz="1125" b="1">
                 <a:solidFill>
                   <a:srgbClr val="006BBE"/>
@@ -3482,6 +3510,7 @@
           <a:lstStyle xmlns:a="http://schemas.openxmlformats.org/drawingml/2006/main"/>
           <a:p xmlns:a="http://schemas.openxmlformats.org/drawingml/2006/main">
             <a:pPr>
+              <a:buNone/>
               <a:defRPr sz="1350" b="0">
                 <a:solidFill>
                   <a:srgbClr val="142D48"/>
@@ -3545,6 +3574,7 @@
               <a:spcAft>
                 <a:spcPts val="0"/>
               </a:spcAft>
+              <a:buNone/>
               <a:defRPr sz="1500" b="0">
                 <a:solidFill>
                   <a:srgbClr val="142D48"/>
@@ -3608,6 +3638,7 @@
               <a:spcAft>
                 <a:spcPts val="0"/>
               </a:spcAft>
+              <a:buNone/>
               <a:defRPr sz="1500" b="0">
                 <a:solidFill>
                   <a:srgbClr val="142D48"/>
@@ -3648,7 +3679,7 @@
         <p:spPr>
           <a:xfrm xmlns:a="http://schemas.openxmlformats.org/drawingml/2006/main">
             <a:off x="304800" y="11258550"/>
-            <a:ext cx="9144000" cy="1457325"/>
+            <a:ext cx="9144000" cy="1685925"/>
           </a:xfrm>
           <a:prstGeom xmlns:a="http://schemas.openxmlformats.org/drawingml/2006/main" prst="roundRect">
             <a:avLst>
@@ -3705,6 +3736,7 @@
               <a:spcAft>
                 <a:spcPts val="0"/>
               </a:spcAft>
+              <a:buNone/>
               <a:defRPr sz="1800" b="1">
                 <a:solidFill>
                   <a:srgbClr val="073C78"/>
@@ -3779,6 +3811,7 @@
               <a:spcAft>
                 <a:spcPts val="0"/>
               </a:spcAft>
+              <a:buNone/>
               <a:defRPr sz="1500" b="0">
                 <a:solidFill>
                   <a:srgbClr val="142D48"/>
@@ -3908,6 +3941,7 @@
               <a:spcAft>
                 <a:spcPts val="0"/>
               </a:spcAft>
+              <a:buNone/>
               <a:defRPr sz="1500" b="0">
                 <a:solidFill>
                   <a:srgbClr val="142D48"/>
@@ -3971,6 +4005,7 @@
               <a:spcAft>
                 <a:spcPts val="0"/>
               </a:spcAft>
+              <a:buNone/>
               <a:defRPr sz="1500" b="0">
                 <a:solidFill>
                   <a:srgbClr val="142D48"/>
@@ -3989,7 +4024,64 @@
                 <a:ea typeface="Arial"/>
                 <a:cs typeface="Arial"/>
               </a:rPr>
-              <a:t>SIN FUENTE: verificar referencia. OK: completar revisión manual.</a:t>
+              <a:t>SIN FUENTE EN DIPS REFERENCES: verificar referencia.</a:t>
+            </a:r>
+          </a:p>
+        </p:txBody>
+      </p:sp>
+      <p:sp>
+        <p:nvSpPr>
+          <p:cNvPr id="54" name="">
+            <a:extLst xmlns:a="http://schemas.openxmlformats.org/drawingml/2006/main">
+              <a:ext uri="{FF2B5EF4-FFF2-40B4-BE49-F238E27FC236}">
+                <a16:creationId xmlns:a16="http://schemas.microsoft.com/office/drawing/2014/main" id="{9B4967CA-71C2-4BFB-8EEC-6EBC913A6ACF}"/>
+              </a:ext>
+            </a:extLst>
+          </p:cNvPr>
+          <p:cNvSpPr>
+            <a:spLocks xmlns:a="http://schemas.openxmlformats.org/drawingml/2006/main" noGrp="1"/>
+          </p:cNvSpPr>
+          <p:nvPr/>
+        </p:nvSpPr>
+        <p:spPr>
+          <a:xfrm xmlns:a="http://schemas.openxmlformats.org/drawingml/2006/main">
+            <a:off x="533400" y="12525375"/>
+            <a:ext cx="8686800" cy="228600"/>
+          </a:xfrm>
+          <a:prstGeom xmlns:a="http://schemas.openxmlformats.org/drawingml/2006/main" prst="rect">
+            <a:avLst/>
+          </a:prstGeom>
+          <a:noFill xmlns:a="http://schemas.openxmlformats.org/drawingml/2006/main"/>
+          <a:ln xmlns:a="http://schemas.openxmlformats.org/drawingml/2006/main" w="0">
+            <a:noFill/>
+          </a:ln>
+        </p:spPr>
+        <p:txBody>
+          <a:bodyPr xmlns:a="http://schemas.openxmlformats.org/drawingml/2006/main" lIns="0" tIns="0" rIns="0" bIns="0">
+            <a:noAutofit/>
+          </a:bodyPr>
+          <a:lstStyle xmlns:a="http://schemas.openxmlformats.org/drawingml/2006/main"/>
+          <a:p xmlns:a="http://schemas.openxmlformats.org/drawingml/2006/main">
+            <a:pPr>
+              <a:defRPr sz="1500">
+                <a:solidFill>
+                  <a:srgbClr val="142D48"/>
+                </a:solidFill>
+                <a:latin typeface="Arial"/>
+                <a:ea typeface="Arial"/>
+                <a:cs typeface="Arial"/>
+              </a:defRPr>
+            </a:pPr>
+            <a:r>
+              <a:rPr sz="1500">
+                <a:solidFill>
+                  <a:srgbClr val="142D48"/>
+                </a:solidFill>
+                <a:latin typeface="Arial"/>
+                <a:ea typeface="Arial"/>
+                <a:cs typeface="Arial"/>
+              </a:rPr>
+              <a:t>CORREGIDO EN CIERRE y OK: completar revisión manual.</a:t>
             </a:r>
           </a:p>
         </p:txBody>
@@ -4101,6 +4193,7 @@
           <a:lstStyle xmlns:a="http://schemas.openxmlformats.org/drawingml/2006/main"/>
           <a:p xmlns:a="http://schemas.openxmlformats.org/drawingml/2006/main">
             <a:pPr>
+              <a:buNone/>
               <a:defRPr sz="3450" b="1">
                 <a:solidFill>
                   <a:srgbClr val="FFFFFF"/>
@@ -4188,6 +4281,7 @@
           <a:lstStyle xmlns:a="http://schemas.openxmlformats.org/drawingml/2006/main"/>
           <a:p xmlns:a="http://schemas.openxmlformats.org/drawingml/2006/main">
             <a:pPr>
+              <a:buNone/>
               <a:defRPr sz="3000" b="1">
                 <a:solidFill>
                   <a:srgbClr val="FFFFFF"/>
@@ -4245,6 +4339,7 @@
           <a:lstStyle xmlns:a="http://schemas.openxmlformats.org/drawingml/2006/main"/>
           <a:p xmlns:a="http://schemas.openxmlformats.org/drawingml/2006/main">
             <a:pPr>
+              <a:buNone/>
               <a:defRPr sz="1650" b="1">
                 <a:solidFill>
                   <a:srgbClr val="FFFFFF"/>
@@ -4270,14 +4365,14 @@
       </p:sp>
       <p:pic>
         <p:nvPicPr>
-          <p:cNvPr id="51" name=""/>
+          <p:cNvPr id="55" name=""/>
           <p:cNvPicPr>
             <a:picLocks xmlns:a="http://schemas.openxmlformats.org/drawingml/2006/main" noChangeAspect="1"/>
           </p:cNvPicPr>
           <p:nvPr/>
         </p:nvPicPr>
         <p:blipFill>
-          <a:blip xmlns:r="http://schemas.openxmlformats.org/officeDocument/2006/relationships" xmlns:a="http://schemas.openxmlformats.org/drawingml/2006/main" r:embed="Ra3404a10c3e143fd"/>
+          <a:blip xmlns:r="http://schemas.openxmlformats.org/officeDocument/2006/relationships" xmlns:a="http://schemas.openxmlformats.org/drawingml/2006/main" r:embed="R61f97f8fa5674d88"/>
           <a:stretch xmlns:a="http://schemas.openxmlformats.org/drawingml/2006/main"/>
         </p:blipFill>
         <p:spPr>
@@ -4330,14 +4425,14 @@
       </p:sp>
       <p:pic>
         <p:nvPicPr>
-          <p:cNvPr id="53" name=""/>
+          <p:cNvPr id="57" name=""/>
           <p:cNvPicPr>
             <a:picLocks xmlns:a="http://schemas.openxmlformats.org/drawingml/2006/main" noChangeAspect="1"/>
           </p:cNvPicPr>
           <p:nvPr/>
         </p:nvPicPr>
         <p:blipFill>
-          <a:blip xmlns:r="http://schemas.openxmlformats.org/officeDocument/2006/relationships" xmlns:a="http://schemas.openxmlformats.org/drawingml/2006/main" r:embed="Re45c7ae809334aac"/>
+          <a:blip xmlns:r="http://schemas.openxmlformats.org/officeDocument/2006/relationships" xmlns:a="http://schemas.openxmlformats.org/drawingml/2006/main" r:embed="Re9b8f472c0f74e1e"/>
           <a:stretch xmlns:a="http://schemas.openxmlformats.org/drawingml/2006/main"/>
         </p:blipFill>
         <p:spPr>
@@ -4384,6 +4479,7 @@
           <a:lstStyle xmlns:a="http://schemas.openxmlformats.org/drawingml/2006/main"/>
           <a:p xmlns:a="http://schemas.openxmlformats.org/drawingml/2006/main">
             <a:pPr>
+              <a:buNone/>
               <a:defRPr sz="2250" b="1">
                 <a:solidFill>
                   <a:srgbClr val="FFFFFF"/>
@@ -4441,6 +4537,7 @@
           <a:lstStyle xmlns:a="http://schemas.openxmlformats.org/drawingml/2006/main"/>
           <a:p xmlns:a="http://schemas.openxmlformats.org/drawingml/2006/main">
             <a:pPr>
+              <a:buNone/>
               <a:defRPr sz="1500" b="0">
                 <a:solidFill>
                   <a:srgbClr val="FFFFFF"/>
@@ -4504,6 +4601,7 @@
               <a:spcAft>
                 <a:spcPts val="0"/>
               </a:spcAft>
+              <a:buNone/>
               <a:defRPr sz="1500" b="0">
                 <a:solidFill>
                   <a:srgbClr val="142D48"/>
@@ -4589,6 +4687,7 @@
               <a:spcAft>
                 <a:spcPts val="0"/>
               </a:spcAft>
+              <a:buNone/>
               <a:defRPr sz="1500" b="0">
                 <a:solidFill>
                   <a:srgbClr val="142D48"/>
@@ -4712,6 +4811,7 @@
           <a:lstStyle xmlns:a="http://schemas.openxmlformats.org/drawingml/2006/main"/>
           <a:p xmlns:a="http://schemas.openxmlformats.org/drawingml/2006/main">
             <a:pPr>
+              <a:buNone/>
               <a:defRPr sz="2025" b="1">
                 <a:solidFill>
                   <a:srgbClr val="FFFFFF"/>
@@ -4769,6 +4869,7 @@
           <a:lstStyle xmlns:a="http://schemas.openxmlformats.org/drawingml/2006/main"/>
           <a:p xmlns:a="http://schemas.openxmlformats.org/drawingml/2006/main">
             <a:pPr>
+              <a:buNone/>
               <a:defRPr sz="1650" b="1">
                 <a:solidFill>
                   <a:srgbClr val="FFFFFF"/>
@@ -4832,6 +4933,7 @@
               <a:spcAft>
                 <a:spcPts val="0"/>
               </a:spcAft>
+              <a:buNone/>
               <a:defRPr sz="1500" b="0">
                 <a:solidFill>
                   <a:srgbClr val="142D48"/>
@@ -4923,6 +5025,7 @@
           <a:lstStyle xmlns:a="http://schemas.openxmlformats.org/drawingml/2006/main"/>
           <a:p xmlns:a="http://schemas.openxmlformats.org/drawingml/2006/main">
             <a:pPr>
+              <a:buNone/>
               <a:defRPr sz="1125" b="1">
                 <a:solidFill>
                   <a:srgbClr val="006BBE"/>
@@ -4980,6 +5083,7 @@
           <a:lstStyle xmlns:a="http://schemas.openxmlformats.org/drawingml/2006/main"/>
           <a:p xmlns:a="http://schemas.openxmlformats.org/drawingml/2006/main">
             <a:pPr>
+              <a:buNone/>
               <a:defRPr sz="1350" b="0">
                 <a:solidFill>
                   <a:srgbClr val="142D48"/>
@@ -5037,6 +5141,7 @@
           <a:lstStyle xmlns:a="http://schemas.openxmlformats.org/drawingml/2006/main"/>
           <a:p xmlns:a="http://schemas.openxmlformats.org/drawingml/2006/main">
             <a:pPr>
+              <a:buNone/>
               <a:defRPr sz="1350" b="0">
                 <a:solidFill>
                   <a:srgbClr val="142D48"/>
@@ -5094,6 +5199,7 @@
           <a:lstStyle xmlns:a="http://schemas.openxmlformats.org/drawingml/2006/main"/>
           <a:p xmlns:a="http://schemas.openxmlformats.org/drawingml/2006/main">
             <a:pPr>
+              <a:buNone/>
               <a:defRPr sz="1350" b="0">
                 <a:solidFill>
                   <a:srgbClr val="142D48"/>
@@ -5151,6 +5257,7 @@
           <a:lstStyle xmlns:a="http://schemas.openxmlformats.org/drawingml/2006/main"/>
           <a:p xmlns:a="http://schemas.openxmlformats.org/drawingml/2006/main">
             <a:pPr>
+              <a:buNone/>
               <a:defRPr sz="1350" b="0">
                 <a:solidFill>
                   <a:srgbClr val="142D48"/>
@@ -5169,7 +5276,18 @@
                 <a:ea typeface="Consolas"/>
                 <a:cs typeface="Consolas"/>
               </a:rPr>
-              <a:t>      intervalo_excedido: CRITICA</a:t>
+              <a:t>      intervalo_excedido: </a:t>
+            </a:r>
+            <a:r>
+              <a:rPr sz="1350" b="0">
+                <a:solidFill>
+                  <a:srgbClr val="142D48"/>
+                </a:solidFill>
+                <a:latin typeface="Consolas"/>
+                <a:ea typeface="Consolas"/>
+                <a:cs typeface="Consolas"/>
+              </a:rPr>
+              <a:t>POSIBLE DISCREPANCIA</a:t>
             </a:r>
           </a:p>
         </p:txBody>
@@ -5208,6 +5326,7 @@
           <a:lstStyle xmlns:a="http://schemas.openxmlformats.org/drawingml/2006/main"/>
           <a:p xmlns:a="http://schemas.openxmlformats.org/drawingml/2006/main">
             <a:pPr>
+              <a:buNone/>
               <a:defRPr sz="1350" b="0">
                 <a:solidFill>
                   <a:srgbClr val="142D48"/>
@@ -5331,6 +5450,7 @@
           <a:lstStyle xmlns:a="http://schemas.openxmlformats.org/drawingml/2006/main"/>
           <a:p xmlns:a="http://schemas.openxmlformats.org/drawingml/2006/main">
             <a:pPr>
+              <a:buNone/>
               <a:defRPr sz="2025" b="1">
                 <a:solidFill>
                   <a:srgbClr val="FFFFFF"/>
@@ -5388,6 +5508,7 @@
           <a:lstStyle xmlns:a="http://schemas.openxmlformats.org/drawingml/2006/main"/>
           <a:p xmlns:a="http://schemas.openxmlformats.org/drawingml/2006/main">
             <a:pPr>
+              <a:buNone/>
               <a:defRPr sz="1650" b="1">
                 <a:solidFill>
                   <a:srgbClr val="FFFFFF"/>
@@ -5451,6 +5572,7 @@
               <a:spcAft>
                 <a:spcPts val="0"/>
               </a:spcAft>
+              <a:buNone/>
               <a:defRPr sz="1500" b="0">
                 <a:solidFill>
                   <a:srgbClr val="142D48"/>
@@ -5542,6 +5664,7 @@
           <a:lstStyle xmlns:a="http://schemas.openxmlformats.org/drawingml/2006/main"/>
           <a:p xmlns:a="http://schemas.openxmlformats.org/drawingml/2006/main">
             <a:pPr>
+              <a:buNone/>
               <a:defRPr sz="1125" b="1">
                 <a:solidFill>
                   <a:srgbClr val="006BBE"/>
@@ -5599,6 +5722,7 @@
           <a:lstStyle xmlns:a="http://schemas.openxmlformats.org/drawingml/2006/main"/>
           <a:p xmlns:a="http://schemas.openxmlformats.org/drawingml/2006/main">
             <a:pPr>
+              <a:buNone/>
               <a:defRPr sz="1350" b="0">
                 <a:solidFill>
                   <a:srgbClr val="142D48"/>
@@ -5617,7 +5741,29 @@
                 <a:ea typeface="Consolas"/>
                 <a:cs typeface="Consolas"/>
               </a:rPr>
-              <a:t>intervalo_excedido: {activa: false, severidad: CRITICA}</a:t>
+              <a:t>intervalo_excedido: {activa: false, severidad: </a:t>
+            </a:r>
+            <a:r>
+              <a:rPr sz="1350" b="0">
+                <a:solidFill>
+                  <a:srgbClr val="142D48"/>
+                </a:solidFill>
+                <a:latin typeface="Consolas"/>
+                <a:ea typeface="Consolas"/>
+                <a:cs typeface="Consolas"/>
+              </a:rPr>
+              <a:t>POSIBLE DISCREPANCIA</a:t>
+            </a:r>
+            <a:r>
+              <a:rPr sz="1350" b="0">
+                <a:solidFill>
+                  <a:srgbClr val="142D48"/>
+                </a:solidFill>
+                <a:latin typeface="Consolas"/>
+                <a:ea typeface="Consolas"/>
+                <a:cs typeface="Consolas"/>
+              </a:rPr>
+              <a:t>}</a:t>
             </a:r>
           </a:p>
         </p:txBody>
@@ -5662,6 +5808,7 @@
               <a:spcAft>
                 <a:spcPts val="0"/>
               </a:spcAft>
+              <a:buNone/>
               <a:defRPr sz="1500" b="0">
                 <a:solidFill>
                   <a:srgbClr val="142D48"/>
@@ -5769,6 +5916,7 @@
               <a:spcAft>
                 <a:spcPts val="0"/>
               </a:spcAft>
+              <a:buNone/>
               <a:defRPr sz="1500" b="0">
                 <a:solidFill>
                   <a:srgbClr val="142D48"/>
@@ -5925,6 +6073,7 @@
           <a:lstStyle xmlns:a="http://schemas.openxmlformats.org/drawingml/2006/main"/>
           <a:p xmlns:a="http://schemas.openxmlformats.org/drawingml/2006/main">
             <a:pPr>
+              <a:buNone/>
               <a:defRPr sz="2025" b="1">
                 <a:solidFill>
                   <a:srgbClr val="FFFFFF"/>
@@ -5982,6 +6131,7 @@
           <a:lstStyle xmlns:a="http://schemas.openxmlformats.org/drawingml/2006/main"/>
           <a:p xmlns:a="http://schemas.openxmlformats.org/drawingml/2006/main">
             <a:pPr>
+              <a:buNone/>
               <a:defRPr sz="1650" b="1">
                 <a:solidFill>
                   <a:srgbClr val="FFFFFF"/>
@@ -6007,7 +6157,7 @@
       </p:sp>
       <p:graphicFrame>
         <p:nvGraphicFramePr>
-          <p:cNvPr id="84" name=""/>
+          <p:cNvPr id="88" name=""/>
           <p:cNvGraphicFramePr/>
           <p:nvPr/>
         </p:nvGraphicFramePr>
@@ -6088,7 +6238,7 @@
                           <a:ea typeface="Consolas"/>
                           <a:cs typeface="Consolas"/>
                         </a:rPr>
-                        <a:t>CRITICA, NO CRITICA, REVISAR</a:t>
+                        <a:t>POSIBLE DISCREPANCIA</a:t>
                       </a:r>
                     </a:p>
                   </a:txBody>
@@ -6138,7 +6288,7 @@
                           <a:ea typeface="Consolas"/>
                           <a:cs typeface="Consolas"/>
                         </a:rPr>
-                        <a:t>CONSULTAR MANUAL</a:t>
+                        <a:t>REVISAR</a:t>
                       </a:r>
                     </a:p>
                   </a:txBody>
@@ -6188,7 +6338,7 @@
                           <a:ea typeface="Consolas"/>
                           <a:cs typeface="Consolas"/>
                         </a:rPr>
-                        <a:t>SIN FUENTE</a:t>
+                        <a:t>SIN FUENTE EN DIPS REFERENCES</a:t>
                       </a:r>
                     </a:p>
                   </a:txBody>
@@ -6212,7 +6362,7 @@
                           <a:ea typeface="Arial"/>
                           <a:cs typeface="Arial"/>
                         </a:rPr>
-                        <a:t>SIN FUENTE</a:t>
+                        <a:t>SIN FUENTE EN DIPS REFERENCES</a:t>
                       </a:r>
                     </a:p>
                   </a:txBody>
@@ -6317,6 +6467,7 @@
               <a:spcAft>
                 <a:spcPts val="0"/>
               </a:spcAft>
+              <a:buNone/>
               <a:defRPr sz="1500" b="1">
                 <a:solidFill>
                   <a:srgbClr val="073C78"/>
@@ -6414,6 +6565,7 @@
               <a:spcAft>
                 <a:spcPts val="0"/>
               </a:spcAft>
+              <a:buNone/>
               <a:defRPr sz="1800" b="1">
                 <a:solidFill>
                   <a:srgbClr val="073C78"/>
@@ -6477,6 +6629,7 @@
               <a:spcAft>
                 <a:spcPts val="0"/>
               </a:spcAft>
+              <a:buNone/>
               <a:defRPr sz="1500" b="0">
                 <a:solidFill>
                   <a:srgbClr val="142D48"/>
@@ -6540,6 +6693,7 @@
               <a:spcAft>
                 <a:spcPts val="0"/>
               </a:spcAft>
+              <a:buNone/>
               <a:defRPr sz="1500" b="0">
                 <a:solidFill>
                   <a:srgbClr val="142D48"/>
@@ -6625,6 +6779,7 @@
               <a:spcAft>
                 <a:spcPts val="0"/>
               </a:spcAft>
+              <a:buNone/>
               <a:defRPr sz="1500" b="0">
                 <a:solidFill>
                   <a:srgbClr val="142D48"/>
@@ -6643,7 +6798,7 @@
                 <a:ea typeface="Arial"/>
                 <a:cs typeface="Arial"/>
               </a:rPr>
-              <a:t>La siguiente auditoría utiliza esta configuración.</a:t>
+              <a:t>CORREGIDO EN CIERRE se calcula; no se asigna a una regla.</a:t>
             </a:r>
           </a:p>
         </p:txBody>
@@ -6755,6 +6910,7 @@
           <a:lstStyle xmlns:a="http://schemas.openxmlformats.org/drawingml/2006/main"/>
           <a:p xmlns:a="http://schemas.openxmlformats.org/drawingml/2006/main">
             <a:pPr>
+              <a:buNone/>
               <a:defRPr sz="3450" b="1">
                 <a:solidFill>
                   <a:srgbClr val="FFFFFF"/>
@@ -6842,6 +6998,7 @@
           <a:lstStyle xmlns:a="http://schemas.openxmlformats.org/drawingml/2006/main"/>
           <a:p xmlns:a="http://schemas.openxmlformats.org/drawingml/2006/main">
             <a:pPr>
+              <a:buNone/>
               <a:defRPr sz="3000" b="1">
                 <a:solidFill>
                   <a:srgbClr val="FFFFFF"/>
@@ -6899,6 +7056,7 @@
           <a:lstStyle xmlns:a="http://schemas.openxmlformats.org/drawingml/2006/main"/>
           <a:p xmlns:a="http://schemas.openxmlformats.org/drawingml/2006/main">
             <a:pPr>
+              <a:buNone/>
               <a:defRPr sz="1650" b="1">
                 <a:solidFill>
                   <a:srgbClr val="FFFFFF"/>
@@ -6924,14 +7082,14 @@
       </p:sp>
       <p:pic>
         <p:nvPicPr>
-          <p:cNvPr id="47" name=""/>
+          <p:cNvPr id="50" name=""/>
           <p:cNvPicPr>
             <a:picLocks xmlns:a="http://schemas.openxmlformats.org/drawingml/2006/main" noChangeAspect="1"/>
           </p:cNvPicPr>
           <p:nvPr/>
         </p:nvPicPr>
         <p:blipFill>
-          <a:blip xmlns:r="http://schemas.openxmlformats.org/officeDocument/2006/relationships" xmlns:a="http://schemas.openxmlformats.org/drawingml/2006/main" r:embed="R7e801b9c87484194"/>
+          <a:blip xmlns:r="http://schemas.openxmlformats.org/officeDocument/2006/relationships" xmlns:a="http://schemas.openxmlformats.org/drawingml/2006/main" r:embed="R23cab6ce193a4d9e"/>
           <a:stretch xmlns:a="http://schemas.openxmlformats.org/drawingml/2006/main"/>
         </p:blipFill>
         <p:spPr>
@@ -6984,14 +7142,14 @@
       </p:sp>
       <p:pic>
         <p:nvPicPr>
-          <p:cNvPr id="49" name=""/>
+          <p:cNvPr id="52" name=""/>
           <p:cNvPicPr>
             <a:picLocks xmlns:a="http://schemas.openxmlformats.org/drawingml/2006/main" noChangeAspect="1"/>
           </p:cNvPicPr>
           <p:nvPr/>
         </p:nvPicPr>
         <p:blipFill>
-          <a:blip xmlns:r="http://schemas.openxmlformats.org/officeDocument/2006/relationships" xmlns:a="http://schemas.openxmlformats.org/drawingml/2006/main" r:embed="Rc1e75211d9ed4b29"/>
+          <a:blip xmlns:r="http://schemas.openxmlformats.org/officeDocument/2006/relationships" xmlns:a="http://schemas.openxmlformats.org/drawingml/2006/main" r:embed="R751d29288c1d4a80"/>
           <a:stretch xmlns:a="http://schemas.openxmlformats.org/drawingml/2006/main"/>
         </p:blipFill>
         <p:spPr>
@@ -7038,6 +7196,7 @@
           <a:lstStyle xmlns:a="http://schemas.openxmlformats.org/drawingml/2006/main"/>
           <a:p xmlns:a="http://schemas.openxmlformats.org/drawingml/2006/main">
             <a:pPr>
+              <a:buNone/>
               <a:defRPr sz="2250" b="1">
                 <a:solidFill>
                   <a:srgbClr val="FFFFFF"/>
@@ -7095,6 +7254,7 @@
           <a:lstStyle xmlns:a="http://schemas.openxmlformats.org/drawingml/2006/main"/>
           <a:p xmlns:a="http://schemas.openxmlformats.org/drawingml/2006/main">
             <a:pPr>
+              <a:buNone/>
               <a:defRPr sz="1500" b="0">
                 <a:solidFill>
                   <a:srgbClr val="FFFFFF"/>
@@ -7158,6 +7318,7 @@
               <a:spcAft>
                 <a:spcPts val="0"/>
               </a:spcAft>
+              <a:buNone/>
               <a:defRPr sz="1500" b="0">
                 <a:solidFill>
                   <a:srgbClr val="142D48"/>
@@ -7287,6 +7448,7 @@
               <a:spcAft>
                 <a:spcPts val="0"/>
               </a:spcAft>
+              <a:buNone/>
               <a:defRPr sz="1500" b="0">
                 <a:solidFill>
                   <a:srgbClr val="142D48"/>
@@ -7410,6 +7572,7 @@
           <a:lstStyle xmlns:a="http://schemas.openxmlformats.org/drawingml/2006/main"/>
           <a:p xmlns:a="http://schemas.openxmlformats.org/drawingml/2006/main">
             <a:pPr>
+              <a:buNone/>
               <a:defRPr sz="2025" b="1">
                 <a:solidFill>
                   <a:srgbClr val="FFFFFF"/>
@@ -7467,6 +7630,7 @@
           <a:lstStyle xmlns:a="http://schemas.openxmlformats.org/drawingml/2006/main"/>
           <a:p xmlns:a="http://schemas.openxmlformats.org/drawingml/2006/main">
             <a:pPr>
+              <a:buNone/>
               <a:defRPr sz="1650" b="1">
                 <a:solidFill>
                   <a:srgbClr val="FFFFFF"/>
@@ -7530,6 +7694,7 @@
               <a:spcAft>
                 <a:spcPts val="0"/>
               </a:spcAft>
+              <a:buNone/>
               <a:defRPr sz="1500" b="1">
                 <a:solidFill>
                   <a:srgbClr val="073C78"/>
@@ -7615,6 +7780,7 @@
               <a:spcAft>
                 <a:spcPts val="0"/>
               </a:spcAft>
+              <a:buNone/>
               <a:defRPr sz="1500" b="1">
                 <a:solidFill>
                   <a:srgbClr val="073C78"/>
@@ -7694,6 +7860,7 @@
           <a:lstStyle xmlns:a="http://schemas.openxmlformats.org/drawingml/2006/main"/>
           <a:p xmlns:a="http://schemas.openxmlformats.org/drawingml/2006/main">
             <a:pPr>
+              <a:buNone/>
               <a:defRPr sz="1500" b="1">
                 <a:solidFill>
                   <a:srgbClr val="006BBE"/>
@@ -7711,7 +7878,7 @@
                 <a:latin typeface="Arial"/>
                 <a:ea typeface="Arial"/>
                 <a:cs typeface="Arial"/>
-                <a:hlinkClick xmlns:r="http://schemas.openxmlformats.org/officeDocument/2006/relationships" r:id="R0858a2c1247c4312"/>
+                <a:hlinkClick xmlns:r="http://schemas.openxmlformats.org/officeDocument/2006/relationships" r:id="Re22b72a8f3fe4e0b"/>
               </a:rPr>
               <a:t>Abrir DIPs References.xlsx en SharePoint</a:t>
             </a:r>
@@ -7758,6 +7925,7 @@
               <a:spcAft>
                 <a:spcPts val="0"/>
               </a:spcAft>
+              <a:buNone/>
               <a:defRPr sz="1500" b="0">
                 <a:solidFill>
                   <a:srgbClr val="142D48"/>
@@ -7865,6 +8033,7 @@
               <a:spcAft>
                 <a:spcPts val="0"/>
               </a:spcAft>
+              <a:buNone/>
               <a:defRPr sz="1500" b="0">
                 <a:solidFill>
                   <a:srgbClr val="142D48"/>
@@ -7961,6 +8130,7 @@
               <a:spcAft>
                 <a:spcPts val="0"/>
               </a:spcAft>
+              <a:buNone/>
               <a:defRPr sz="1500" b="0">
                 <a:solidFill>
                   <a:srgbClr val="142D48"/>
@@ -8084,6 +8254,7 @@
           <a:lstStyle xmlns:a="http://schemas.openxmlformats.org/drawingml/2006/main"/>
           <a:p xmlns:a="http://schemas.openxmlformats.org/drawingml/2006/main">
             <a:pPr>
+              <a:buNone/>
               <a:defRPr sz="2025" b="1">
                 <a:solidFill>
                   <a:srgbClr val="FFFFFF"/>
@@ -8141,6 +8312,7 @@
           <a:lstStyle xmlns:a="http://schemas.openxmlformats.org/drawingml/2006/main"/>
           <a:p xmlns:a="http://schemas.openxmlformats.org/drawingml/2006/main">
             <a:pPr>
+              <a:buNone/>
               <a:defRPr sz="1650" b="1">
                 <a:solidFill>
                   <a:srgbClr val="FFFFFF"/>
@@ -8204,6 +8376,7 @@
               <a:spcAft>
                 <a:spcPts val="0"/>
               </a:spcAft>
+              <a:buNone/>
               <a:defRPr sz="1500" b="0">
                 <a:solidFill>
                   <a:srgbClr val="142D48"/>
@@ -8267,6 +8440,7 @@
               <a:spcAft>
                 <a:spcPts val="0"/>
               </a:spcAft>
+              <a:buNone/>
               <a:defRPr sz="1500" b="0">
                 <a:solidFill>
                   <a:srgbClr val="142D48"/>
@@ -8380,6 +8554,7 @@
           <a:lstStyle xmlns:a="http://schemas.openxmlformats.org/drawingml/2006/main"/>
           <a:p xmlns:a="http://schemas.openxmlformats.org/drawingml/2006/main">
             <a:pPr>
+              <a:buNone/>
               <a:defRPr sz="1125" b="1">
                 <a:solidFill>
                   <a:srgbClr val="006BBE"/>
@@ -8437,6 +8612,7 @@
           <a:lstStyle xmlns:a="http://schemas.openxmlformats.org/drawingml/2006/main"/>
           <a:p xmlns:a="http://schemas.openxmlformats.org/drawingml/2006/main">
             <a:pPr>
+              <a:buNone/>
               <a:defRPr sz="1350" b="0">
                 <a:solidFill>
                   <a:srgbClr val="142D48"/>
@@ -8494,6 +8670,7 @@
           <a:lstStyle xmlns:a="http://schemas.openxmlformats.org/drawingml/2006/main"/>
           <a:p xmlns:a="http://schemas.openxmlformats.org/drawingml/2006/main">
             <a:pPr>
+              <a:buNone/>
               <a:defRPr sz="1350" b="0">
                 <a:solidFill>
                   <a:srgbClr val="142D48"/>
@@ -8557,6 +8734,7 @@
               <a:spcAft>
                 <a:spcPts val="0"/>
               </a:spcAft>
+              <a:buNone/>
               <a:defRPr sz="1500" b="0">
                 <a:solidFill>
                   <a:srgbClr val="142D48"/>
@@ -8735,6 +8913,7 @@
           <a:lstStyle xmlns:a="http://schemas.openxmlformats.org/drawingml/2006/main"/>
           <a:p xmlns:a="http://schemas.openxmlformats.org/drawingml/2006/main">
             <a:pPr>
+              <a:buNone/>
               <a:defRPr sz="2025" b="1">
                 <a:solidFill>
                   <a:srgbClr val="FFFFFF"/>
@@ -8792,6 +8971,7 @@
           <a:lstStyle xmlns:a="http://schemas.openxmlformats.org/drawingml/2006/main"/>
           <a:p xmlns:a="http://schemas.openxmlformats.org/drawingml/2006/main">
             <a:pPr>
+              <a:buNone/>
               <a:defRPr sz="1650" b="1">
                 <a:solidFill>
                   <a:srgbClr val="FFFFFF"/>
@@ -8855,6 +9035,7 @@
               <a:spcAft>
                 <a:spcPts val="0"/>
               </a:spcAft>
+              <a:buNone/>
               <a:defRPr sz="1500" b="0">
                 <a:solidFill>
                   <a:srgbClr val="142D48"/>
@@ -8918,6 +9099,7 @@
               <a:spcAft>
                 <a:spcPts val="0"/>
               </a:spcAft>
+              <a:buNone/>
               <a:defRPr sz="1500" b="0">
                 <a:solidFill>
                   <a:srgbClr val="142D48"/>
@@ -8981,6 +9163,7 @@
               <a:spcAft>
                 <a:spcPts val="0"/>
               </a:spcAft>
+              <a:buNone/>
               <a:defRPr sz="1500" b="1">
                 <a:solidFill>
                   <a:srgbClr val="073C78"/>
@@ -9044,6 +9227,7 @@
               <a:spcAft>
                 <a:spcPts val="0"/>
               </a:spcAft>
+              <a:buNone/>
               <a:defRPr sz="1500" b="1">
                 <a:solidFill>
                   <a:srgbClr val="073C78"/>

</xml_diff>

<commit_message>
Elimina observación y registra los casos aceptados como OK
</commit_message>
<xml_diff>
--- a/docs/Guia_DIPS_reglas_referencias.pptx
+++ b/docs/Guia_DIPS_reglas_referencias.pptx
@@ -2,15 +2,15 @@
 <file path=ppt/presentation.xml><?xml version="1.0" encoding="utf-8"?>
 <p:presentation xmlns:p="http://schemas.openxmlformats.org/presentationml/2006/main">
   <p:sldMasterIdLst>
-    <p:sldMasterId xmlns:r="http://schemas.openxmlformats.org/officeDocument/2006/relationships" id="2147483648" r:id="Rd9f84b851fb04261"/>
+    <p:sldMasterId xmlns:r="http://schemas.openxmlformats.org/officeDocument/2006/relationships" id="2147483648" r:id="R02745854fc374880"/>
   </p:sldMasterIdLst>
   <p:notesMasterIdLst>
-    <p:notesMasterId xmlns:r="http://schemas.openxmlformats.org/officeDocument/2006/relationships" r:id="R7a7b749c24db4fe7"/>
+    <p:notesMasterId xmlns:r="http://schemas.openxmlformats.org/officeDocument/2006/relationships" r:id="Rbb141aa091524497"/>
   </p:notesMasterIdLst>
   <p:sldIdLst>
-    <p:sldId xmlns:r="http://schemas.openxmlformats.org/officeDocument/2006/relationships" id="256" r:id="Rc4b42ffcceb042be"/>
-    <p:sldId xmlns:r="http://schemas.openxmlformats.org/officeDocument/2006/relationships" id="257" r:id="Rbad0a0b8a0b84da2"/>
-    <p:sldId xmlns:r="http://schemas.openxmlformats.org/officeDocument/2006/relationships" id="258" r:id="Rc3cbef05f1714dc2"/>
+    <p:sldId xmlns:r="http://schemas.openxmlformats.org/officeDocument/2006/relationships" id="256" r:id="Rf4d04a1fd5af44d0"/>
+    <p:sldId xmlns:r="http://schemas.openxmlformats.org/officeDocument/2006/relationships" id="257" r:id="R67aba973fcb94847"/>
+    <p:sldId xmlns:r="http://schemas.openxmlformats.org/officeDocument/2006/relationships" id="258" r:id="Rb90340e7fa4b434c"/>
   </p:sldIdLst>
   <p:sldSz cx="9753600" cy="14630400"/>
   <p:notesSz cx="6858000" cy="9144000"/>
@@ -652,7 +652,7 @@
   </p:cSld>
   <p:clrMap bg1="lt1" tx1="dk1" bg2="lt2" tx2="dk2" accent1="accent1" accent2="accent2" accent3="accent3" accent4="accent4" accent5="accent5" accent6="accent6" hlink="hlink" folHlink="folHlink"/>
   <p:sldLayoutIdLst>
-    <p:sldLayoutId xmlns:r="http://schemas.openxmlformats.org/officeDocument/2006/relationships" id="2147483649" r:id="R77aae3c7c14843c1"/>
+    <p:sldLayoutId xmlns:r="http://schemas.openxmlformats.org/officeDocument/2006/relationships" id="2147483649" r:id="R52421d15368143fc"/>
   </p:sldLayoutIdLst>
   <p:txStyles>
     <p:titleStyle>
@@ -1448,14 +1448,14 @@
       </p:sp>
       <p:pic>
         <p:nvPicPr>
-          <p:cNvPr id="60" name=""/>
+          <p:cNvPr id="62" name=""/>
           <p:cNvPicPr>
             <a:picLocks xmlns:a="http://schemas.openxmlformats.org/drawingml/2006/main" noChangeAspect="1"/>
           </p:cNvPicPr>
           <p:nvPr/>
         </p:nvPicPr>
         <p:blipFill>
-          <a:blip xmlns:r="http://schemas.openxmlformats.org/officeDocument/2006/relationships" xmlns:a="http://schemas.openxmlformats.org/drawingml/2006/main" r:embed="R20f9ef8d25eb43ad"/>
+          <a:blip xmlns:r="http://schemas.openxmlformats.org/officeDocument/2006/relationships" xmlns:a="http://schemas.openxmlformats.org/drawingml/2006/main" r:embed="R3a6e739c327d42c7"/>
           <a:stretch xmlns:a="http://schemas.openxmlformats.org/drawingml/2006/main"/>
         </p:blipFill>
         <p:spPr>
@@ -1508,14 +1508,14 @@
       </p:sp>
       <p:pic>
         <p:nvPicPr>
-          <p:cNvPr id="62" name=""/>
+          <p:cNvPr id="64" name=""/>
           <p:cNvPicPr>
             <a:picLocks xmlns:a="http://schemas.openxmlformats.org/drawingml/2006/main" noChangeAspect="1"/>
           </p:cNvPicPr>
           <p:nvPr/>
         </p:nvPicPr>
         <p:blipFill>
-          <a:blip xmlns:r="http://schemas.openxmlformats.org/officeDocument/2006/relationships" xmlns:a="http://schemas.openxmlformats.org/drawingml/2006/main" r:embed="R444cc8f8a0194550"/>
+          <a:blip xmlns:r="http://schemas.openxmlformats.org/officeDocument/2006/relationships" xmlns:a="http://schemas.openxmlformats.org/drawingml/2006/main" r:embed="Reba084e84bbb4593"/>
           <a:stretch xmlns:a="http://schemas.openxmlformats.org/drawingml/2006/main"/>
         </p:blipFill>
         <p:spPr>
@@ -4063,6 +4063,7 @@
           <a:lstStyle xmlns:a="http://schemas.openxmlformats.org/drawingml/2006/main"/>
           <a:p xmlns:a="http://schemas.openxmlformats.org/drawingml/2006/main">
             <a:pPr>
+              <a:buNone/>
               <a:defRPr sz="1500">
                 <a:solidFill>
                   <a:srgbClr val="142D48"/>
@@ -4372,7 +4373,7 @@
           <p:nvPr/>
         </p:nvPicPr>
         <p:blipFill>
-          <a:blip xmlns:r="http://schemas.openxmlformats.org/officeDocument/2006/relationships" xmlns:a="http://schemas.openxmlformats.org/drawingml/2006/main" r:embed="R61f97f8fa5674d88"/>
+          <a:blip xmlns:r="http://schemas.openxmlformats.org/officeDocument/2006/relationships" xmlns:a="http://schemas.openxmlformats.org/drawingml/2006/main" r:embed="R54d510a854ef4dad"/>
           <a:stretch xmlns:a="http://schemas.openxmlformats.org/drawingml/2006/main"/>
         </p:blipFill>
         <p:spPr>
@@ -4432,7 +4433,7 @@
           <p:nvPr/>
         </p:nvPicPr>
         <p:blipFill>
-          <a:blip xmlns:r="http://schemas.openxmlformats.org/officeDocument/2006/relationships" xmlns:a="http://schemas.openxmlformats.org/drawingml/2006/main" r:embed="Re9b8f472c0f74e1e"/>
+          <a:blip xmlns:r="http://schemas.openxmlformats.org/officeDocument/2006/relationships" xmlns:a="http://schemas.openxmlformats.org/drawingml/2006/main" r:embed="R6cb6191ba2c547a6"/>
           <a:stretch xmlns:a="http://schemas.openxmlformats.org/drawingml/2006/main"/>
         </p:blipFill>
         <p:spPr>
@@ -5345,7 +5346,18 @@
                 <a:ea typeface="Consolas"/>
                 <a:cs typeface="Consolas"/>
               </a:rPr>
-              <a:t>      intervalo_menor: OBSERVACION</a:t>
+              <a:t>      intervalo_menor: </a:t>
+            </a:r>
+            <a:r>
+              <a:rPr sz="1350" b="0">
+                <a:solidFill>
+                  <a:srgbClr val="142D48"/>
+                </a:solidFill>
+                <a:latin typeface="Consolas"/>
+                <a:ea typeface="Consolas"/>
+                <a:cs typeface="Consolas"/>
+              </a:rPr>
+              <a:t>OK</a:t>
             </a:r>
           </a:p>
         </p:txBody>
@@ -6388,7 +6400,7 @@
                           <a:ea typeface="Consolas"/>
                           <a:cs typeface="Consolas"/>
                         </a:rPr>
-                        <a:t>OBSERVACION</a:t>
+                        <a:t>OK</a:t>
                       </a:r>
                     </a:p>
                   </a:txBody>
@@ -6412,7 +6424,7 @@
                           <a:ea typeface="Arial"/>
                           <a:cs typeface="Arial"/>
                         </a:rPr>
-                        <a:t>Informa sin cambiar el resultado</a:t>
+                        <a:t>OK si no hay otros hallazgos</a:t>
                       </a:r>
                     </a:p>
                   </a:txBody>
@@ -7089,7 +7101,7 @@
           <p:nvPr/>
         </p:nvPicPr>
         <p:blipFill>
-          <a:blip xmlns:r="http://schemas.openxmlformats.org/officeDocument/2006/relationships" xmlns:a="http://schemas.openxmlformats.org/drawingml/2006/main" r:embed="R23cab6ce193a4d9e"/>
+          <a:blip xmlns:r="http://schemas.openxmlformats.org/officeDocument/2006/relationships" xmlns:a="http://schemas.openxmlformats.org/drawingml/2006/main" r:embed="Rfe3976f00d77417f"/>
           <a:stretch xmlns:a="http://schemas.openxmlformats.org/drawingml/2006/main"/>
         </p:blipFill>
         <p:spPr>
@@ -7149,7 +7161,7 @@
           <p:nvPr/>
         </p:nvPicPr>
         <p:blipFill>
-          <a:blip xmlns:r="http://schemas.openxmlformats.org/officeDocument/2006/relationships" xmlns:a="http://schemas.openxmlformats.org/drawingml/2006/main" r:embed="R751d29288c1d4a80"/>
+          <a:blip xmlns:r="http://schemas.openxmlformats.org/officeDocument/2006/relationships" xmlns:a="http://schemas.openxmlformats.org/drawingml/2006/main" r:embed="Ra8729cc9dbf14170"/>
           <a:stretch xmlns:a="http://schemas.openxmlformats.org/drawingml/2006/main"/>
         </p:blipFill>
         <p:spPr>
@@ -7878,7 +7890,7 @@
                 <a:latin typeface="Arial"/>
                 <a:ea typeface="Arial"/>
                 <a:cs typeface="Arial"/>
-                <a:hlinkClick xmlns:r="http://schemas.openxmlformats.org/officeDocument/2006/relationships" r:id="Re22b72a8f3fe4e0b"/>
+                <a:hlinkClick xmlns:r="http://schemas.openxmlformats.org/officeDocument/2006/relationships" r:id="R4d68707d1dcb46db"/>
               </a:rPr>
               <a:t>Abrir DIPs References.xlsx en SharePoint</a:t>
             </a:r>

</xml_diff>

<commit_message>
Aclara la referencia tecnica y el uso futuro del YAML
</commit_message>
<xml_diff>
--- a/docs/Guia_DIPS_reglas_referencias.pptx
+++ b/docs/Guia_DIPS_reglas_referencias.pptx
@@ -2,16 +2,16 @@
 <file path=ppt/presentation.xml><?xml version="1.0" encoding="utf-8"?>
 <p:presentation xmlns:p="http://schemas.openxmlformats.org/presentationml/2006/main">
   <p:sldMasterIdLst>
-    <p:sldMasterId xmlns:r="http://schemas.openxmlformats.org/officeDocument/2006/relationships" id="2147483648" r:id="Rbd2c35509bc94b0d"/>
+    <p:sldMasterId xmlns:r="http://schemas.openxmlformats.org/officeDocument/2006/relationships" id="2147483648" r:id="R2f0e0c2751374831"/>
   </p:sldMasterIdLst>
   <p:notesMasterIdLst>
-    <p:notesMasterId xmlns:r="http://schemas.openxmlformats.org/officeDocument/2006/relationships" r:id="R503f637e2ac546db"/>
+    <p:notesMasterId xmlns:r="http://schemas.openxmlformats.org/officeDocument/2006/relationships" r:id="Rdf1f9d684bc347c2"/>
   </p:notesMasterIdLst>
   <p:sldIdLst>
-    <p:sldId xmlns:r="http://schemas.openxmlformats.org/officeDocument/2006/relationships" id="256" r:id="R43dd966f956a45f8"/>
-    <p:sldId xmlns:r="http://schemas.openxmlformats.org/officeDocument/2006/relationships" id="257" r:id="Rc645a83bfb8d4ca4"/>
-    <p:sldId xmlns:r="http://schemas.openxmlformats.org/officeDocument/2006/relationships" id="258" r:id="R3a549ab2c7ac458f"/>
-    <p:sldId xmlns:r="http://schemas.openxmlformats.org/officeDocument/2006/relationships" id="259" r:id="Re19ad5fd852a4918"/>
+    <p:sldId xmlns:r="http://schemas.openxmlformats.org/officeDocument/2006/relationships" id="256" r:id="Ra6c2fa0a309f4fd9"/>
+    <p:sldId xmlns:r="http://schemas.openxmlformats.org/officeDocument/2006/relationships" id="257" r:id="Rb0875f77766c4979"/>
+    <p:sldId xmlns:r="http://schemas.openxmlformats.org/officeDocument/2006/relationships" id="258" r:id="R87a94bce6f134c27"/>
+    <p:sldId xmlns:r="http://schemas.openxmlformats.org/officeDocument/2006/relationships" id="259" r:id="R45be0c598c824c91"/>
   </p:sldIdLst>
   <p:sldSz cx="9753600" cy="14630400"/>
   <p:notesSz cx="6858000" cy="9144000"/>
@@ -723,7 +723,7 @@
   </p:cSld>
   <p:clrMap bg1="lt1" tx1="dk1" bg2="lt2" tx2="dk2" accent1="accent1" accent2="accent2" accent3="accent3" accent4="accent4" accent5="accent5" accent6="accent6" hlink="hlink" folHlink="folHlink"/>
   <p:sldLayoutIdLst>
-    <p:sldLayoutId xmlns:r="http://schemas.openxmlformats.org/officeDocument/2006/relationships" id="2147483649" r:id="Ra9bd339915cf4a21"/>
+    <p:sldLayoutId xmlns:r="http://schemas.openxmlformats.org/officeDocument/2006/relationships" id="2147483649" r:id="R2776401435b244f5"/>
   </p:sldLayoutIdLst>
   <p:txStyles>
     <p:titleStyle>
@@ -1519,14 +1519,14 @@
       </p:sp>
       <p:pic>
         <p:nvPicPr>
-          <p:cNvPr id="65" name=""/>
+          <p:cNvPr id="67" name=""/>
           <p:cNvPicPr>
             <a:picLocks xmlns:a="http://schemas.openxmlformats.org/drawingml/2006/main" noChangeAspect="1"/>
           </p:cNvPicPr>
           <p:nvPr/>
         </p:nvPicPr>
         <p:blipFill>
-          <a:blip xmlns:r="http://schemas.openxmlformats.org/officeDocument/2006/relationships" xmlns:a="http://schemas.openxmlformats.org/drawingml/2006/main" r:embed="R79d839684be24869"/>
+          <a:blip xmlns:r="http://schemas.openxmlformats.org/officeDocument/2006/relationships" xmlns:a="http://schemas.openxmlformats.org/drawingml/2006/main" r:embed="Rf656e617e9424675"/>
           <a:stretch xmlns:a="http://schemas.openxmlformats.org/drawingml/2006/main"/>
         </p:blipFill>
         <p:spPr>
@@ -1579,14 +1579,14 @@
       </p:sp>
       <p:pic>
         <p:nvPicPr>
-          <p:cNvPr id="67" name=""/>
+          <p:cNvPr id="69" name=""/>
           <p:cNvPicPr>
             <a:picLocks xmlns:a="http://schemas.openxmlformats.org/drawingml/2006/main" noChangeAspect="1"/>
           </p:cNvPicPr>
           <p:nvPr/>
         </p:nvPicPr>
         <p:blipFill>
-          <a:blip xmlns:r="http://schemas.openxmlformats.org/officeDocument/2006/relationships" xmlns:a="http://schemas.openxmlformats.org/drawingml/2006/main" r:embed="R64cdc672e1d54fec"/>
+          <a:blip xmlns:r="http://schemas.openxmlformats.org/officeDocument/2006/relationships" xmlns:a="http://schemas.openxmlformats.org/drawingml/2006/main" r:embed="Rbb60749dc68043c6"/>
           <a:stretch xmlns:a="http://schemas.openxmlformats.org/drawingml/2006/main"/>
         </p:blipFill>
         <p:spPr>
@@ -3876,6 +3876,7 @@
           <a:lstStyle xmlns:a="http://schemas.openxmlformats.org/drawingml/2006/main"/>
           <a:p xmlns:a="http://schemas.openxmlformats.org/drawingml/2006/main">
             <a:pPr>
+              <a:buNone/>
               <a:defRPr sz="1500" b="0">
                 <a:solidFill>
                   <a:srgbClr val="142D48"/>
@@ -3933,6 +3934,7 @@
           <a:lstStyle xmlns:a="http://schemas.openxmlformats.org/drawingml/2006/main"/>
           <a:p xmlns:a="http://schemas.openxmlformats.org/drawingml/2006/main">
             <a:pPr>
+              <a:buNone/>
               <a:defRPr sz="1500" b="0">
                 <a:solidFill>
                   <a:srgbClr val="142D48"/>
@@ -3990,6 +3992,7 @@
           <a:lstStyle xmlns:a="http://schemas.openxmlformats.org/drawingml/2006/main"/>
           <a:p xmlns:a="http://schemas.openxmlformats.org/drawingml/2006/main">
             <a:pPr>
+              <a:buNone/>
               <a:defRPr sz="1500" b="0">
                 <a:solidFill>
                   <a:srgbClr val="142D48"/>
@@ -4292,14 +4295,14 @@
       </p:sp>
       <p:pic>
         <p:nvPicPr>
-          <p:cNvPr id="57" name=""/>
+          <p:cNvPr id="60" name=""/>
           <p:cNvPicPr>
             <a:picLocks xmlns:a="http://schemas.openxmlformats.org/drawingml/2006/main" noChangeAspect="1"/>
           </p:cNvPicPr>
           <p:nvPr/>
         </p:nvPicPr>
         <p:blipFill>
-          <a:blip xmlns:r="http://schemas.openxmlformats.org/officeDocument/2006/relationships" xmlns:a="http://schemas.openxmlformats.org/drawingml/2006/main" r:embed="R81fcecc80e92415e"/>
+          <a:blip xmlns:r="http://schemas.openxmlformats.org/officeDocument/2006/relationships" xmlns:a="http://schemas.openxmlformats.org/drawingml/2006/main" r:embed="R43d159ed8dd44634"/>
           <a:stretch xmlns:a="http://schemas.openxmlformats.org/drawingml/2006/main"/>
         </p:blipFill>
         <p:spPr>
@@ -4352,14 +4355,14 @@
       </p:sp>
       <p:pic>
         <p:nvPicPr>
-          <p:cNvPr id="59" name=""/>
+          <p:cNvPr id="62" name=""/>
           <p:cNvPicPr>
             <a:picLocks xmlns:a="http://schemas.openxmlformats.org/drawingml/2006/main" noChangeAspect="1"/>
           </p:cNvPicPr>
           <p:nvPr/>
         </p:nvPicPr>
         <p:blipFill>
-          <a:blip xmlns:r="http://schemas.openxmlformats.org/officeDocument/2006/relationships" xmlns:a="http://schemas.openxmlformats.org/drawingml/2006/main" r:embed="Ra3fe612d01c24f3b"/>
+          <a:blip xmlns:r="http://schemas.openxmlformats.org/officeDocument/2006/relationships" xmlns:a="http://schemas.openxmlformats.org/drawingml/2006/main" r:embed="R73b941dcab374e9d"/>
           <a:stretch xmlns:a="http://schemas.openxmlformats.org/drawingml/2006/main"/>
         </p:blipFill>
         <p:spPr>
@@ -4522,6 +4525,7 @@
           <a:lstStyle xmlns:a="http://schemas.openxmlformats.org/drawingml/2006/main"/>
           <a:p xmlns:a="http://schemas.openxmlformats.org/drawingml/2006/main">
             <a:pPr>
+              <a:buNone/>
               <a:defRPr sz="1500" b="0">
                 <a:solidFill>
                   <a:srgbClr val="142D48"/>
@@ -4579,6 +4583,7 @@
           <a:lstStyle xmlns:a="http://schemas.openxmlformats.org/drawingml/2006/main"/>
           <a:p xmlns:a="http://schemas.openxmlformats.org/drawingml/2006/main">
             <a:pPr>
+              <a:buNone/>
               <a:defRPr sz="1500" b="0">
                 <a:solidFill>
                   <a:srgbClr val="142D48"/>
@@ -4636,6 +4641,7 @@
           <a:lstStyle xmlns:a="http://schemas.openxmlformats.org/drawingml/2006/main"/>
           <a:p xmlns:a="http://schemas.openxmlformats.org/drawingml/2006/main">
             <a:pPr>
+              <a:buNone/>
               <a:defRPr sz="1500" b="0">
                 <a:solidFill>
                   <a:srgbClr val="142D48"/>
@@ -4661,7 +4667,7 @@
       </p:sp>
       <p:graphicFrame>
         <p:nvGraphicFramePr>
-          <p:cNvPr id="65" name=""/>
+          <p:cNvPr id="68" name=""/>
           <p:cNvGraphicFramePr/>
           <p:nvPr/>
         </p:nvGraphicFramePr>
@@ -4689,6 +4695,7 @@
                         <a:spcAft>
                           <a:spcPts val="1000"/>
                         </a:spcAft>
+                        <a:buNone/>
                       </a:pPr>
                       <a:r>
                         <a:rPr sz="1650" b="1">
@@ -4710,6 +4717,7 @@
                         <a:spcAft>
                           <a:spcPts val="0"/>
                         </a:spcAft>
+                        <a:buNone/>
                       </a:pPr>
                       <a:r>
                         <a:rPr sz="1500">
@@ -4731,6 +4739,7 @@
                         <a:spcAft>
                           <a:spcPts val="0"/>
                         </a:spcAft>
+                        <a:buNone/>
                       </a:pPr>
                       <a:r>
                         <a:rPr sz="1500">
@@ -4765,6 +4774,7 @@
                         <a:spcAft>
                           <a:spcPts val="1000"/>
                         </a:spcAft>
+                        <a:buNone/>
                       </a:pPr>
                       <a:r>
                         <a:rPr sz="1650" b="1">
@@ -4786,6 +4796,7 @@
                         <a:spcAft>
                           <a:spcPts val="0"/>
                         </a:spcAft>
+                        <a:buNone/>
                       </a:pPr>
                       <a:r>
                         <a:rPr sz="1500">
@@ -4807,6 +4818,7 @@
                         <a:spcAft>
                           <a:spcPts val="0"/>
                         </a:spcAft>
+                        <a:buNone/>
                       </a:pPr>
                       <a:r>
                         <a:rPr sz="1500">
@@ -4841,6 +4853,7 @@
                         <a:spcAft>
                           <a:spcPts val="1000"/>
                         </a:spcAft>
+                        <a:buNone/>
                       </a:pPr>
                       <a:r>
                         <a:rPr sz="1650" b="1">
@@ -4862,6 +4875,7 @@
                         <a:spcAft>
                           <a:spcPts val="0"/>
                         </a:spcAft>
+                        <a:buNone/>
                       </a:pPr>
                       <a:r>
                         <a:rPr sz="1500">
@@ -4883,6 +4897,7 @@
                         <a:spcAft>
                           <a:spcPts val="0"/>
                         </a:spcAft>
+                        <a:buNone/>
                       </a:pPr>
                       <a:r>
                         <a:rPr sz="1500">
@@ -4893,7 +4908,29 @@
                           <a:ea typeface="Arial"/>
                           <a:cs typeface="Arial"/>
                         </a:rPr>
-                        <a:t>Consulte la fuente técnica para definir el límite aplicable.</a:t>
+                        <a:t>Consulte la </a:t>
+                      </a:r>
+                      <a:r>
+                        <a:rPr sz="1500">
+                          <a:solidFill>
+                            <a:srgbClr val="142D48"/>
+                          </a:solidFill>
+                          <a:latin typeface="Arial"/>
+                          <a:ea typeface="Arial"/>
+                          <a:cs typeface="Arial"/>
+                        </a:rPr>
+                        <a:t>referencia técnica</a:t>
+                      </a:r>
+                      <a:r>
+                        <a:rPr sz="1500">
+                          <a:solidFill>
+                            <a:srgbClr val="142D48"/>
+                          </a:solidFill>
+                          <a:latin typeface="Arial"/>
+                          <a:ea typeface="Arial"/>
+                          <a:cs typeface="Arial"/>
+                        </a:rPr>
+                        <a:t> para definir el límite aplicable.</a:t>
                       </a:r>
                     </a:p>
                   </a:txBody>
@@ -4917,6 +4954,7 @@
                         <a:spcAft>
                           <a:spcPts val="1000"/>
                         </a:spcAft>
+                        <a:buNone/>
                       </a:pPr>
                       <a:r>
                         <a:rPr sz="1650" b="1">
@@ -4938,6 +4976,7 @@
                         <a:spcAft>
                           <a:spcPts val="0"/>
                         </a:spcAft>
+                        <a:buNone/>
                       </a:pPr>
                       <a:r>
                         <a:rPr sz="1500">
@@ -4959,6 +4998,7 @@
                         <a:spcAft>
                           <a:spcPts val="0"/>
                         </a:spcAft>
+                        <a:buNone/>
                       </a:pPr>
                       <a:r>
                         <a:rPr sz="1500">
@@ -4993,6 +5033,7 @@
                         <a:spcAft>
                           <a:spcPts val="1000"/>
                         </a:spcAft>
+                        <a:buNone/>
                       </a:pPr>
                       <a:r>
                         <a:rPr sz="1650" b="1">
@@ -5014,6 +5055,7 @@
                         <a:spcAft>
                           <a:spcPts val="0"/>
                         </a:spcAft>
+                        <a:buNone/>
                       </a:pPr>
                       <a:r>
                         <a:rPr sz="1500">
@@ -5035,6 +5077,7 @@
                         <a:spcAft>
                           <a:spcPts val="0"/>
                         </a:spcAft>
+                        <a:buNone/>
                       </a:pPr>
                       <a:r>
                         <a:rPr sz="1500">
@@ -5069,6 +5112,7 @@
                         <a:spcAft>
                           <a:spcPts val="1000"/>
                         </a:spcAft>
+                        <a:buNone/>
                       </a:pPr>
                       <a:r>
                         <a:rPr sz="1650" b="1">
@@ -5090,6 +5134,7 @@
                         <a:spcAft>
                           <a:spcPts val="0"/>
                         </a:spcAft>
+                        <a:buNone/>
                       </a:pPr>
                       <a:r>
                         <a:rPr sz="1500">
@@ -5111,6 +5156,7 @@
                         <a:spcAft>
                           <a:spcPts val="0"/>
                         </a:spcAft>
+                        <a:buNone/>
                       </a:pPr>
                       <a:r>
                         <a:rPr sz="1500">
@@ -5170,6 +5216,7 @@
           <a:lstStyle xmlns:a="http://schemas.openxmlformats.org/drawingml/2006/main"/>
           <a:p xmlns:a="http://schemas.openxmlformats.org/drawingml/2006/main">
             <a:pPr>
+              <a:buNone/>
               <a:defRPr sz="1500" b="0">
                 <a:solidFill>
                   <a:srgbClr val="142D48"/>
@@ -5227,6 +5274,7 @@
           <a:lstStyle xmlns:a="http://schemas.openxmlformats.org/drawingml/2006/main"/>
           <a:p xmlns:a="http://schemas.openxmlformats.org/drawingml/2006/main">
             <a:pPr>
+              <a:buNone/>
               <a:defRPr sz="1500" b="0">
                 <a:solidFill>
                   <a:srgbClr val="142D48"/>
@@ -5284,6 +5332,7 @@
           <a:lstStyle xmlns:a="http://schemas.openxmlformats.org/drawingml/2006/main"/>
           <a:p xmlns:a="http://schemas.openxmlformats.org/drawingml/2006/main">
             <a:pPr>
+              <a:buNone/>
               <a:defRPr sz="1500" b="0">
                 <a:solidFill>
                   <a:srgbClr val="142D48"/>
@@ -5586,14 +5635,14 @@
       </p:sp>
       <p:pic>
         <p:nvPicPr>
-          <p:cNvPr id="75" name=""/>
+          <p:cNvPr id="78" name=""/>
           <p:cNvPicPr>
             <a:picLocks xmlns:a="http://schemas.openxmlformats.org/drawingml/2006/main" noChangeAspect="1"/>
           </p:cNvPicPr>
           <p:nvPr/>
         </p:nvPicPr>
         <p:blipFill>
-          <a:blip xmlns:r="http://schemas.openxmlformats.org/officeDocument/2006/relationships" xmlns:a="http://schemas.openxmlformats.org/drawingml/2006/main" r:embed="Rab93e269d0de4aa9"/>
+          <a:blip xmlns:r="http://schemas.openxmlformats.org/officeDocument/2006/relationships" xmlns:a="http://schemas.openxmlformats.org/drawingml/2006/main" r:embed="R2182e17556644e8d"/>
           <a:stretch xmlns:a="http://schemas.openxmlformats.org/drawingml/2006/main"/>
         </p:blipFill>
         <p:spPr>
@@ -5646,14 +5695,14 @@
       </p:sp>
       <p:pic>
         <p:nvPicPr>
-          <p:cNvPr id="77" name=""/>
+          <p:cNvPr id="80" name=""/>
           <p:cNvPicPr>
             <a:picLocks xmlns:a="http://schemas.openxmlformats.org/drawingml/2006/main" noChangeAspect="1"/>
           </p:cNvPicPr>
           <p:nvPr/>
         </p:nvPicPr>
         <p:blipFill>
-          <a:blip xmlns:r="http://schemas.openxmlformats.org/officeDocument/2006/relationships" xmlns:a="http://schemas.openxmlformats.org/drawingml/2006/main" r:embed="R662d74af7f0a4385"/>
+          <a:blip xmlns:r="http://schemas.openxmlformats.org/officeDocument/2006/relationships" xmlns:a="http://schemas.openxmlformats.org/drawingml/2006/main" r:embed="R306e130d1a664a44"/>
           <a:stretch xmlns:a="http://schemas.openxmlformats.org/drawingml/2006/main"/>
         </p:blipFill>
         <p:spPr>
@@ -5816,6 +5865,7 @@
           <a:lstStyle xmlns:a="http://schemas.openxmlformats.org/drawingml/2006/main"/>
           <a:p xmlns:a="http://schemas.openxmlformats.org/drawingml/2006/main">
             <a:pPr>
+              <a:buNone/>
               <a:defRPr sz="1500" b="0">
                 <a:solidFill>
                   <a:srgbClr val="142D48"/>
@@ -5873,6 +5923,7 @@
           <a:lstStyle xmlns:a="http://schemas.openxmlformats.org/drawingml/2006/main"/>
           <a:p xmlns:a="http://schemas.openxmlformats.org/drawingml/2006/main">
             <a:pPr>
+              <a:buNone/>
               <a:defRPr sz="1500" b="0">
                 <a:solidFill>
                   <a:srgbClr val="142D48"/>
@@ -5930,6 +5981,7 @@
           <a:lstStyle xmlns:a="http://schemas.openxmlformats.org/drawingml/2006/main"/>
           <a:p xmlns:a="http://schemas.openxmlformats.org/drawingml/2006/main">
             <a:pPr>
+              <a:buNone/>
               <a:defRPr sz="1500" b="0">
                 <a:solidFill>
                   <a:srgbClr val="142D48"/>
@@ -6053,6 +6105,7 @@
           <a:lstStyle xmlns:a="http://schemas.openxmlformats.org/drawingml/2006/main"/>
           <a:p xmlns:a="http://schemas.openxmlformats.org/drawingml/2006/main">
             <a:pPr>
+              <a:buNone/>
               <a:defRPr sz="2025" b="1">
                 <a:solidFill>
                   <a:srgbClr val="FFFFFF"/>
@@ -6110,6 +6163,7 @@
           <a:lstStyle xmlns:a="http://schemas.openxmlformats.org/drawingml/2006/main"/>
           <a:p xmlns:a="http://schemas.openxmlformats.org/drawingml/2006/main">
             <a:pPr>
+              <a:buNone/>
               <a:defRPr sz="1650" b="1">
                 <a:solidFill>
                   <a:srgbClr val="FFFFFF"/>
@@ -6167,6 +6221,7 @@
           <a:lstStyle xmlns:a="http://schemas.openxmlformats.org/drawingml/2006/main"/>
           <a:p xmlns:a="http://schemas.openxmlformats.org/drawingml/2006/main">
             <a:pPr>
+              <a:buNone/>
               <a:defRPr sz="1500" b="1">
                 <a:solidFill>
                   <a:srgbClr val="073C78"/>
@@ -6224,6 +6279,7 @@
           <a:lstStyle xmlns:a="http://schemas.openxmlformats.org/drawingml/2006/main"/>
           <a:p xmlns:a="http://schemas.openxmlformats.org/drawingml/2006/main">
             <a:pPr>
+              <a:buNone/>
               <a:defRPr sz="1500" b="1">
                 <a:solidFill>
                   <a:srgbClr val="006BBE"/>
@@ -6241,7 +6297,7 @@
                 <a:latin typeface="Arial"/>
                 <a:ea typeface="Arial"/>
                 <a:cs typeface="Arial"/>
-                <a:hlinkClick xmlns:r="http://schemas.openxmlformats.org/officeDocument/2006/relationships" r:id="Rb8a57cb2dd3745f6"/>
+                <a:hlinkClick xmlns:r="http://schemas.openxmlformats.org/officeDocument/2006/relationships" r:id="Rb491143d2d624366"/>
               </a:rPr>
               <a:t>Abrir DIPs References.xlsx en SharePoint</a:t>
             </a:r>
@@ -6282,6 +6338,7 @@
           <a:lstStyle xmlns:a="http://schemas.openxmlformats.org/drawingml/2006/main"/>
           <a:p xmlns:a="http://schemas.openxmlformats.org/drawingml/2006/main">
             <a:pPr>
+              <a:buNone/>
               <a:defRPr sz="1500" b="0">
                 <a:solidFill>
                   <a:srgbClr val="142D48"/>
@@ -6339,6 +6396,7 @@
           <a:lstStyle xmlns:a="http://schemas.openxmlformats.org/drawingml/2006/main"/>
           <a:p xmlns:a="http://schemas.openxmlformats.org/drawingml/2006/main">
             <a:pPr>
+              <a:buNone/>
               <a:defRPr sz="1500" b="0">
                 <a:solidFill>
                   <a:srgbClr val="142D48"/>
@@ -6396,6 +6454,7 @@
           <a:lstStyle xmlns:a="http://schemas.openxmlformats.org/drawingml/2006/main"/>
           <a:p xmlns:a="http://schemas.openxmlformats.org/drawingml/2006/main">
             <a:pPr>
+              <a:buNone/>
               <a:defRPr sz="1500" b="0">
                 <a:solidFill>
                   <a:srgbClr val="142D48"/>
@@ -6519,6 +6578,7 @@
           <a:lstStyle xmlns:a="http://schemas.openxmlformats.org/drawingml/2006/main"/>
           <a:p xmlns:a="http://schemas.openxmlformats.org/drawingml/2006/main">
             <a:pPr>
+              <a:buNone/>
               <a:defRPr sz="2025" b="1">
                 <a:solidFill>
                   <a:srgbClr val="FFFFFF"/>
@@ -6576,6 +6636,7 @@
           <a:lstStyle xmlns:a="http://schemas.openxmlformats.org/drawingml/2006/main"/>
           <a:p xmlns:a="http://schemas.openxmlformats.org/drawingml/2006/main">
             <a:pPr>
+              <a:buNone/>
               <a:defRPr sz="1650" b="1">
                 <a:solidFill>
                   <a:srgbClr val="FFFFFF"/>
@@ -6601,7 +6662,7 @@
       </p:sp>
       <p:graphicFrame>
         <p:nvGraphicFramePr>
-          <p:cNvPr id="96" name=""/>
+          <p:cNvPr id="99" name=""/>
           <p:cNvGraphicFramePr/>
           <p:nvPr/>
         </p:nvGraphicFramePr>
@@ -7155,6 +7216,7 @@
           <a:lstStyle xmlns:a="http://schemas.openxmlformats.org/drawingml/2006/main"/>
           <a:p xmlns:a="http://schemas.openxmlformats.org/drawingml/2006/main">
             <a:pPr>
+              <a:buNone/>
               <a:defRPr sz="1500" b="0">
                 <a:solidFill>
                   <a:srgbClr val="142D48"/>
@@ -7278,6 +7340,7 @@
           <a:lstStyle xmlns:a="http://schemas.openxmlformats.org/drawingml/2006/main"/>
           <a:p xmlns:a="http://schemas.openxmlformats.org/drawingml/2006/main">
             <a:pPr>
+              <a:buNone/>
               <a:defRPr sz="2025" b="1">
                 <a:solidFill>
                   <a:srgbClr val="FFFFFF"/>
@@ -7335,6 +7398,7 @@
           <a:lstStyle xmlns:a="http://schemas.openxmlformats.org/drawingml/2006/main"/>
           <a:p xmlns:a="http://schemas.openxmlformats.org/drawingml/2006/main">
             <a:pPr>
+              <a:buNone/>
               <a:defRPr sz="1650" b="1">
                 <a:solidFill>
                   <a:srgbClr val="FFFFFF"/>
@@ -7392,6 +7456,7 @@
           <a:lstStyle xmlns:a="http://schemas.openxmlformats.org/drawingml/2006/main"/>
           <a:p xmlns:a="http://schemas.openxmlformats.org/drawingml/2006/main">
             <a:pPr>
+              <a:buNone/>
               <a:defRPr sz="1500" b="0">
                 <a:solidFill>
                   <a:srgbClr val="142D48"/>
@@ -7449,6 +7514,7 @@
           <a:lstStyle xmlns:a="http://schemas.openxmlformats.org/drawingml/2006/main"/>
           <a:p xmlns:a="http://schemas.openxmlformats.org/drawingml/2006/main">
             <a:pPr>
+              <a:buNone/>
               <a:defRPr sz="1500" b="0">
                 <a:solidFill>
                   <a:srgbClr val="142D48"/>
@@ -7506,6 +7572,7 @@
           <a:lstStyle xmlns:a="http://schemas.openxmlformats.org/drawingml/2006/main"/>
           <a:p xmlns:a="http://schemas.openxmlformats.org/drawingml/2006/main">
             <a:pPr>
+              <a:buNone/>
               <a:defRPr sz="1500" b="0">
                 <a:solidFill>
                   <a:srgbClr val="142D48"/>
@@ -7808,14 +7875,14 @@
       </p:sp>
       <p:pic>
         <p:nvPicPr>
-          <p:cNvPr id="56" name=""/>
+          <p:cNvPr id="59" name=""/>
           <p:cNvPicPr>
             <a:picLocks xmlns:a="http://schemas.openxmlformats.org/drawingml/2006/main" noChangeAspect="1"/>
           </p:cNvPicPr>
           <p:nvPr/>
         </p:nvPicPr>
         <p:blipFill>
-          <a:blip xmlns:r="http://schemas.openxmlformats.org/officeDocument/2006/relationships" xmlns:a="http://schemas.openxmlformats.org/drawingml/2006/main" r:embed="R87776d54cbf346d6"/>
+          <a:blip xmlns:r="http://schemas.openxmlformats.org/officeDocument/2006/relationships" xmlns:a="http://schemas.openxmlformats.org/drawingml/2006/main" r:embed="R13bf0eb15ad84c28"/>
           <a:stretch xmlns:a="http://schemas.openxmlformats.org/drawingml/2006/main"/>
         </p:blipFill>
         <p:spPr>
@@ -7868,14 +7935,14 @@
       </p:sp>
       <p:pic>
         <p:nvPicPr>
-          <p:cNvPr id="58" name=""/>
+          <p:cNvPr id="61" name=""/>
           <p:cNvPicPr>
             <a:picLocks xmlns:a="http://schemas.openxmlformats.org/drawingml/2006/main" noChangeAspect="1"/>
           </p:cNvPicPr>
           <p:nvPr/>
         </p:nvPicPr>
         <p:blipFill>
-          <a:blip xmlns:r="http://schemas.openxmlformats.org/officeDocument/2006/relationships" xmlns:a="http://schemas.openxmlformats.org/drawingml/2006/main" r:embed="R939f1842a46c48af"/>
+          <a:blip xmlns:r="http://schemas.openxmlformats.org/officeDocument/2006/relationships" xmlns:a="http://schemas.openxmlformats.org/drawingml/2006/main" r:embed="R785b0b46cbb8480e"/>
           <a:stretch xmlns:a="http://schemas.openxmlformats.org/drawingml/2006/main"/>
         </p:blipFill>
         <p:spPr>
@@ -8063,29 +8130,7 @@
                 <a:ea typeface="Arial"/>
                 <a:cs typeface="Arial"/>
               </a:rPr>
-              <a:t>Abra </a:t>
-            </a:r>
-            <a:r>
-              <a:rPr sz="1350" b="0">
-                <a:solidFill>
-                  <a:srgbClr val="073C78"/>
-                </a:solidFill>
-                <a:latin typeface="Consolas"/>
-                <a:ea typeface="Consolas"/>
-                <a:cs typeface="Consolas"/>
-              </a:rPr>
-              <a:t>config/discrepancias.yaml</a:t>
-            </a:r>
-            <a:r>
-              <a:rPr sz="1500" b="0">
-                <a:solidFill>
-                  <a:srgbClr val="142D48"/>
-                </a:solidFill>
-                <a:latin typeface="Arial"/>
-                <a:ea typeface="Arial"/>
-                <a:cs typeface="Arial"/>
-              </a:rPr>
-              <a:t>, cambie la regla y guarde.</a:t>
+              <a:t>El programa ya está configurado para funcionar correctamente.</a:t>
             </a:r>
           </a:p>
         </p:txBody>
@@ -8149,7 +8194,7 @@
                 <a:ea typeface="Arial"/>
                 <a:cs typeface="Arial"/>
               </a:rPr>
-              <a:t>La siguiente auditoría valida el YAML. Conserve la sangría con espacios.</a:t>
+              <a:t>No necesita modificar el YAML ahora. Esta sección es para cambios futuros.</a:t>
             </a:r>
           </a:p>
         </p:txBody>
@@ -9611,7 +9656,7 @@
       </p:sp>
       <p:graphicFrame>
         <p:nvGraphicFramePr>
-          <p:cNvPr id="89" name=""/>
+          <p:cNvPr id="92" name=""/>
           <p:cNvGraphicFramePr/>
           <p:nvPr/>
         </p:nvGraphicFramePr>
@@ -10102,29 +10147,7 @@
                 <a:ea typeface="Arial"/>
                 <a:cs typeface="Arial"/>
               </a:rPr>
-              <a:t>Edite </a:t>
-            </a:r>
-            <a:r>
-              <a:rPr sz="1350" b="0">
-                <a:solidFill>
-                  <a:srgbClr val="073C78"/>
-                </a:solidFill>
-                <a:latin typeface="Consolas"/>
-                <a:ea typeface="Consolas"/>
-                <a:cs typeface="Consolas"/>
-              </a:rPr>
-              <a:t>config/discrepancias.yaml</a:t>
-            </a:r>
-            <a:r>
-              <a:rPr sz="1500" b="0">
-                <a:solidFill>
-                  <a:srgbClr val="142D48"/>
-                </a:solidFill>
-                <a:latin typeface="Arial"/>
-                <a:ea typeface="Arial"/>
-                <a:cs typeface="Arial"/>
-              </a:rPr>
-              <a:t> y guarde.</a:t>
+              <a:t>Para cambios futuros, edite config/discrepancias.yaml y guarde.</a:t>
             </a:r>
           </a:p>
         </p:txBody>
@@ -10227,6 +10250,7 @@
           <a:lstStyle xmlns:a="http://schemas.openxmlformats.org/drawingml/2006/main"/>
           <a:p xmlns:a="http://schemas.openxmlformats.org/drawingml/2006/main">
             <a:pPr>
+              <a:buNone/>
               <a:defRPr sz="1500" b="1">
                 <a:solidFill>
                   <a:srgbClr val="073C78"/>

</xml_diff>

<commit_message>
Menciona Dashboard en los resultados de la guia DIPS
</commit_message>
<xml_diff>
--- a/docs/Guia_DIPS_reglas_referencias.pptx
+++ b/docs/Guia_DIPS_reglas_referencias.pptx
@@ -2,16 +2,16 @@
 <file path=ppt/presentation.xml><?xml version="1.0" encoding="utf-8"?>
 <p:presentation xmlns:p="http://schemas.openxmlformats.org/presentationml/2006/main">
   <p:sldMasterIdLst>
-    <p:sldMasterId xmlns:r="http://schemas.openxmlformats.org/officeDocument/2006/relationships" id="2147483648" r:id="R2f0e0c2751374831"/>
+    <p:sldMasterId xmlns:r="http://schemas.openxmlformats.org/officeDocument/2006/relationships" id="2147483648" r:id="R3e24f35c1d1643d0"/>
   </p:sldMasterIdLst>
   <p:notesMasterIdLst>
-    <p:notesMasterId xmlns:r="http://schemas.openxmlformats.org/officeDocument/2006/relationships" r:id="Rdf1f9d684bc347c2"/>
+    <p:notesMasterId xmlns:r="http://schemas.openxmlformats.org/officeDocument/2006/relationships" r:id="R957655461aba4b19"/>
   </p:notesMasterIdLst>
   <p:sldIdLst>
-    <p:sldId xmlns:r="http://schemas.openxmlformats.org/officeDocument/2006/relationships" id="256" r:id="Ra6c2fa0a309f4fd9"/>
-    <p:sldId xmlns:r="http://schemas.openxmlformats.org/officeDocument/2006/relationships" id="257" r:id="Rb0875f77766c4979"/>
-    <p:sldId xmlns:r="http://schemas.openxmlformats.org/officeDocument/2006/relationships" id="258" r:id="R87a94bce6f134c27"/>
-    <p:sldId xmlns:r="http://schemas.openxmlformats.org/officeDocument/2006/relationships" id="259" r:id="R45be0c598c824c91"/>
+    <p:sldId xmlns:r="http://schemas.openxmlformats.org/officeDocument/2006/relationships" id="256" r:id="R47ac6b1ead884621"/>
+    <p:sldId xmlns:r="http://schemas.openxmlformats.org/officeDocument/2006/relationships" id="257" r:id="Rf01b10388a2d4a1d"/>
+    <p:sldId xmlns:r="http://schemas.openxmlformats.org/officeDocument/2006/relationships" id="258" r:id="R9e4a463edf114616"/>
+    <p:sldId xmlns:r="http://schemas.openxmlformats.org/officeDocument/2006/relationships" id="259" r:id="Rcd375ac5e197417e"/>
   </p:sldIdLst>
   <p:sldSz cx="9753600" cy="14630400"/>
   <p:notesSz cx="6858000" cy="9144000"/>
@@ -723,7 +723,7 @@
   </p:cSld>
   <p:clrMap bg1="lt1" tx1="dk1" bg2="lt2" tx2="dk2" accent1="accent1" accent2="accent2" accent3="accent3" accent4="accent4" accent5="accent5" accent6="accent6" hlink="hlink" folHlink="folHlink"/>
   <p:sldLayoutIdLst>
-    <p:sldLayoutId xmlns:r="http://schemas.openxmlformats.org/officeDocument/2006/relationships" id="2147483649" r:id="R2776401435b244f5"/>
+    <p:sldLayoutId xmlns:r="http://schemas.openxmlformats.org/officeDocument/2006/relationships" id="2147483649" r:id="Rfc6ec61f6a8248d0"/>
   </p:sldLayoutIdLst>
   <p:txStyles>
     <p:titleStyle>
@@ -1526,7 +1526,7 @@
           <p:nvPr/>
         </p:nvPicPr>
         <p:blipFill>
-          <a:blip xmlns:r="http://schemas.openxmlformats.org/officeDocument/2006/relationships" xmlns:a="http://schemas.openxmlformats.org/drawingml/2006/main" r:embed="Rf656e617e9424675"/>
+          <a:blip xmlns:r="http://schemas.openxmlformats.org/officeDocument/2006/relationships" xmlns:a="http://schemas.openxmlformats.org/drawingml/2006/main" r:embed="Rba5996164e3241b9"/>
           <a:stretch xmlns:a="http://schemas.openxmlformats.org/drawingml/2006/main"/>
         </p:blipFill>
         <p:spPr>
@@ -1586,7 +1586,7 @@
           <p:nvPr/>
         </p:nvPicPr>
         <p:blipFill>
-          <a:blip xmlns:r="http://schemas.openxmlformats.org/officeDocument/2006/relationships" xmlns:a="http://schemas.openxmlformats.org/drawingml/2006/main" r:embed="Rbb60749dc68043c6"/>
+          <a:blip xmlns:r="http://schemas.openxmlformats.org/officeDocument/2006/relationships" xmlns:a="http://schemas.openxmlformats.org/drawingml/2006/main" r:embed="R12d1c6eea1fe4404"/>
           <a:stretch xmlns:a="http://schemas.openxmlformats.org/drawingml/2006/main"/>
         </p:blipFill>
         <p:spPr>
@@ -3826,7 +3826,18 @@
                 <a:ea typeface="Arial"/>
                 <a:cs typeface="Arial"/>
               </a:rPr>
-              <a:t>Resultado: carpeta </a:t>
+              <a:t>Resultados:</a:t>
+            </a:r>
+            <a:r>
+              <a:rPr sz="1800" b="1">
+                <a:solidFill>
+                  <a:srgbClr val="073C78"/>
+                </a:solidFill>
+                <a:latin typeface="Arial"/>
+                <a:ea typeface="Arial"/>
+                <a:cs typeface="Arial"/>
+              </a:rPr>
+              <a:t> carpeta </a:t>
             </a:r>
             <a:r>
               <a:rPr sz="1650" b="0">
@@ -3895,7 +3906,7 @@
                 <a:ea typeface="Arial"/>
                 <a:cs typeface="Arial"/>
               </a:rPr>
-              <a:t>Revise RESULTADO, HALLAZGOS y VERIFICACIÓN MANUAL.</a:t>
+              <a:t>El Excel incluye los resultados de la auditoría.</a:t>
             </a:r>
           </a:p>
         </p:txBody>
@@ -3953,7 +3964,7 @@
                 <a:ea typeface="Arial"/>
                 <a:cs typeface="Arial"/>
               </a:rPr>
-              <a:t>La página siguiente explica los seis resultados y sus colores.</a:t>
+              <a:t>La hoja Dashboard muestra indicadores y gráficos del resultado.</a:t>
             </a:r>
           </a:p>
         </p:txBody>
@@ -4011,7 +4022,7 @@
                 <a:ea typeface="Arial"/>
                 <a:cs typeface="Arial"/>
               </a:rPr>
-              <a:t>Complete las verificaciones manuales indicadas en cada DIP.</a:t>
+              <a:t>La página siguiente explica los seis resultados y sus colores.</a:t>
             </a:r>
           </a:p>
         </p:txBody>
@@ -4302,7 +4313,7 @@
           <p:nvPr/>
         </p:nvPicPr>
         <p:blipFill>
-          <a:blip xmlns:r="http://schemas.openxmlformats.org/officeDocument/2006/relationships" xmlns:a="http://schemas.openxmlformats.org/drawingml/2006/main" r:embed="R43d159ed8dd44634"/>
+          <a:blip xmlns:r="http://schemas.openxmlformats.org/officeDocument/2006/relationships" xmlns:a="http://schemas.openxmlformats.org/drawingml/2006/main" r:embed="Redcddb329259418f"/>
           <a:stretch xmlns:a="http://schemas.openxmlformats.org/drawingml/2006/main"/>
         </p:blipFill>
         <p:spPr>
@@ -4362,7 +4373,7 @@
           <p:nvPr/>
         </p:nvPicPr>
         <p:blipFill>
-          <a:blip xmlns:r="http://schemas.openxmlformats.org/officeDocument/2006/relationships" xmlns:a="http://schemas.openxmlformats.org/drawingml/2006/main" r:embed="R73b941dcab374e9d"/>
+          <a:blip xmlns:r="http://schemas.openxmlformats.org/officeDocument/2006/relationships" xmlns:a="http://schemas.openxmlformats.org/drawingml/2006/main" r:embed="R6a85e9a0c4e042af"/>
           <a:stretch xmlns:a="http://schemas.openxmlformats.org/drawingml/2006/main"/>
         </p:blipFill>
         <p:spPr>
@@ -5642,7 +5653,7 @@
           <p:nvPr/>
         </p:nvPicPr>
         <p:blipFill>
-          <a:blip xmlns:r="http://schemas.openxmlformats.org/officeDocument/2006/relationships" xmlns:a="http://schemas.openxmlformats.org/drawingml/2006/main" r:embed="R2182e17556644e8d"/>
+          <a:blip xmlns:r="http://schemas.openxmlformats.org/officeDocument/2006/relationships" xmlns:a="http://schemas.openxmlformats.org/drawingml/2006/main" r:embed="Rbab92c1515014ccd"/>
           <a:stretch xmlns:a="http://schemas.openxmlformats.org/drawingml/2006/main"/>
         </p:blipFill>
         <p:spPr>
@@ -5702,7 +5713,7 @@
           <p:nvPr/>
         </p:nvPicPr>
         <p:blipFill>
-          <a:blip xmlns:r="http://schemas.openxmlformats.org/officeDocument/2006/relationships" xmlns:a="http://schemas.openxmlformats.org/drawingml/2006/main" r:embed="R306e130d1a664a44"/>
+          <a:blip xmlns:r="http://schemas.openxmlformats.org/officeDocument/2006/relationships" xmlns:a="http://schemas.openxmlformats.org/drawingml/2006/main" r:embed="R4ad4c3bee00d4381"/>
           <a:stretch xmlns:a="http://schemas.openxmlformats.org/drawingml/2006/main"/>
         </p:blipFill>
         <p:spPr>
@@ -6297,7 +6308,7 @@
                 <a:latin typeface="Arial"/>
                 <a:ea typeface="Arial"/>
                 <a:cs typeface="Arial"/>
-                <a:hlinkClick xmlns:r="http://schemas.openxmlformats.org/officeDocument/2006/relationships" r:id="Rb491143d2d624366"/>
+                <a:hlinkClick xmlns:r="http://schemas.openxmlformats.org/officeDocument/2006/relationships" r:id="R7deacbb8635441e0"/>
               </a:rPr>
               <a:t>Abrir DIPs References.xlsx en SharePoint</a:t>
             </a:r>
@@ -7882,7 +7893,7 @@
           <p:nvPr/>
         </p:nvPicPr>
         <p:blipFill>
-          <a:blip xmlns:r="http://schemas.openxmlformats.org/officeDocument/2006/relationships" xmlns:a="http://schemas.openxmlformats.org/drawingml/2006/main" r:embed="R13bf0eb15ad84c28"/>
+          <a:blip xmlns:r="http://schemas.openxmlformats.org/officeDocument/2006/relationships" xmlns:a="http://schemas.openxmlformats.org/drawingml/2006/main" r:embed="Rb481e48441a045e2"/>
           <a:stretch xmlns:a="http://schemas.openxmlformats.org/drawingml/2006/main"/>
         </p:blipFill>
         <p:spPr>
@@ -7942,7 +7953,7 @@
           <p:nvPr/>
         </p:nvPicPr>
         <p:blipFill>
-          <a:blip xmlns:r="http://schemas.openxmlformats.org/officeDocument/2006/relationships" xmlns:a="http://schemas.openxmlformats.org/drawingml/2006/main" r:embed="R785b0b46cbb8480e"/>
+          <a:blip xmlns:r="http://schemas.openxmlformats.org/officeDocument/2006/relationships" xmlns:a="http://schemas.openxmlformats.org/drawingml/2006/main" r:embed="R4e6e0994212c49a7"/>
           <a:stretch xmlns:a="http://schemas.openxmlformats.org/drawingml/2006/main"/>
         </p:blipFill>
         <p:spPr>

</xml_diff>

<commit_message>
Justifica resultados y aclara etapas de auditoria en la guia
</commit_message>
<xml_diff>
--- a/docs/Guia_DIPS_reglas_referencias.pptx
+++ b/docs/Guia_DIPS_reglas_referencias.pptx
@@ -2,16 +2,16 @@
 <file path=ppt/presentation.xml><?xml version="1.0" encoding="utf-8"?>
 <p:presentation xmlns:p="http://schemas.openxmlformats.org/presentationml/2006/main">
   <p:sldMasterIdLst>
-    <p:sldMasterId xmlns:r="http://schemas.openxmlformats.org/officeDocument/2006/relationships" id="2147483648" r:id="R3e24f35c1d1643d0"/>
+    <p:sldMasterId xmlns:r="http://schemas.openxmlformats.org/officeDocument/2006/relationships" id="2147483648" r:id="R032f31a94ae34d83"/>
   </p:sldMasterIdLst>
   <p:notesMasterIdLst>
-    <p:notesMasterId xmlns:r="http://schemas.openxmlformats.org/officeDocument/2006/relationships" r:id="R957655461aba4b19"/>
+    <p:notesMasterId xmlns:r="http://schemas.openxmlformats.org/officeDocument/2006/relationships" r:id="R1fab1639d2a840cf"/>
   </p:notesMasterIdLst>
   <p:sldIdLst>
-    <p:sldId xmlns:r="http://schemas.openxmlformats.org/officeDocument/2006/relationships" id="256" r:id="R47ac6b1ead884621"/>
-    <p:sldId xmlns:r="http://schemas.openxmlformats.org/officeDocument/2006/relationships" id="257" r:id="Rf01b10388a2d4a1d"/>
-    <p:sldId xmlns:r="http://schemas.openxmlformats.org/officeDocument/2006/relationships" id="258" r:id="R9e4a463edf114616"/>
-    <p:sldId xmlns:r="http://schemas.openxmlformats.org/officeDocument/2006/relationships" id="259" r:id="Rcd375ac5e197417e"/>
+    <p:sldId xmlns:r="http://schemas.openxmlformats.org/officeDocument/2006/relationships" id="256" r:id="Rcde79d1f290d46b4"/>
+    <p:sldId xmlns:r="http://schemas.openxmlformats.org/officeDocument/2006/relationships" id="257" r:id="R1d82365269e64b50"/>
+    <p:sldId xmlns:r="http://schemas.openxmlformats.org/officeDocument/2006/relationships" id="258" r:id="R7f81dc7a5c4f4a32"/>
+    <p:sldId xmlns:r="http://schemas.openxmlformats.org/officeDocument/2006/relationships" id="259" r:id="Reb32090255214781"/>
   </p:sldIdLst>
   <p:sldSz cx="9753600" cy="14630400"/>
   <p:notesSz cx="6858000" cy="9144000"/>
@@ -723,7 +723,7 @@
   </p:cSld>
   <p:clrMap bg1="lt1" tx1="dk1" bg2="lt2" tx2="dk2" accent1="accent1" accent2="accent2" accent3="accent3" accent4="accent4" accent5="accent5" accent6="accent6" hlink="hlink" folHlink="folHlink"/>
   <p:sldLayoutIdLst>
-    <p:sldLayoutId xmlns:r="http://schemas.openxmlformats.org/officeDocument/2006/relationships" id="2147483649" r:id="Rfc6ec61f6a8248d0"/>
+    <p:sldLayoutId xmlns:r="http://schemas.openxmlformats.org/officeDocument/2006/relationships" id="2147483649" r:id="Rbb2bbbd8f9604e10"/>
   </p:sldLayoutIdLst>
   <p:txStyles>
     <p:titleStyle>
@@ -1526,7 +1526,7 @@
           <p:nvPr/>
         </p:nvPicPr>
         <p:blipFill>
-          <a:blip xmlns:r="http://schemas.openxmlformats.org/officeDocument/2006/relationships" xmlns:a="http://schemas.openxmlformats.org/drawingml/2006/main" r:embed="Rba5996164e3241b9"/>
+          <a:blip xmlns:r="http://schemas.openxmlformats.org/officeDocument/2006/relationships" xmlns:a="http://schemas.openxmlformats.org/drawingml/2006/main" r:embed="Rf83b7b65cbe540ff"/>
           <a:stretch xmlns:a="http://schemas.openxmlformats.org/drawingml/2006/main"/>
         </p:blipFill>
         <p:spPr>
@@ -1586,7 +1586,7 @@
           <p:nvPr/>
         </p:nvPicPr>
         <p:blipFill>
-          <a:blip xmlns:r="http://schemas.openxmlformats.org/officeDocument/2006/relationships" xmlns:a="http://schemas.openxmlformats.org/drawingml/2006/main" r:embed="R12d1c6eea1fe4404"/>
+          <a:blip xmlns:r="http://schemas.openxmlformats.org/officeDocument/2006/relationships" xmlns:a="http://schemas.openxmlformats.org/drawingml/2006/main" r:embed="Rd158694ca001492f"/>
           <a:stretch xmlns:a="http://schemas.openxmlformats.org/drawingml/2006/main"/>
         </p:blipFill>
         <p:spPr>
@@ -4306,14 +4306,14 @@
       </p:sp>
       <p:pic>
         <p:nvPicPr>
-          <p:cNvPr id="60" name=""/>
+          <p:cNvPr id="62" name=""/>
           <p:cNvPicPr>
             <a:picLocks xmlns:a="http://schemas.openxmlformats.org/drawingml/2006/main" noChangeAspect="1"/>
           </p:cNvPicPr>
           <p:nvPr/>
         </p:nvPicPr>
         <p:blipFill>
-          <a:blip xmlns:r="http://schemas.openxmlformats.org/officeDocument/2006/relationships" xmlns:a="http://schemas.openxmlformats.org/drawingml/2006/main" r:embed="Redcddb329259418f"/>
+          <a:blip xmlns:r="http://schemas.openxmlformats.org/officeDocument/2006/relationships" xmlns:a="http://schemas.openxmlformats.org/drawingml/2006/main" r:embed="R165f8c9e6ad54e4c"/>
           <a:stretch xmlns:a="http://schemas.openxmlformats.org/drawingml/2006/main"/>
         </p:blipFill>
         <p:spPr>
@@ -4366,14 +4366,14 @@
       </p:sp>
       <p:pic>
         <p:nvPicPr>
-          <p:cNvPr id="62" name=""/>
+          <p:cNvPr id="64" name=""/>
           <p:cNvPicPr>
             <a:picLocks xmlns:a="http://schemas.openxmlformats.org/drawingml/2006/main" noChangeAspect="1"/>
           </p:cNvPicPr>
           <p:nvPr/>
         </p:nvPicPr>
         <p:blipFill>
-          <a:blip xmlns:r="http://schemas.openxmlformats.org/officeDocument/2006/relationships" xmlns:a="http://schemas.openxmlformats.org/drawingml/2006/main" r:embed="R6a85e9a0c4e042af"/>
+          <a:blip xmlns:r="http://schemas.openxmlformats.org/officeDocument/2006/relationships" xmlns:a="http://schemas.openxmlformats.org/drawingml/2006/main" r:embed="Rab6e4d67498c4788"/>
           <a:stretch xmlns:a="http://schemas.openxmlformats.org/drawingml/2006/main"/>
         </p:blipFill>
         <p:spPr>
@@ -4502,183 +4502,9 @@
           </a:p>
         </p:txBody>
       </p:sp>
-      <p:sp>
-        <p:nvSpPr>
-          <p:cNvPr id="45" name="">
-            <a:extLst xmlns:a="http://schemas.openxmlformats.org/drawingml/2006/main">
-              <a:ext uri="{FF2B5EF4-FFF2-40B4-BE49-F238E27FC236}">
-                <a16:creationId xmlns:a16="http://schemas.microsoft.com/office/drawing/2014/main" id="{ACB0E82F-4000-4217-BDF6-B2598DC20755}"/>
-              </a:ext>
-            </a:extLst>
-          </p:cNvPr>
-          <p:cNvSpPr>
-            <a:spLocks xmlns:a="http://schemas.openxmlformats.org/drawingml/2006/main" noGrp="1"/>
-          </p:cNvSpPr>
-          <p:nvPr/>
-        </p:nvSpPr>
-        <p:spPr>
-          <a:xfrm xmlns:a="http://schemas.openxmlformats.org/drawingml/2006/main">
-            <a:off x="533400" y="1866900"/>
-            <a:ext cx="8686800" cy="228600"/>
-          </a:xfrm>
-          <a:prstGeom xmlns:a="http://schemas.openxmlformats.org/drawingml/2006/main" prst="rect">
-            <a:avLst/>
-          </a:prstGeom>
-          <a:noFill xmlns:a="http://schemas.openxmlformats.org/drawingml/2006/main"/>
-          <a:ln xmlns:a="http://schemas.openxmlformats.org/drawingml/2006/main" w="0">
-            <a:noFill/>
-          </a:ln>
-        </p:spPr>
-        <p:txBody>
-          <a:bodyPr xmlns:a="http://schemas.openxmlformats.org/drawingml/2006/main" wrap="none" lIns="0" tIns="0" rIns="0" bIns="0" anchor="t">
-            <a:noAutofit/>
-          </a:bodyPr>
-          <a:lstStyle xmlns:a="http://schemas.openxmlformats.org/drawingml/2006/main"/>
-          <a:p xmlns:a="http://schemas.openxmlformats.org/drawingml/2006/main">
-            <a:pPr>
-              <a:buNone/>
-              <a:defRPr sz="1500" b="0">
-                <a:solidFill>
-                  <a:srgbClr val="142D48"/>
-                </a:solidFill>
-                <a:latin typeface="Arial"/>
-                <a:ea typeface="Arial"/>
-                <a:cs typeface="Arial"/>
-              </a:defRPr>
-            </a:pPr>
-            <a:r>
-              <a:rPr sz="1500" b="0">
-                <a:solidFill>
-                  <a:srgbClr val="142D48"/>
-                </a:solidFill>
-                <a:latin typeface="Arial"/>
-                <a:ea typeface="Arial"/>
-                <a:cs typeface="Arial"/>
-              </a:rPr>
-              <a:t>La columna RESULTADO usa estos colores en el Excel de salida.</a:t>
-            </a:r>
-          </a:p>
-        </p:txBody>
-      </p:sp>
-      <p:sp>
-        <p:nvSpPr>
-          <p:cNvPr id="46" name="">
-            <a:extLst xmlns:a="http://schemas.openxmlformats.org/drawingml/2006/main">
-              <a:ext uri="{FF2B5EF4-FFF2-40B4-BE49-F238E27FC236}">
-                <a16:creationId xmlns:a16="http://schemas.microsoft.com/office/drawing/2014/main" id="{6C8D54DA-9B68-4505-9A50-41ABEC19C8C7}"/>
-              </a:ext>
-            </a:extLst>
-          </p:cNvPr>
-          <p:cNvSpPr>
-            <a:spLocks xmlns:a="http://schemas.openxmlformats.org/drawingml/2006/main" noGrp="1"/>
-          </p:cNvSpPr>
-          <p:nvPr/>
-        </p:nvSpPr>
-        <p:spPr>
-          <a:xfrm xmlns:a="http://schemas.openxmlformats.org/drawingml/2006/main">
-            <a:off x="533400" y="2095500"/>
-            <a:ext cx="8686800" cy="228600"/>
-          </a:xfrm>
-          <a:prstGeom xmlns:a="http://schemas.openxmlformats.org/drawingml/2006/main" prst="rect">
-            <a:avLst/>
-          </a:prstGeom>
-          <a:noFill xmlns:a="http://schemas.openxmlformats.org/drawingml/2006/main"/>
-          <a:ln xmlns:a="http://schemas.openxmlformats.org/drawingml/2006/main" w="0">
-            <a:noFill/>
-          </a:ln>
-        </p:spPr>
-        <p:txBody>
-          <a:bodyPr xmlns:a="http://schemas.openxmlformats.org/drawingml/2006/main" wrap="none" lIns="0" tIns="0" rIns="0" bIns="0" anchor="t">
-            <a:noAutofit/>
-          </a:bodyPr>
-          <a:lstStyle xmlns:a="http://schemas.openxmlformats.org/drawingml/2006/main"/>
-          <a:p xmlns:a="http://schemas.openxmlformats.org/drawingml/2006/main">
-            <a:pPr>
-              <a:buNone/>
-              <a:defRPr sz="1500" b="0">
-                <a:solidFill>
-                  <a:srgbClr val="142D48"/>
-                </a:solidFill>
-                <a:latin typeface="Arial"/>
-                <a:ea typeface="Arial"/>
-                <a:cs typeface="Arial"/>
-              </a:defRPr>
-            </a:pPr>
-            <a:r>
-              <a:rPr sz="1500" b="0">
-                <a:solidFill>
-                  <a:srgbClr val="142D48"/>
-                </a:solidFill>
-                <a:latin typeface="Arial"/>
-                <a:ea typeface="Arial"/>
-                <a:cs typeface="Arial"/>
-              </a:rPr>
-              <a:t>Cada resultado indica qué revisar. Lea también HALLAZGOS y</a:t>
-            </a:r>
-          </a:p>
-        </p:txBody>
-      </p:sp>
-      <p:sp>
-        <p:nvSpPr>
-          <p:cNvPr id="47" name="">
-            <a:extLst xmlns:a="http://schemas.openxmlformats.org/drawingml/2006/main">
-              <a:ext uri="{FF2B5EF4-FFF2-40B4-BE49-F238E27FC236}">
-                <a16:creationId xmlns:a16="http://schemas.microsoft.com/office/drawing/2014/main" id="{AAA599E3-7713-40B7-9AAF-D272C33B79B5}"/>
-              </a:ext>
-            </a:extLst>
-          </p:cNvPr>
-          <p:cNvSpPr>
-            <a:spLocks xmlns:a="http://schemas.openxmlformats.org/drawingml/2006/main" noGrp="1"/>
-          </p:cNvSpPr>
-          <p:nvPr/>
-        </p:nvSpPr>
-        <p:spPr>
-          <a:xfrm xmlns:a="http://schemas.openxmlformats.org/drawingml/2006/main">
-            <a:off x="533400" y="2324100"/>
-            <a:ext cx="8686800" cy="228600"/>
-          </a:xfrm>
-          <a:prstGeom xmlns:a="http://schemas.openxmlformats.org/drawingml/2006/main" prst="rect">
-            <a:avLst/>
-          </a:prstGeom>
-          <a:noFill xmlns:a="http://schemas.openxmlformats.org/drawingml/2006/main"/>
-          <a:ln xmlns:a="http://schemas.openxmlformats.org/drawingml/2006/main" w="0">
-            <a:noFill/>
-          </a:ln>
-        </p:spPr>
-        <p:txBody>
-          <a:bodyPr xmlns:a="http://schemas.openxmlformats.org/drawingml/2006/main" wrap="none" lIns="0" tIns="0" rIns="0" bIns="0" anchor="t">
-            <a:noAutofit/>
-          </a:bodyPr>
-          <a:lstStyle xmlns:a="http://schemas.openxmlformats.org/drawingml/2006/main"/>
-          <a:p xmlns:a="http://schemas.openxmlformats.org/drawingml/2006/main">
-            <a:pPr>
-              <a:buNone/>
-              <a:defRPr sz="1500" b="0">
-                <a:solidFill>
-                  <a:srgbClr val="142D48"/>
-                </a:solidFill>
-                <a:latin typeface="Arial"/>
-                <a:ea typeface="Arial"/>
-                <a:cs typeface="Arial"/>
-              </a:defRPr>
-            </a:pPr>
-            <a:r>
-              <a:rPr sz="1500" b="0">
-                <a:solidFill>
-                  <a:srgbClr val="142D48"/>
-                </a:solidFill>
-                <a:latin typeface="Arial"/>
-                <a:ea typeface="Arial"/>
-                <a:cs typeface="Arial"/>
-              </a:rPr>
-              <a:t>VERIFICACIÓN MANUAL para conocer la evidencia y los pasos pendientes.</a:t>
-            </a:r>
-          </a:p>
-        </p:txBody>
-      </p:sp>
       <p:graphicFrame>
         <p:nvGraphicFramePr>
-          <p:cNvPr id="68" name=""/>
+          <p:cNvPr id="67" name=""/>
           <p:cNvGraphicFramePr/>
           <p:nvPr/>
         </p:nvGraphicFramePr>
@@ -4699,14 +4525,13 @@
                     <a:bodyPr lIns="228600" tIns="209550" rIns="228600" bIns="171450"/>
                     <a:lstStyle/>
                     <a:p>
-                      <a:pPr>
+                      <a:pPr algn="just">
                         <a:spcBef>
                           <a:spcPts val="0"/>
                         </a:spcBef>
                         <a:spcAft>
                           <a:spcPts val="1000"/>
                         </a:spcAft>
-                        <a:buNone/>
                       </a:pPr>
                       <a:r>
                         <a:rPr sz="1650" b="1">
@@ -4717,18 +4542,17 @@
                           <a:ea typeface="Arial"/>
                           <a:cs typeface="Arial"/>
                         </a:rPr>
-                        <a:t>1. POSIBLE DISCREPANCIA (naranja)</a:t>
+                        <a:t>1. POSIBLE DISCREPANCIA</a:t>
                       </a:r>
                     </a:p>
                     <a:p>
-                      <a:pPr>
+                      <a:pPr algn="just">
                         <a:spcBef>
                           <a:spcPts val="0"/>
                         </a:spcBef>
                         <a:spcAft>
                           <a:spcPts val="0"/>
                         </a:spcAft>
-                        <a:buNone/>
                       </a:pPr>
                       <a:r>
                         <a:rPr sz="1500">
@@ -4739,29 +4563,7 @@
                           <a:ea typeface="Arial"/>
                           <a:cs typeface="Arial"/>
                         </a:rPr>
-                        <a:t>El programa detectó una posible discrepancia. Revise el hallazgo</a:t>
-                      </a:r>
-                    </a:p>
-                    <a:p>
-                      <a:pPr>
-                        <a:spcBef>
-                          <a:spcPts val="0"/>
-                        </a:spcBef>
-                        <a:spcAft>
-                          <a:spcPts val="0"/>
-                        </a:spcAft>
-                        <a:buNone/>
-                      </a:pPr>
-                      <a:r>
-                        <a:rPr sz="1500">
-                          <a:solidFill>
-                            <a:srgbClr val="142D48"/>
-                          </a:solidFill>
-                          <a:latin typeface="Arial"/>
-                          <a:ea typeface="Arial"/>
-                          <a:cs typeface="Arial"/>
-                        </a:rPr>
-                        <a:t>y su evidencia antes de registrar la auditoría.</a:t>
+                        <a:t>El programa detectó una posible discrepancia. Revise el hallazgo y su evidencia antes de registrar la auditoría.</a:t>
                       </a:r>
                     </a:p>
                   </a:txBody>
@@ -4778,14 +4580,13 @@
                     <a:bodyPr lIns="228600" tIns="209550" rIns="228600" bIns="171450"/>
                     <a:lstStyle/>
                     <a:p>
-                      <a:pPr>
+                      <a:pPr algn="just">
                         <a:spcBef>
                           <a:spcPts val="0"/>
                         </a:spcBef>
                         <a:spcAft>
                           <a:spcPts val="1000"/>
                         </a:spcAft>
-                        <a:buNone/>
                       </a:pPr>
                       <a:r>
                         <a:rPr sz="1650" b="1">
@@ -4796,18 +4597,17 @@
                           <a:ea typeface="Arial"/>
                           <a:cs typeface="Arial"/>
                         </a:rPr>
-                        <a:t>2. CORREGIDO EN CIERRE (turquesa)</a:t>
+                        <a:t>2. CORREGIDO EN CIERRE</a:t>
                       </a:r>
                     </a:p>
                     <a:p>
-                      <a:pPr>
+                      <a:pPr algn="just">
                         <a:spcBef>
                           <a:spcPts val="0"/>
                         </a:spcBef>
                         <a:spcAft>
                           <a:spcPts val="0"/>
                         </a:spcAft>
-                        <a:buNone/>
                       </a:pPr>
                       <a:r>
                         <a:rPr sz="1500">
@@ -4818,29 +4618,7 @@
                           <a:ea typeface="Arial"/>
                           <a:cs typeface="Arial"/>
                         </a:rPr>
-                        <a:t>DIP COMPLETE: la apertura tuvo una posible discrepancia y el cierre</a:t>
-                      </a:r>
-                    </a:p>
-                    <a:p>
-                      <a:pPr>
-                        <a:spcBef>
-                          <a:spcPts val="0"/>
-                        </a:spcBef>
-                        <a:spcAft>
-                          <a:spcPts val="0"/>
-                        </a:spcAft>
-                        <a:buNone/>
-                      </a:pPr>
-                      <a:r>
-                        <a:rPr sz="1500">
-                          <a:solidFill>
-                            <a:srgbClr val="142D48"/>
-                          </a:solidFill>
-                          <a:latin typeface="Arial"/>
-                          <a:ea typeface="Arial"/>
-                          <a:cs typeface="Arial"/>
-                        </a:rPr>
-                        <a:t>quedó OK. Revise ambos estados y complete la verificación manual.</a:t>
+                        <a:t>DIP COMPLETE: la apertura tuvo una posible discrepancia y el cierre quedó OK. Revise ambos estados y complete la verificación manual.</a:t>
                       </a:r>
                     </a:p>
                   </a:txBody>
@@ -4857,14 +4635,13 @@
                     <a:bodyPr lIns="228600" tIns="209550" rIns="228600" bIns="171450"/>
                     <a:lstStyle/>
                     <a:p>
-                      <a:pPr>
+                      <a:pPr algn="just">
                         <a:spcBef>
                           <a:spcPts val="0"/>
                         </a:spcBef>
                         <a:spcAft>
                           <a:spcPts val="1000"/>
                         </a:spcAft>
-                        <a:buNone/>
                       </a:pPr>
                       <a:r>
                         <a:rPr sz="1650" b="1">
@@ -4875,18 +4652,17 @@
                           <a:ea typeface="Arial"/>
                           <a:cs typeface="Arial"/>
                         </a:rPr>
-                        <a:t>3. REVISAR (amarillo)</a:t>
+                        <a:t>3. REVISAR</a:t>
                       </a:r>
                     </a:p>
                     <a:p>
-                      <a:pPr>
+                      <a:pPr algn="just">
                         <a:spcBef>
                           <a:spcPts val="0"/>
                         </a:spcBef>
                         <a:spcAft>
                           <a:spcPts val="0"/>
                         </a:spcAft>
-                        <a:buNone/>
                       </a:pPr>
                       <a:r>
                         <a:rPr sz="1500">
@@ -4897,51 +4673,7 @@
                           <a:ea typeface="Arial"/>
                           <a:cs typeface="Arial"/>
                         </a:rPr>
-                        <a:t>El TA o el RIR depende del daño, de una condición o del manual.</a:t>
-                      </a:r>
-                    </a:p>
-                    <a:p>
-                      <a:pPr>
-                        <a:spcBef>
-                          <a:spcPts val="0"/>
-                        </a:spcBef>
-                        <a:spcAft>
-                          <a:spcPts val="0"/>
-                        </a:spcAft>
-                        <a:buNone/>
-                      </a:pPr>
-                      <a:r>
-                        <a:rPr sz="1500">
-                          <a:solidFill>
-                            <a:srgbClr val="142D48"/>
-                          </a:solidFill>
-                          <a:latin typeface="Arial"/>
-                          <a:ea typeface="Arial"/>
-                          <a:cs typeface="Arial"/>
-                        </a:rPr>
-                        <a:t>Consulte la </a:t>
-                      </a:r>
-                      <a:r>
-                        <a:rPr sz="1500">
-                          <a:solidFill>
-                            <a:srgbClr val="142D48"/>
-                          </a:solidFill>
-                          <a:latin typeface="Arial"/>
-                          <a:ea typeface="Arial"/>
-                          <a:cs typeface="Arial"/>
-                        </a:rPr>
-                        <a:t>referencia técnica</a:t>
-                      </a:r>
-                      <a:r>
-                        <a:rPr sz="1500">
-                          <a:solidFill>
-                            <a:srgbClr val="142D48"/>
-                          </a:solidFill>
-                          <a:latin typeface="Arial"/>
-                          <a:ea typeface="Arial"/>
-                          <a:cs typeface="Arial"/>
-                        </a:rPr>
-                        <a:t> para definir el límite aplicable.</a:t>
+                        <a:t>El TA o el RIR depende del daño, de una condición o del manual. Consulte la referencia técnica para definir el límite aplicable.</a:t>
                       </a:r>
                     </a:p>
                   </a:txBody>
@@ -4958,14 +4690,13 @@
                     <a:bodyPr lIns="228600" tIns="209550" rIns="228600" bIns="171450"/>
                     <a:lstStyle/>
                     <a:p>
-                      <a:pPr>
+                      <a:pPr algn="just">
                         <a:spcBef>
                           <a:spcPts val="0"/>
                         </a:spcBef>
                         <a:spcAft>
                           <a:spcPts val="1000"/>
                         </a:spcAft>
-                        <a:buNone/>
                       </a:pPr>
                       <a:r>
                         <a:rPr sz="1650" b="1">
@@ -4976,18 +4707,17 @@
                           <a:ea typeface="Arial"/>
                           <a:cs typeface="Arial"/>
                         </a:rPr>
-                        <a:t>4. SIN FUENTE EN DIPS REFERENCES (azul)</a:t>
+                        <a:t>4. SIN FUENTE EN DIPS REFERENCES</a:t>
                       </a:r>
                     </a:p>
                     <a:p>
-                      <a:pPr>
+                      <a:pPr algn="just">
                         <a:spcBef>
                           <a:spcPts val="0"/>
                         </a:spcBef>
                         <a:spcAft>
                           <a:spcPts val="0"/>
                         </a:spcAft>
-                        <a:buNone/>
                       </a:pPr>
                       <a:r>
                         <a:rPr sz="1500">
@@ -4998,29 +4728,7 @@
                           <a:ea typeface="Arial"/>
                           <a:cs typeface="Arial"/>
                         </a:rPr>
-                        <a:t>El DIP no tiene una referencia asociada en el Excel de referencias.</a:t>
-                      </a:r>
-                    </a:p>
-                    <a:p>
-                      <a:pPr>
-                        <a:spcBef>
-                          <a:spcPts val="0"/>
-                        </a:spcBef>
-                        <a:spcAft>
-                          <a:spcPts val="0"/>
-                        </a:spcAft>
-                        <a:buNone/>
-                      </a:pPr>
-                      <a:r>
-                        <a:rPr sz="1500">
-                          <a:solidFill>
-                            <a:srgbClr val="142D48"/>
-                          </a:solidFill>
-                          <a:latin typeface="Arial"/>
-                          <a:ea typeface="Arial"/>
-                          <a:cs typeface="Arial"/>
-                        </a:rPr>
-                        <a:t>Compruebe la fuente y complete los datos aprobados de la tabla.</a:t>
+                        <a:t>El DIP no tiene una referencia asociada en el Excel de referencias. Compruebe la fuente y complete los datos aprobados de la tabla.</a:t>
                       </a:r>
                     </a:p>
                   </a:txBody>
@@ -5037,14 +4745,13 @@
                     <a:bodyPr lIns="228600" tIns="209550" rIns="228600" bIns="171450"/>
                     <a:lstStyle/>
                     <a:p>
-                      <a:pPr>
+                      <a:pPr algn="just">
                         <a:spcBef>
                           <a:spcPts val="0"/>
                         </a:spcBef>
                         <a:spcAft>
                           <a:spcPts val="1000"/>
                         </a:spcAft>
-                        <a:buNone/>
                       </a:pPr>
                       <a:r>
                         <a:rPr sz="1650" b="1">
@@ -5055,18 +4762,17 @@
                           <a:ea typeface="Arial"/>
                           <a:cs typeface="Arial"/>
                         </a:rPr>
-                        <a:t>5. OK (verde)</a:t>
+                        <a:t>5. OK</a:t>
                       </a:r>
                     </a:p>
                     <a:p>
-                      <a:pPr>
+                      <a:pPr algn="just">
                         <a:spcBef>
                           <a:spcPts val="0"/>
                         </a:spcBef>
                         <a:spcAft>
                           <a:spcPts val="0"/>
                         </a:spcAft>
-                        <a:buNone/>
                       </a:pPr>
                       <a:r>
                         <a:rPr sz="1500">
@@ -5077,29 +4783,7 @@
                           <a:ea typeface="Arial"/>
                           <a:cs typeface="Arial"/>
                         </a:rPr>
-                        <a:t>La auditoría automática no detectó una posible discrepancia.</a:t>
-                      </a:r>
-                    </a:p>
-                    <a:p>
-                      <a:pPr>
-                        <a:spcBef>
-                          <a:spcPts val="0"/>
-                        </a:spcBef>
-                        <a:spcAft>
-                          <a:spcPts val="0"/>
-                        </a:spcAft>
-                        <a:buNone/>
-                      </a:pPr>
-                      <a:r>
-                        <a:rPr sz="1500">
-                          <a:solidFill>
-                            <a:srgbClr val="142D48"/>
-                          </a:solidFill>
-                          <a:latin typeface="Arial"/>
-                          <a:ea typeface="Arial"/>
-                          <a:cs typeface="Arial"/>
-                        </a:rPr>
-                        <a:t>Complete los puntos pendientes en VERIFICACIÓN MANUAL.</a:t>
+                        <a:t>La auditoría automática no detectó una posible discrepancia. Complete los puntos pendientes en VERIFICACIÓN MANUAL.</a:t>
                       </a:r>
                     </a:p>
                   </a:txBody>
@@ -5116,14 +4800,13 @@
                     <a:bodyPr lIns="228600" tIns="209550" rIns="228600" bIns="171450"/>
                     <a:lstStyle/>
                     <a:p>
-                      <a:pPr>
+                      <a:pPr algn="just">
                         <a:spcBef>
                           <a:spcPts val="0"/>
                         </a:spcBef>
                         <a:spcAft>
                           <a:spcPts val="1000"/>
                         </a:spcAft>
-                        <a:buNone/>
                       </a:pPr>
                       <a:r>
                         <a:rPr sz="1650" b="1">
@@ -5134,18 +4817,17 @@
                           <a:ea typeface="Arial"/>
                           <a:cs typeface="Arial"/>
                         </a:rPr>
-                        <a:t>6. FUERA DE ALCANCE (gris)</a:t>
+                        <a:t>6. FUERA DE ALCANCE</a:t>
                       </a:r>
                     </a:p>
                     <a:p>
-                      <a:pPr>
+                      <a:pPr algn="just">
                         <a:spcBef>
                           <a:spcPts val="0"/>
                         </a:spcBef>
                         <a:spcAft>
                           <a:spcPts val="0"/>
                         </a:spcAft>
-                        <a:buNone/>
                       </a:pPr>
                       <a:r>
                         <a:rPr sz="1500">
@@ -5156,29 +4838,7 @@
                           <a:ea typeface="Arial"/>
                           <a:cs typeface="Arial"/>
                         </a:rPr>
-                        <a:t>El tipo de DIP quedó fuera de los tipos elegidos para auditar.</a:t>
-                      </a:r>
-                    </a:p>
-                    <a:p>
-                      <a:pPr>
-                        <a:spcBef>
-                          <a:spcPts val="0"/>
-                        </a:spcBef>
-                        <a:spcAft>
-                          <a:spcPts val="0"/>
-                        </a:spcAft>
-                        <a:buNone/>
-                      </a:pPr>
-                      <a:r>
-                        <a:rPr sz="1500">
-                          <a:solidFill>
-                            <a:srgbClr val="142D48"/>
-                          </a:solidFill>
-                          <a:latin typeface="Arial"/>
-                          <a:ea typeface="Arial"/>
-                          <a:cs typeface="Arial"/>
-                        </a:rPr>
-                        <a:t>El programa no evaluó ese DIP en esta ejecución.</a:t>
+                        <a:t>El tipo de DIP quedó fuera de los tipos elegidos para auditar. El programa no evaluó ese DIP en esta ejecución.</a:t>
                       </a:r>
                     </a:p>
                   </a:txBody>
@@ -5195,22 +4855,22 @@
       </p:graphicFrame>
       <p:sp>
         <p:nvSpPr>
-          <p:cNvPr id="49" name="">
-            <a:extLst xmlns:a="http://schemas.openxmlformats.org/drawingml/2006/main">
-              <a:ext uri="{FF2B5EF4-FFF2-40B4-BE49-F238E27FC236}">
-                <a16:creationId xmlns:a16="http://schemas.microsoft.com/office/drawing/2014/main" id="{2178EC0C-A565-45A3-BA48-C47AD7936BEE}"/>
-              </a:ext>
-            </a:extLst>
-          </p:cNvPr>
-          <p:cNvSpPr>
-            <a:spLocks xmlns:a="http://schemas.openxmlformats.org/drawingml/2006/main" noGrp="1"/>
-          </p:cNvSpPr>
-          <p:nvPr/>
-        </p:nvSpPr>
-        <p:spPr>
-          <a:xfrm xmlns:a="http://schemas.openxmlformats.org/drawingml/2006/main">
-            <a:off x="533400" y="12192000"/>
-            <a:ext cx="8686800" cy="228600"/>
+          <p:cNvPr id="55" name="">
+            <a:extLst xmlns:a="http://schemas.openxmlformats.org/drawingml/2006/main">
+              <a:ext uri="{FF2B5EF4-FFF2-40B4-BE49-F238E27FC236}">
+                <a16:creationId xmlns:a16="http://schemas.microsoft.com/office/drawing/2014/main" id="{508FBB26-DA54-45F9-89B3-8F717165AE1E}"/>
+              </a:ext>
+            </a:extLst>
+          </p:cNvPr>
+          <p:cNvSpPr>
+            <a:spLocks xmlns:a="http://schemas.openxmlformats.org/drawingml/2006/main" noGrp="1"/>
+          </p:cNvSpPr>
+          <p:nvPr/>
+        </p:nvSpPr>
+        <p:spPr>
+          <a:xfrm xmlns:a="http://schemas.openxmlformats.org/drawingml/2006/main">
+            <a:off x="533400" y="1866900"/>
+            <a:ext cx="8686800" cy="685800"/>
           </a:xfrm>
           <a:prstGeom xmlns:a="http://schemas.openxmlformats.org/drawingml/2006/main" prst="rect">
             <a:avLst/>
@@ -5221,14 +4881,13 @@
           </a:ln>
         </p:spPr>
         <p:txBody>
-          <a:bodyPr xmlns:a="http://schemas.openxmlformats.org/drawingml/2006/main" wrap="none" lIns="0" tIns="0" rIns="0" bIns="0" anchor="t">
+          <a:bodyPr xmlns:a="http://schemas.openxmlformats.org/drawingml/2006/main" wrap="square" lIns="0" tIns="0" rIns="0" bIns="0" anchor="t">
             <a:noAutofit/>
           </a:bodyPr>
           <a:lstStyle xmlns:a="http://schemas.openxmlformats.org/drawingml/2006/main"/>
           <a:p xmlns:a="http://schemas.openxmlformats.org/drawingml/2006/main">
-            <a:pPr>
-              <a:buNone/>
-              <a:defRPr sz="1500" b="0">
+            <a:pPr algn="just">
+              <a:defRPr sz="1500">
                 <a:solidFill>
                   <a:srgbClr val="142D48"/>
                 </a:solidFill>
@@ -5238,37 +4897,37 @@
               </a:defRPr>
             </a:pPr>
             <a:r>
-              <a:rPr sz="1500" b="0">
-                <a:solidFill>
-                  <a:srgbClr val="142D48"/>
-                </a:solidFill>
-                <a:latin typeface="Arial"/>
-                <a:ea typeface="Arial"/>
-                <a:cs typeface="Arial"/>
-              </a:rPr>
-              <a:t>En cada etapa prevalece POSIBLE DISCREPANCIA, luego REVISAR</a:t>
+              <a:rPr sz="1500">
+                <a:solidFill>
+                  <a:srgbClr val="142D48"/>
+                </a:solidFill>
+                <a:latin typeface="Arial"/>
+                <a:ea typeface="Arial"/>
+                <a:cs typeface="Arial"/>
+              </a:rPr>
+              <a:t>La columna RESULTADO usa estos colores en el Excel de salida. Cada resultado indica qué revisar. Lea también HALLAZGOS y VERIFICACIÓN MANUAL para conocer la evidencia y los pasos pendientes.</a:t>
             </a:r>
           </a:p>
         </p:txBody>
       </p:sp>
       <p:sp>
         <p:nvSpPr>
-          <p:cNvPr id="50" name="">
-            <a:extLst xmlns:a="http://schemas.openxmlformats.org/drawingml/2006/main">
-              <a:ext uri="{FF2B5EF4-FFF2-40B4-BE49-F238E27FC236}">
-                <a16:creationId xmlns:a16="http://schemas.microsoft.com/office/drawing/2014/main" id="{26642307-611E-46E0-89D5-610A1FE07D81}"/>
-              </a:ext>
-            </a:extLst>
-          </p:cNvPr>
-          <p:cNvSpPr>
-            <a:spLocks xmlns:a="http://schemas.openxmlformats.org/drawingml/2006/main" noGrp="1"/>
-          </p:cNvSpPr>
-          <p:nvPr/>
-        </p:nvSpPr>
-        <p:spPr>
-          <a:xfrm xmlns:a="http://schemas.openxmlformats.org/drawingml/2006/main">
-            <a:off x="533400" y="12420600"/>
-            <a:ext cx="8686800" cy="228600"/>
+          <p:cNvPr id="56" name="">
+            <a:extLst xmlns:a="http://schemas.openxmlformats.org/drawingml/2006/main">
+              <a:ext uri="{FF2B5EF4-FFF2-40B4-BE49-F238E27FC236}">
+                <a16:creationId xmlns:a16="http://schemas.microsoft.com/office/drawing/2014/main" id="{8B7EA56E-D611-4C48-B9ED-28F842D2959C}"/>
+              </a:ext>
+            </a:extLst>
+          </p:cNvPr>
+          <p:cNvSpPr>
+            <a:spLocks xmlns:a="http://schemas.openxmlformats.org/drawingml/2006/main" noGrp="1"/>
+          </p:cNvSpPr>
+          <p:nvPr/>
+        </p:nvSpPr>
+        <p:spPr>
+          <a:xfrm xmlns:a="http://schemas.openxmlformats.org/drawingml/2006/main">
+            <a:off x="533400" y="12192000"/>
+            <a:ext cx="8686800" cy="914400"/>
           </a:xfrm>
           <a:prstGeom xmlns:a="http://schemas.openxmlformats.org/drawingml/2006/main" prst="rect">
             <a:avLst/>
@@ -5279,14 +4938,13 @@
           </a:ln>
         </p:spPr>
         <p:txBody>
-          <a:bodyPr xmlns:a="http://schemas.openxmlformats.org/drawingml/2006/main" wrap="none" lIns="0" tIns="0" rIns="0" bIns="0" anchor="t">
+          <a:bodyPr xmlns:a="http://schemas.openxmlformats.org/drawingml/2006/main" wrap="square" lIns="0" tIns="0" rIns="0" bIns="0" anchor="t">
             <a:noAutofit/>
           </a:bodyPr>
           <a:lstStyle xmlns:a="http://schemas.openxmlformats.org/drawingml/2006/main"/>
           <a:p xmlns:a="http://schemas.openxmlformats.org/drawingml/2006/main">
-            <a:pPr>
-              <a:buNone/>
-              <a:defRPr sz="1500" b="0">
+            <a:pPr algn="just">
+              <a:defRPr sz="1500">
                 <a:solidFill>
                   <a:srgbClr val="142D48"/>
                 </a:solidFill>
@@ -5296,73 +4954,15 @@
               </a:defRPr>
             </a:pPr>
             <a:r>
-              <a:rPr sz="1500" b="0">
-                <a:solidFill>
-                  <a:srgbClr val="142D48"/>
-                </a:solidFill>
-                <a:latin typeface="Arial"/>
-                <a:ea typeface="Arial"/>
-                <a:cs typeface="Arial"/>
-              </a:rPr>
-              <a:t>y después SIN FUENTE EN DIPS REFERENCES. Los demás hallazgos</a:t>
-            </a:r>
-          </a:p>
-        </p:txBody>
-      </p:sp>
-      <p:sp>
-        <p:nvSpPr>
-          <p:cNvPr id="51" name="">
-            <a:extLst xmlns:a="http://schemas.openxmlformats.org/drawingml/2006/main">
-              <a:ext uri="{FF2B5EF4-FFF2-40B4-BE49-F238E27FC236}">
-                <a16:creationId xmlns:a16="http://schemas.microsoft.com/office/drawing/2014/main" id="{04C217F4-45DD-4128-A033-A5A19CD46495}"/>
-              </a:ext>
-            </a:extLst>
-          </p:cNvPr>
-          <p:cNvSpPr>
-            <a:spLocks xmlns:a="http://schemas.openxmlformats.org/drawingml/2006/main" noGrp="1"/>
-          </p:cNvSpPr>
-          <p:nvPr/>
-        </p:nvSpPr>
-        <p:spPr>
-          <a:xfrm xmlns:a="http://schemas.openxmlformats.org/drawingml/2006/main">
-            <a:off x="533400" y="12649200"/>
-            <a:ext cx="8686800" cy="228600"/>
-          </a:xfrm>
-          <a:prstGeom xmlns:a="http://schemas.openxmlformats.org/drawingml/2006/main" prst="rect">
-            <a:avLst/>
-          </a:prstGeom>
-          <a:noFill xmlns:a="http://schemas.openxmlformats.org/drawingml/2006/main"/>
-          <a:ln xmlns:a="http://schemas.openxmlformats.org/drawingml/2006/main" w="0">
-            <a:noFill/>
-          </a:ln>
-        </p:spPr>
-        <p:txBody>
-          <a:bodyPr xmlns:a="http://schemas.openxmlformats.org/drawingml/2006/main" wrap="none" lIns="0" tIns="0" rIns="0" bIns="0" anchor="t">
-            <a:noAutofit/>
-          </a:bodyPr>
-          <a:lstStyle xmlns:a="http://schemas.openxmlformats.org/drawingml/2006/main"/>
-          <a:p xmlns:a="http://schemas.openxmlformats.org/drawingml/2006/main">
-            <a:pPr>
-              <a:buNone/>
-              <a:defRPr sz="1500" b="0">
-                <a:solidFill>
-                  <a:srgbClr val="142D48"/>
-                </a:solidFill>
-                <a:latin typeface="Arial"/>
-                <a:ea typeface="Arial"/>
-                <a:cs typeface="Arial"/>
-              </a:defRPr>
-            </a:pPr>
-            <a:r>
-              <a:rPr sz="1500" b="0">
-                <a:solidFill>
-                  <a:srgbClr val="142D48"/>
-                </a:solidFill>
-                <a:latin typeface="Arial"/>
-                <a:ea typeface="Arial"/>
-                <a:cs typeface="Arial"/>
-              </a:rPr>
-              <a:t>siguen visibles. CORREGIDO EN CIERRE se calcula al comparar las etapas.</a:t>
+              <a:rPr sz="1500">
+                <a:solidFill>
+                  <a:srgbClr val="142D48"/>
+                </a:solidFill>
+                <a:latin typeface="Arial"/>
+                <a:ea typeface="Arial"/>
+                <a:cs typeface="Arial"/>
+              </a:rPr>
+              <a:t>En cada etapa de auditoría prevalece POSIBLE DISCREPANCIA, luego REVISAR y después SIN FUENTE EN DIPS REFERENCES. Los demás hallazgos siguen visibles. CORREGIDO EN CIERRE se calcula al comparar las etapas de auditoría (apertura y cierre).</a:t>
             </a:r>
           </a:p>
         </p:txBody>
@@ -5653,7 +5253,7 @@
           <p:nvPr/>
         </p:nvPicPr>
         <p:blipFill>
-          <a:blip xmlns:r="http://schemas.openxmlformats.org/officeDocument/2006/relationships" xmlns:a="http://schemas.openxmlformats.org/drawingml/2006/main" r:embed="Rbab92c1515014ccd"/>
+          <a:blip xmlns:r="http://schemas.openxmlformats.org/officeDocument/2006/relationships" xmlns:a="http://schemas.openxmlformats.org/drawingml/2006/main" r:embed="R4e5369d92f9a453d"/>
           <a:stretch xmlns:a="http://schemas.openxmlformats.org/drawingml/2006/main"/>
         </p:blipFill>
         <p:spPr>
@@ -5713,7 +5313,7 @@
           <p:nvPr/>
         </p:nvPicPr>
         <p:blipFill>
-          <a:blip xmlns:r="http://schemas.openxmlformats.org/officeDocument/2006/relationships" xmlns:a="http://schemas.openxmlformats.org/drawingml/2006/main" r:embed="R4ad4c3bee00d4381"/>
+          <a:blip xmlns:r="http://schemas.openxmlformats.org/officeDocument/2006/relationships" xmlns:a="http://schemas.openxmlformats.org/drawingml/2006/main" r:embed="R642b60bd92934507"/>
           <a:stretch xmlns:a="http://schemas.openxmlformats.org/drawingml/2006/main"/>
         </p:blipFill>
         <p:spPr>
@@ -6308,7 +5908,7 @@
                 <a:latin typeface="Arial"/>
                 <a:ea typeface="Arial"/>
                 <a:cs typeface="Arial"/>
-                <a:hlinkClick xmlns:r="http://schemas.openxmlformats.org/officeDocument/2006/relationships" r:id="R7deacbb8635441e0"/>
+                <a:hlinkClick xmlns:r="http://schemas.openxmlformats.org/officeDocument/2006/relationships" r:id="R4e548e63993d46cb"/>
               </a:rPr>
               <a:t>Abrir DIPs References.xlsx en SharePoint</a:t>
             </a:r>
@@ -7893,7 +7493,7 @@
           <p:nvPr/>
         </p:nvPicPr>
         <p:blipFill>
-          <a:blip xmlns:r="http://schemas.openxmlformats.org/officeDocument/2006/relationships" xmlns:a="http://schemas.openxmlformats.org/drawingml/2006/main" r:embed="Rb481e48441a045e2"/>
+          <a:blip xmlns:r="http://schemas.openxmlformats.org/officeDocument/2006/relationships" xmlns:a="http://schemas.openxmlformats.org/drawingml/2006/main" r:embed="Rb602b4d21c9b4c2b"/>
           <a:stretch xmlns:a="http://schemas.openxmlformats.org/drawingml/2006/main"/>
         </p:blipFill>
         <p:spPr>
@@ -7953,7 +7553,7 @@
           <p:nvPr/>
         </p:nvPicPr>
         <p:blipFill>
-          <a:blip xmlns:r="http://schemas.openxmlformats.org/officeDocument/2006/relationships" xmlns:a="http://schemas.openxmlformats.org/drawingml/2006/main" r:embed="R4e6e0994212c49a7"/>
+          <a:blip xmlns:r="http://schemas.openxmlformats.org/officeDocument/2006/relationships" xmlns:a="http://schemas.openxmlformats.org/drawingml/2006/main" r:embed="R42960e3b683045a1"/>
           <a:stretch xmlns:a="http://schemas.openxmlformats.org/drawingml/2006/main"/>
         </p:blipFill>
         <p:spPr>

</xml_diff>